<commit_message>
Apply project steering decisions to presentation
</commit_message>
<xml_diff>
--- a/deliverables/07_executive_board_presentation/final/nhn_readmission_board_presentation.pptx
+++ b/deliverables/07_executive_board_presentation/final/nhn_readmission_board_presentation.pptx
@@ -2,27 +2,27 @@
 <file path=ppt/presentation.xml><?xml version="1.0" encoding="utf-8"?>
 <p:presentation xmlns:p="http://schemas.openxmlformats.org/presentationml/2006/main">
   <p:sldMasterIdLst>
-    <p:sldMasterId xmlns:r="http://schemas.openxmlformats.org/officeDocument/2006/relationships" id="2147483648" r:id="Rce9ea4476c8546a8"/>
+    <p:sldMasterId xmlns:r="http://schemas.openxmlformats.org/officeDocument/2006/relationships" id="2147483648" r:id="Re65559a9d94a4ecf"/>
   </p:sldMasterIdLst>
   <p:notesMasterIdLst>
-    <p:notesMasterId xmlns:r="http://schemas.openxmlformats.org/officeDocument/2006/relationships" r:id="Rfedebbef001d4c92"/>
+    <p:notesMasterId xmlns:r="http://schemas.openxmlformats.org/officeDocument/2006/relationships" r:id="R057a2977ca1e4022"/>
   </p:notesMasterIdLst>
   <p:sldIdLst>
-    <p:sldId xmlns:r="http://schemas.openxmlformats.org/officeDocument/2006/relationships" id="256" r:id="R2188a27f28344fc6"/>
-    <p:sldId xmlns:r="http://schemas.openxmlformats.org/officeDocument/2006/relationships" id="257" r:id="R1695d25f8c204cc3"/>
-    <p:sldId xmlns:r="http://schemas.openxmlformats.org/officeDocument/2006/relationships" id="258" r:id="R516dc63966584f06"/>
-    <p:sldId xmlns:r="http://schemas.openxmlformats.org/officeDocument/2006/relationships" id="259" r:id="R91a5446eb785435f"/>
-    <p:sldId xmlns:r="http://schemas.openxmlformats.org/officeDocument/2006/relationships" id="260" r:id="R8a86d17f8d944054"/>
-    <p:sldId xmlns:r="http://schemas.openxmlformats.org/officeDocument/2006/relationships" id="261" r:id="Rb8ddb1e6821c4c47"/>
-    <p:sldId xmlns:r="http://schemas.openxmlformats.org/officeDocument/2006/relationships" id="262" r:id="R4bcdb0ddefda4e9b"/>
-    <p:sldId xmlns:r="http://schemas.openxmlformats.org/officeDocument/2006/relationships" id="263" r:id="R9b4e58cd67704889"/>
-    <p:sldId xmlns:r="http://schemas.openxmlformats.org/officeDocument/2006/relationships" id="264" r:id="R3039b46d4d934edf"/>
-    <p:sldId xmlns:r="http://schemas.openxmlformats.org/officeDocument/2006/relationships" id="265" r:id="R9b16dc90d7234878"/>
-    <p:sldId xmlns:r="http://schemas.openxmlformats.org/officeDocument/2006/relationships" id="266" r:id="R4e3777c57f1d4e45"/>
-    <p:sldId xmlns:r="http://schemas.openxmlformats.org/officeDocument/2006/relationships" id="267" r:id="Ra14edddea21b4f5b"/>
-    <p:sldId xmlns:r="http://schemas.openxmlformats.org/officeDocument/2006/relationships" id="268" r:id="Rc2ef4ecfa87e441d"/>
-    <p:sldId xmlns:r="http://schemas.openxmlformats.org/officeDocument/2006/relationships" id="269" r:id="Rf20e343fb41a4ce5"/>
-    <p:sldId xmlns:r="http://schemas.openxmlformats.org/officeDocument/2006/relationships" id="270" r:id="Re91eba28bcde455c"/>
+    <p:sldId xmlns:r="http://schemas.openxmlformats.org/officeDocument/2006/relationships" id="256" r:id="Ra61ed94e34e242e0"/>
+    <p:sldId xmlns:r="http://schemas.openxmlformats.org/officeDocument/2006/relationships" id="257" r:id="R5dbe16e9772841ad"/>
+    <p:sldId xmlns:r="http://schemas.openxmlformats.org/officeDocument/2006/relationships" id="258" r:id="R4c5f3517d7a64264"/>
+    <p:sldId xmlns:r="http://schemas.openxmlformats.org/officeDocument/2006/relationships" id="259" r:id="Rd297c05516b341b9"/>
+    <p:sldId xmlns:r="http://schemas.openxmlformats.org/officeDocument/2006/relationships" id="260" r:id="R0905fcf879c746af"/>
+    <p:sldId xmlns:r="http://schemas.openxmlformats.org/officeDocument/2006/relationships" id="261" r:id="Rb909471a9c70491a"/>
+    <p:sldId xmlns:r="http://schemas.openxmlformats.org/officeDocument/2006/relationships" id="262" r:id="R99a4c7a82a6f4fb7"/>
+    <p:sldId xmlns:r="http://schemas.openxmlformats.org/officeDocument/2006/relationships" id="263" r:id="Rfaf96555d6fa45f2"/>
+    <p:sldId xmlns:r="http://schemas.openxmlformats.org/officeDocument/2006/relationships" id="264" r:id="R13ff89529fee4a01"/>
+    <p:sldId xmlns:r="http://schemas.openxmlformats.org/officeDocument/2006/relationships" id="265" r:id="Rd1f40b2a29304f85"/>
+    <p:sldId xmlns:r="http://schemas.openxmlformats.org/officeDocument/2006/relationships" id="266" r:id="Rfb32b08ee18e4827"/>
+    <p:sldId xmlns:r="http://schemas.openxmlformats.org/officeDocument/2006/relationships" id="267" r:id="R121439044b464fb9"/>
+    <p:sldId xmlns:r="http://schemas.openxmlformats.org/officeDocument/2006/relationships" id="268" r:id="R1c679e8c9bbf4b31"/>
+    <p:sldId xmlns:r="http://schemas.openxmlformats.org/officeDocument/2006/relationships" id="269" r:id="R61c501048dff4df6"/>
+    <p:sldId xmlns:r="http://schemas.openxmlformats.org/officeDocument/2006/relationships" id="270" r:id="R45c2f793b6f547a6"/>
   </p:sldIdLst>
   <p:sldSz cx="12192000" cy="6858000"/>
   <p:notesSz cx="6858000" cy="9144000"/>
@@ -1226,7 +1226,7 @@
           <a:lstStyle xmlns:a="http://schemas.openxmlformats.org/drawingml/2006/main"/>
           <a:p xmlns:a="http://schemas.openxmlformats.org/drawingml/2006/main">
             <a:r>
-              <a:t>The model is not positioned as a black box. It is explainable and aligns with clinical expectations.</a:t>
+              <a:t>The model is not positioned as a single decision engine. Use staged risk scoring, clinical rules, and operational review to balance recall and precision.</a:t>
             </a:r>
           </a:p>
         </p:txBody>
@@ -1296,7 +1296,7 @@
           <a:lstStyle xmlns:a="http://schemas.openxmlformats.org/drawingml/2006/main"/>
           <a:p xmlns:a="http://schemas.openxmlformats.org/drawingml/2006/main">
             <a:r>
-              <a:t>Risk deciles turn the model into an operational queue for discharge planning and care coordination.</a:t>
+              <a:t>Risk deciles turn the model into an operational queue, but coverage should be broad and supported by clinical rules rather than a narrow decile-10-only pilot.</a:t>
             </a:r>
           </a:p>
         </p:txBody>
@@ -1366,7 +1366,7 @@
           <a:lstStyle xmlns:a="http://schemas.openxmlformats.org/drawingml/2006/main"/>
           <a:p xmlns:a="http://schemas.openxmlformats.org/drawingml/2006/main">
             <a:r>
-              <a:t>Do not overclaim intervention effectiveness. Recommend better targeting and evaluation instead.</a:t>
+              <a:t>Keep the causal caveat visible, then make the stronger operational point: NHN should redesign targeting, timing, and intervention completion for high-risk patients.</a:t>
             </a:r>
           </a:p>
         </p:txBody>
@@ -1504,7 +1504,7 @@
   </p:cSld>
   <p:clrMap bg1="lt1" tx1="dk1" bg2="lt2" tx2="dk2" accent1="accent1" accent2="accent2" accent3="accent3" accent4="accent4" accent5="accent5" accent6="accent6" hlink="hlink" folHlink="folHlink"/>
   <p:sldLayoutIdLst>
-    <p:sldLayoutId xmlns:r="http://schemas.openxmlformats.org/officeDocument/2006/relationships" id="2147483649" r:id="R0794e6a3e1b843ad"/>
+    <p:sldLayoutId xmlns:r="http://schemas.openxmlformats.org/officeDocument/2006/relationships" id="2147483649" r:id="R8bb6ccf7cdab4601"/>
   </p:sldLayoutIdLst>
   <p:txStyles>
     <p:titleStyle>
@@ -3193,22 +3193,22 @@
               <c:strCache>
                 <c:ptCount val="6"/>
                 <c:pt idx="0">
-                  <c:v>Medication review completed</c:v>
+                  <c:v>Medication review</c:v>
                 </c:pt>
                 <c:pt idx="1">
-                  <c:v>Any post-discharge call</c:v>
+                  <c:v>Post-discharge call</c:v>
                 </c:pt>
                 <c:pt idx="2">
-                  <c:v>Care coordinator assigned</c:v>
+                  <c:v>Coordinator</c:v>
                 </c:pt>
                 <c:pt idx="3">
-                  <c:v>Follow-up completed</c:v>
+                  <c:v>Follow-up</c:v>
                 </c:pt>
                 <c:pt idx="4">
-                  <c:v>Transportation</c:v>
+                  <c:v>Transport</c:v>
                 </c:pt>
                 <c:pt idx="5">
-                  <c:v>Home health referral</c:v>
+                  <c:v>Home health</c:v>
                 </c:pt>
               </c:strCache>
             </c:strRef>
@@ -3877,7 +3877,7 @@
           <p:cNvPr id="25" name="">
             <a:extLst xmlns:a="http://schemas.openxmlformats.org/drawingml/2006/main">
               <a:ext uri="{FF2B5EF4-FFF2-40B4-BE49-F238E27FC236}">
-                <a16:creationId xmlns:a16="http://schemas.microsoft.com/office/drawing/2014/main" id="{B4F47C6B-E37D-4769-B9EB-16A9AA5FC1A3}"/>
+                <a16:creationId xmlns:a16="http://schemas.microsoft.com/office/drawing/2014/main" id="{439E7B07-C4D5-4AB5-8F2B-591AEB1B0361}"/>
               </a:ext>
             </a:extLst>
           </p:cNvPr>
@@ -3910,7 +3910,7 @@
           <p:cNvPr id="2" name="">
             <a:extLst xmlns:a="http://schemas.openxmlformats.org/drawingml/2006/main">
               <a:ext uri="{FF2B5EF4-FFF2-40B4-BE49-F238E27FC236}">
-                <a16:creationId xmlns:a16="http://schemas.microsoft.com/office/drawing/2014/main" id="{15CFDD7E-8659-4F02-9961-84022861A8A9}"/>
+                <a16:creationId xmlns:a16="http://schemas.microsoft.com/office/drawing/2014/main" id="{B372924F-A67F-4905-A8DE-5D0E5214557B}"/>
               </a:ext>
             </a:extLst>
           </p:cNvPr>
@@ -3968,7 +3968,7 @@
           <p:cNvPr id="3" name="">
             <a:extLst xmlns:a="http://schemas.openxmlformats.org/drawingml/2006/main">
               <a:ext uri="{FF2B5EF4-FFF2-40B4-BE49-F238E27FC236}">
-                <a16:creationId xmlns:a16="http://schemas.microsoft.com/office/drawing/2014/main" id="{E81AFFE9-451F-45B5-B99B-20833220A91A}"/>
+                <a16:creationId xmlns:a16="http://schemas.microsoft.com/office/drawing/2014/main" id="{42088275-66DB-4F99-8FE6-556F85DA7A18}"/>
               </a:ext>
             </a:extLst>
           </p:cNvPr>
@@ -4026,7 +4026,7 @@
           <p:cNvPr id="4" name="">
             <a:extLst xmlns:a="http://schemas.openxmlformats.org/drawingml/2006/main">
               <a:ext uri="{FF2B5EF4-FFF2-40B4-BE49-F238E27FC236}">
-                <a16:creationId xmlns:a16="http://schemas.microsoft.com/office/drawing/2014/main" id="{37B346E8-DC54-40A3-9EDF-E0F145E2A015}"/>
+                <a16:creationId xmlns:a16="http://schemas.microsoft.com/office/drawing/2014/main" id="{79D8579A-5E49-4734-AC1A-5264FB2D9BA6}"/>
               </a:ext>
             </a:extLst>
           </p:cNvPr>
@@ -4057,7 +4057,7 @@
           <p:cNvPr id="5" name="">
             <a:extLst xmlns:a="http://schemas.openxmlformats.org/drawingml/2006/main">
               <a:ext uri="{FF2B5EF4-FFF2-40B4-BE49-F238E27FC236}">
-                <a16:creationId xmlns:a16="http://schemas.microsoft.com/office/drawing/2014/main" id="{0FF3848E-9F2A-406E-BB69-326C2C2997B9}"/>
+                <a16:creationId xmlns:a16="http://schemas.microsoft.com/office/drawing/2014/main" id="{33D91A6B-C849-4CBB-A244-B76E3415D628}"/>
               </a:ext>
             </a:extLst>
           </p:cNvPr>
@@ -4115,7 +4115,7 @@
           <p:cNvPr id="6" name="">
             <a:extLst xmlns:a="http://schemas.openxmlformats.org/drawingml/2006/main">
               <a:ext uri="{FF2B5EF4-FFF2-40B4-BE49-F238E27FC236}">
-                <a16:creationId xmlns:a16="http://schemas.microsoft.com/office/drawing/2014/main" id="{32779306-30D3-41CB-A88F-0976FF9A2567}"/>
+                <a16:creationId xmlns:a16="http://schemas.microsoft.com/office/drawing/2014/main" id="{A45B67B6-6D1D-4DAA-9A5B-4F2C74145DB6}"/>
               </a:ext>
             </a:extLst>
           </p:cNvPr>
@@ -4173,7 +4173,7 @@
           <p:cNvPr id="7" name="">
             <a:extLst xmlns:a="http://schemas.openxmlformats.org/drawingml/2006/main">
               <a:ext uri="{FF2B5EF4-FFF2-40B4-BE49-F238E27FC236}">
-                <a16:creationId xmlns:a16="http://schemas.microsoft.com/office/drawing/2014/main" id="{28DD9256-BA87-463A-8E47-D6F01C2C8EFE}"/>
+                <a16:creationId xmlns:a16="http://schemas.microsoft.com/office/drawing/2014/main" id="{9A5FB2EC-D7D7-422F-B109-DFE33A0DF2BA}"/>
               </a:ext>
             </a:extLst>
           </p:cNvPr>
@@ -4204,7 +4204,7 @@
           <p:cNvPr id="8" name="">
             <a:extLst xmlns:a="http://schemas.openxmlformats.org/drawingml/2006/main">
               <a:ext uri="{FF2B5EF4-FFF2-40B4-BE49-F238E27FC236}">
-                <a16:creationId xmlns:a16="http://schemas.microsoft.com/office/drawing/2014/main" id="{966DD828-E5A5-4458-B3E3-B7A183587017}"/>
+                <a16:creationId xmlns:a16="http://schemas.microsoft.com/office/drawing/2014/main" id="{02348C08-87DF-4277-AF11-E0056336854A}"/>
               </a:ext>
             </a:extLst>
           </p:cNvPr>
@@ -4262,7 +4262,7 @@
           <p:cNvPr id="9" name="">
             <a:extLst xmlns:a="http://schemas.openxmlformats.org/drawingml/2006/main">
               <a:ext uri="{FF2B5EF4-FFF2-40B4-BE49-F238E27FC236}">
-                <a16:creationId xmlns:a16="http://schemas.microsoft.com/office/drawing/2014/main" id="{8D5530D0-103E-4B88-AB33-D0BC2413C475}"/>
+                <a16:creationId xmlns:a16="http://schemas.microsoft.com/office/drawing/2014/main" id="{32EB9014-3E35-476F-8E90-8E9CA5DFD28D}"/>
               </a:ext>
             </a:extLst>
           </p:cNvPr>
@@ -4320,7 +4320,7 @@
           <p:cNvPr id="10" name="">
             <a:extLst xmlns:a="http://schemas.openxmlformats.org/drawingml/2006/main">
               <a:ext uri="{FF2B5EF4-FFF2-40B4-BE49-F238E27FC236}">
-                <a16:creationId xmlns:a16="http://schemas.microsoft.com/office/drawing/2014/main" id="{9950A18D-431F-4F7A-B3DB-CB223E8C1758}"/>
+                <a16:creationId xmlns:a16="http://schemas.microsoft.com/office/drawing/2014/main" id="{7345E351-6491-4156-96E7-0592123BAA15}"/>
               </a:ext>
             </a:extLst>
           </p:cNvPr>
@@ -4351,7 +4351,7 @@
           <p:cNvPr id="11" name="">
             <a:extLst xmlns:a="http://schemas.openxmlformats.org/drawingml/2006/main">
               <a:ext uri="{FF2B5EF4-FFF2-40B4-BE49-F238E27FC236}">
-                <a16:creationId xmlns:a16="http://schemas.microsoft.com/office/drawing/2014/main" id="{0ED738D0-242C-4B08-8EF3-4E2B6D8525A6}"/>
+                <a16:creationId xmlns:a16="http://schemas.microsoft.com/office/drawing/2014/main" id="{57DEC62F-69B7-428C-B598-997E9F6DCD61}"/>
               </a:ext>
             </a:extLst>
           </p:cNvPr>
@@ -4409,7 +4409,7 @@
           <p:cNvPr id="12" name="">
             <a:extLst xmlns:a="http://schemas.openxmlformats.org/drawingml/2006/main">
               <a:ext uri="{FF2B5EF4-FFF2-40B4-BE49-F238E27FC236}">
-                <a16:creationId xmlns:a16="http://schemas.microsoft.com/office/drawing/2014/main" id="{78E3BF46-3AE2-4C97-9DE2-A05D31D7FEED}"/>
+                <a16:creationId xmlns:a16="http://schemas.microsoft.com/office/drawing/2014/main" id="{AC62A115-8A80-437E-AD14-1C59237C829D}"/>
               </a:ext>
             </a:extLst>
           </p:cNvPr>
@@ -4467,7 +4467,7 @@
           <p:cNvPr id="13" name="">
             <a:extLst xmlns:a="http://schemas.openxmlformats.org/drawingml/2006/main">
               <a:ext uri="{FF2B5EF4-FFF2-40B4-BE49-F238E27FC236}">
-                <a16:creationId xmlns:a16="http://schemas.microsoft.com/office/drawing/2014/main" id="{7BD96AF2-4884-4661-B111-7DFE5861A55F}"/>
+                <a16:creationId xmlns:a16="http://schemas.microsoft.com/office/drawing/2014/main" id="{03AB14CB-461D-44D7-B997-80238A8228ED}"/>
               </a:ext>
             </a:extLst>
           </p:cNvPr>
@@ -4525,7 +4525,7 @@
           <p:cNvPr id="14" name="">
             <a:extLst xmlns:a="http://schemas.openxmlformats.org/drawingml/2006/main">
               <a:ext uri="{FF2B5EF4-FFF2-40B4-BE49-F238E27FC236}">
-                <a16:creationId xmlns:a16="http://schemas.microsoft.com/office/drawing/2014/main" id="{60FC1D3D-CE9F-4D33-B0B2-F78D0A01868C}"/>
+                <a16:creationId xmlns:a16="http://schemas.microsoft.com/office/drawing/2014/main" id="{C767AB11-C979-42A0-B23A-7F299905CEF3}"/>
               </a:ext>
             </a:extLst>
           </p:cNvPr>
@@ -4583,7 +4583,7 @@
           <p:cNvPr id="15" name="">
             <a:extLst xmlns:a="http://schemas.openxmlformats.org/drawingml/2006/main">
               <a:ext uri="{FF2B5EF4-FFF2-40B4-BE49-F238E27FC236}">
-                <a16:creationId xmlns:a16="http://schemas.microsoft.com/office/drawing/2014/main" id="{22759642-960E-41E7-9C6F-BC6F46D68C1D}"/>
+                <a16:creationId xmlns:a16="http://schemas.microsoft.com/office/drawing/2014/main" id="{16476F35-EA2F-4321-81DD-99F11ACA74F7}"/>
               </a:ext>
             </a:extLst>
           </p:cNvPr>
@@ -4641,7 +4641,7 @@
           <p:cNvPr id="16" name="">
             <a:extLst xmlns:a="http://schemas.openxmlformats.org/drawingml/2006/main">
               <a:ext uri="{FF2B5EF4-FFF2-40B4-BE49-F238E27FC236}">
-                <a16:creationId xmlns:a16="http://schemas.microsoft.com/office/drawing/2014/main" id="{73E8DCA5-D10A-4EF6-88F0-C6F555D80E76}"/>
+                <a16:creationId xmlns:a16="http://schemas.microsoft.com/office/drawing/2014/main" id="{3E0713E7-EE73-40B2-89E1-6B465416A60F}"/>
               </a:ext>
             </a:extLst>
           </p:cNvPr>
@@ -4699,7 +4699,7 @@
           <p:cNvPr id="17" name="">
             <a:extLst xmlns:a="http://schemas.openxmlformats.org/drawingml/2006/main">
               <a:ext uri="{FF2B5EF4-FFF2-40B4-BE49-F238E27FC236}">
-                <a16:creationId xmlns:a16="http://schemas.microsoft.com/office/drawing/2014/main" id="{13D746D8-CB6C-4F6C-83B3-20AC035D59E5}"/>
+                <a16:creationId xmlns:a16="http://schemas.microsoft.com/office/drawing/2014/main" id="{A4C528B4-008A-4B70-A1D4-4610B6CCC8D2}"/>
               </a:ext>
             </a:extLst>
           </p:cNvPr>
@@ -4757,7 +4757,7 @@
           <p:cNvPr id="18" name="">
             <a:extLst xmlns:a="http://schemas.openxmlformats.org/drawingml/2006/main">
               <a:ext uri="{FF2B5EF4-FFF2-40B4-BE49-F238E27FC236}">
-                <a16:creationId xmlns:a16="http://schemas.microsoft.com/office/drawing/2014/main" id="{0D863D45-B03B-41C0-A6C4-A91B518CAE48}"/>
+                <a16:creationId xmlns:a16="http://schemas.microsoft.com/office/drawing/2014/main" id="{89C93DC2-709A-4428-B0C9-E789B5B1BE15}"/>
               </a:ext>
             </a:extLst>
           </p:cNvPr>
@@ -4815,7 +4815,7 @@
           <p:cNvPr id="19" name="">
             <a:extLst xmlns:a="http://schemas.openxmlformats.org/drawingml/2006/main">
               <a:ext uri="{FF2B5EF4-FFF2-40B4-BE49-F238E27FC236}">
-                <a16:creationId xmlns:a16="http://schemas.microsoft.com/office/drawing/2014/main" id="{9C28970D-BF10-4569-954F-708295E91251}"/>
+                <a16:creationId xmlns:a16="http://schemas.microsoft.com/office/drawing/2014/main" id="{6DBF302E-FADB-4075-B45F-CC76358FF3BE}"/>
               </a:ext>
             </a:extLst>
           </p:cNvPr>
@@ -4873,7 +4873,7 @@
           <p:cNvPr id="20" name="">
             <a:extLst xmlns:a="http://schemas.openxmlformats.org/drawingml/2006/main">
               <a:ext uri="{FF2B5EF4-FFF2-40B4-BE49-F238E27FC236}">
-                <a16:creationId xmlns:a16="http://schemas.microsoft.com/office/drawing/2014/main" id="{335A6B0F-3C2B-492C-95A2-A965A505B6FD}"/>
+                <a16:creationId xmlns:a16="http://schemas.microsoft.com/office/drawing/2014/main" id="{88E95FC4-EAA4-4425-A2D2-D6DF735F533E}"/>
               </a:ext>
             </a:extLst>
           </p:cNvPr>
@@ -4931,7 +4931,7 @@
           <p:cNvPr id="21" name="">
             <a:extLst xmlns:a="http://schemas.openxmlformats.org/drawingml/2006/main">
               <a:ext uri="{FF2B5EF4-FFF2-40B4-BE49-F238E27FC236}">
-                <a16:creationId xmlns:a16="http://schemas.microsoft.com/office/drawing/2014/main" id="{965546BA-1C2A-4BEF-AA4E-452F29F82D78}"/>
+                <a16:creationId xmlns:a16="http://schemas.microsoft.com/office/drawing/2014/main" id="{F0492752-B1C7-4D6D-A445-9A39F125A8CB}"/>
               </a:ext>
             </a:extLst>
           </p:cNvPr>
@@ -4989,7 +4989,7 @@
           <p:cNvPr id="22" name="">
             <a:extLst xmlns:a="http://schemas.openxmlformats.org/drawingml/2006/main">
               <a:ext uri="{FF2B5EF4-FFF2-40B4-BE49-F238E27FC236}">
-                <a16:creationId xmlns:a16="http://schemas.microsoft.com/office/drawing/2014/main" id="{97F8E01D-7399-4B29-9FF3-7817C9FB468A}"/>
+                <a16:creationId xmlns:a16="http://schemas.microsoft.com/office/drawing/2014/main" id="{A01FB986-8AED-4FDB-9620-64519E845F2A}"/>
               </a:ext>
             </a:extLst>
           </p:cNvPr>
@@ -5047,7 +5047,7 @@
           <p:cNvPr id="23" name="">
             <a:extLst xmlns:a="http://schemas.openxmlformats.org/drawingml/2006/main">
               <a:ext uri="{FF2B5EF4-FFF2-40B4-BE49-F238E27FC236}">
-                <a16:creationId xmlns:a16="http://schemas.microsoft.com/office/drawing/2014/main" id="{19582B4D-234C-4ED6-B395-C1A1AEF2A86F}"/>
+                <a16:creationId xmlns:a16="http://schemas.microsoft.com/office/drawing/2014/main" id="{F38407F9-FCE4-4C15-9FCE-96674E8DF912}"/>
               </a:ext>
             </a:extLst>
           </p:cNvPr>
@@ -5078,7 +5078,7 @@
           <p:cNvPr id="24" name="">
             <a:extLst xmlns:a="http://schemas.openxmlformats.org/drawingml/2006/main">
               <a:ext uri="{FF2B5EF4-FFF2-40B4-BE49-F238E27FC236}">
-                <a16:creationId xmlns:a16="http://schemas.microsoft.com/office/drawing/2014/main" id="{69C3E40D-397A-4777-B338-AA96B3EC29B1}"/>
+                <a16:creationId xmlns:a16="http://schemas.microsoft.com/office/drawing/2014/main" id="{5BAF69AE-5124-449A-98BB-C85118280E9A}"/>
               </a:ext>
             </a:extLst>
           </p:cNvPr>
@@ -5134,7 +5134,7 @@
     </p:spTree>
     <p:extLst>
       <p:ext uri="{BB962C8B-B14F-4D97-AF65-F5344CB8AC3E}">
-        <p14:creationId xmlns:p14="http://schemas.microsoft.com/office/powerpoint/2010/main" val="2010359460"/>
+        <p14:creationId xmlns:p14="http://schemas.microsoft.com/office/powerpoint/2010/main" val="1698933873"/>
       </p:ext>
     </p:extLst>
   </p:cSld>
@@ -5165,7 +5165,7 @@
           <p:cNvPr id="16" name="">
             <a:extLst xmlns:a="http://schemas.openxmlformats.org/drawingml/2006/main">
               <a:ext uri="{FF2B5EF4-FFF2-40B4-BE49-F238E27FC236}">
-                <a16:creationId xmlns:a16="http://schemas.microsoft.com/office/drawing/2014/main" id="{65FFAC0A-6798-49D9-B6CB-1DE6A49F8B5E}"/>
+                <a16:creationId xmlns:a16="http://schemas.microsoft.com/office/drawing/2014/main" id="{83821B71-7827-4533-B0A5-847F58CA708E}"/>
               </a:ext>
             </a:extLst>
           </p:cNvPr>
@@ -5198,7 +5198,7 @@
           <p:cNvPr id="2" name="">
             <a:extLst xmlns:a="http://schemas.openxmlformats.org/drawingml/2006/main">
               <a:ext uri="{FF2B5EF4-FFF2-40B4-BE49-F238E27FC236}">
-                <a16:creationId xmlns:a16="http://schemas.microsoft.com/office/drawing/2014/main" id="{DB30ECA4-BE58-45F2-8E51-A058C2DE79F4}"/>
+                <a16:creationId xmlns:a16="http://schemas.microsoft.com/office/drawing/2014/main" id="{C8DBA3E4-68A7-4F28-B7A0-1C30CC85C990}"/>
               </a:ext>
             </a:extLst>
           </p:cNvPr>
@@ -5256,7 +5256,7 @@
           <p:cNvPr id="3" name="">
             <a:extLst xmlns:a="http://schemas.openxmlformats.org/drawingml/2006/main">
               <a:ext uri="{FF2B5EF4-FFF2-40B4-BE49-F238E27FC236}">
-                <a16:creationId xmlns:a16="http://schemas.microsoft.com/office/drawing/2014/main" id="{974775DD-A45B-4E9A-9780-3B9AA218E1CB}"/>
+                <a16:creationId xmlns:a16="http://schemas.microsoft.com/office/drawing/2014/main" id="{1553B1E8-CFBA-4322-AFDA-CA3E42865B84}"/>
               </a:ext>
             </a:extLst>
           </p:cNvPr>
@@ -5314,7 +5314,7 @@
           <p:cNvPr id="4" name="">
             <a:extLst xmlns:a="http://schemas.openxmlformats.org/drawingml/2006/main">
               <a:ext uri="{FF2B5EF4-FFF2-40B4-BE49-F238E27FC236}">
-                <a16:creationId xmlns:a16="http://schemas.microsoft.com/office/drawing/2014/main" id="{1FA83C61-BF54-4C44-8EBC-AC26F4D16834}"/>
+                <a16:creationId xmlns:a16="http://schemas.microsoft.com/office/drawing/2014/main" id="{3C2D9A77-A298-43A7-94F6-FA7C56B0CCAE}"/>
               </a:ext>
             </a:extLst>
           </p:cNvPr>
@@ -5372,7 +5372,7 @@
           <p:cNvPr id="5" name="">
             <a:extLst xmlns:a="http://schemas.openxmlformats.org/drawingml/2006/main">
               <a:ext uri="{FF2B5EF4-FFF2-40B4-BE49-F238E27FC236}">
-                <a16:creationId xmlns:a16="http://schemas.microsoft.com/office/drawing/2014/main" id="{253BF97B-7B88-401C-A62A-2BE5EC84F9BC}"/>
+                <a16:creationId xmlns:a16="http://schemas.microsoft.com/office/drawing/2014/main" id="{F98D3071-323C-48D3-A534-383A1E091726}"/>
               </a:ext>
             </a:extLst>
           </p:cNvPr>
@@ -5403,7 +5403,7 @@
           <p:cNvPr id="6" name="">
             <a:extLst xmlns:a="http://schemas.openxmlformats.org/drawingml/2006/main">
               <a:ext uri="{FF2B5EF4-FFF2-40B4-BE49-F238E27FC236}">
-                <a16:creationId xmlns:a16="http://schemas.microsoft.com/office/drawing/2014/main" id="{C285681C-7E14-4F9F-8E03-025477B50CAA}"/>
+                <a16:creationId xmlns:a16="http://schemas.microsoft.com/office/drawing/2014/main" id="{6A17F3C1-FC7C-40FC-A317-44EF2F0673D2}"/>
               </a:ext>
             </a:extLst>
           </p:cNvPr>
@@ -5434,7 +5434,7 @@
           <p:cNvPr id="7" name="">
             <a:extLst xmlns:a="http://schemas.openxmlformats.org/drawingml/2006/main">
               <a:ext uri="{FF2B5EF4-FFF2-40B4-BE49-F238E27FC236}">
-                <a16:creationId xmlns:a16="http://schemas.microsoft.com/office/drawing/2014/main" id="{08857D68-A153-4821-ACD4-BFD82419C788}"/>
+                <a16:creationId xmlns:a16="http://schemas.microsoft.com/office/drawing/2014/main" id="{CBFB8834-28AC-49BF-B672-9F4DC4ADC3D3}"/>
               </a:ext>
             </a:extLst>
           </p:cNvPr>
@@ -5615,7 +5615,7 @@
                           <a:ea typeface="Helvetica Neue"/>
                           <a:cs typeface="Helvetica Neue"/>
                         </a:rPr>
-                        <a:t>Board-level status</a:t>
+                        <a:t>Presentation-level status</a:t>
                       </a:r>
                     </a:p>
                   </a:txBody>
@@ -5899,7 +5899,7 @@
           <p:cNvPr id="9" name="">
             <a:extLst xmlns:a="http://schemas.openxmlformats.org/drawingml/2006/main">
               <a:ext uri="{FF2B5EF4-FFF2-40B4-BE49-F238E27FC236}">
-                <a16:creationId xmlns:a16="http://schemas.microsoft.com/office/drawing/2014/main" id="{2504BE71-57A6-4B2D-8A5F-04F26C86230D}"/>
+                <a16:creationId xmlns:a16="http://schemas.microsoft.com/office/drawing/2014/main" id="{5A8AA28D-FB2C-428E-A732-31C72000A6AD}"/>
               </a:ext>
             </a:extLst>
           </p:cNvPr>
@@ -5957,7 +5957,7 @@
           <p:cNvPr id="10" name="">
             <a:extLst xmlns:a="http://schemas.openxmlformats.org/drawingml/2006/main">
               <a:ext uri="{FF2B5EF4-FFF2-40B4-BE49-F238E27FC236}">
-                <a16:creationId xmlns:a16="http://schemas.microsoft.com/office/drawing/2014/main" id="{F332AB8A-51C9-4820-A361-4CBC71A4BCDF}"/>
+                <a16:creationId xmlns:a16="http://schemas.microsoft.com/office/drawing/2014/main" id="{0D9151E9-1D8C-4EDF-94A2-76D6A1859EF5}"/>
               </a:ext>
             </a:extLst>
           </p:cNvPr>
@@ -5982,7 +5982,7 @@
         </p:spPr>
         <p:txBody>
           <a:bodyPr xmlns:a="http://schemas.openxmlformats.org/drawingml/2006/main">
-            <a:normAutofit fontScale="80458"/>
+            <a:normAutofit fontScale="95556"/>
           </a:bodyPr>
           <a:lstStyle xmlns:a="http://schemas.openxmlformats.org/drawingml/2006/main"/>
           <a:p xmlns:a="http://schemas.openxmlformats.org/drawingml/2006/main">
@@ -6005,7 +6005,7 @@
                 <a:ea typeface="Helvetica Neue"/>
                 <a:cs typeface="Helvetica Neue"/>
               </a:rPr>
-              <a:t>Tableau or Power BI</a:t>
+              <a:t>Tableau first</a:t>
             </a:r>
           </a:p>
         </p:txBody>
@@ -6015,7 +6015,7 @@
           <p:cNvPr id="11" name="">
             <a:extLst xmlns:a="http://schemas.openxmlformats.org/drawingml/2006/main">
               <a:ext uri="{FF2B5EF4-FFF2-40B4-BE49-F238E27FC236}">
-                <a16:creationId xmlns:a16="http://schemas.microsoft.com/office/drawing/2014/main" id="{1263A92E-EE22-48DF-B8AB-F09A7644F079}"/>
+                <a16:creationId xmlns:a16="http://schemas.microsoft.com/office/drawing/2014/main" id="{131D2F64-69D7-4836-9AF0-21A8AE343EEA}"/>
               </a:ext>
             </a:extLst>
           </p:cNvPr>
@@ -6063,7 +6063,7 @@
                 <a:ea typeface="Helvetica Neue"/>
                 <a:cs typeface="Helvetica Neue"/>
               </a:rPr>
-              <a:t>Build package included</a:t>
+              <a:t>Power BI backup path</a:t>
             </a:r>
           </a:p>
         </p:txBody>
@@ -6073,7 +6073,7 @@
           <p:cNvPr id="12" name="">
             <a:extLst xmlns:a="http://schemas.openxmlformats.org/drawingml/2006/main">
               <a:ext uri="{FF2B5EF4-FFF2-40B4-BE49-F238E27FC236}">
-                <a16:creationId xmlns:a16="http://schemas.microsoft.com/office/drawing/2014/main" id="{D3662AA0-ED75-4C5E-9437-7BE8B19CC1AB}"/>
+                <a16:creationId xmlns:a16="http://schemas.microsoft.com/office/drawing/2014/main" id="{6B1C6B73-EB66-4105-95D2-625C9984B2EE}"/>
               </a:ext>
             </a:extLst>
           </p:cNvPr>
@@ -6131,7 +6131,7 @@
           <p:cNvPr id="13" name="">
             <a:extLst xmlns:a="http://schemas.openxmlformats.org/drawingml/2006/main">
               <a:ext uri="{FF2B5EF4-FFF2-40B4-BE49-F238E27FC236}">
-                <a16:creationId xmlns:a16="http://schemas.microsoft.com/office/drawing/2014/main" id="{487F34F2-373C-4A4C-AD44-CE6EBCADAB51}"/>
+                <a16:creationId xmlns:a16="http://schemas.microsoft.com/office/drawing/2014/main" id="{91542F8E-7AE9-4C16-9D5F-A4FCB8E71E47}"/>
               </a:ext>
             </a:extLst>
           </p:cNvPr>
@@ -6189,7 +6189,7 @@
           <p:cNvPr id="14" name="">
             <a:extLst xmlns:a="http://schemas.openxmlformats.org/drawingml/2006/main">
               <a:ext uri="{FF2B5EF4-FFF2-40B4-BE49-F238E27FC236}">
-                <a16:creationId xmlns:a16="http://schemas.microsoft.com/office/drawing/2014/main" id="{53D3F808-ACA9-4926-B6BC-3CC94A363581}"/>
+                <a16:creationId xmlns:a16="http://schemas.microsoft.com/office/drawing/2014/main" id="{33F8F00A-E308-4B74-9256-837CD04D1A33}"/>
               </a:ext>
             </a:extLst>
           </p:cNvPr>
@@ -6247,7 +6247,7 @@
           <p:cNvPr id="15" name="">
             <a:extLst xmlns:a="http://schemas.openxmlformats.org/drawingml/2006/main">
               <a:ext uri="{FF2B5EF4-FFF2-40B4-BE49-F238E27FC236}">
-                <a16:creationId xmlns:a16="http://schemas.microsoft.com/office/drawing/2014/main" id="{8F7A758F-2C13-42C2-A279-19AB63417BF8}"/>
+                <a16:creationId xmlns:a16="http://schemas.microsoft.com/office/drawing/2014/main" id="{2E019303-775F-48E8-98AE-27018AADD0DE}"/>
               </a:ext>
             </a:extLst>
           </p:cNvPr>
@@ -6272,7 +6272,7 @@
         </p:spPr>
         <p:txBody>
           <a:bodyPr xmlns:a="http://schemas.openxmlformats.org/drawingml/2006/main">
-            <a:normAutofit fontScale="89203"/>
+            <a:normAutofit fontScale="85968"/>
           </a:bodyPr>
           <a:lstStyle xmlns:a="http://schemas.openxmlformats.org/drawingml/2006/main"/>
           <a:p xmlns:a="http://schemas.openxmlformats.org/drawingml/2006/main">
@@ -6295,7 +6295,7 @@
                 <a:ea typeface="Helvetica Neue"/>
                 <a:cs typeface="Helvetica Neue"/>
               </a:rPr>
-              <a:t>Use dashboard_ready_extract.csv plus the KPI and measure definition files in section 08.</a:t>
+              <a:t>Use dashboard_ready_extract.csv plus the Tableau build package and validation checks in deliverable 06.</a:t>
             </a:r>
           </a:p>
         </p:txBody>
@@ -6303,7 +6303,7 @@
     </p:spTree>
     <p:extLst>
       <p:ext uri="{BB962C8B-B14F-4D97-AF65-F5344CB8AC3E}">
-        <p14:creationId xmlns:p14="http://schemas.microsoft.com/office/powerpoint/2010/main" val="1038460896"/>
+        <p14:creationId xmlns:p14="http://schemas.microsoft.com/office/powerpoint/2010/main" val="206534543"/>
       </p:ext>
     </p:extLst>
   </p:cSld>
@@ -6334,7 +6334,7 @@
           <p:cNvPr id="10" name="">
             <a:extLst xmlns:a="http://schemas.openxmlformats.org/drawingml/2006/main">
               <a:ext uri="{FF2B5EF4-FFF2-40B4-BE49-F238E27FC236}">
-                <a16:creationId xmlns:a16="http://schemas.microsoft.com/office/drawing/2014/main" id="{97FE391E-2DC6-479E-A31F-CA97860627EE}"/>
+                <a16:creationId xmlns:a16="http://schemas.microsoft.com/office/drawing/2014/main" id="{B507F7CD-390D-4E52-BBED-4E569F0BBEDA}"/>
               </a:ext>
             </a:extLst>
           </p:cNvPr>
@@ -6367,7 +6367,7 @@
           <p:cNvPr id="2" name="">
             <a:extLst xmlns:a="http://schemas.openxmlformats.org/drawingml/2006/main">
               <a:ext uri="{FF2B5EF4-FFF2-40B4-BE49-F238E27FC236}">
-                <a16:creationId xmlns:a16="http://schemas.microsoft.com/office/drawing/2014/main" id="{AE2E735E-B3BA-4B90-9057-938E7E77D13B}"/>
+                <a16:creationId xmlns:a16="http://schemas.microsoft.com/office/drawing/2014/main" id="{1443E70E-C8E0-4FC1-A0EF-6B1C75B9A394}"/>
               </a:ext>
             </a:extLst>
           </p:cNvPr>
@@ -6425,7 +6425,7 @@
           <p:cNvPr id="3" name="">
             <a:extLst xmlns:a="http://schemas.openxmlformats.org/drawingml/2006/main">
               <a:ext uri="{FF2B5EF4-FFF2-40B4-BE49-F238E27FC236}">
-                <a16:creationId xmlns:a16="http://schemas.microsoft.com/office/drawing/2014/main" id="{68BB7685-FDBD-44A7-9E28-76E801DE8364}"/>
+                <a16:creationId xmlns:a16="http://schemas.microsoft.com/office/drawing/2014/main" id="{9CE48A09-BEB3-4B49-8BF4-07FF52654F9E}"/>
               </a:ext>
             </a:extLst>
           </p:cNvPr>
@@ -6483,7 +6483,7 @@
           <p:cNvPr id="4" name="">
             <a:extLst xmlns:a="http://schemas.openxmlformats.org/drawingml/2006/main">
               <a:ext uri="{FF2B5EF4-FFF2-40B4-BE49-F238E27FC236}">
-                <a16:creationId xmlns:a16="http://schemas.microsoft.com/office/drawing/2014/main" id="{0F3BE217-6004-4312-8612-5F07E3AC7044}"/>
+                <a16:creationId xmlns:a16="http://schemas.microsoft.com/office/drawing/2014/main" id="{630683AD-6892-4891-81AB-A87076D8BEED}"/>
               </a:ext>
             </a:extLst>
           </p:cNvPr>
@@ -6541,7 +6541,7 @@
           <p:cNvPr id="5" name="">
             <a:extLst xmlns:a="http://schemas.openxmlformats.org/drawingml/2006/main">
               <a:ext uri="{FF2B5EF4-FFF2-40B4-BE49-F238E27FC236}">
-                <a16:creationId xmlns:a16="http://schemas.microsoft.com/office/drawing/2014/main" id="{C11510D0-2B74-47BE-A028-48C746C8A625}"/>
+                <a16:creationId xmlns:a16="http://schemas.microsoft.com/office/drawing/2014/main" id="{FBCE7552-1375-4CCF-814B-3FA26E0D0862}"/>
               </a:ext>
             </a:extLst>
           </p:cNvPr>
@@ -6572,7 +6572,7 @@
           <p:cNvPr id="6" name="">
             <a:extLst xmlns:a="http://schemas.openxmlformats.org/drawingml/2006/main">
               <a:ext uri="{FF2B5EF4-FFF2-40B4-BE49-F238E27FC236}">
-                <a16:creationId xmlns:a16="http://schemas.microsoft.com/office/drawing/2014/main" id="{0F069052-7A50-410D-AF9E-435690D5F570}"/>
+                <a16:creationId xmlns:a16="http://schemas.microsoft.com/office/drawing/2014/main" id="{D4BE0B6F-8928-45B4-9312-529F9DA4756A}"/>
               </a:ext>
             </a:extLst>
           </p:cNvPr>
@@ -6603,7 +6603,7 @@
           <p:cNvPr id="7" name="">
             <a:extLst xmlns:a="http://schemas.openxmlformats.org/drawingml/2006/main">
               <a:ext uri="{FF2B5EF4-FFF2-40B4-BE49-F238E27FC236}">
-                <a16:creationId xmlns:a16="http://schemas.microsoft.com/office/drawing/2014/main" id="{43898F5E-9DB8-40DC-BFC8-4C00BCA24DCB}"/>
+                <a16:creationId xmlns:a16="http://schemas.microsoft.com/office/drawing/2014/main" id="{520A9B4E-4DF9-455E-8901-4C343549B2EA}"/>
               </a:ext>
             </a:extLst>
           </p:cNvPr>
@@ -7068,7 +7068,7 @@
           <p:cNvPr id="9" name="">
             <a:extLst xmlns:a="http://schemas.openxmlformats.org/drawingml/2006/main">
               <a:ext uri="{FF2B5EF4-FFF2-40B4-BE49-F238E27FC236}">
-                <a16:creationId xmlns:a16="http://schemas.microsoft.com/office/drawing/2014/main" id="{4920B77F-F7B9-4892-B88A-EB91EB24AC25}"/>
+                <a16:creationId xmlns:a16="http://schemas.microsoft.com/office/drawing/2014/main" id="{7FEF5E2C-A00B-4FF2-8F19-94BBF4628884}"/>
               </a:ext>
             </a:extLst>
           </p:cNvPr>
@@ -7124,7 +7124,7 @@
     </p:spTree>
     <p:extLst>
       <p:ext uri="{BB962C8B-B14F-4D97-AF65-F5344CB8AC3E}">
-        <p14:creationId xmlns:p14="http://schemas.microsoft.com/office/powerpoint/2010/main" val="1517502405"/>
+        <p14:creationId xmlns:p14="http://schemas.microsoft.com/office/powerpoint/2010/main" val="1409476747"/>
       </p:ext>
     </p:extLst>
   </p:cSld>
@@ -7155,7 +7155,7 @@
           <p:cNvPr id="11" name="">
             <a:extLst xmlns:a="http://schemas.openxmlformats.org/drawingml/2006/main">
               <a:ext uri="{FF2B5EF4-FFF2-40B4-BE49-F238E27FC236}">
-                <a16:creationId xmlns:a16="http://schemas.microsoft.com/office/drawing/2014/main" id="{E9247C56-7D3D-449F-8AAF-11B56B523413}"/>
+                <a16:creationId xmlns:a16="http://schemas.microsoft.com/office/drawing/2014/main" id="{A9BF50F2-61A7-4505-8F99-E3DEE011BE33}"/>
               </a:ext>
             </a:extLst>
           </p:cNvPr>
@@ -7188,7 +7188,7 @@
           <p:cNvPr id="2" name="">
             <a:extLst xmlns:a="http://schemas.openxmlformats.org/drawingml/2006/main">
               <a:ext uri="{FF2B5EF4-FFF2-40B4-BE49-F238E27FC236}">
-                <a16:creationId xmlns:a16="http://schemas.microsoft.com/office/drawing/2014/main" id="{6174EC70-1356-43A8-8395-4BF2CF98C92D}"/>
+                <a16:creationId xmlns:a16="http://schemas.microsoft.com/office/drawing/2014/main" id="{A3688D4A-CA7D-4DCB-AE33-40447324F61A}"/>
               </a:ext>
             </a:extLst>
           </p:cNvPr>
@@ -7246,7 +7246,7 @@
           <p:cNvPr id="3" name="">
             <a:extLst xmlns:a="http://schemas.openxmlformats.org/drawingml/2006/main">
               <a:ext uri="{FF2B5EF4-FFF2-40B4-BE49-F238E27FC236}">
-                <a16:creationId xmlns:a16="http://schemas.microsoft.com/office/drawing/2014/main" id="{D4437755-C28E-492E-983A-4D680E6EEDDD}"/>
+                <a16:creationId xmlns:a16="http://schemas.microsoft.com/office/drawing/2014/main" id="{504A1BD0-712C-4F06-A513-263D4ACE9F27}"/>
               </a:ext>
             </a:extLst>
           </p:cNvPr>
@@ -7304,7 +7304,7 @@
           <p:cNvPr id="4" name="">
             <a:extLst xmlns:a="http://schemas.openxmlformats.org/drawingml/2006/main">
               <a:ext uri="{FF2B5EF4-FFF2-40B4-BE49-F238E27FC236}">
-                <a16:creationId xmlns:a16="http://schemas.microsoft.com/office/drawing/2014/main" id="{B4E17BD3-EADC-42AB-8128-86736F2BAB1D}"/>
+                <a16:creationId xmlns:a16="http://schemas.microsoft.com/office/drawing/2014/main" id="{F82FCF62-6FF9-4C97-AEBD-38AAEC49155B}"/>
               </a:ext>
             </a:extLst>
           </p:cNvPr>
@@ -7362,7 +7362,7 @@
           <p:cNvPr id="5" name="">
             <a:extLst xmlns:a="http://schemas.openxmlformats.org/drawingml/2006/main">
               <a:ext uri="{FF2B5EF4-FFF2-40B4-BE49-F238E27FC236}">
-                <a16:creationId xmlns:a16="http://schemas.microsoft.com/office/drawing/2014/main" id="{DB857D1B-BCC7-41F1-82AB-5884D5BBB464}"/>
+                <a16:creationId xmlns:a16="http://schemas.microsoft.com/office/drawing/2014/main" id="{8ECDC92D-D0B4-4C60-8CF2-2D363829EE24}"/>
               </a:ext>
             </a:extLst>
           </p:cNvPr>
@@ -7393,7 +7393,7 @@
           <p:cNvPr id="6" name="">
             <a:extLst xmlns:a="http://schemas.openxmlformats.org/drawingml/2006/main">
               <a:ext uri="{FF2B5EF4-FFF2-40B4-BE49-F238E27FC236}">
-                <a16:creationId xmlns:a16="http://schemas.microsoft.com/office/drawing/2014/main" id="{73915516-827C-42A1-922D-8A745A0A35FA}"/>
+                <a16:creationId xmlns:a16="http://schemas.microsoft.com/office/drawing/2014/main" id="{F99045E0-9DDD-49E1-BBB7-DA22F5EF0007}"/>
               </a:ext>
             </a:extLst>
           </p:cNvPr>
@@ -7424,7 +7424,7 @@
           <p:cNvPr id="7" name="">
             <a:extLst xmlns:a="http://schemas.openxmlformats.org/drawingml/2006/main">
               <a:ext uri="{FF2B5EF4-FFF2-40B4-BE49-F238E27FC236}">
-                <a16:creationId xmlns:a16="http://schemas.microsoft.com/office/drawing/2014/main" id="{D8192526-01E4-4EC0-A7F6-922B0C97DCBF}"/>
+                <a16:creationId xmlns:a16="http://schemas.microsoft.com/office/drawing/2014/main" id="{9206C92F-9EC0-4ADB-85F9-3B244BE5F771}"/>
               </a:ext>
             </a:extLst>
           </p:cNvPr>
@@ -7489,7 +7489,7 @@
         </p:xfrm>
         <a:graphic xmlns:a="http://schemas.openxmlformats.org/drawingml/2006/main">
           <a:graphicData uri="http://schemas.openxmlformats.org/drawingml/2006/chart">
-            <c:chart xmlns:r="http://schemas.openxmlformats.org/officeDocument/2006/relationships" xmlns:c="http://schemas.openxmlformats.org/drawingml/2006/chart" r:id="R9e212f1ca535414b"/>
+            <c:chart xmlns:r="http://schemas.openxmlformats.org/officeDocument/2006/relationships" xmlns:c="http://schemas.openxmlformats.org/drawingml/2006/chart" r:id="Ra1ef5e475428458e"/>
           </a:graphicData>
         </a:graphic>
       </p:graphicFrame>
@@ -7951,7 +7951,7 @@
           <p:cNvPr id="10" name="">
             <a:extLst xmlns:a="http://schemas.openxmlformats.org/drawingml/2006/main">
               <a:ext uri="{FF2B5EF4-FFF2-40B4-BE49-F238E27FC236}">
-                <a16:creationId xmlns:a16="http://schemas.microsoft.com/office/drawing/2014/main" id="{DFC0FDBC-9D02-4091-BF63-82BABF8ABA90}"/>
+                <a16:creationId xmlns:a16="http://schemas.microsoft.com/office/drawing/2014/main" id="{4BF3E0CE-E455-42C9-B382-D26A57B7B32E}"/>
               </a:ext>
             </a:extLst>
           </p:cNvPr>
@@ -8007,7 +8007,7 @@
     </p:spTree>
     <p:extLst>
       <p:ext uri="{BB962C8B-B14F-4D97-AF65-F5344CB8AC3E}">
-        <p14:creationId xmlns:p14="http://schemas.microsoft.com/office/powerpoint/2010/main" val="276452079"/>
+        <p14:creationId xmlns:p14="http://schemas.microsoft.com/office/powerpoint/2010/main" val="703660515"/>
       </p:ext>
     </p:extLst>
   </p:cSld>
@@ -8038,7 +8038,7 @@
           <p:cNvPr id="9" name="">
             <a:extLst xmlns:a="http://schemas.openxmlformats.org/drawingml/2006/main">
               <a:ext uri="{FF2B5EF4-FFF2-40B4-BE49-F238E27FC236}">
-                <a16:creationId xmlns:a16="http://schemas.microsoft.com/office/drawing/2014/main" id="{C1191E56-36D9-4FBA-8658-CDCC42F6FBE1}"/>
+                <a16:creationId xmlns:a16="http://schemas.microsoft.com/office/drawing/2014/main" id="{EF8C87C2-75E6-44E0-9B96-2206FC71979F}"/>
               </a:ext>
             </a:extLst>
           </p:cNvPr>
@@ -8071,7 +8071,7 @@
           <p:cNvPr id="2" name="">
             <a:extLst xmlns:a="http://schemas.openxmlformats.org/drawingml/2006/main">
               <a:ext uri="{FF2B5EF4-FFF2-40B4-BE49-F238E27FC236}">
-                <a16:creationId xmlns:a16="http://schemas.microsoft.com/office/drawing/2014/main" id="{D280293D-30DF-4EBD-A1C8-E9FCA8234FB9}"/>
+                <a16:creationId xmlns:a16="http://schemas.microsoft.com/office/drawing/2014/main" id="{B5576396-AB08-4760-A704-4A645811D5E1}"/>
               </a:ext>
             </a:extLst>
           </p:cNvPr>
@@ -8129,7 +8129,7 @@
           <p:cNvPr id="3" name="">
             <a:extLst xmlns:a="http://schemas.openxmlformats.org/drawingml/2006/main">
               <a:ext uri="{FF2B5EF4-FFF2-40B4-BE49-F238E27FC236}">
-                <a16:creationId xmlns:a16="http://schemas.microsoft.com/office/drawing/2014/main" id="{0DF26374-C628-43C2-B291-CC61CDFF7033}"/>
+                <a16:creationId xmlns:a16="http://schemas.microsoft.com/office/drawing/2014/main" id="{193E03AD-8264-42B7-9598-E1194A894862}"/>
               </a:ext>
             </a:extLst>
           </p:cNvPr>
@@ -8187,7 +8187,7 @@
           <p:cNvPr id="4" name="">
             <a:extLst xmlns:a="http://schemas.openxmlformats.org/drawingml/2006/main">
               <a:ext uri="{FF2B5EF4-FFF2-40B4-BE49-F238E27FC236}">
-                <a16:creationId xmlns:a16="http://schemas.microsoft.com/office/drawing/2014/main" id="{5C19FBF9-BA4E-4FFB-BCED-2F55CC4C2FF2}"/>
+                <a16:creationId xmlns:a16="http://schemas.microsoft.com/office/drawing/2014/main" id="{6B6DC849-3B89-43EB-9A90-513F1469C51A}"/>
               </a:ext>
             </a:extLst>
           </p:cNvPr>
@@ -8245,7 +8245,7 @@
           <p:cNvPr id="5" name="">
             <a:extLst xmlns:a="http://schemas.openxmlformats.org/drawingml/2006/main">
               <a:ext uri="{FF2B5EF4-FFF2-40B4-BE49-F238E27FC236}">
-                <a16:creationId xmlns:a16="http://schemas.microsoft.com/office/drawing/2014/main" id="{A973FA37-B1AD-49A1-BACF-A86EC81B48FB}"/>
+                <a16:creationId xmlns:a16="http://schemas.microsoft.com/office/drawing/2014/main" id="{21F5E8D5-8F62-4AAE-AFD2-849FA76A9322}"/>
               </a:ext>
             </a:extLst>
           </p:cNvPr>
@@ -8276,7 +8276,7 @@
           <p:cNvPr id="6" name="">
             <a:extLst xmlns:a="http://schemas.openxmlformats.org/drawingml/2006/main">
               <a:ext uri="{FF2B5EF4-FFF2-40B4-BE49-F238E27FC236}">
-                <a16:creationId xmlns:a16="http://schemas.microsoft.com/office/drawing/2014/main" id="{2485874D-2EB7-4AA2-891C-D70CD8E6CE0F}"/>
+                <a16:creationId xmlns:a16="http://schemas.microsoft.com/office/drawing/2014/main" id="{F3BB6525-CFE6-44E8-A339-CFC9C2AF54D8}"/>
               </a:ext>
             </a:extLst>
           </p:cNvPr>
@@ -8307,7 +8307,7 @@
           <p:cNvPr id="7" name="">
             <a:extLst xmlns:a="http://schemas.openxmlformats.org/drawingml/2006/main">
               <a:ext uri="{FF2B5EF4-FFF2-40B4-BE49-F238E27FC236}">
-                <a16:creationId xmlns:a16="http://schemas.microsoft.com/office/drawing/2014/main" id="{DF10FB19-F28D-4756-ADA9-38776A1C1FD4}"/>
+                <a16:creationId xmlns:a16="http://schemas.microsoft.com/office/drawing/2014/main" id="{49A0D1F2-2D6B-455D-A6C9-35670CB73449}"/>
               </a:ext>
             </a:extLst>
           </p:cNvPr>
@@ -8894,7 +8894,7 @@
     </p:spTree>
     <p:extLst>
       <p:ext uri="{BB962C8B-B14F-4D97-AF65-F5344CB8AC3E}">
-        <p14:creationId xmlns:p14="http://schemas.microsoft.com/office/powerpoint/2010/main" val="1649408079"/>
+        <p14:creationId xmlns:p14="http://schemas.microsoft.com/office/powerpoint/2010/main" val="1473638739"/>
       </p:ext>
     </p:extLst>
   </p:cSld>
@@ -8925,7 +8925,7 @@
           <p:cNvPr id="15" name="">
             <a:extLst xmlns:a="http://schemas.openxmlformats.org/drawingml/2006/main">
               <a:ext uri="{FF2B5EF4-FFF2-40B4-BE49-F238E27FC236}">
-                <a16:creationId xmlns:a16="http://schemas.microsoft.com/office/drawing/2014/main" id="{BBB22CC9-775E-4E61-9D3B-E885B0C6CC83}"/>
+                <a16:creationId xmlns:a16="http://schemas.microsoft.com/office/drawing/2014/main" id="{763EE97D-7ABA-4E5A-9FFD-D2E524AA09A9}"/>
               </a:ext>
             </a:extLst>
           </p:cNvPr>
@@ -8958,7 +8958,7 @@
           <p:cNvPr id="2" name="">
             <a:extLst xmlns:a="http://schemas.openxmlformats.org/drawingml/2006/main">
               <a:ext uri="{FF2B5EF4-FFF2-40B4-BE49-F238E27FC236}">
-                <a16:creationId xmlns:a16="http://schemas.microsoft.com/office/drawing/2014/main" id="{F7A6A00E-53A1-4AC0-98A4-2678D070D1C1}"/>
+                <a16:creationId xmlns:a16="http://schemas.microsoft.com/office/drawing/2014/main" id="{4341200B-B214-4E53-9643-1658486BD38F}"/>
               </a:ext>
             </a:extLst>
           </p:cNvPr>
@@ -9016,7 +9016,7 @@
           <p:cNvPr id="3" name="">
             <a:extLst xmlns:a="http://schemas.openxmlformats.org/drawingml/2006/main">
               <a:ext uri="{FF2B5EF4-FFF2-40B4-BE49-F238E27FC236}">
-                <a16:creationId xmlns:a16="http://schemas.microsoft.com/office/drawing/2014/main" id="{83D6FED3-F2F6-4DCF-B47B-602C103EF408}"/>
+                <a16:creationId xmlns:a16="http://schemas.microsoft.com/office/drawing/2014/main" id="{EF90C26A-A4C8-4A9F-9519-C28E1EAAE920}"/>
               </a:ext>
             </a:extLst>
           </p:cNvPr>
@@ -9074,7 +9074,7 @@
           <p:cNvPr id="4" name="">
             <a:extLst xmlns:a="http://schemas.openxmlformats.org/drawingml/2006/main">
               <a:ext uri="{FF2B5EF4-FFF2-40B4-BE49-F238E27FC236}">
-                <a16:creationId xmlns:a16="http://schemas.microsoft.com/office/drawing/2014/main" id="{6E58B553-F252-4AB4-AD90-360E17DCA31A}"/>
+                <a16:creationId xmlns:a16="http://schemas.microsoft.com/office/drawing/2014/main" id="{545E2D77-B51A-4FDD-9FF6-9A4FBC38A12B}"/>
               </a:ext>
             </a:extLst>
           </p:cNvPr>
@@ -9132,7 +9132,7 @@
           <p:cNvPr id="5" name="">
             <a:extLst xmlns:a="http://schemas.openxmlformats.org/drawingml/2006/main">
               <a:ext uri="{FF2B5EF4-FFF2-40B4-BE49-F238E27FC236}">
-                <a16:creationId xmlns:a16="http://schemas.microsoft.com/office/drawing/2014/main" id="{AA75CB6D-A69B-4353-A7FE-5317E07A8B0C}"/>
+                <a16:creationId xmlns:a16="http://schemas.microsoft.com/office/drawing/2014/main" id="{2D7846AA-66E4-4E92-B378-C02A93870967}"/>
               </a:ext>
             </a:extLst>
           </p:cNvPr>
@@ -9163,7 +9163,7 @@
           <p:cNvPr id="6" name="">
             <a:extLst xmlns:a="http://schemas.openxmlformats.org/drawingml/2006/main">
               <a:ext uri="{FF2B5EF4-FFF2-40B4-BE49-F238E27FC236}">
-                <a16:creationId xmlns:a16="http://schemas.microsoft.com/office/drawing/2014/main" id="{D5345EE8-AD29-4D10-B3F8-0C9A70033DAD}"/>
+                <a16:creationId xmlns:a16="http://schemas.microsoft.com/office/drawing/2014/main" id="{D8FF1495-E2CF-479E-876C-C35FB4C06A1F}"/>
               </a:ext>
             </a:extLst>
           </p:cNvPr>
@@ -9194,7 +9194,7 @@
           <p:cNvPr id="7" name="">
             <a:extLst xmlns:a="http://schemas.openxmlformats.org/drawingml/2006/main">
               <a:ext uri="{FF2B5EF4-FFF2-40B4-BE49-F238E27FC236}">
-                <a16:creationId xmlns:a16="http://schemas.microsoft.com/office/drawing/2014/main" id="{196781C1-DFC0-468A-BB4B-95DE18DE37C0}"/>
+                <a16:creationId xmlns:a16="http://schemas.microsoft.com/office/drawing/2014/main" id="{96B53F55-4D6F-4F3D-8809-5002D783675B}"/>
               </a:ext>
             </a:extLst>
           </p:cNvPr>
@@ -9866,7 +9866,7 @@
           <p:cNvPr id="9" name="">
             <a:extLst xmlns:a="http://schemas.openxmlformats.org/drawingml/2006/main">
               <a:ext uri="{FF2B5EF4-FFF2-40B4-BE49-F238E27FC236}">
-                <a16:creationId xmlns:a16="http://schemas.microsoft.com/office/drawing/2014/main" id="{8D08D740-5D49-4345-969E-24BA8B3965CE}"/>
+                <a16:creationId xmlns:a16="http://schemas.microsoft.com/office/drawing/2014/main" id="{25E0537E-5EFC-46C7-9013-B5877F298AFD}"/>
               </a:ext>
             </a:extLst>
           </p:cNvPr>
@@ -9924,7 +9924,7 @@
           <p:cNvPr id="10" name="">
             <a:extLst xmlns:a="http://schemas.openxmlformats.org/drawingml/2006/main">
               <a:ext uri="{FF2B5EF4-FFF2-40B4-BE49-F238E27FC236}">
-                <a16:creationId xmlns:a16="http://schemas.microsoft.com/office/drawing/2014/main" id="{BFFB9C50-2E4D-40B0-B720-98287A1CB8CC}"/>
+                <a16:creationId xmlns:a16="http://schemas.microsoft.com/office/drawing/2014/main" id="{ED0DDA90-A0A9-4572-A972-81F42BD07399}"/>
               </a:ext>
             </a:extLst>
           </p:cNvPr>
@@ -9982,7 +9982,7 @@
           <p:cNvPr id="11" name="">
             <a:extLst xmlns:a="http://schemas.openxmlformats.org/drawingml/2006/main">
               <a:ext uri="{FF2B5EF4-FFF2-40B4-BE49-F238E27FC236}">
-                <a16:creationId xmlns:a16="http://schemas.microsoft.com/office/drawing/2014/main" id="{E597FA47-D6FC-42D7-8F7A-A6DEB1EC9539}"/>
+                <a16:creationId xmlns:a16="http://schemas.microsoft.com/office/drawing/2014/main" id="{628EEB44-E82B-4C6B-B1A7-42B50750DC81}"/>
               </a:ext>
             </a:extLst>
           </p:cNvPr>
@@ -10040,7 +10040,7 @@
           <p:cNvPr id="12" name="">
             <a:extLst xmlns:a="http://schemas.openxmlformats.org/drawingml/2006/main">
               <a:ext uri="{FF2B5EF4-FFF2-40B4-BE49-F238E27FC236}">
-                <a16:creationId xmlns:a16="http://schemas.microsoft.com/office/drawing/2014/main" id="{75431BDB-F89F-4D9C-A531-76DCA38D771F}"/>
+                <a16:creationId xmlns:a16="http://schemas.microsoft.com/office/drawing/2014/main" id="{2DD0DB62-65A2-46C4-8B66-C1B21A219788}"/>
               </a:ext>
             </a:extLst>
           </p:cNvPr>
@@ -10098,7 +10098,7 @@
           <p:cNvPr id="13" name="">
             <a:extLst xmlns:a="http://schemas.openxmlformats.org/drawingml/2006/main">
               <a:ext uri="{FF2B5EF4-FFF2-40B4-BE49-F238E27FC236}">
-                <a16:creationId xmlns:a16="http://schemas.microsoft.com/office/drawing/2014/main" id="{D33DC517-3E5B-4A43-9115-5840558CD899}"/>
+                <a16:creationId xmlns:a16="http://schemas.microsoft.com/office/drawing/2014/main" id="{120D5FAC-EE7C-41B1-8A79-01D921A05D24}"/>
               </a:ext>
             </a:extLst>
           </p:cNvPr>
@@ -10156,7 +10156,7 @@
           <p:cNvPr id="14" name="">
             <a:extLst xmlns:a="http://schemas.openxmlformats.org/drawingml/2006/main">
               <a:ext uri="{FF2B5EF4-FFF2-40B4-BE49-F238E27FC236}">
-                <a16:creationId xmlns:a16="http://schemas.microsoft.com/office/drawing/2014/main" id="{248A276A-3413-4B06-A455-1395DEC04264}"/>
+                <a16:creationId xmlns:a16="http://schemas.microsoft.com/office/drawing/2014/main" id="{2131ACC7-89F9-48AC-B3B2-AD86AB6B03CF}"/>
               </a:ext>
             </a:extLst>
           </p:cNvPr>
@@ -10212,7 +10212,7 @@
     </p:spTree>
     <p:extLst>
       <p:ext uri="{BB962C8B-B14F-4D97-AF65-F5344CB8AC3E}">
-        <p14:creationId xmlns:p14="http://schemas.microsoft.com/office/powerpoint/2010/main" val="1043434135"/>
+        <p14:creationId xmlns:p14="http://schemas.microsoft.com/office/powerpoint/2010/main" val="710527400"/>
       </p:ext>
     </p:extLst>
   </p:cSld>
@@ -10240,10 +10240,10 @@
       </p:grpSpPr>
       <p:sp>
         <p:nvSpPr>
-          <p:cNvPr id="18" name="">
-            <a:extLst xmlns:a="http://schemas.openxmlformats.org/drawingml/2006/main">
-              <a:ext uri="{FF2B5EF4-FFF2-40B4-BE49-F238E27FC236}">
-                <a16:creationId xmlns:a16="http://schemas.microsoft.com/office/drawing/2014/main" id="{668575E5-D0E2-4DFA-93EF-4B024A0F7B7B}"/>
+          <p:cNvPr id="20" name="">
+            <a:extLst xmlns:a="http://schemas.openxmlformats.org/drawingml/2006/main">
+              <a:ext uri="{FF2B5EF4-FFF2-40B4-BE49-F238E27FC236}">
+                <a16:creationId xmlns:a16="http://schemas.microsoft.com/office/drawing/2014/main" id="{647010C8-495A-458C-8ED3-C9F7AC6B609D}"/>
               </a:ext>
             </a:extLst>
           </p:cNvPr>
@@ -10276,7 +10276,7 @@
           <p:cNvPr id="2" name="">
             <a:extLst xmlns:a="http://schemas.openxmlformats.org/drawingml/2006/main">
               <a:ext uri="{FF2B5EF4-FFF2-40B4-BE49-F238E27FC236}">
-                <a16:creationId xmlns:a16="http://schemas.microsoft.com/office/drawing/2014/main" id="{793DA75A-5A47-455C-9808-48E3765043A3}"/>
+                <a16:creationId xmlns:a16="http://schemas.microsoft.com/office/drawing/2014/main" id="{488A34C1-DF2D-418B-8E19-FE24F515D4D7}"/>
               </a:ext>
             </a:extLst>
           </p:cNvPr>
@@ -10334,7 +10334,7 @@
           <p:cNvPr id="3" name="">
             <a:extLst xmlns:a="http://schemas.openxmlformats.org/drawingml/2006/main">
               <a:ext uri="{FF2B5EF4-FFF2-40B4-BE49-F238E27FC236}">
-                <a16:creationId xmlns:a16="http://schemas.microsoft.com/office/drawing/2014/main" id="{043D5F78-E733-4D83-837C-76FEAA1AF5E5}"/>
+                <a16:creationId xmlns:a16="http://schemas.microsoft.com/office/drawing/2014/main" id="{9D233319-8CA4-43A2-8C06-C6B2E05EB8F5}"/>
               </a:ext>
             </a:extLst>
           </p:cNvPr>
@@ -10392,7 +10392,7 @@
           <p:cNvPr id="4" name="">
             <a:extLst xmlns:a="http://schemas.openxmlformats.org/drawingml/2006/main">
               <a:ext uri="{FF2B5EF4-FFF2-40B4-BE49-F238E27FC236}">
-                <a16:creationId xmlns:a16="http://schemas.microsoft.com/office/drawing/2014/main" id="{59EC1582-222B-4637-98F1-FE56545A8762}"/>
+                <a16:creationId xmlns:a16="http://schemas.microsoft.com/office/drawing/2014/main" id="{FDAE26A6-68C6-4D61-864F-9C756D37A5A1}"/>
               </a:ext>
             </a:extLst>
           </p:cNvPr>
@@ -10450,7 +10450,7 @@
           <p:cNvPr id="5" name="">
             <a:extLst xmlns:a="http://schemas.openxmlformats.org/drawingml/2006/main">
               <a:ext uri="{FF2B5EF4-FFF2-40B4-BE49-F238E27FC236}">
-                <a16:creationId xmlns:a16="http://schemas.microsoft.com/office/drawing/2014/main" id="{48393B7B-7A46-4BF8-B4B2-9BE54C1C4FEE}"/>
+                <a16:creationId xmlns:a16="http://schemas.microsoft.com/office/drawing/2014/main" id="{D68E23C8-BCE4-4F82-9860-3BF2C195E4E6}"/>
               </a:ext>
             </a:extLst>
           </p:cNvPr>
@@ -10481,7 +10481,7 @@
           <p:cNvPr id="6" name="">
             <a:extLst xmlns:a="http://schemas.openxmlformats.org/drawingml/2006/main">
               <a:ext uri="{FF2B5EF4-FFF2-40B4-BE49-F238E27FC236}">
-                <a16:creationId xmlns:a16="http://schemas.microsoft.com/office/drawing/2014/main" id="{CD6B2FB2-33B0-4C85-9EE2-40A5BE9D8A54}"/>
+                <a16:creationId xmlns:a16="http://schemas.microsoft.com/office/drawing/2014/main" id="{E8F9A4D5-16CC-4A36-AD6C-35D9CE72F731}"/>
               </a:ext>
             </a:extLst>
           </p:cNvPr>
@@ -10512,7 +10512,7 @@
           <p:cNvPr id="7" name="">
             <a:extLst xmlns:a="http://schemas.openxmlformats.org/drawingml/2006/main">
               <a:ext uri="{FF2B5EF4-FFF2-40B4-BE49-F238E27FC236}">
-                <a16:creationId xmlns:a16="http://schemas.microsoft.com/office/drawing/2014/main" id="{2E8BF13E-726A-4419-A9C5-0D2C7F551DFF}"/>
+                <a16:creationId xmlns:a16="http://schemas.microsoft.com/office/drawing/2014/main" id="{510A94D6-191D-4EB0-A647-13132F77FF76}"/>
               </a:ext>
             </a:extLst>
           </p:cNvPr>
@@ -10570,18 +10570,18 @@
           <p:cNvPr id="8" name="">
             <a:extLst xmlns:a="http://schemas.openxmlformats.org/drawingml/2006/main">
               <a:ext uri="{FF2B5EF4-FFF2-40B4-BE49-F238E27FC236}">
-                <a16:creationId xmlns:a16="http://schemas.microsoft.com/office/drawing/2014/main" id="{1DBE27CF-5B59-4B87-931F-4F3E7E80673B}"/>
-              </a:ext>
-            </a:extLst>
-          </p:cNvPr>
-          <p:cNvSpPr>
-            <a:spLocks xmlns:a="http://schemas.openxmlformats.org/drawingml/2006/main" noGrp="1"/>
-          </p:cNvSpPr>
-          <p:nvPr/>
-        </p:nvSpPr>
-        <p:spPr>
-          <a:xfrm xmlns:a="http://schemas.openxmlformats.org/drawingml/2006/main">
-            <a:off x="1104900" y="1724025"/>
+                <a16:creationId xmlns:a16="http://schemas.microsoft.com/office/drawing/2014/main" id="{AEE3BB0D-EA73-427C-A73F-1AC0EB7E180F}"/>
+              </a:ext>
+            </a:extLst>
+          </p:cNvPr>
+          <p:cNvSpPr>
+            <a:spLocks xmlns:a="http://schemas.openxmlformats.org/drawingml/2006/main" noGrp="1"/>
+          </p:cNvSpPr>
+          <p:nvPr/>
+        </p:nvSpPr>
+        <p:spPr>
+          <a:xfrm xmlns:a="http://schemas.openxmlformats.org/drawingml/2006/main">
+            <a:off x="1104900" y="1647825"/>
             <a:ext cx="228600" cy="266700"/>
           </a:xfrm>
           <a:prstGeom xmlns:a="http://schemas.openxmlformats.org/drawingml/2006/main" prst="rect">
@@ -10628,18 +10628,18 @@
           <p:cNvPr id="9" name="">
             <a:extLst xmlns:a="http://schemas.openxmlformats.org/drawingml/2006/main">
               <a:ext uri="{FF2B5EF4-FFF2-40B4-BE49-F238E27FC236}">
-                <a16:creationId xmlns:a16="http://schemas.microsoft.com/office/drawing/2014/main" id="{72A17AD4-EC98-4659-A047-E860477E3275}"/>
-              </a:ext>
-            </a:extLst>
-          </p:cNvPr>
-          <p:cNvSpPr>
-            <a:spLocks xmlns:a="http://schemas.openxmlformats.org/drawingml/2006/main" noGrp="1"/>
-          </p:cNvSpPr>
-          <p:nvPr/>
-        </p:nvSpPr>
-        <p:spPr>
-          <a:xfrm xmlns:a="http://schemas.openxmlformats.org/drawingml/2006/main">
-            <a:off x="1371600" y="1733550"/>
+                <a16:creationId xmlns:a16="http://schemas.microsoft.com/office/drawing/2014/main" id="{78042922-E4C4-4892-8E03-F8EB25D7658B}"/>
+              </a:ext>
+            </a:extLst>
+          </p:cNvPr>
+          <p:cNvSpPr>
+            <a:spLocks xmlns:a="http://schemas.openxmlformats.org/drawingml/2006/main" noGrp="1"/>
+          </p:cNvSpPr>
+          <p:nvPr/>
+        </p:nvSpPr>
+        <p:spPr>
+          <a:xfrm xmlns:a="http://schemas.openxmlformats.org/drawingml/2006/main">
+            <a:off x="1371600" y="1657350"/>
             <a:ext cx="8572500" cy="400050"/>
           </a:xfrm>
           <a:prstGeom xmlns:a="http://schemas.openxmlformats.org/drawingml/2006/main" prst="rect">
@@ -10653,12 +10653,12 @@
         </p:spPr>
         <p:txBody>
           <a:bodyPr xmlns:a="http://schemas.openxmlformats.org/drawingml/2006/main">
-            <a:normAutofit fontScale="100000"/>
+            <a:normAutofit fontScale="86720"/>
           </a:bodyPr>
           <a:lstStyle xmlns:a="http://schemas.openxmlformats.org/drawingml/2006/main"/>
           <a:p xmlns:a="http://schemas.openxmlformats.org/drawingml/2006/main">
             <a:pPr algn="l">
-              <a:defRPr sz="1800" b="0">
+              <a:defRPr sz="1650" b="0">
                 <a:solidFill>
                   <a:srgbClr val="0B2A33"/>
                 </a:solidFill>
@@ -10668,7 +10668,7 @@
               </a:defRPr>
             </a:pPr>
             <a:r>
-              <a:rPr sz="1800" b="0">
+              <a:rPr sz="1650" b="0">
                 <a:solidFill>
                   <a:srgbClr val="0B2A33"/>
                 </a:solidFill>
@@ -10676,7 +10676,7 @@
                 <a:ea typeface="Helvetica Neue"/>
                 <a:cs typeface="Helvetica Neue"/>
               </a:rPr>
-              <a:t>Approve a pilot for pre-discharge readmission risk scoring.</a:t>
+              <a:t>Approve a broad high-risk readmission reduction pilot covering deciles 8-10 and clinical-rule segments.</a:t>
             </a:r>
           </a:p>
         </p:txBody>
@@ -10686,18 +10686,18 @@
           <p:cNvPr id="10" name="">
             <a:extLst xmlns:a="http://schemas.openxmlformats.org/drawingml/2006/main">
               <a:ext uri="{FF2B5EF4-FFF2-40B4-BE49-F238E27FC236}">
-                <a16:creationId xmlns:a16="http://schemas.microsoft.com/office/drawing/2014/main" id="{0E681293-E634-4857-A786-207B1F06FA15}"/>
-              </a:ext>
-            </a:extLst>
-          </p:cNvPr>
-          <p:cNvSpPr>
-            <a:spLocks xmlns:a="http://schemas.openxmlformats.org/drawingml/2006/main" noGrp="1"/>
-          </p:cNvSpPr>
-          <p:nvPr/>
-        </p:nvSpPr>
-        <p:spPr>
-          <a:xfrm xmlns:a="http://schemas.openxmlformats.org/drawingml/2006/main">
-            <a:off x="1104900" y="2562225"/>
+                <a16:creationId xmlns:a16="http://schemas.microsoft.com/office/drawing/2014/main" id="{8335782D-0C28-42BA-8110-1A07E23D324A}"/>
+              </a:ext>
+            </a:extLst>
+          </p:cNvPr>
+          <p:cNvSpPr>
+            <a:spLocks xmlns:a="http://schemas.openxmlformats.org/drawingml/2006/main" noGrp="1"/>
+          </p:cNvSpPr>
+          <p:nvPr/>
+        </p:nvSpPr>
+        <p:spPr>
+          <a:xfrm xmlns:a="http://schemas.openxmlformats.org/drawingml/2006/main">
+            <a:off x="1104900" y="2314575"/>
             <a:ext cx="228600" cy="266700"/>
           </a:xfrm>
           <a:prstGeom xmlns:a="http://schemas.openxmlformats.org/drawingml/2006/main" prst="rect">
@@ -10744,18 +10744,18 @@
           <p:cNvPr id="11" name="">
             <a:extLst xmlns:a="http://schemas.openxmlformats.org/drawingml/2006/main">
               <a:ext uri="{FF2B5EF4-FFF2-40B4-BE49-F238E27FC236}">
-                <a16:creationId xmlns:a16="http://schemas.microsoft.com/office/drawing/2014/main" id="{A1C79291-C76F-4984-9EA9-F1A246843523}"/>
-              </a:ext>
-            </a:extLst>
-          </p:cNvPr>
-          <p:cNvSpPr>
-            <a:spLocks xmlns:a="http://schemas.openxmlformats.org/drawingml/2006/main" noGrp="1"/>
-          </p:cNvSpPr>
-          <p:nvPr/>
-        </p:nvSpPr>
-        <p:spPr>
-          <a:xfrm xmlns:a="http://schemas.openxmlformats.org/drawingml/2006/main">
-            <a:off x="1371600" y="2571750"/>
+                <a16:creationId xmlns:a16="http://schemas.microsoft.com/office/drawing/2014/main" id="{1B67B7F7-912E-405A-9CD1-F3072206B040}"/>
+              </a:ext>
+            </a:extLst>
+          </p:cNvPr>
+          <p:cNvSpPr>
+            <a:spLocks xmlns:a="http://schemas.openxmlformats.org/drawingml/2006/main" noGrp="1"/>
+          </p:cNvSpPr>
+          <p:nvPr/>
+        </p:nvSpPr>
+        <p:spPr>
+          <a:xfrm xmlns:a="http://schemas.openxmlformats.org/drawingml/2006/main">
+            <a:off x="1371600" y="2324100"/>
             <a:ext cx="8572500" cy="400050"/>
           </a:xfrm>
           <a:prstGeom xmlns:a="http://schemas.openxmlformats.org/drawingml/2006/main" prst="rect">
@@ -10769,12 +10769,12 @@
         </p:spPr>
         <p:txBody>
           <a:bodyPr xmlns:a="http://schemas.openxmlformats.org/drawingml/2006/main">
-            <a:normAutofit fontScale="100000"/>
+            <a:normAutofit fontScale="95184"/>
           </a:bodyPr>
           <a:lstStyle xmlns:a="http://schemas.openxmlformats.org/drawingml/2006/main"/>
           <a:p xmlns:a="http://schemas.openxmlformats.org/drawingml/2006/main">
             <a:pPr algn="l">
-              <a:defRPr sz="1800" b="0">
+              <a:defRPr sz="1650" b="0">
                 <a:solidFill>
                   <a:srgbClr val="0B2A33"/>
                 </a:solidFill>
@@ -10784,7 +10784,7 @@
               </a:defRPr>
             </a:pPr>
             <a:r>
-              <a:rPr sz="1800" b="0">
+              <a:rPr sz="1650" b="0">
                 <a:solidFill>
                   <a:srgbClr val="0B2A33"/>
                 </a:solidFill>
@@ -10792,7 +10792,7 @@
                 <a:ea typeface="Helvetica Neue"/>
                 <a:cs typeface="Helvetica Neue"/>
               </a:rPr>
-              <a:t>Approve dashboard development in Tableau or Power BI.</a:t>
+              <a:t>Approve staged model governance so no single model carries the full healthcare decision risk.</a:t>
             </a:r>
           </a:p>
         </p:txBody>
@@ -10802,18 +10802,18 @@
           <p:cNvPr id="12" name="">
             <a:extLst xmlns:a="http://schemas.openxmlformats.org/drawingml/2006/main">
               <a:ext uri="{FF2B5EF4-FFF2-40B4-BE49-F238E27FC236}">
-                <a16:creationId xmlns:a16="http://schemas.microsoft.com/office/drawing/2014/main" id="{2571FC08-3DF3-4BFE-87EF-EC9FDF42DF4F}"/>
-              </a:ext>
-            </a:extLst>
-          </p:cNvPr>
-          <p:cNvSpPr>
-            <a:spLocks xmlns:a="http://schemas.openxmlformats.org/drawingml/2006/main" noGrp="1"/>
-          </p:cNvSpPr>
-          <p:nvPr/>
-        </p:nvSpPr>
-        <p:spPr>
-          <a:xfrm xmlns:a="http://schemas.openxmlformats.org/drawingml/2006/main">
-            <a:off x="1104900" y="3400425"/>
+                <a16:creationId xmlns:a16="http://schemas.microsoft.com/office/drawing/2014/main" id="{049EF215-DB35-4D03-A845-9AB5E6805C6F}"/>
+              </a:ext>
+            </a:extLst>
+          </p:cNvPr>
+          <p:cNvSpPr>
+            <a:spLocks xmlns:a="http://schemas.openxmlformats.org/drawingml/2006/main" noGrp="1"/>
+          </p:cNvSpPr>
+          <p:nvPr/>
+        </p:nvSpPr>
+        <p:spPr>
+          <a:xfrm xmlns:a="http://schemas.openxmlformats.org/drawingml/2006/main">
+            <a:off x="1104900" y="2981325"/>
             <a:ext cx="228600" cy="266700"/>
           </a:xfrm>
           <a:prstGeom xmlns:a="http://schemas.openxmlformats.org/drawingml/2006/main" prst="rect">
@@ -10860,18 +10860,18 @@
           <p:cNvPr id="13" name="">
             <a:extLst xmlns:a="http://schemas.openxmlformats.org/drawingml/2006/main">
               <a:ext uri="{FF2B5EF4-FFF2-40B4-BE49-F238E27FC236}">
-                <a16:creationId xmlns:a16="http://schemas.microsoft.com/office/drawing/2014/main" id="{FE40699B-E916-4680-A6C8-96831769D69C}"/>
-              </a:ext>
-            </a:extLst>
-          </p:cNvPr>
-          <p:cNvSpPr>
-            <a:spLocks xmlns:a="http://schemas.openxmlformats.org/drawingml/2006/main" noGrp="1"/>
-          </p:cNvSpPr>
-          <p:nvPr/>
-        </p:nvSpPr>
-        <p:spPr>
-          <a:xfrm xmlns:a="http://schemas.openxmlformats.org/drawingml/2006/main">
-            <a:off x="1371600" y="3409950"/>
+                <a16:creationId xmlns:a16="http://schemas.microsoft.com/office/drawing/2014/main" id="{8CE2CAAB-9CE9-4A3A-B558-4C5DFB6E3C83}"/>
+              </a:ext>
+            </a:extLst>
+          </p:cNvPr>
+          <p:cNvSpPr>
+            <a:spLocks xmlns:a="http://schemas.openxmlformats.org/drawingml/2006/main" noGrp="1"/>
+          </p:cNvSpPr>
+          <p:nvPr/>
+        </p:nvSpPr>
+        <p:spPr>
+          <a:xfrm xmlns:a="http://schemas.openxmlformats.org/drawingml/2006/main">
+            <a:off x="1371600" y="2990850"/>
             <a:ext cx="8572500" cy="400050"/>
           </a:xfrm>
           <a:prstGeom xmlns:a="http://schemas.openxmlformats.org/drawingml/2006/main" prst="rect">
@@ -10890,7 +10890,7 @@
           <a:lstStyle xmlns:a="http://schemas.openxmlformats.org/drawingml/2006/main"/>
           <a:p xmlns:a="http://schemas.openxmlformats.org/drawingml/2006/main">
             <a:pPr algn="l">
-              <a:defRPr sz="1800" b="0">
+              <a:defRPr sz="1650" b="0">
                 <a:solidFill>
                   <a:srgbClr val="0B2A33"/>
                 </a:solidFill>
@@ -10900,7 +10900,123 @@
               </a:defRPr>
             </a:pPr>
             <a:r>
-              <a:rPr sz="1800" b="0">
+              <a:rPr sz="1650" b="0">
+                <a:solidFill>
+                  <a:srgbClr val="0B2A33"/>
+                </a:solidFill>
+                <a:latin typeface="Helvetica Neue"/>
+                <a:ea typeface="Helvetica Neue"/>
+                <a:cs typeface="Helvetica Neue"/>
+              </a:rPr>
+              <a:t>Approve Tableau dashboard development for presentation and executive review.</a:t>
+            </a:r>
+          </a:p>
+        </p:txBody>
+      </p:sp>
+      <p:sp>
+        <p:nvSpPr>
+          <p:cNvPr id="14" name="">
+            <a:extLst xmlns:a="http://schemas.openxmlformats.org/drawingml/2006/main">
+              <a:ext uri="{FF2B5EF4-FFF2-40B4-BE49-F238E27FC236}">
+                <a16:creationId xmlns:a16="http://schemas.microsoft.com/office/drawing/2014/main" id="{A9FF9E6E-3D49-4E0F-847D-F4DC6C58E140}"/>
+              </a:ext>
+            </a:extLst>
+          </p:cNvPr>
+          <p:cNvSpPr>
+            <a:spLocks xmlns:a="http://schemas.openxmlformats.org/drawingml/2006/main" noGrp="1"/>
+          </p:cNvSpPr>
+          <p:nvPr/>
+        </p:nvSpPr>
+        <p:spPr>
+          <a:xfrm xmlns:a="http://schemas.openxmlformats.org/drawingml/2006/main">
+            <a:off x="1104900" y="3648075"/>
+            <a:ext cx="228600" cy="266700"/>
+          </a:xfrm>
+          <a:prstGeom xmlns:a="http://schemas.openxmlformats.org/drawingml/2006/main" prst="rect">
+            <a:avLst/>
+          </a:prstGeom>
+          <a:noFill xmlns:a="http://schemas.openxmlformats.org/drawingml/2006/main"/>
+          <a:ln xmlns:a="http://schemas.openxmlformats.org/drawingml/2006/main" w="0">
+            <a:noFill/>
+            <a:prstDash val="solid"/>
+          </a:ln>
+        </p:spPr>
+        <p:txBody>
+          <a:bodyPr xmlns:a="http://schemas.openxmlformats.org/drawingml/2006/main">
+            <a:normAutofit fontScale="58946"/>
+          </a:bodyPr>
+          <a:lstStyle xmlns:a="http://schemas.openxmlformats.org/drawingml/2006/main"/>
+          <a:p xmlns:a="http://schemas.openxmlformats.org/drawingml/2006/main">
+            <a:pPr algn="l">
+              <a:defRPr sz="1725" b="1">
+                <a:solidFill>
+                  <a:srgbClr val="16A34A"/>
+                </a:solidFill>
+                <a:latin typeface="Helvetica Neue"/>
+                <a:ea typeface="Helvetica Neue"/>
+                <a:cs typeface="Helvetica Neue"/>
+              </a:defRPr>
+            </a:pPr>
+            <a:r>
+              <a:rPr sz="1725" b="1">
+                <a:solidFill>
+                  <a:srgbClr val="16A34A"/>
+                </a:solidFill>
+                <a:latin typeface="Helvetica Neue"/>
+                <a:ea typeface="Helvetica Neue"/>
+                <a:cs typeface="Helvetica Neue"/>
+              </a:rPr>
+              <a:t>•</a:t>
+            </a:r>
+          </a:p>
+        </p:txBody>
+      </p:sp>
+      <p:sp>
+        <p:nvSpPr>
+          <p:cNvPr id="15" name="">
+            <a:extLst xmlns:a="http://schemas.openxmlformats.org/drawingml/2006/main">
+              <a:ext uri="{FF2B5EF4-FFF2-40B4-BE49-F238E27FC236}">
+                <a16:creationId xmlns:a16="http://schemas.microsoft.com/office/drawing/2014/main" id="{FB498C5F-E4F7-4EDC-AB7D-9EAB1D04C495}"/>
+              </a:ext>
+            </a:extLst>
+          </p:cNvPr>
+          <p:cNvSpPr>
+            <a:spLocks xmlns:a="http://schemas.openxmlformats.org/drawingml/2006/main" noGrp="1"/>
+          </p:cNvSpPr>
+          <p:nvPr/>
+        </p:nvSpPr>
+        <p:spPr>
+          <a:xfrm xmlns:a="http://schemas.openxmlformats.org/drawingml/2006/main">
+            <a:off x="1371600" y="3657600"/>
+            <a:ext cx="8572500" cy="400050"/>
+          </a:xfrm>
+          <a:prstGeom xmlns:a="http://schemas.openxmlformats.org/drawingml/2006/main" prst="rect">
+            <a:avLst/>
+          </a:prstGeom>
+          <a:noFill xmlns:a="http://schemas.openxmlformats.org/drawingml/2006/main"/>
+          <a:ln xmlns:a="http://schemas.openxmlformats.org/drawingml/2006/main" w="0">
+            <a:noFill/>
+            <a:prstDash val="solid"/>
+          </a:ln>
+        </p:spPr>
+        <p:txBody>
+          <a:bodyPr xmlns:a="http://schemas.openxmlformats.org/drawingml/2006/main">
+            <a:normAutofit fontScale="100000"/>
+          </a:bodyPr>
+          <a:lstStyle xmlns:a="http://schemas.openxmlformats.org/drawingml/2006/main"/>
+          <a:p xmlns:a="http://schemas.openxmlformats.org/drawingml/2006/main">
+            <a:pPr algn="l">
+              <a:defRPr sz="1650" b="0">
+                <a:solidFill>
+                  <a:srgbClr val="0B2A33"/>
+                </a:solidFill>
+                <a:latin typeface="Helvetica Neue"/>
+                <a:ea typeface="Helvetica Neue"/>
+                <a:cs typeface="Helvetica Neue"/>
+              </a:defRPr>
+            </a:pPr>
+            <a:r>
+              <a:rPr sz="1650" b="0">
                 <a:solidFill>
                   <a:srgbClr val="0B2A33"/>
                 </a:solidFill>
@@ -10915,21 +11031,21 @@
       </p:sp>
       <p:sp>
         <p:nvSpPr>
-          <p:cNvPr id="14" name="">
-            <a:extLst xmlns:a="http://schemas.openxmlformats.org/drawingml/2006/main">
-              <a:ext uri="{FF2B5EF4-FFF2-40B4-BE49-F238E27FC236}">
-                <a16:creationId xmlns:a16="http://schemas.microsoft.com/office/drawing/2014/main" id="{5A371132-DD4F-47D9-9309-1BBF10AA474A}"/>
-              </a:ext>
-            </a:extLst>
-          </p:cNvPr>
-          <p:cNvSpPr>
-            <a:spLocks xmlns:a="http://schemas.openxmlformats.org/drawingml/2006/main" noGrp="1"/>
-          </p:cNvSpPr>
-          <p:nvPr/>
-        </p:nvSpPr>
-        <p:spPr>
-          <a:xfrm xmlns:a="http://schemas.openxmlformats.org/drawingml/2006/main">
-            <a:off x="1104900" y="4238625"/>
+          <p:cNvPr id="16" name="">
+            <a:extLst xmlns:a="http://schemas.openxmlformats.org/drawingml/2006/main">
+              <a:ext uri="{FF2B5EF4-FFF2-40B4-BE49-F238E27FC236}">
+                <a16:creationId xmlns:a16="http://schemas.microsoft.com/office/drawing/2014/main" id="{B8364671-68D7-473A-96FC-DCCE7CF6CB7E}"/>
+              </a:ext>
+            </a:extLst>
+          </p:cNvPr>
+          <p:cNvSpPr>
+            <a:spLocks xmlns:a="http://schemas.openxmlformats.org/drawingml/2006/main" noGrp="1"/>
+          </p:cNvSpPr>
+          <p:nvPr/>
+        </p:nvSpPr>
+        <p:spPr>
+          <a:xfrm xmlns:a="http://schemas.openxmlformats.org/drawingml/2006/main">
+            <a:off x="1104900" y="4314825"/>
             <a:ext cx="228600" cy="266700"/>
           </a:xfrm>
           <a:prstGeom xmlns:a="http://schemas.openxmlformats.org/drawingml/2006/main" prst="rect">
@@ -10973,21 +11089,21 @@
       </p:sp>
       <p:sp>
         <p:nvSpPr>
-          <p:cNvPr id="15" name="">
-            <a:extLst xmlns:a="http://schemas.openxmlformats.org/drawingml/2006/main">
-              <a:ext uri="{FF2B5EF4-FFF2-40B4-BE49-F238E27FC236}">
-                <a16:creationId xmlns:a16="http://schemas.microsoft.com/office/drawing/2014/main" id="{1D332C8C-72A0-4E3B-A0E6-FC38FA9FBDBF}"/>
-              </a:ext>
-            </a:extLst>
-          </p:cNvPr>
-          <p:cNvSpPr>
-            <a:spLocks xmlns:a="http://schemas.openxmlformats.org/drawingml/2006/main" noGrp="1"/>
-          </p:cNvSpPr>
-          <p:nvPr/>
-        </p:nvSpPr>
-        <p:spPr>
-          <a:xfrm xmlns:a="http://schemas.openxmlformats.org/drawingml/2006/main">
-            <a:off x="1371600" y="4248150"/>
+          <p:cNvPr id="17" name="">
+            <a:extLst xmlns:a="http://schemas.openxmlformats.org/drawingml/2006/main">
+              <a:ext uri="{FF2B5EF4-FFF2-40B4-BE49-F238E27FC236}">
+                <a16:creationId xmlns:a16="http://schemas.microsoft.com/office/drawing/2014/main" id="{7021C20E-D189-47AE-B440-18FF41233689}"/>
+              </a:ext>
+            </a:extLst>
+          </p:cNvPr>
+          <p:cNvSpPr>
+            <a:spLocks xmlns:a="http://schemas.openxmlformats.org/drawingml/2006/main" noGrp="1"/>
+          </p:cNvSpPr>
+          <p:nvPr/>
+        </p:nvSpPr>
+        <p:spPr>
+          <a:xfrm xmlns:a="http://schemas.openxmlformats.org/drawingml/2006/main">
+            <a:off x="1371600" y="4324350"/>
             <a:ext cx="8572500" cy="400050"/>
           </a:xfrm>
           <a:prstGeom xmlns:a="http://schemas.openxmlformats.org/drawingml/2006/main" prst="rect">
@@ -11006,7 +11122,7 @@
           <a:lstStyle xmlns:a="http://schemas.openxmlformats.org/drawingml/2006/main"/>
           <a:p xmlns:a="http://schemas.openxmlformats.org/drawingml/2006/main">
             <a:pPr algn="l">
-              <a:defRPr sz="1800" b="0">
+              <a:defRPr sz="1650" b="0">
                 <a:solidFill>
                   <a:srgbClr val="0B2A33"/>
                 </a:solidFill>
@@ -11016,7 +11132,7 @@
               </a:defRPr>
             </a:pPr>
             <a:r>
-              <a:rPr sz="1800" b="0">
+              <a:rPr sz="1650" b="0">
                 <a:solidFill>
                   <a:srgbClr val="0B2A33"/>
                 </a:solidFill>
@@ -11031,10 +11147,10 @@
       </p:sp>
       <p:sp>
         <p:nvSpPr>
-          <p:cNvPr id="16" name="">
-            <a:extLst xmlns:a="http://schemas.openxmlformats.org/drawingml/2006/main">
-              <a:ext uri="{FF2B5EF4-FFF2-40B4-BE49-F238E27FC236}">
-                <a16:creationId xmlns:a16="http://schemas.microsoft.com/office/drawing/2014/main" id="{97D2E541-1524-4572-A10B-30D43EEE4913}"/>
+          <p:cNvPr id="18" name="">
+            <a:extLst xmlns:a="http://schemas.openxmlformats.org/drawingml/2006/main">
+              <a:ext uri="{FF2B5EF4-FFF2-40B4-BE49-F238E27FC236}">
+                <a16:creationId xmlns:a16="http://schemas.microsoft.com/office/drawing/2014/main" id="{F58230EA-439E-4314-98E3-7519A80F6257}"/>
               </a:ext>
             </a:extLst>
           </p:cNvPr>
@@ -11064,10 +11180,10 @@
       </p:sp>
       <p:sp>
         <p:nvSpPr>
-          <p:cNvPr id="17" name="">
-            <a:extLst xmlns:a="http://schemas.openxmlformats.org/drawingml/2006/main">
-              <a:ext uri="{FF2B5EF4-FFF2-40B4-BE49-F238E27FC236}">
-                <a16:creationId xmlns:a16="http://schemas.microsoft.com/office/drawing/2014/main" id="{FC083CF2-0050-4706-98A9-CE45D25B62F0}"/>
+          <p:cNvPr id="19" name="">
+            <a:extLst xmlns:a="http://schemas.openxmlformats.org/drawingml/2006/main">
+              <a:ext uri="{FF2B5EF4-FFF2-40B4-BE49-F238E27FC236}">
+                <a16:creationId xmlns:a16="http://schemas.microsoft.com/office/drawing/2014/main" id="{7AAE882B-FED5-4012-B263-91E5A4EE581E}"/>
               </a:ext>
             </a:extLst>
           </p:cNvPr>
@@ -11123,7 +11239,7 @@
     </p:spTree>
     <p:extLst>
       <p:ext uri="{BB962C8B-B14F-4D97-AF65-F5344CB8AC3E}">
-        <p14:creationId xmlns:p14="http://schemas.microsoft.com/office/powerpoint/2010/main" val="581753597"/>
+        <p14:creationId xmlns:p14="http://schemas.microsoft.com/office/powerpoint/2010/main" val="284079066"/>
       </p:ext>
     </p:extLst>
   </p:cSld>
@@ -11154,7 +11270,7 @@
           <p:cNvPr id="26" name="">
             <a:extLst xmlns:a="http://schemas.openxmlformats.org/drawingml/2006/main">
               <a:ext uri="{FF2B5EF4-FFF2-40B4-BE49-F238E27FC236}">
-                <a16:creationId xmlns:a16="http://schemas.microsoft.com/office/drawing/2014/main" id="{F1D13E21-865E-496E-9366-313B4BCE577E}"/>
+                <a16:creationId xmlns:a16="http://schemas.microsoft.com/office/drawing/2014/main" id="{D243622B-F5AE-48E7-86BB-F961BE055CB7}"/>
               </a:ext>
             </a:extLst>
           </p:cNvPr>
@@ -11187,7 +11303,7 @@
           <p:cNvPr id="2" name="">
             <a:extLst xmlns:a="http://schemas.openxmlformats.org/drawingml/2006/main">
               <a:ext uri="{FF2B5EF4-FFF2-40B4-BE49-F238E27FC236}">
-                <a16:creationId xmlns:a16="http://schemas.microsoft.com/office/drawing/2014/main" id="{BCD3FD1C-9030-49CA-9B37-E8C854129CD8}"/>
+                <a16:creationId xmlns:a16="http://schemas.microsoft.com/office/drawing/2014/main" id="{52511823-63C8-4D41-87F4-7C063CF45BAE}"/>
               </a:ext>
             </a:extLst>
           </p:cNvPr>
@@ -11245,7 +11361,7 @@
           <p:cNvPr id="3" name="">
             <a:extLst xmlns:a="http://schemas.openxmlformats.org/drawingml/2006/main">
               <a:ext uri="{FF2B5EF4-FFF2-40B4-BE49-F238E27FC236}">
-                <a16:creationId xmlns:a16="http://schemas.microsoft.com/office/drawing/2014/main" id="{3E651FC8-657F-4C89-8526-C96BCF698937}"/>
+                <a16:creationId xmlns:a16="http://schemas.microsoft.com/office/drawing/2014/main" id="{28A26CCF-F5A3-4A80-AD38-11C7392775E3}"/>
               </a:ext>
             </a:extLst>
           </p:cNvPr>
@@ -11303,7 +11419,7 @@
           <p:cNvPr id="4" name="">
             <a:extLst xmlns:a="http://schemas.openxmlformats.org/drawingml/2006/main">
               <a:ext uri="{FF2B5EF4-FFF2-40B4-BE49-F238E27FC236}">
-                <a16:creationId xmlns:a16="http://schemas.microsoft.com/office/drawing/2014/main" id="{BDE0BFF2-C689-4031-8DD8-192038F7E822}"/>
+                <a16:creationId xmlns:a16="http://schemas.microsoft.com/office/drawing/2014/main" id="{F8BDAB80-26A9-47CD-9117-7E4F49443AC0}"/>
               </a:ext>
             </a:extLst>
           </p:cNvPr>
@@ -11361,7 +11477,7 @@
           <p:cNvPr id="5" name="">
             <a:extLst xmlns:a="http://schemas.openxmlformats.org/drawingml/2006/main">
               <a:ext uri="{FF2B5EF4-FFF2-40B4-BE49-F238E27FC236}">
-                <a16:creationId xmlns:a16="http://schemas.microsoft.com/office/drawing/2014/main" id="{C9BF026B-1E3D-49FE-BC12-87469BCB3375}"/>
+                <a16:creationId xmlns:a16="http://schemas.microsoft.com/office/drawing/2014/main" id="{6D59480E-8F60-4484-8BA7-199CDD55C9F9}"/>
               </a:ext>
             </a:extLst>
           </p:cNvPr>
@@ -11392,7 +11508,7 @@
           <p:cNvPr id="6" name="">
             <a:extLst xmlns:a="http://schemas.openxmlformats.org/drawingml/2006/main">
               <a:ext uri="{FF2B5EF4-FFF2-40B4-BE49-F238E27FC236}">
-                <a16:creationId xmlns:a16="http://schemas.microsoft.com/office/drawing/2014/main" id="{1E0EE201-5D7A-4CA2-A52D-A563C5286496}"/>
+                <a16:creationId xmlns:a16="http://schemas.microsoft.com/office/drawing/2014/main" id="{23AB3C9C-404E-4D5B-BEEA-BD664B374A74}"/>
               </a:ext>
             </a:extLst>
           </p:cNvPr>
@@ -11423,7 +11539,7 @@
           <p:cNvPr id="7" name="">
             <a:extLst xmlns:a="http://schemas.openxmlformats.org/drawingml/2006/main">
               <a:ext uri="{FF2B5EF4-FFF2-40B4-BE49-F238E27FC236}">
-                <a16:creationId xmlns:a16="http://schemas.microsoft.com/office/drawing/2014/main" id="{FE37F1C2-C859-46C5-A4FA-8DD47FFB141D}"/>
+                <a16:creationId xmlns:a16="http://schemas.microsoft.com/office/drawing/2014/main" id="{C92C5EB1-BD86-4EEB-AEFF-0AF0DA0D95AC}"/>
               </a:ext>
             </a:extLst>
           </p:cNvPr>
@@ -11481,7 +11597,7 @@
           <p:cNvPr id="8" name="">
             <a:extLst xmlns:a="http://schemas.openxmlformats.org/drawingml/2006/main">
               <a:ext uri="{FF2B5EF4-FFF2-40B4-BE49-F238E27FC236}">
-                <a16:creationId xmlns:a16="http://schemas.microsoft.com/office/drawing/2014/main" id="{D79DB6DF-93AA-409F-AB78-EDC251D18497}"/>
+                <a16:creationId xmlns:a16="http://schemas.microsoft.com/office/drawing/2014/main" id="{4CFA757C-B466-4D66-AF6B-AA48D4BCC46F}"/>
               </a:ext>
             </a:extLst>
           </p:cNvPr>
@@ -11539,7 +11655,7 @@
           <p:cNvPr id="9" name="">
             <a:extLst xmlns:a="http://schemas.openxmlformats.org/drawingml/2006/main">
               <a:ext uri="{FF2B5EF4-FFF2-40B4-BE49-F238E27FC236}">
-                <a16:creationId xmlns:a16="http://schemas.microsoft.com/office/drawing/2014/main" id="{EA9357B1-986D-470F-9E7D-EB5F42E58CC3}"/>
+                <a16:creationId xmlns:a16="http://schemas.microsoft.com/office/drawing/2014/main" id="{00B59234-37AF-4824-B882-82B5BD1FBE68}"/>
               </a:ext>
             </a:extLst>
           </p:cNvPr>
@@ -11597,7 +11713,7 @@
           <p:cNvPr id="10" name="">
             <a:extLst xmlns:a="http://schemas.openxmlformats.org/drawingml/2006/main">
               <a:ext uri="{FF2B5EF4-FFF2-40B4-BE49-F238E27FC236}">
-                <a16:creationId xmlns:a16="http://schemas.microsoft.com/office/drawing/2014/main" id="{79FE9676-0CFF-4FD8-B919-C5577A76858B}"/>
+                <a16:creationId xmlns:a16="http://schemas.microsoft.com/office/drawing/2014/main" id="{7519065D-2098-471F-B80F-6A6994B09335}"/>
               </a:ext>
             </a:extLst>
           </p:cNvPr>
@@ -11655,7 +11771,7 @@
           <p:cNvPr id="11" name="">
             <a:extLst xmlns:a="http://schemas.openxmlformats.org/drawingml/2006/main">
               <a:ext uri="{FF2B5EF4-FFF2-40B4-BE49-F238E27FC236}">
-                <a16:creationId xmlns:a16="http://schemas.microsoft.com/office/drawing/2014/main" id="{2F5B4FE0-A3AB-4ABF-8095-A809C35AB179}"/>
+                <a16:creationId xmlns:a16="http://schemas.microsoft.com/office/drawing/2014/main" id="{C85EBBB6-BF01-4AA3-ACB4-50F859230A28}"/>
               </a:ext>
             </a:extLst>
           </p:cNvPr>
@@ -11713,7 +11829,7 @@
           <p:cNvPr id="12" name="">
             <a:extLst xmlns:a="http://schemas.openxmlformats.org/drawingml/2006/main">
               <a:ext uri="{FF2B5EF4-FFF2-40B4-BE49-F238E27FC236}">
-                <a16:creationId xmlns:a16="http://schemas.microsoft.com/office/drawing/2014/main" id="{41CD9D59-D699-49A1-9AB4-7D2C9FD6901D}"/>
+                <a16:creationId xmlns:a16="http://schemas.microsoft.com/office/drawing/2014/main" id="{8640ABAD-186D-4A35-AA96-1612ADC9815B}"/>
               </a:ext>
             </a:extLst>
           </p:cNvPr>
@@ -11771,7 +11887,7 @@
           <p:cNvPr id="13" name="">
             <a:extLst xmlns:a="http://schemas.openxmlformats.org/drawingml/2006/main">
               <a:ext uri="{FF2B5EF4-FFF2-40B4-BE49-F238E27FC236}">
-                <a16:creationId xmlns:a16="http://schemas.microsoft.com/office/drawing/2014/main" id="{5E33F263-0459-4AEB-AC9F-5C1806F44CC2}"/>
+                <a16:creationId xmlns:a16="http://schemas.microsoft.com/office/drawing/2014/main" id="{34971C6D-CAF5-40A3-8B5D-173A7C303B7D}"/>
               </a:ext>
             </a:extLst>
           </p:cNvPr>
@@ -11829,7 +11945,7 @@
           <p:cNvPr id="14" name="">
             <a:extLst xmlns:a="http://schemas.openxmlformats.org/drawingml/2006/main">
               <a:ext uri="{FF2B5EF4-FFF2-40B4-BE49-F238E27FC236}">
-                <a16:creationId xmlns:a16="http://schemas.microsoft.com/office/drawing/2014/main" id="{BCC2E288-05E8-47FB-8F7C-34D0139AF2F2}"/>
+                <a16:creationId xmlns:a16="http://schemas.microsoft.com/office/drawing/2014/main" id="{B4B290D1-B025-4EA1-9B14-8FFB8FA46DE3}"/>
               </a:ext>
             </a:extLst>
           </p:cNvPr>
@@ -11887,7 +12003,7 @@
           <p:cNvPr id="15" name="">
             <a:extLst xmlns:a="http://schemas.openxmlformats.org/drawingml/2006/main">
               <a:ext uri="{FF2B5EF4-FFF2-40B4-BE49-F238E27FC236}">
-                <a16:creationId xmlns:a16="http://schemas.microsoft.com/office/drawing/2014/main" id="{AF458D57-489D-4967-9F2F-DC4820F5A0FE}"/>
+                <a16:creationId xmlns:a16="http://schemas.microsoft.com/office/drawing/2014/main" id="{DEE79C02-BA9B-42E3-A108-86517E8CBED6}"/>
               </a:ext>
             </a:extLst>
           </p:cNvPr>
@@ -11945,7 +12061,7 @@
           <p:cNvPr id="16" name="">
             <a:extLst xmlns:a="http://schemas.openxmlformats.org/drawingml/2006/main">
               <a:ext uri="{FF2B5EF4-FFF2-40B4-BE49-F238E27FC236}">
-                <a16:creationId xmlns:a16="http://schemas.microsoft.com/office/drawing/2014/main" id="{C713DDAB-3202-4BA5-817D-5703BFF5AC6A}"/>
+                <a16:creationId xmlns:a16="http://schemas.microsoft.com/office/drawing/2014/main" id="{3F2CBAAD-C2FF-4952-821A-8510A82D14B9}"/>
               </a:ext>
             </a:extLst>
           </p:cNvPr>
@@ -12003,7 +12119,7 @@
           <p:cNvPr id="17" name="">
             <a:extLst xmlns:a="http://schemas.openxmlformats.org/drawingml/2006/main">
               <a:ext uri="{FF2B5EF4-FFF2-40B4-BE49-F238E27FC236}">
-                <a16:creationId xmlns:a16="http://schemas.microsoft.com/office/drawing/2014/main" id="{81EE9076-F010-481D-A58E-81E8B691FA09}"/>
+                <a16:creationId xmlns:a16="http://schemas.microsoft.com/office/drawing/2014/main" id="{B8FB98EA-7D7A-46FA-89EE-E02DF08E3EEB}"/>
               </a:ext>
             </a:extLst>
           </p:cNvPr>
@@ -12061,7 +12177,7 @@
           <p:cNvPr id="18" name="">
             <a:extLst xmlns:a="http://schemas.openxmlformats.org/drawingml/2006/main">
               <a:ext uri="{FF2B5EF4-FFF2-40B4-BE49-F238E27FC236}">
-                <a16:creationId xmlns:a16="http://schemas.microsoft.com/office/drawing/2014/main" id="{1D9401A6-286A-4C51-9B07-F68C6DDEF593}"/>
+                <a16:creationId xmlns:a16="http://schemas.microsoft.com/office/drawing/2014/main" id="{BDAC89C9-3D9D-41D0-970A-E145ACC7CB65}"/>
               </a:ext>
             </a:extLst>
           </p:cNvPr>
@@ -12119,7 +12235,7 @@
           <p:cNvPr id="19" name="">
             <a:extLst xmlns:a="http://schemas.openxmlformats.org/drawingml/2006/main">
               <a:ext uri="{FF2B5EF4-FFF2-40B4-BE49-F238E27FC236}">
-                <a16:creationId xmlns:a16="http://schemas.microsoft.com/office/drawing/2014/main" id="{4B950ADB-CB8D-4B8A-A197-EEA5CEE3987B}"/>
+                <a16:creationId xmlns:a16="http://schemas.microsoft.com/office/drawing/2014/main" id="{FF4D12C6-B7E5-49E9-A593-3934A95F4039}"/>
               </a:ext>
             </a:extLst>
           </p:cNvPr>
@@ -12177,7 +12293,7 @@
           <p:cNvPr id="20" name="">
             <a:extLst xmlns:a="http://schemas.openxmlformats.org/drawingml/2006/main">
               <a:ext uri="{FF2B5EF4-FFF2-40B4-BE49-F238E27FC236}">
-                <a16:creationId xmlns:a16="http://schemas.microsoft.com/office/drawing/2014/main" id="{17251905-8E69-4993-95D9-40176F6E0D2F}"/>
+                <a16:creationId xmlns:a16="http://schemas.microsoft.com/office/drawing/2014/main" id="{1FE5351B-E9E7-4278-8ACA-E6A7C0E96A8B}"/>
               </a:ext>
             </a:extLst>
           </p:cNvPr>
@@ -12235,7 +12351,7 @@
           <p:cNvPr id="21" name="">
             <a:extLst xmlns:a="http://schemas.openxmlformats.org/drawingml/2006/main">
               <a:ext uri="{FF2B5EF4-FFF2-40B4-BE49-F238E27FC236}">
-                <a16:creationId xmlns:a16="http://schemas.microsoft.com/office/drawing/2014/main" id="{9BF49D19-0DD7-4E42-8DE9-BDAD2E9B609C}"/>
+                <a16:creationId xmlns:a16="http://schemas.microsoft.com/office/drawing/2014/main" id="{A0DD7038-9E73-4C3F-B06F-1E8B43C3C8B8}"/>
               </a:ext>
             </a:extLst>
           </p:cNvPr>
@@ -12260,7 +12376,7 @@
         </p:spPr>
         <p:txBody>
           <a:bodyPr xmlns:a="http://schemas.openxmlformats.org/drawingml/2006/main">
-            <a:normAutofit fontScale="95217"/>
+            <a:normAutofit fontScale="92152"/>
           </a:bodyPr>
           <a:lstStyle xmlns:a="http://schemas.openxmlformats.org/drawingml/2006/main"/>
           <a:p xmlns:a="http://schemas.openxmlformats.org/drawingml/2006/main">
@@ -12283,7 +12399,7 @@
                 <a:ea typeface="Helvetica Neue"/>
                 <a:cs typeface="Helvetica Neue"/>
               </a:rPr>
-              <a:t>Prioritize emergency admissions, skilled nursing discharges, high chronic-condition burden, and repeat admissions.</a:t>
+              <a:t>Use separate clinical quality, financial, capacity, care coordination, and data quality lenses for the readmission problem.</a:t>
             </a:r>
           </a:p>
         </p:txBody>
@@ -12293,7 +12409,7 @@
           <p:cNvPr id="22" name="">
             <a:extLst xmlns:a="http://schemas.openxmlformats.org/drawingml/2006/main">
               <a:ext uri="{FF2B5EF4-FFF2-40B4-BE49-F238E27FC236}">
-                <a16:creationId xmlns:a16="http://schemas.microsoft.com/office/drawing/2014/main" id="{EBEE77E0-8C40-45E4-9C2E-AD8142EED614}"/>
+                <a16:creationId xmlns:a16="http://schemas.microsoft.com/office/drawing/2014/main" id="{1A3A5F48-FEE0-4BCB-B20B-D94294475F66}"/>
               </a:ext>
             </a:extLst>
           </p:cNvPr>
@@ -12351,7 +12467,7 @@
           <p:cNvPr id="23" name="">
             <a:extLst xmlns:a="http://schemas.openxmlformats.org/drawingml/2006/main">
               <a:ext uri="{FF2B5EF4-FFF2-40B4-BE49-F238E27FC236}">
-                <a16:creationId xmlns:a16="http://schemas.microsoft.com/office/drawing/2014/main" id="{F4B45328-2F3E-474A-ABF5-A32ACCD9A037}"/>
+                <a16:creationId xmlns:a16="http://schemas.microsoft.com/office/drawing/2014/main" id="{033E8FD0-17DD-4D46-9A2D-E1ECC56DDE74}"/>
               </a:ext>
             </a:extLst>
           </p:cNvPr>
@@ -12376,7 +12492,7 @@
         </p:spPr>
         <p:txBody>
           <a:bodyPr xmlns:a="http://schemas.openxmlformats.org/drawingml/2006/main">
-            <a:normAutofit fontScale="100000"/>
+            <a:normAutofit fontScale="99152"/>
           </a:bodyPr>
           <a:lstStyle xmlns:a="http://schemas.openxmlformats.org/drawingml/2006/main"/>
           <a:p xmlns:a="http://schemas.openxmlformats.org/drawingml/2006/main">
@@ -12399,7 +12515,7 @@
                 <a:ea typeface="Helvetica Neue"/>
                 <a:cs typeface="Helvetica Neue"/>
               </a:rPr>
-              <a:t>Use an explainable pre-discharge risk score so care teams can intervene before patients leave the hospital.</a:t>
+              <a:t>Cover deciles 8-10 and other high-risk clinical groups rather than narrowing the pilot to one minimum segment.</a:t>
             </a:r>
           </a:p>
         </p:txBody>
@@ -12409,7 +12525,7 @@
           <p:cNvPr id="24" name="">
             <a:extLst xmlns:a="http://schemas.openxmlformats.org/drawingml/2006/main">
               <a:ext uri="{FF2B5EF4-FFF2-40B4-BE49-F238E27FC236}">
-                <a16:creationId xmlns:a16="http://schemas.microsoft.com/office/drawing/2014/main" id="{A8A4F077-1F29-4E7A-BAC0-1A83841E3BA3}"/>
+                <a16:creationId xmlns:a16="http://schemas.microsoft.com/office/drawing/2014/main" id="{F7CDC9FE-BEF5-4890-811C-EAE28D58C9D1}"/>
               </a:ext>
             </a:extLst>
           </p:cNvPr>
@@ -12467,7 +12583,7 @@
           <p:cNvPr id="25" name="">
             <a:extLst xmlns:a="http://schemas.openxmlformats.org/drawingml/2006/main">
               <a:ext uri="{FF2B5EF4-FFF2-40B4-BE49-F238E27FC236}">
-                <a16:creationId xmlns:a16="http://schemas.microsoft.com/office/drawing/2014/main" id="{3BFD1A10-05F4-4D66-B5D4-8A1AB827E763}"/>
+                <a16:creationId xmlns:a16="http://schemas.microsoft.com/office/drawing/2014/main" id="{F75C446A-5B57-4A93-8749-ECE28B6F25B4}"/>
               </a:ext>
             </a:extLst>
           </p:cNvPr>
@@ -12492,7 +12608,7 @@
         </p:spPr>
         <p:txBody>
           <a:bodyPr xmlns:a="http://schemas.openxmlformats.org/drawingml/2006/main">
-            <a:normAutofit fontScale="100000"/>
+            <a:normAutofit fontScale="98517"/>
           </a:bodyPr>
           <a:lstStyle xmlns:a="http://schemas.openxmlformats.org/drawingml/2006/main"/>
           <a:p xmlns:a="http://schemas.openxmlformats.org/drawingml/2006/main">
@@ -12515,7 +12631,7 @@
                 <a:ea typeface="Helvetica Neue"/>
                 <a:cs typeface="Helvetica Neue"/>
               </a:rPr>
-              <a:t>Build the executive dashboard in Tableau or Power BI using the prepared extract and KPI definitions.</a:t>
+              <a:t>Build the executive dashboard in Tableau first using the prepared extract, KPI definitions, and validation checks.</a:t>
             </a:r>
           </a:p>
         </p:txBody>
@@ -12523,7 +12639,7 @@
     </p:spTree>
     <p:extLst>
       <p:ext uri="{BB962C8B-B14F-4D97-AF65-F5344CB8AC3E}">
-        <p14:creationId xmlns:p14="http://schemas.microsoft.com/office/powerpoint/2010/main" val="287791020"/>
+        <p14:creationId xmlns:p14="http://schemas.microsoft.com/office/powerpoint/2010/main" val="419728171"/>
       </p:ext>
     </p:extLst>
   </p:cSld>
@@ -12554,7 +12670,7 @@
           <p:cNvPr id="15" name="">
             <a:extLst xmlns:a="http://schemas.openxmlformats.org/drawingml/2006/main">
               <a:ext uri="{FF2B5EF4-FFF2-40B4-BE49-F238E27FC236}">
-                <a16:creationId xmlns:a16="http://schemas.microsoft.com/office/drawing/2014/main" id="{95E16C75-FBC7-4C15-B23E-DDB71FE752E9}"/>
+                <a16:creationId xmlns:a16="http://schemas.microsoft.com/office/drawing/2014/main" id="{6829FEA4-DCC0-4766-A00F-99101135CB54}"/>
               </a:ext>
             </a:extLst>
           </p:cNvPr>
@@ -12587,7 +12703,7 @@
           <p:cNvPr id="2" name="">
             <a:extLst xmlns:a="http://schemas.openxmlformats.org/drawingml/2006/main">
               <a:ext uri="{FF2B5EF4-FFF2-40B4-BE49-F238E27FC236}">
-                <a16:creationId xmlns:a16="http://schemas.microsoft.com/office/drawing/2014/main" id="{070BA108-6A30-4FBD-B810-955AAB4B6D8A}"/>
+                <a16:creationId xmlns:a16="http://schemas.microsoft.com/office/drawing/2014/main" id="{0D57F728-F5FA-4A24-B814-F262D6D0B5DD}"/>
               </a:ext>
             </a:extLst>
           </p:cNvPr>
@@ -12645,7 +12761,7 @@
           <p:cNvPr id="3" name="">
             <a:extLst xmlns:a="http://schemas.openxmlformats.org/drawingml/2006/main">
               <a:ext uri="{FF2B5EF4-FFF2-40B4-BE49-F238E27FC236}">
-                <a16:creationId xmlns:a16="http://schemas.microsoft.com/office/drawing/2014/main" id="{C8BAE0A1-668F-4B3D-9564-6E8950007D7A}"/>
+                <a16:creationId xmlns:a16="http://schemas.microsoft.com/office/drawing/2014/main" id="{BAE4EEFE-E8A6-4F6E-9CF5-A5F6EE5C6F58}"/>
               </a:ext>
             </a:extLst>
           </p:cNvPr>
@@ -12703,7 +12819,7 @@
           <p:cNvPr id="4" name="">
             <a:extLst xmlns:a="http://schemas.openxmlformats.org/drawingml/2006/main">
               <a:ext uri="{FF2B5EF4-FFF2-40B4-BE49-F238E27FC236}">
-                <a16:creationId xmlns:a16="http://schemas.microsoft.com/office/drawing/2014/main" id="{06E05F84-67E6-4CF6-837D-9EB8C4BCF45E}"/>
+                <a16:creationId xmlns:a16="http://schemas.microsoft.com/office/drawing/2014/main" id="{F3D28402-CE9F-4C50-BA1D-38A3B92DB35E}"/>
               </a:ext>
             </a:extLst>
           </p:cNvPr>
@@ -12761,7 +12877,7 @@
           <p:cNvPr id="5" name="">
             <a:extLst xmlns:a="http://schemas.openxmlformats.org/drawingml/2006/main">
               <a:ext uri="{FF2B5EF4-FFF2-40B4-BE49-F238E27FC236}">
-                <a16:creationId xmlns:a16="http://schemas.microsoft.com/office/drawing/2014/main" id="{934AF7CF-E3AF-4A22-8D58-4FF7E830B9B9}"/>
+                <a16:creationId xmlns:a16="http://schemas.microsoft.com/office/drawing/2014/main" id="{05F91669-52A2-4B3C-A3F7-274147DE45EF}"/>
               </a:ext>
             </a:extLst>
           </p:cNvPr>
@@ -12792,7 +12908,7 @@
           <p:cNvPr id="6" name="">
             <a:extLst xmlns:a="http://schemas.openxmlformats.org/drawingml/2006/main">
               <a:ext uri="{FF2B5EF4-FFF2-40B4-BE49-F238E27FC236}">
-                <a16:creationId xmlns:a16="http://schemas.microsoft.com/office/drawing/2014/main" id="{BD627083-EBD7-4CB4-82D0-604B74FF567B}"/>
+                <a16:creationId xmlns:a16="http://schemas.microsoft.com/office/drawing/2014/main" id="{6E8D77C3-D502-4D7B-BDF3-1689C91A9CFD}"/>
               </a:ext>
             </a:extLst>
           </p:cNvPr>
@@ -12823,7 +12939,7 @@
           <p:cNvPr id="7" name="">
             <a:extLst xmlns:a="http://schemas.openxmlformats.org/drawingml/2006/main">
               <a:ext uri="{FF2B5EF4-FFF2-40B4-BE49-F238E27FC236}">
-                <a16:creationId xmlns:a16="http://schemas.microsoft.com/office/drawing/2014/main" id="{FB96B7B6-7223-4CFA-AB00-E37A1CDE84D4}"/>
+                <a16:creationId xmlns:a16="http://schemas.microsoft.com/office/drawing/2014/main" id="{46A72346-3E81-4928-825E-633843B799A1}"/>
               </a:ext>
             </a:extLst>
           </p:cNvPr>
@@ -12888,7 +13004,7 @@
         </p:xfrm>
         <a:graphic xmlns:a="http://schemas.openxmlformats.org/drawingml/2006/main">
           <a:graphicData uri="http://schemas.openxmlformats.org/drawingml/2006/chart">
-            <c:chart xmlns:r="http://schemas.openxmlformats.org/officeDocument/2006/relationships" xmlns:c="http://schemas.openxmlformats.org/drawingml/2006/chart" r:id="Rd08d729e3edd4a8c"/>
+            <c:chart xmlns:r="http://schemas.openxmlformats.org/officeDocument/2006/relationships" xmlns:c="http://schemas.openxmlformats.org/drawingml/2006/chart" r:id="Rc6f35de54efd4421"/>
           </a:graphicData>
         </a:graphic>
       </p:graphicFrame>
@@ -12897,7 +13013,7 @@
           <p:cNvPr id="9" name="">
             <a:extLst xmlns:a="http://schemas.openxmlformats.org/drawingml/2006/main">
               <a:ext uri="{FF2B5EF4-FFF2-40B4-BE49-F238E27FC236}">
-                <a16:creationId xmlns:a16="http://schemas.microsoft.com/office/drawing/2014/main" id="{9492F078-0632-403A-A6A7-1838B42E6F7A}"/>
+                <a16:creationId xmlns:a16="http://schemas.microsoft.com/office/drawing/2014/main" id="{D00F6F06-4CD4-48E4-A1BD-6D1113930C0B}"/>
               </a:ext>
             </a:extLst>
           </p:cNvPr>
@@ -12955,7 +13071,7 @@
           <p:cNvPr id="10" name="">
             <a:extLst xmlns:a="http://schemas.openxmlformats.org/drawingml/2006/main">
               <a:ext uri="{FF2B5EF4-FFF2-40B4-BE49-F238E27FC236}">
-                <a16:creationId xmlns:a16="http://schemas.microsoft.com/office/drawing/2014/main" id="{4A1E6AE3-1D1A-437C-AD1D-AECD432B2D28}"/>
+                <a16:creationId xmlns:a16="http://schemas.microsoft.com/office/drawing/2014/main" id="{6F45632A-F3C1-44A3-9EA1-2647FC67C065}"/>
               </a:ext>
             </a:extLst>
           </p:cNvPr>
@@ -13013,7 +13129,7 @@
           <p:cNvPr id="11" name="">
             <a:extLst xmlns:a="http://schemas.openxmlformats.org/drawingml/2006/main">
               <a:ext uri="{FF2B5EF4-FFF2-40B4-BE49-F238E27FC236}">
-                <a16:creationId xmlns:a16="http://schemas.microsoft.com/office/drawing/2014/main" id="{DA671F05-ACEB-47A1-B79C-4FA31EF68939}"/>
+                <a16:creationId xmlns:a16="http://schemas.microsoft.com/office/drawing/2014/main" id="{73882036-A3F3-4D69-BED9-F1C396AC64BF}"/>
               </a:ext>
             </a:extLst>
           </p:cNvPr>
@@ -13071,7 +13187,7 @@
           <p:cNvPr id="12" name="">
             <a:extLst xmlns:a="http://schemas.openxmlformats.org/drawingml/2006/main">
               <a:ext uri="{FF2B5EF4-FFF2-40B4-BE49-F238E27FC236}">
-                <a16:creationId xmlns:a16="http://schemas.microsoft.com/office/drawing/2014/main" id="{4BBC612E-2567-4E07-BB32-BCA5CBCC050D}"/>
+                <a16:creationId xmlns:a16="http://schemas.microsoft.com/office/drawing/2014/main" id="{5BC821AA-FBA3-4C16-BE2B-EEBF83B89545}"/>
               </a:ext>
             </a:extLst>
           </p:cNvPr>
@@ -13129,7 +13245,7 @@
           <p:cNvPr id="13" name="">
             <a:extLst xmlns:a="http://schemas.openxmlformats.org/drawingml/2006/main">
               <a:ext uri="{FF2B5EF4-FFF2-40B4-BE49-F238E27FC236}">
-                <a16:creationId xmlns:a16="http://schemas.microsoft.com/office/drawing/2014/main" id="{D0710B36-3D48-4B75-A9A0-96D46AE64B19}"/>
+                <a16:creationId xmlns:a16="http://schemas.microsoft.com/office/drawing/2014/main" id="{A627DCF5-AE62-4E9D-B735-ED65638AEDE0}"/>
               </a:ext>
             </a:extLst>
           </p:cNvPr>
@@ -13187,7 +13303,7 @@
           <p:cNvPr id="14" name="">
             <a:extLst xmlns:a="http://schemas.openxmlformats.org/drawingml/2006/main">
               <a:ext uri="{FF2B5EF4-FFF2-40B4-BE49-F238E27FC236}">
-                <a16:creationId xmlns:a16="http://schemas.microsoft.com/office/drawing/2014/main" id="{E3DD80BC-910F-412E-825F-5648298DD657}"/>
+                <a16:creationId xmlns:a16="http://schemas.microsoft.com/office/drawing/2014/main" id="{87D3B4EF-A7E7-41B8-940C-B734A95E3233}"/>
               </a:ext>
             </a:extLst>
           </p:cNvPr>
@@ -13243,7 +13359,7 @@
     </p:spTree>
     <p:extLst>
       <p:ext uri="{BB962C8B-B14F-4D97-AF65-F5344CB8AC3E}">
-        <p14:creationId xmlns:p14="http://schemas.microsoft.com/office/powerpoint/2010/main" val="251146191"/>
+        <p14:creationId xmlns:p14="http://schemas.microsoft.com/office/powerpoint/2010/main" val="887650448"/>
       </p:ext>
     </p:extLst>
   </p:cSld>
@@ -13274,7 +13390,7 @@
           <p:cNvPr id="11" name="">
             <a:extLst xmlns:a="http://schemas.openxmlformats.org/drawingml/2006/main">
               <a:ext uri="{FF2B5EF4-FFF2-40B4-BE49-F238E27FC236}">
-                <a16:creationId xmlns:a16="http://schemas.microsoft.com/office/drawing/2014/main" id="{5913850A-58E4-486C-84EC-FC67E505CF29}"/>
+                <a16:creationId xmlns:a16="http://schemas.microsoft.com/office/drawing/2014/main" id="{50EED113-4676-4724-8709-58172C9B1013}"/>
               </a:ext>
             </a:extLst>
           </p:cNvPr>
@@ -13307,7 +13423,7 @@
           <p:cNvPr id="2" name="">
             <a:extLst xmlns:a="http://schemas.openxmlformats.org/drawingml/2006/main">
               <a:ext uri="{FF2B5EF4-FFF2-40B4-BE49-F238E27FC236}">
-                <a16:creationId xmlns:a16="http://schemas.microsoft.com/office/drawing/2014/main" id="{CC747CF3-B703-4F68-B915-8367D24594AB}"/>
+                <a16:creationId xmlns:a16="http://schemas.microsoft.com/office/drawing/2014/main" id="{269CDF15-795E-4DBF-95F2-0A6DA7AE5643}"/>
               </a:ext>
             </a:extLst>
           </p:cNvPr>
@@ -13365,7 +13481,7 @@
           <p:cNvPr id="3" name="">
             <a:extLst xmlns:a="http://schemas.openxmlformats.org/drawingml/2006/main">
               <a:ext uri="{FF2B5EF4-FFF2-40B4-BE49-F238E27FC236}">
-                <a16:creationId xmlns:a16="http://schemas.microsoft.com/office/drawing/2014/main" id="{4577FEC7-27FC-4471-B3FC-3EE1C4A005BD}"/>
+                <a16:creationId xmlns:a16="http://schemas.microsoft.com/office/drawing/2014/main" id="{5B048A33-EAFC-4A7D-97CD-E512892EF667}"/>
               </a:ext>
             </a:extLst>
           </p:cNvPr>
@@ -13423,7 +13539,7 @@
           <p:cNvPr id="4" name="">
             <a:extLst xmlns:a="http://schemas.openxmlformats.org/drawingml/2006/main">
               <a:ext uri="{FF2B5EF4-FFF2-40B4-BE49-F238E27FC236}">
-                <a16:creationId xmlns:a16="http://schemas.microsoft.com/office/drawing/2014/main" id="{182AAC38-2F4F-40E7-88B5-F4C5BA326434}"/>
+                <a16:creationId xmlns:a16="http://schemas.microsoft.com/office/drawing/2014/main" id="{6F55E3DE-B6BF-4C4D-AB8E-2D52F87C7A37}"/>
               </a:ext>
             </a:extLst>
           </p:cNvPr>
@@ -13481,7 +13597,7 @@
           <p:cNvPr id="5" name="">
             <a:extLst xmlns:a="http://schemas.openxmlformats.org/drawingml/2006/main">
               <a:ext uri="{FF2B5EF4-FFF2-40B4-BE49-F238E27FC236}">
-                <a16:creationId xmlns:a16="http://schemas.microsoft.com/office/drawing/2014/main" id="{BBB3847B-60A5-45E2-89C6-B5BF6223ED80}"/>
+                <a16:creationId xmlns:a16="http://schemas.microsoft.com/office/drawing/2014/main" id="{2C1A4318-A2EE-47FA-9A05-D3CDB1727F41}"/>
               </a:ext>
             </a:extLst>
           </p:cNvPr>
@@ -13512,7 +13628,7 @@
           <p:cNvPr id="6" name="">
             <a:extLst xmlns:a="http://schemas.openxmlformats.org/drawingml/2006/main">
               <a:ext uri="{FF2B5EF4-FFF2-40B4-BE49-F238E27FC236}">
-                <a16:creationId xmlns:a16="http://schemas.microsoft.com/office/drawing/2014/main" id="{4C267C47-C243-4932-836C-5C1781337E85}"/>
+                <a16:creationId xmlns:a16="http://schemas.microsoft.com/office/drawing/2014/main" id="{1FEDE7E7-6FB9-46B7-9300-8AF1485482F2}"/>
               </a:ext>
             </a:extLst>
           </p:cNvPr>
@@ -13543,7 +13659,7 @@
           <p:cNvPr id="7" name="">
             <a:extLst xmlns:a="http://schemas.openxmlformats.org/drawingml/2006/main">
               <a:ext uri="{FF2B5EF4-FFF2-40B4-BE49-F238E27FC236}">
-                <a16:creationId xmlns:a16="http://schemas.microsoft.com/office/drawing/2014/main" id="{6B25705B-38CC-4A83-BE2D-A692C59F7AAD}"/>
+                <a16:creationId xmlns:a16="http://schemas.microsoft.com/office/drawing/2014/main" id="{6B4D5A27-F8C7-40AF-AC2B-789801FE3756}"/>
               </a:ext>
             </a:extLst>
           </p:cNvPr>
@@ -14291,7 +14407,7 @@
           <p:cNvPr id="10" name="">
             <a:extLst xmlns:a="http://schemas.openxmlformats.org/drawingml/2006/main">
               <a:ext uri="{FF2B5EF4-FFF2-40B4-BE49-F238E27FC236}">
-                <a16:creationId xmlns:a16="http://schemas.microsoft.com/office/drawing/2014/main" id="{B530D372-3F31-4359-9DB3-72737628F126}"/>
+                <a16:creationId xmlns:a16="http://schemas.microsoft.com/office/drawing/2014/main" id="{7C573BB0-4A33-4788-AC87-9DE1B0D34D02}"/>
               </a:ext>
             </a:extLst>
           </p:cNvPr>
@@ -14347,7 +14463,7 @@
     </p:spTree>
     <p:extLst>
       <p:ext uri="{BB962C8B-B14F-4D97-AF65-F5344CB8AC3E}">
-        <p14:creationId xmlns:p14="http://schemas.microsoft.com/office/powerpoint/2010/main" val="1906420444"/>
+        <p14:creationId xmlns:p14="http://schemas.microsoft.com/office/powerpoint/2010/main" val="979313966"/>
       </p:ext>
     </p:extLst>
   </p:cSld>
@@ -14378,7 +14494,7 @@
           <p:cNvPr id="15" name="">
             <a:extLst xmlns:a="http://schemas.openxmlformats.org/drawingml/2006/main">
               <a:ext uri="{FF2B5EF4-FFF2-40B4-BE49-F238E27FC236}">
-                <a16:creationId xmlns:a16="http://schemas.microsoft.com/office/drawing/2014/main" id="{E7FAA30B-9727-47E2-BD1D-7BAE49D94F02}"/>
+                <a16:creationId xmlns:a16="http://schemas.microsoft.com/office/drawing/2014/main" id="{8207F2B7-491B-4B48-9152-A1C26F1339CC}"/>
               </a:ext>
             </a:extLst>
           </p:cNvPr>
@@ -14411,7 +14527,7 @@
           <p:cNvPr id="2" name="">
             <a:extLst xmlns:a="http://schemas.openxmlformats.org/drawingml/2006/main">
               <a:ext uri="{FF2B5EF4-FFF2-40B4-BE49-F238E27FC236}">
-                <a16:creationId xmlns:a16="http://schemas.microsoft.com/office/drawing/2014/main" id="{7592A9CF-807E-49FC-BAF3-4B77396BB2FF}"/>
+                <a16:creationId xmlns:a16="http://schemas.microsoft.com/office/drawing/2014/main" id="{9F8ED8BB-B718-4D08-B4D2-981BB449527E}"/>
               </a:ext>
             </a:extLst>
           </p:cNvPr>
@@ -14469,7 +14585,7 @@
           <p:cNvPr id="3" name="">
             <a:extLst xmlns:a="http://schemas.openxmlformats.org/drawingml/2006/main">
               <a:ext uri="{FF2B5EF4-FFF2-40B4-BE49-F238E27FC236}">
-                <a16:creationId xmlns:a16="http://schemas.microsoft.com/office/drawing/2014/main" id="{D8405060-BF4D-4954-A161-E8BCC5B24D4B}"/>
+                <a16:creationId xmlns:a16="http://schemas.microsoft.com/office/drawing/2014/main" id="{3E7204FF-4569-443B-9909-1261E6102809}"/>
               </a:ext>
             </a:extLst>
           </p:cNvPr>
@@ -14527,7 +14643,7 @@
           <p:cNvPr id="4" name="">
             <a:extLst xmlns:a="http://schemas.openxmlformats.org/drawingml/2006/main">
               <a:ext uri="{FF2B5EF4-FFF2-40B4-BE49-F238E27FC236}">
-                <a16:creationId xmlns:a16="http://schemas.microsoft.com/office/drawing/2014/main" id="{DDA24B55-B553-40E1-BA43-111CF587D940}"/>
+                <a16:creationId xmlns:a16="http://schemas.microsoft.com/office/drawing/2014/main" id="{92489F4C-FEE4-4F94-8D00-83EC2E575298}"/>
               </a:ext>
             </a:extLst>
           </p:cNvPr>
@@ -14585,7 +14701,7 @@
           <p:cNvPr id="5" name="">
             <a:extLst xmlns:a="http://schemas.openxmlformats.org/drawingml/2006/main">
               <a:ext uri="{FF2B5EF4-FFF2-40B4-BE49-F238E27FC236}">
-                <a16:creationId xmlns:a16="http://schemas.microsoft.com/office/drawing/2014/main" id="{D11FFC33-6BD5-489E-8FA8-7BCF0559AA91}"/>
+                <a16:creationId xmlns:a16="http://schemas.microsoft.com/office/drawing/2014/main" id="{DA9ACB0B-BFDA-4878-B8A3-4AD439B49455}"/>
               </a:ext>
             </a:extLst>
           </p:cNvPr>
@@ -14616,7 +14732,7 @@
           <p:cNvPr id="6" name="">
             <a:extLst xmlns:a="http://schemas.openxmlformats.org/drawingml/2006/main">
               <a:ext uri="{FF2B5EF4-FFF2-40B4-BE49-F238E27FC236}">
-                <a16:creationId xmlns:a16="http://schemas.microsoft.com/office/drawing/2014/main" id="{AC3D3EFE-95AE-41CA-946B-E444874EC54C}"/>
+                <a16:creationId xmlns:a16="http://schemas.microsoft.com/office/drawing/2014/main" id="{32FD8BCB-A4D5-42D5-AE0B-34EA786DF8CF}"/>
               </a:ext>
             </a:extLst>
           </p:cNvPr>
@@ -14647,7 +14763,7 @@
           <p:cNvPr id="7" name="">
             <a:extLst xmlns:a="http://schemas.openxmlformats.org/drawingml/2006/main">
               <a:ext uri="{FF2B5EF4-FFF2-40B4-BE49-F238E27FC236}">
-                <a16:creationId xmlns:a16="http://schemas.microsoft.com/office/drawing/2014/main" id="{F02979A5-0182-4811-B532-029C141F9203}"/>
+                <a16:creationId xmlns:a16="http://schemas.microsoft.com/office/drawing/2014/main" id="{D4DD4190-7B2E-4FE6-ABFA-94CC1C5B7425}"/>
               </a:ext>
             </a:extLst>
           </p:cNvPr>
@@ -14712,7 +14828,7 @@
         </p:xfrm>
         <a:graphic xmlns:a="http://schemas.openxmlformats.org/drawingml/2006/main">
           <a:graphicData uri="http://schemas.openxmlformats.org/drawingml/2006/chart">
-            <c:chart xmlns:r="http://schemas.openxmlformats.org/officeDocument/2006/relationships" xmlns:c="http://schemas.openxmlformats.org/drawingml/2006/chart" r:id="Rb787c60b10d34c27"/>
+            <c:chart xmlns:r="http://schemas.openxmlformats.org/officeDocument/2006/relationships" xmlns:c="http://schemas.openxmlformats.org/drawingml/2006/chart" r:id="R9721f9cf7a4c466b"/>
           </a:graphicData>
         </a:graphic>
       </p:graphicFrame>
@@ -14721,7 +14837,7 @@
           <p:cNvPr id="9" name="">
             <a:extLst xmlns:a="http://schemas.openxmlformats.org/drawingml/2006/main">
               <a:ext uri="{FF2B5EF4-FFF2-40B4-BE49-F238E27FC236}">
-                <a16:creationId xmlns:a16="http://schemas.microsoft.com/office/drawing/2014/main" id="{62B7357E-CAEC-4110-B5BE-342960BEC2F7}"/>
+                <a16:creationId xmlns:a16="http://schemas.microsoft.com/office/drawing/2014/main" id="{2EBADE8D-BF55-485D-9A92-5601B8919308}"/>
               </a:ext>
             </a:extLst>
           </p:cNvPr>
@@ -14779,7 +14895,7 @@
           <p:cNvPr id="10" name="">
             <a:extLst xmlns:a="http://schemas.openxmlformats.org/drawingml/2006/main">
               <a:ext uri="{FF2B5EF4-FFF2-40B4-BE49-F238E27FC236}">
-                <a16:creationId xmlns:a16="http://schemas.microsoft.com/office/drawing/2014/main" id="{01F434E7-F8E5-4F84-9AF7-D882EB1F2BE0}"/>
+                <a16:creationId xmlns:a16="http://schemas.microsoft.com/office/drawing/2014/main" id="{33210240-4665-4A48-A6C1-8D6409AAF33E}"/>
               </a:ext>
             </a:extLst>
           </p:cNvPr>
@@ -14837,7 +14953,7 @@
           <p:cNvPr id="11" name="">
             <a:extLst xmlns:a="http://schemas.openxmlformats.org/drawingml/2006/main">
               <a:ext uri="{FF2B5EF4-FFF2-40B4-BE49-F238E27FC236}">
-                <a16:creationId xmlns:a16="http://schemas.microsoft.com/office/drawing/2014/main" id="{59EB97BD-3871-4189-A9DB-E4CC7951DDD2}"/>
+                <a16:creationId xmlns:a16="http://schemas.microsoft.com/office/drawing/2014/main" id="{2E9A378F-FA15-4F7B-A27E-4F67C58E75F4}"/>
               </a:ext>
             </a:extLst>
           </p:cNvPr>
@@ -14895,7 +15011,7 @@
           <p:cNvPr id="12" name="">
             <a:extLst xmlns:a="http://schemas.openxmlformats.org/drawingml/2006/main">
               <a:ext uri="{FF2B5EF4-FFF2-40B4-BE49-F238E27FC236}">
-                <a16:creationId xmlns:a16="http://schemas.microsoft.com/office/drawing/2014/main" id="{64F1B6C1-4585-48EE-83B9-0C2374D4D7CF}"/>
+                <a16:creationId xmlns:a16="http://schemas.microsoft.com/office/drawing/2014/main" id="{F9664400-5CC0-4B15-B775-3370D4C7E93B}"/>
               </a:ext>
             </a:extLst>
           </p:cNvPr>
@@ -14953,7 +15069,7 @@
           <p:cNvPr id="13" name="">
             <a:extLst xmlns:a="http://schemas.openxmlformats.org/drawingml/2006/main">
               <a:ext uri="{FF2B5EF4-FFF2-40B4-BE49-F238E27FC236}">
-                <a16:creationId xmlns:a16="http://schemas.microsoft.com/office/drawing/2014/main" id="{5A1464D7-20B3-43AF-9A8C-6944D30C0BB2}"/>
+                <a16:creationId xmlns:a16="http://schemas.microsoft.com/office/drawing/2014/main" id="{3F3984C5-B76D-4231-AA07-0BD1C3FD3C10}"/>
               </a:ext>
             </a:extLst>
           </p:cNvPr>
@@ -15011,7 +15127,7 @@
           <p:cNvPr id="14" name="">
             <a:extLst xmlns:a="http://schemas.openxmlformats.org/drawingml/2006/main">
               <a:ext uri="{FF2B5EF4-FFF2-40B4-BE49-F238E27FC236}">
-                <a16:creationId xmlns:a16="http://schemas.microsoft.com/office/drawing/2014/main" id="{BFE0E263-31C4-4271-B516-F00D7647B5E2}"/>
+                <a16:creationId xmlns:a16="http://schemas.microsoft.com/office/drawing/2014/main" id="{D3DD2B1A-F2FB-4A46-9B5C-7B3B3257BA0F}"/>
               </a:ext>
             </a:extLst>
           </p:cNvPr>
@@ -15067,7 +15183,7 @@
     </p:spTree>
     <p:extLst>
       <p:ext uri="{BB962C8B-B14F-4D97-AF65-F5344CB8AC3E}">
-        <p14:creationId xmlns:p14="http://schemas.microsoft.com/office/powerpoint/2010/main" val="1933111319"/>
+        <p14:creationId xmlns:p14="http://schemas.microsoft.com/office/powerpoint/2010/main" val="141616397"/>
       </p:ext>
     </p:extLst>
   </p:cSld>
@@ -15095,10 +15211,10 @@
       </p:grpSpPr>
       <p:sp>
         <p:nvSpPr>
-          <p:cNvPr id="10" name="">
-            <a:extLst xmlns:a="http://schemas.openxmlformats.org/drawingml/2006/main">
-              <a:ext uri="{FF2B5EF4-FFF2-40B4-BE49-F238E27FC236}">
-                <a16:creationId xmlns:a16="http://schemas.microsoft.com/office/drawing/2014/main" id="{8BA7FB3D-6A63-49F8-8FE5-920CD4E3C65D}"/>
+          <p:cNvPr id="11" name="">
+            <a:extLst xmlns:a="http://schemas.openxmlformats.org/drawingml/2006/main">
+              <a:ext uri="{FF2B5EF4-FFF2-40B4-BE49-F238E27FC236}">
+                <a16:creationId xmlns:a16="http://schemas.microsoft.com/office/drawing/2014/main" id="{8E16DAF1-8B8D-4DDC-8695-F91B56F89807}"/>
               </a:ext>
             </a:extLst>
           </p:cNvPr>
@@ -15131,7 +15247,7 @@
           <p:cNvPr id="2" name="">
             <a:extLst xmlns:a="http://schemas.openxmlformats.org/drawingml/2006/main">
               <a:ext uri="{FF2B5EF4-FFF2-40B4-BE49-F238E27FC236}">
-                <a16:creationId xmlns:a16="http://schemas.microsoft.com/office/drawing/2014/main" id="{C7F52EDE-C4B0-47BD-A924-64D32D82A603}"/>
+                <a16:creationId xmlns:a16="http://schemas.microsoft.com/office/drawing/2014/main" id="{396E090D-59AE-47CE-8D33-AF71D0F672A3}"/>
               </a:ext>
             </a:extLst>
           </p:cNvPr>
@@ -15189,7 +15305,7 @@
           <p:cNvPr id="3" name="">
             <a:extLst xmlns:a="http://schemas.openxmlformats.org/drawingml/2006/main">
               <a:ext uri="{FF2B5EF4-FFF2-40B4-BE49-F238E27FC236}">
-                <a16:creationId xmlns:a16="http://schemas.microsoft.com/office/drawing/2014/main" id="{985AC199-1C9A-4307-B0FD-80A5A66305FD}"/>
+                <a16:creationId xmlns:a16="http://schemas.microsoft.com/office/drawing/2014/main" id="{7465F6E0-C69A-4929-A339-CE0DEEEBD402}"/>
               </a:ext>
             </a:extLst>
           </p:cNvPr>
@@ -15247,7 +15363,7 @@
           <p:cNvPr id="4" name="">
             <a:extLst xmlns:a="http://schemas.openxmlformats.org/drawingml/2006/main">
               <a:ext uri="{FF2B5EF4-FFF2-40B4-BE49-F238E27FC236}">
-                <a16:creationId xmlns:a16="http://schemas.microsoft.com/office/drawing/2014/main" id="{10489640-C6F5-4709-AAE8-BEF804EE7935}"/>
+                <a16:creationId xmlns:a16="http://schemas.microsoft.com/office/drawing/2014/main" id="{CD630FD0-4C44-4C19-AEB3-9FECD2967C20}"/>
               </a:ext>
             </a:extLst>
           </p:cNvPr>
@@ -15295,7 +15411,7 @@
                 <a:ea typeface="Helvetica Neue"/>
                 <a:cs typeface="Helvetica Neue"/>
               </a:rPr>
-              <a:t>Expanded Clinical Model Improves Risk Detection</a:t>
+              <a:t>Use A Staged Modeling Approach</a:t>
             </a:r>
           </a:p>
         </p:txBody>
@@ -15305,7 +15421,7 @@
           <p:cNvPr id="5" name="">
             <a:extLst xmlns:a="http://schemas.openxmlformats.org/drawingml/2006/main">
               <a:ext uri="{FF2B5EF4-FFF2-40B4-BE49-F238E27FC236}">
-                <a16:creationId xmlns:a16="http://schemas.microsoft.com/office/drawing/2014/main" id="{6A646B30-4E57-476F-81A5-654C902DF7ED}"/>
+                <a16:creationId xmlns:a16="http://schemas.microsoft.com/office/drawing/2014/main" id="{81891705-8B35-4603-A19E-3A61EA805B30}"/>
               </a:ext>
             </a:extLst>
           </p:cNvPr>
@@ -15336,7 +15452,7 @@
           <p:cNvPr id="6" name="">
             <a:extLst xmlns:a="http://schemas.openxmlformats.org/drawingml/2006/main">
               <a:ext uri="{FF2B5EF4-FFF2-40B4-BE49-F238E27FC236}">
-                <a16:creationId xmlns:a16="http://schemas.microsoft.com/office/drawing/2014/main" id="{E1F819A5-6ED7-4321-8202-85977E35C191}"/>
+                <a16:creationId xmlns:a16="http://schemas.microsoft.com/office/drawing/2014/main" id="{A5293AB6-7744-4359-AE2E-EEC31D76A7E0}"/>
               </a:ext>
             </a:extLst>
           </p:cNvPr>
@@ -15367,7 +15483,7 @@
           <p:cNvPr id="7" name="">
             <a:extLst xmlns:a="http://schemas.openxmlformats.org/drawingml/2006/main">
               <a:ext uri="{FF2B5EF4-FFF2-40B4-BE49-F238E27FC236}">
-                <a16:creationId xmlns:a16="http://schemas.microsoft.com/office/drawing/2014/main" id="{091909FC-33CF-4104-943B-0EEF1B5C13B3}"/>
+                <a16:creationId xmlns:a16="http://schemas.microsoft.com/office/drawing/2014/main" id="{6CA5B1EB-56BD-4B9E-AB84-AC9344388800}"/>
               </a:ext>
             </a:extLst>
           </p:cNvPr>
@@ -15422,7 +15538,7 @@
       </p:sp>
       <p:graphicFrame>
         <p:nvGraphicFramePr>
-          <p:cNvPr id="17" name="Chart"/>
+          <p:cNvPr id="18" name="Chart"/>
           <p:cNvGraphicFramePr/>
           <p:nvPr/>
         </p:nvGraphicFramePr>
@@ -15432,13 +15548,13 @@
         </p:xfrm>
         <a:graphic xmlns:a="http://schemas.openxmlformats.org/drawingml/2006/main">
           <a:graphicData uri="http://schemas.openxmlformats.org/drawingml/2006/chart">
-            <c:chart xmlns:r="http://schemas.openxmlformats.org/officeDocument/2006/relationships" xmlns:c="http://schemas.openxmlformats.org/drawingml/2006/chart" r:id="R54b286d63c6e4923"/>
+            <c:chart xmlns:r="http://schemas.openxmlformats.org/officeDocument/2006/relationships" xmlns:c="http://schemas.openxmlformats.org/drawingml/2006/chart" r:id="Rb8315d8531af466d"/>
           </a:graphicData>
         </a:graphic>
       </p:graphicFrame>
       <p:graphicFrame>
         <p:nvGraphicFramePr>
-          <p:cNvPr id="18" name=""/>
+          <p:cNvPr id="19" name=""/>
           <p:cNvGraphicFramePr/>
           <p:nvPr/>
         </p:nvGraphicFramePr>
@@ -15760,10 +15876,68 @@
           </a:graphicData>
         </a:graphic>
       </p:graphicFrame>
+      <p:sp>
+        <p:nvSpPr>
+          <p:cNvPr id="10" name="">
+            <a:extLst xmlns:a="http://schemas.openxmlformats.org/drawingml/2006/main">
+              <a:ext uri="{FF2B5EF4-FFF2-40B4-BE49-F238E27FC236}">
+                <a16:creationId xmlns:a16="http://schemas.microsoft.com/office/drawing/2014/main" id="{2822DFFE-D974-490F-AC86-E9C2CDE3CCB3}"/>
+              </a:ext>
+            </a:extLst>
+          </p:cNvPr>
+          <p:cNvSpPr>
+            <a:spLocks xmlns:a="http://schemas.openxmlformats.org/drawingml/2006/main" noGrp="1"/>
+          </p:cNvSpPr>
+          <p:nvPr/>
+        </p:nvSpPr>
+        <p:spPr>
+          <a:xfrm xmlns:a="http://schemas.openxmlformats.org/drawingml/2006/main">
+            <a:off x="6991350" y="5219700"/>
+            <a:ext cx="4000500" cy="419100"/>
+          </a:xfrm>
+          <a:prstGeom xmlns:a="http://schemas.openxmlformats.org/drawingml/2006/main" prst="rect">
+            <a:avLst/>
+          </a:prstGeom>
+          <a:noFill xmlns:a="http://schemas.openxmlformats.org/drawingml/2006/main"/>
+          <a:ln xmlns:a="http://schemas.openxmlformats.org/drawingml/2006/main" w="0">
+            <a:noFill/>
+            <a:prstDash val="solid"/>
+          </a:ln>
+        </p:spPr>
+        <p:txBody>
+          <a:bodyPr xmlns:a="http://schemas.openxmlformats.org/drawingml/2006/main">
+            <a:normAutofit fontScale="84314"/>
+          </a:bodyPr>
+          <a:lstStyle xmlns:a="http://schemas.openxmlformats.org/drawingml/2006/main"/>
+          <a:p xmlns:a="http://schemas.openxmlformats.org/drawingml/2006/main">
+            <a:pPr algn="ctr">
+              <a:defRPr sz="1275" b="1">
+                <a:solidFill>
+                  <a:srgbClr val="0B6F75"/>
+                </a:solidFill>
+                <a:latin typeface="Helvetica Neue"/>
+                <a:ea typeface="Helvetica Neue"/>
+                <a:cs typeface="Helvetica Neue"/>
+              </a:defRPr>
+            </a:pPr>
+            <a:r>
+              <a:rPr sz="1275" b="1">
+                <a:solidFill>
+                  <a:srgbClr val="0B6F75"/>
+                </a:solidFill>
+                <a:latin typeface="Helvetica Neue"/>
+                <a:ea typeface="Helvetica Neue"/>
+                <a:cs typeface="Helvetica Neue"/>
+              </a:rPr>
+              <a:t>Use model output as one layer in a broader risk workflow, not as the only decision rule.</a:t>
+            </a:r>
+          </a:p>
+        </p:txBody>
+      </p:sp>
     </p:spTree>
     <p:extLst>
       <p:ext uri="{BB962C8B-B14F-4D97-AF65-F5344CB8AC3E}">
-        <p14:creationId xmlns:p14="http://schemas.microsoft.com/office/powerpoint/2010/main" val="921548648"/>
+        <p14:creationId xmlns:p14="http://schemas.microsoft.com/office/powerpoint/2010/main" val="1570559966"/>
       </p:ext>
     </p:extLst>
   </p:cSld>
@@ -15794,7 +15968,7 @@
           <p:cNvPr id="13" name="">
             <a:extLst xmlns:a="http://schemas.openxmlformats.org/drawingml/2006/main">
               <a:ext uri="{FF2B5EF4-FFF2-40B4-BE49-F238E27FC236}">
-                <a16:creationId xmlns:a16="http://schemas.microsoft.com/office/drawing/2014/main" id="{32A65A2D-963F-4478-A9F0-B2966C00AC43}"/>
+                <a16:creationId xmlns:a16="http://schemas.microsoft.com/office/drawing/2014/main" id="{1935A2AD-E8B9-49C6-B3C5-7C8BDFB4B64A}"/>
               </a:ext>
             </a:extLst>
           </p:cNvPr>
@@ -15827,7 +16001,7 @@
           <p:cNvPr id="2" name="">
             <a:extLst xmlns:a="http://schemas.openxmlformats.org/drawingml/2006/main">
               <a:ext uri="{FF2B5EF4-FFF2-40B4-BE49-F238E27FC236}">
-                <a16:creationId xmlns:a16="http://schemas.microsoft.com/office/drawing/2014/main" id="{BED880B1-8357-4B76-A270-79EA0435A5F0}"/>
+                <a16:creationId xmlns:a16="http://schemas.microsoft.com/office/drawing/2014/main" id="{5690E54C-EE41-41FD-B834-776B67B67635}"/>
               </a:ext>
             </a:extLst>
           </p:cNvPr>
@@ -15885,7 +16059,7 @@
           <p:cNvPr id="3" name="">
             <a:extLst xmlns:a="http://schemas.openxmlformats.org/drawingml/2006/main">
               <a:ext uri="{FF2B5EF4-FFF2-40B4-BE49-F238E27FC236}">
-                <a16:creationId xmlns:a16="http://schemas.microsoft.com/office/drawing/2014/main" id="{F3000E12-FA1A-4DA2-86D2-0228F68D34AF}"/>
+                <a16:creationId xmlns:a16="http://schemas.microsoft.com/office/drawing/2014/main" id="{DECBFD0E-D23E-4DA3-8644-FD9F0D6D517E}"/>
               </a:ext>
             </a:extLst>
           </p:cNvPr>
@@ -15943,7 +16117,7 @@
           <p:cNvPr id="4" name="">
             <a:extLst xmlns:a="http://schemas.openxmlformats.org/drawingml/2006/main">
               <a:ext uri="{FF2B5EF4-FFF2-40B4-BE49-F238E27FC236}">
-                <a16:creationId xmlns:a16="http://schemas.microsoft.com/office/drawing/2014/main" id="{9AE905B5-59F3-4E1E-A52C-059F9578119D}"/>
+                <a16:creationId xmlns:a16="http://schemas.microsoft.com/office/drawing/2014/main" id="{E115C2FC-DEC4-4982-AD2F-199E1582AEF7}"/>
               </a:ext>
             </a:extLst>
           </p:cNvPr>
@@ -16001,7 +16175,7 @@
           <p:cNvPr id="5" name="">
             <a:extLst xmlns:a="http://schemas.openxmlformats.org/drawingml/2006/main">
               <a:ext uri="{FF2B5EF4-FFF2-40B4-BE49-F238E27FC236}">
-                <a16:creationId xmlns:a16="http://schemas.microsoft.com/office/drawing/2014/main" id="{088DE4B1-1CF3-41C3-B148-06869691C151}"/>
+                <a16:creationId xmlns:a16="http://schemas.microsoft.com/office/drawing/2014/main" id="{6D90D2AD-CAA7-426C-ADBA-D0A47ECF33DB}"/>
               </a:ext>
             </a:extLst>
           </p:cNvPr>
@@ -16032,7 +16206,7 @@
           <p:cNvPr id="6" name="">
             <a:extLst xmlns:a="http://schemas.openxmlformats.org/drawingml/2006/main">
               <a:ext uri="{FF2B5EF4-FFF2-40B4-BE49-F238E27FC236}">
-                <a16:creationId xmlns:a16="http://schemas.microsoft.com/office/drawing/2014/main" id="{DD50A5CA-4305-4765-A80A-527072AC4278}"/>
+                <a16:creationId xmlns:a16="http://schemas.microsoft.com/office/drawing/2014/main" id="{627E2D98-622C-45D7-9D1A-8B60B759F99F}"/>
               </a:ext>
             </a:extLst>
           </p:cNvPr>
@@ -16063,7 +16237,7 @@
           <p:cNvPr id="7" name="">
             <a:extLst xmlns:a="http://schemas.openxmlformats.org/drawingml/2006/main">
               <a:ext uri="{FF2B5EF4-FFF2-40B4-BE49-F238E27FC236}">
-                <a16:creationId xmlns:a16="http://schemas.microsoft.com/office/drawing/2014/main" id="{3A5DB549-0155-4543-9BB0-C3C00001A360}"/>
+                <a16:creationId xmlns:a16="http://schemas.microsoft.com/office/drawing/2014/main" id="{FDC10387-D5EE-4F48-8231-407ABA44F2C8}"/>
               </a:ext>
             </a:extLst>
           </p:cNvPr>
@@ -16128,7 +16302,7 @@
         </p:xfrm>
         <a:graphic xmlns:a="http://schemas.openxmlformats.org/drawingml/2006/main">
           <a:graphicData uri="http://schemas.openxmlformats.org/drawingml/2006/chart">
-            <c:chart xmlns:r="http://schemas.openxmlformats.org/officeDocument/2006/relationships" xmlns:c="http://schemas.openxmlformats.org/drawingml/2006/chart" r:id="R5e4afa9698eb448a"/>
+            <c:chart xmlns:r="http://schemas.openxmlformats.org/officeDocument/2006/relationships" xmlns:c="http://schemas.openxmlformats.org/drawingml/2006/chart" r:id="Rb587a4e4d1664521"/>
           </a:graphicData>
         </a:graphic>
       </p:graphicFrame>
@@ -16137,7 +16311,7 @@
           <p:cNvPr id="9" name="">
             <a:extLst xmlns:a="http://schemas.openxmlformats.org/drawingml/2006/main">
               <a:ext uri="{FF2B5EF4-FFF2-40B4-BE49-F238E27FC236}">
-                <a16:creationId xmlns:a16="http://schemas.microsoft.com/office/drawing/2014/main" id="{A322B02A-DF32-4961-9F3D-44E23A7827A6}"/>
+                <a16:creationId xmlns:a16="http://schemas.microsoft.com/office/drawing/2014/main" id="{9DD422AD-2352-4EC6-A825-0BABCFA6AD2C}"/>
               </a:ext>
             </a:extLst>
           </p:cNvPr>
@@ -16170,7 +16344,7 @@
           <p:cNvPr id="10" name="">
             <a:extLst xmlns:a="http://schemas.openxmlformats.org/drawingml/2006/main">
               <a:ext uri="{FF2B5EF4-FFF2-40B4-BE49-F238E27FC236}">
-                <a16:creationId xmlns:a16="http://schemas.microsoft.com/office/drawing/2014/main" id="{0E253385-CDA6-434C-B9C9-8661211171E6}"/>
+                <a16:creationId xmlns:a16="http://schemas.microsoft.com/office/drawing/2014/main" id="{87E7E831-3E28-4AB9-B3E2-B69135B5012A}"/>
               </a:ext>
             </a:extLst>
           </p:cNvPr>
@@ -16228,7 +16402,7 @@
           <p:cNvPr id="11" name="">
             <a:extLst xmlns:a="http://schemas.openxmlformats.org/drawingml/2006/main">
               <a:ext uri="{FF2B5EF4-FFF2-40B4-BE49-F238E27FC236}">
-                <a16:creationId xmlns:a16="http://schemas.microsoft.com/office/drawing/2014/main" id="{8E793E1A-8E61-433C-BE81-F4C0AA3603BF}"/>
+                <a16:creationId xmlns:a16="http://schemas.microsoft.com/office/drawing/2014/main" id="{8224014D-3D33-4530-850B-11FF00A98155}"/>
               </a:ext>
             </a:extLst>
           </p:cNvPr>
@@ -16253,7 +16427,7 @@
         </p:spPr>
         <p:txBody>
           <a:bodyPr xmlns:a="http://schemas.openxmlformats.org/drawingml/2006/main">
-            <a:normAutofit fontScale="95088"/>
+            <a:normAutofit fontScale="87866"/>
           </a:bodyPr>
           <a:lstStyle xmlns:a="http://schemas.openxmlformats.org/drawingml/2006/main"/>
           <a:p xmlns:a="http://schemas.openxmlformats.org/drawingml/2006/main">
@@ -16276,7 +16450,7 @@
                 <a:ea typeface="Helvetica Neue"/>
                 <a:cs typeface="Helvetica Neue"/>
               </a:rPr>
-              <a:t>Start with deciles 8-10 for enhanced discharge review, then tune capacity thresholds with care coordination leadership.</a:t>
+              <a:t>Start with deciles 8-10 plus clinical rules for repeat admissions, chronic burden, emergency admission, and skilled nursing discharge.</a:t>
             </a:r>
           </a:p>
         </p:txBody>
@@ -16286,7 +16460,7 @@
           <p:cNvPr id="12" name="">
             <a:extLst xmlns:a="http://schemas.openxmlformats.org/drawingml/2006/main">
               <a:ext uri="{FF2B5EF4-FFF2-40B4-BE49-F238E27FC236}">
-                <a16:creationId xmlns:a16="http://schemas.microsoft.com/office/drawing/2014/main" id="{647C7832-F0FE-427A-B422-80B7381D5955}"/>
+                <a16:creationId xmlns:a16="http://schemas.microsoft.com/office/drawing/2014/main" id="{37A12535-9153-4DF5-B687-31013935C795}"/>
               </a:ext>
             </a:extLst>
           </p:cNvPr>
@@ -16342,7 +16516,7 @@
     </p:spTree>
     <p:extLst>
       <p:ext uri="{BB962C8B-B14F-4D97-AF65-F5344CB8AC3E}">
-        <p14:creationId xmlns:p14="http://schemas.microsoft.com/office/powerpoint/2010/main" val="814002410"/>
+        <p14:creationId xmlns:p14="http://schemas.microsoft.com/office/powerpoint/2010/main" val="1189871397"/>
       </p:ext>
     </p:extLst>
   </p:cSld>
@@ -16373,7 +16547,7 @@
           <p:cNvPr id="15" name="">
             <a:extLst xmlns:a="http://schemas.openxmlformats.org/drawingml/2006/main">
               <a:ext uri="{FF2B5EF4-FFF2-40B4-BE49-F238E27FC236}">
-                <a16:creationId xmlns:a16="http://schemas.microsoft.com/office/drawing/2014/main" id="{5BDF4BE7-D3AF-4AB4-A14A-D75074A79ED5}"/>
+                <a16:creationId xmlns:a16="http://schemas.microsoft.com/office/drawing/2014/main" id="{1CB6E78B-4A7C-422D-9F61-143308BB5A75}"/>
               </a:ext>
             </a:extLst>
           </p:cNvPr>
@@ -16406,7 +16580,7 @@
           <p:cNvPr id="2" name="">
             <a:extLst xmlns:a="http://schemas.openxmlformats.org/drawingml/2006/main">
               <a:ext uri="{FF2B5EF4-FFF2-40B4-BE49-F238E27FC236}">
-                <a16:creationId xmlns:a16="http://schemas.microsoft.com/office/drawing/2014/main" id="{206C5F30-6C14-4980-9410-9FE02E7DCD0C}"/>
+                <a16:creationId xmlns:a16="http://schemas.microsoft.com/office/drawing/2014/main" id="{5D64EA10-E126-4DEC-8A95-0C089803DA42}"/>
               </a:ext>
             </a:extLst>
           </p:cNvPr>
@@ -16464,7 +16638,7 @@
           <p:cNvPr id="3" name="">
             <a:extLst xmlns:a="http://schemas.openxmlformats.org/drawingml/2006/main">
               <a:ext uri="{FF2B5EF4-FFF2-40B4-BE49-F238E27FC236}">
-                <a16:creationId xmlns:a16="http://schemas.microsoft.com/office/drawing/2014/main" id="{06C1BDA8-474B-4C81-9B1F-B30EC357A7B9}"/>
+                <a16:creationId xmlns:a16="http://schemas.microsoft.com/office/drawing/2014/main" id="{FCE77B2A-B9FA-4DFD-BA6C-2FFE7AF71400}"/>
               </a:ext>
             </a:extLst>
           </p:cNvPr>
@@ -16522,7 +16696,7 @@
           <p:cNvPr id="4" name="">
             <a:extLst xmlns:a="http://schemas.openxmlformats.org/drawingml/2006/main">
               <a:ext uri="{FF2B5EF4-FFF2-40B4-BE49-F238E27FC236}">
-                <a16:creationId xmlns:a16="http://schemas.microsoft.com/office/drawing/2014/main" id="{EC2DE8DA-BB46-41E8-8078-598AA240E228}"/>
+                <a16:creationId xmlns:a16="http://schemas.microsoft.com/office/drawing/2014/main" id="{26CBED8C-0689-4004-A084-5850EA24C509}"/>
               </a:ext>
             </a:extLst>
           </p:cNvPr>
@@ -16570,7 +16744,7 @@
                 <a:ea typeface="Helvetica Neue"/>
                 <a:cs typeface="Helvetica Neue"/>
               </a:rPr>
-              <a:t>Care Coordination Results Need Causal Caution</a:t>
+              <a:t>Redesign Targeting And Timing</a:t>
             </a:r>
           </a:p>
         </p:txBody>
@@ -16580,7 +16754,7 @@
           <p:cNvPr id="5" name="">
             <a:extLst xmlns:a="http://schemas.openxmlformats.org/drawingml/2006/main">
               <a:ext uri="{FF2B5EF4-FFF2-40B4-BE49-F238E27FC236}">
-                <a16:creationId xmlns:a16="http://schemas.microsoft.com/office/drawing/2014/main" id="{55188167-EC8D-40D7-8908-9BD60877477A}"/>
+                <a16:creationId xmlns:a16="http://schemas.microsoft.com/office/drawing/2014/main" id="{A41B576F-4D16-403C-AABB-4CC5C8C682AE}"/>
               </a:ext>
             </a:extLst>
           </p:cNvPr>
@@ -16611,7 +16785,7 @@
           <p:cNvPr id="6" name="">
             <a:extLst xmlns:a="http://schemas.openxmlformats.org/drawingml/2006/main">
               <a:ext uri="{FF2B5EF4-FFF2-40B4-BE49-F238E27FC236}">
-                <a16:creationId xmlns:a16="http://schemas.microsoft.com/office/drawing/2014/main" id="{0C8F3BB7-3E63-4796-A64D-920B15DC4174}"/>
+                <a16:creationId xmlns:a16="http://schemas.microsoft.com/office/drawing/2014/main" id="{2A039B33-72D9-4FBE-A94D-07020B1BC1F6}"/>
               </a:ext>
             </a:extLst>
           </p:cNvPr>
@@ -16642,7 +16816,7 @@
           <p:cNvPr id="7" name="">
             <a:extLst xmlns:a="http://schemas.openxmlformats.org/drawingml/2006/main">
               <a:ext uri="{FF2B5EF4-FFF2-40B4-BE49-F238E27FC236}">
-                <a16:creationId xmlns:a16="http://schemas.microsoft.com/office/drawing/2014/main" id="{3155BF2B-C3F0-425F-8B3A-757286C76D0E}"/>
+                <a16:creationId xmlns:a16="http://schemas.microsoft.com/office/drawing/2014/main" id="{BA5B6B7D-F5EE-41E1-A6D5-65D7ECA49BC3}"/>
               </a:ext>
             </a:extLst>
           </p:cNvPr>
@@ -16707,7 +16881,7 @@
         </p:xfrm>
         <a:graphic xmlns:a="http://schemas.openxmlformats.org/drawingml/2006/main">
           <a:graphicData uri="http://schemas.openxmlformats.org/drawingml/2006/chart">
-            <c:chart xmlns:r="http://schemas.openxmlformats.org/officeDocument/2006/relationships" xmlns:c="http://schemas.openxmlformats.org/drawingml/2006/chart" r:id="Rb44fde82380842ff"/>
+            <c:chart xmlns:r="http://schemas.openxmlformats.org/officeDocument/2006/relationships" xmlns:c="http://schemas.openxmlformats.org/drawingml/2006/chart" r:id="R9e8de37064ee42e4"/>
           </a:graphicData>
         </a:graphic>
       </p:graphicFrame>
@@ -16716,7 +16890,7 @@
           <p:cNvPr id="9" name="">
             <a:extLst xmlns:a="http://schemas.openxmlformats.org/drawingml/2006/main">
               <a:ext uri="{FF2B5EF4-FFF2-40B4-BE49-F238E27FC236}">
-                <a16:creationId xmlns:a16="http://schemas.microsoft.com/office/drawing/2014/main" id="{6A27BEAE-D48A-41C8-B322-E332A9DACCE5}"/>
+                <a16:creationId xmlns:a16="http://schemas.microsoft.com/office/drawing/2014/main" id="{9681EA5F-4829-45F1-8206-D17127E7C722}"/>
               </a:ext>
             </a:extLst>
           </p:cNvPr>
@@ -16774,7 +16948,7 @@
           <p:cNvPr id="10" name="">
             <a:extLst xmlns:a="http://schemas.openxmlformats.org/drawingml/2006/main">
               <a:ext uri="{FF2B5EF4-FFF2-40B4-BE49-F238E27FC236}">
-                <a16:creationId xmlns:a16="http://schemas.microsoft.com/office/drawing/2014/main" id="{8DA1D747-C62D-4A01-9910-608730CE9733}"/>
+                <a16:creationId xmlns:a16="http://schemas.microsoft.com/office/drawing/2014/main" id="{80095EFC-5566-4DE2-B08E-B739882845DB}"/>
               </a:ext>
             </a:extLst>
           </p:cNvPr>
@@ -16832,7 +17006,7 @@
           <p:cNvPr id="11" name="">
             <a:extLst xmlns:a="http://schemas.openxmlformats.org/drawingml/2006/main">
               <a:ext uri="{FF2B5EF4-FFF2-40B4-BE49-F238E27FC236}">
-                <a16:creationId xmlns:a16="http://schemas.microsoft.com/office/drawing/2014/main" id="{24A54CBD-0F3F-47CD-909B-522E8D8B035D}"/>
+                <a16:creationId xmlns:a16="http://schemas.microsoft.com/office/drawing/2014/main" id="{E34F8325-2951-4854-8CCD-6CA143C5A8EA}"/>
               </a:ext>
             </a:extLst>
           </p:cNvPr>
@@ -16890,7 +17064,7 @@
           <p:cNvPr id="12" name="">
             <a:extLst xmlns:a="http://schemas.openxmlformats.org/drawingml/2006/main">
               <a:ext uri="{FF2B5EF4-FFF2-40B4-BE49-F238E27FC236}">
-                <a16:creationId xmlns:a16="http://schemas.microsoft.com/office/drawing/2014/main" id="{264CFABA-0CA4-4620-9D87-9713C7E7E93B}"/>
+                <a16:creationId xmlns:a16="http://schemas.microsoft.com/office/drawing/2014/main" id="{85E5AEC0-404C-4895-8F1C-586F93AE3561}"/>
               </a:ext>
             </a:extLst>
           </p:cNvPr>
@@ -16938,7 +17112,7 @@
                 <a:ea typeface="Helvetica Neue"/>
                 <a:cs typeface="Helvetica Neue"/>
               </a:rPr>
-              <a:t>Higher-risk patients may receive more support, which can lift raw intervention readmission rates.</a:t>
+              <a:t>Selection bias strengthens the case for better targeting and earlier intervention timing.</a:t>
             </a:r>
           </a:p>
         </p:txBody>
@@ -16948,7 +17122,7 @@
           <p:cNvPr id="13" name="">
             <a:extLst xmlns:a="http://schemas.openxmlformats.org/drawingml/2006/main">
               <a:ext uri="{FF2B5EF4-FFF2-40B4-BE49-F238E27FC236}">
-                <a16:creationId xmlns:a16="http://schemas.microsoft.com/office/drawing/2014/main" id="{1D02A7C7-EF15-43EB-A361-2D2ABD3F3197}"/>
+                <a16:creationId xmlns:a16="http://schemas.microsoft.com/office/drawing/2014/main" id="{C9D467AD-E45E-41C8-B22E-70DF7018BE17}"/>
               </a:ext>
             </a:extLst>
           </p:cNvPr>
@@ -17006,7 +17180,7 @@
           <p:cNvPr id="14" name="">
             <a:extLst xmlns:a="http://schemas.openxmlformats.org/drawingml/2006/main">
               <a:ext uri="{FF2B5EF4-FFF2-40B4-BE49-F238E27FC236}">
-                <a16:creationId xmlns:a16="http://schemas.microsoft.com/office/drawing/2014/main" id="{679A48CB-6EA0-4640-BE15-CBE5814C2FEF}"/>
+                <a16:creationId xmlns:a16="http://schemas.microsoft.com/office/drawing/2014/main" id="{6F4C45E9-665B-43EC-8E2A-FF2525E21B57}"/>
               </a:ext>
             </a:extLst>
           </p:cNvPr>
@@ -17054,7 +17228,7 @@
                 <a:ea typeface="Helvetica Neue"/>
                 <a:cs typeface="Helvetica Neue"/>
               </a:rPr>
-              <a:t>Priority should be timing, targeting, and completion for patients with high pre-discharge risk.</a:t>
+              <a:t>Priority should be broad high-risk coverage, completion tracking, and redesign of intervention assignment rules.</a:t>
             </a:r>
           </a:p>
         </p:txBody>
@@ -17062,7 +17236,7 @@
     </p:spTree>
     <p:extLst>
       <p:ext uri="{BB962C8B-B14F-4D97-AF65-F5344CB8AC3E}">
-        <p14:creationId xmlns:p14="http://schemas.microsoft.com/office/powerpoint/2010/main" val="1208862108"/>
+        <p14:creationId xmlns:p14="http://schemas.microsoft.com/office/powerpoint/2010/main" val="1451116441"/>
       </p:ext>
     </p:extLst>
   </p:cSld>
@@ -17093,7 +17267,7 @@
           <p:cNvPr id="11" name="">
             <a:extLst xmlns:a="http://schemas.openxmlformats.org/drawingml/2006/main">
               <a:ext uri="{FF2B5EF4-FFF2-40B4-BE49-F238E27FC236}">
-                <a16:creationId xmlns:a16="http://schemas.microsoft.com/office/drawing/2014/main" id="{B11DBB1E-B39C-47CE-B743-D2B864799AEB}"/>
+                <a16:creationId xmlns:a16="http://schemas.microsoft.com/office/drawing/2014/main" id="{87F314C6-2469-448A-9F3D-04BBB4CE6EE7}"/>
               </a:ext>
             </a:extLst>
           </p:cNvPr>
@@ -17126,7 +17300,7 @@
           <p:cNvPr id="2" name="">
             <a:extLst xmlns:a="http://schemas.openxmlformats.org/drawingml/2006/main">
               <a:ext uri="{FF2B5EF4-FFF2-40B4-BE49-F238E27FC236}">
-                <a16:creationId xmlns:a16="http://schemas.microsoft.com/office/drawing/2014/main" id="{154032C2-88E3-4A8C-BCF3-6471FDD9AA12}"/>
+                <a16:creationId xmlns:a16="http://schemas.microsoft.com/office/drawing/2014/main" id="{A9EF3B88-C182-4F3D-A5A2-E374FD0BEADA}"/>
               </a:ext>
             </a:extLst>
           </p:cNvPr>
@@ -17184,7 +17358,7 @@
           <p:cNvPr id="3" name="">
             <a:extLst xmlns:a="http://schemas.openxmlformats.org/drawingml/2006/main">
               <a:ext uri="{FF2B5EF4-FFF2-40B4-BE49-F238E27FC236}">
-                <a16:creationId xmlns:a16="http://schemas.microsoft.com/office/drawing/2014/main" id="{A75BEFFC-BC5C-49D4-ADF7-F2BF03B052CA}"/>
+                <a16:creationId xmlns:a16="http://schemas.microsoft.com/office/drawing/2014/main" id="{8C6A9FE8-184C-43D8-9CD1-789FE22A44AF}"/>
               </a:ext>
             </a:extLst>
           </p:cNvPr>
@@ -17242,7 +17416,7 @@
           <p:cNvPr id="4" name="">
             <a:extLst xmlns:a="http://schemas.openxmlformats.org/drawingml/2006/main">
               <a:ext uri="{FF2B5EF4-FFF2-40B4-BE49-F238E27FC236}">
-                <a16:creationId xmlns:a16="http://schemas.microsoft.com/office/drawing/2014/main" id="{E0F760E7-E9EB-4CDB-AE40-C34D9174AE7B}"/>
+                <a16:creationId xmlns:a16="http://schemas.microsoft.com/office/drawing/2014/main" id="{6478654B-9E78-4263-8E63-A5D2F239ADB7}"/>
               </a:ext>
             </a:extLst>
           </p:cNvPr>
@@ -17300,7 +17474,7 @@
           <p:cNvPr id="5" name="">
             <a:extLst xmlns:a="http://schemas.openxmlformats.org/drawingml/2006/main">
               <a:ext uri="{FF2B5EF4-FFF2-40B4-BE49-F238E27FC236}">
-                <a16:creationId xmlns:a16="http://schemas.microsoft.com/office/drawing/2014/main" id="{0985ACB8-EB7B-4DE1-B662-0E35BF70F08C}"/>
+                <a16:creationId xmlns:a16="http://schemas.microsoft.com/office/drawing/2014/main" id="{F5D58281-A65B-4619-A8B9-455E6E0BFA95}"/>
               </a:ext>
             </a:extLst>
           </p:cNvPr>
@@ -17331,7 +17505,7 @@
           <p:cNvPr id="6" name="">
             <a:extLst xmlns:a="http://schemas.openxmlformats.org/drawingml/2006/main">
               <a:ext uri="{FF2B5EF4-FFF2-40B4-BE49-F238E27FC236}">
-                <a16:creationId xmlns:a16="http://schemas.microsoft.com/office/drawing/2014/main" id="{FEEBF4D9-5452-4BAE-9A93-22172CDFD82B}"/>
+                <a16:creationId xmlns:a16="http://schemas.microsoft.com/office/drawing/2014/main" id="{3DB16A33-3C87-4DF5-81C7-203D460DDFBC}"/>
               </a:ext>
             </a:extLst>
           </p:cNvPr>
@@ -17362,7 +17536,7 @@
           <p:cNvPr id="7" name="">
             <a:extLst xmlns:a="http://schemas.openxmlformats.org/drawingml/2006/main">
               <a:ext uri="{FF2B5EF4-FFF2-40B4-BE49-F238E27FC236}">
-                <a16:creationId xmlns:a16="http://schemas.microsoft.com/office/drawing/2014/main" id="{90F32EA2-673D-4E6D-AE90-D459CF0E371B}"/>
+                <a16:creationId xmlns:a16="http://schemas.microsoft.com/office/drawing/2014/main" id="{D6834F27-DD74-4A03-BF9F-823FD1137D21}"/>
               </a:ext>
             </a:extLst>
           </p:cNvPr>
@@ -17427,7 +17601,7 @@
         </p:xfrm>
         <a:graphic xmlns:a="http://schemas.openxmlformats.org/drawingml/2006/main">
           <a:graphicData uri="http://schemas.openxmlformats.org/drawingml/2006/chart">
-            <c:chart xmlns:r="http://schemas.openxmlformats.org/officeDocument/2006/relationships" xmlns:c="http://schemas.openxmlformats.org/drawingml/2006/chart" r:id="R253b0d3fc98a41de"/>
+            <c:chart xmlns:r="http://schemas.openxmlformats.org/officeDocument/2006/relationships" xmlns:c="http://schemas.openxmlformats.org/drawingml/2006/chart" r:id="R89c126d5e70e412f"/>
           </a:graphicData>
         </a:graphic>
       </p:graphicFrame>
@@ -17722,7 +17896,7 @@
           <p:cNvPr id="10" name="">
             <a:extLst xmlns:a="http://schemas.openxmlformats.org/drawingml/2006/main">
               <a:ext uri="{FF2B5EF4-FFF2-40B4-BE49-F238E27FC236}">
-                <a16:creationId xmlns:a16="http://schemas.microsoft.com/office/drawing/2014/main" id="{B4CD6514-0F7F-4698-92DB-1E97831B76CB}"/>
+                <a16:creationId xmlns:a16="http://schemas.microsoft.com/office/drawing/2014/main" id="{FA70C294-BC8A-438C-B86A-183B2FC556AC}"/>
               </a:ext>
             </a:extLst>
           </p:cNvPr>
@@ -17778,7 +17952,7 @@
     </p:spTree>
     <p:extLst>
       <p:ext uri="{BB962C8B-B14F-4D97-AF65-F5344CB8AC3E}">
-        <p14:creationId xmlns:p14="http://schemas.microsoft.com/office/powerpoint/2010/main" val="88796667"/>
+        <p14:creationId xmlns:p14="http://schemas.microsoft.com/office/powerpoint/2010/main" val="497804570"/>
       </p:ext>
     </p:extLst>
   </p:cSld>

</xml_diff>

<commit_message>
Update board presentation and Tableau deliverables
</commit_message>
<xml_diff>
--- a/deliverables/07_executive_board_presentation/final/nhn_readmission_board_presentation.pptx
+++ b/deliverables/07_executive_board_presentation/final/nhn_readmission_board_presentation.pptx
@@ -2,27 +2,28 @@
 <file path=ppt/presentation.xml><?xml version="1.0" encoding="utf-8"?>
 <p:presentation xmlns:p="http://schemas.openxmlformats.org/presentationml/2006/main">
   <p:sldMasterIdLst>
-    <p:sldMasterId xmlns:r="http://schemas.openxmlformats.org/officeDocument/2006/relationships" id="2147483648" r:id="Re65559a9d94a4ecf"/>
+    <p:sldMasterId xmlns:r="http://schemas.openxmlformats.org/officeDocument/2006/relationships" id="2147483648" r:id="R3a8c7291d28645b7"/>
   </p:sldMasterIdLst>
   <p:notesMasterIdLst>
-    <p:notesMasterId xmlns:r="http://schemas.openxmlformats.org/officeDocument/2006/relationships" r:id="R057a2977ca1e4022"/>
+    <p:notesMasterId xmlns:r="http://schemas.openxmlformats.org/officeDocument/2006/relationships" r:id="Rf80748d49a204cb0"/>
   </p:notesMasterIdLst>
   <p:sldIdLst>
-    <p:sldId xmlns:r="http://schemas.openxmlformats.org/officeDocument/2006/relationships" id="256" r:id="Ra61ed94e34e242e0"/>
-    <p:sldId xmlns:r="http://schemas.openxmlformats.org/officeDocument/2006/relationships" id="257" r:id="R5dbe16e9772841ad"/>
-    <p:sldId xmlns:r="http://schemas.openxmlformats.org/officeDocument/2006/relationships" id="258" r:id="R4c5f3517d7a64264"/>
-    <p:sldId xmlns:r="http://schemas.openxmlformats.org/officeDocument/2006/relationships" id="259" r:id="Rd297c05516b341b9"/>
-    <p:sldId xmlns:r="http://schemas.openxmlformats.org/officeDocument/2006/relationships" id="260" r:id="R0905fcf879c746af"/>
-    <p:sldId xmlns:r="http://schemas.openxmlformats.org/officeDocument/2006/relationships" id="261" r:id="Rb909471a9c70491a"/>
-    <p:sldId xmlns:r="http://schemas.openxmlformats.org/officeDocument/2006/relationships" id="262" r:id="R99a4c7a82a6f4fb7"/>
-    <p:sldId xmlns:r="http://schemas.openxmlformats.org/officeDocument/2006/relationships" id="263" r:id="Rfaf96555d6fa45f2"/>
-    <p:sldId xmlns:r="http://schemas.openxmlformats.org/officeDocument/2006/relationships" id="264" r:id="R13ff89529fee4a01"/>
-    <p:sldId xmlns:r="http://schemas.openxmlformats.org/officeDocument/2006/relationships" id="265" r:id="Rd1f40b2a29304f85"/>
-    <p:sldId xmlns:r="http://schemas.openxmlformats.org/officeDocument/2006/relationships" id="266" r:id="Rfb32b08ee18e4827"/>
-    <p:sldId xmlns:r="http://schemas.openxmlformats.org/officeDocument/2006/relationships" id="267" r:id="R121439044b464fb9"/>
-    <p:sldId xmlns:r="http://schemas.openxmlformats.org/officeDocument/2006/relationships" id="268" r:id="R1c679e8c9bbf4b31"/>
-    <p:sldId xmlns:r="http://schemas.openxmlformats.org/officeDocument/2006/relationships" id="269" r:id="R61c501048dff4df6"/>
-    <p:sldId xmlns:r="http://schemas.openxmlformats.org/officeDocument/2006/relationships" id="270" r:id="R45c2f793b6f547a6"/>
+    <p:sldId xmlns:r="http://schemas.openxmlformats.org/officeDocument/2006/relationships" id="256" r:id="R09f034d214c44bbc"/>
+    <p:sldId xmlns:r="http://schemas.openxmlformats.org/officeDocument/2006/relationships" id="257" r:id="R5fd6fa4608fa4a49"/>
+    <p:sldId xmlns:r="http://schemas.openxmlformats.org/officeDocument/2006/relationships" id="258" r:id="Rc7f4198a6b434252"/>
+    <p:sldId xmlns:r="http://schemas.openxmlformats.org/officeDocument/2006/relationships" id="259" r:id="Rbfba2d1cd4b34a6a"/>
+    <p:sldId xmlns:r="http://schemas.openxmlformats.org/officeDocument/2006/relationships" id="260" r:id="Ra240ff8394cd4e6c"/>
+    <p:sldId xmlns:r="http://schemas.openxmlformats.org/officeDocument/2006/relationships" id="261" r:id="R549b295a97b94020"/>
+    <p:sldId xmlns:r="http://schemas.openxmlformats.org/officeDocument/2006/relationships" id="262" r:id="R1604128c85c7422a"/>
+    <p:sldId xmlns:r="http://schemas.openxmlformats.org/officeDocument/2006/relationships" id="263" r:id="R0cc1a80b40f84e72"/>
+    <p:sldId xmlns:r="http://schemas.openxmlformats.org/officeDocument/2006/relationships" id="264" r:id="Rb04c3a1270b346e3"/>
+    <p:sldId xmlns:r="http://schemas.openxmlformats.org/officeDocument/2006/relationships" id="265" r:id="R997aa3b63aa04b53"/>
+    <p:sldId xmlns:r="http://schemas.openxmlformats.org/officeDocument/2006/relationships" id="266" r:id="Ra7210b3d6da44f36"/>
+    <p:sldId xmlns:r="http://schemas.openxmlformats.org/officeDocument/2006/relationships" id="267" r:id="R7c839596696f4a2f"/>
+    <p:sldId xmlns:r="http://schemas.openxmlformats.org/officeDocument/2006/relationships" id="268" r:id="R06e483fb30534cd1"/>
+    <p:sldId xmlns:r="http://schemas.openxmlformats.org/officeDocument/2006/relationships" id="269" r:id="R51543605088041f3"/>
+    <p:sldId xmlns:r="http://schemas.openxmlformats.org/officeDocument/2006/relationships" id="270" r:id="R9535caf8ae1e4d1f"/>
+    <p:sldId xmlns:r="http://schemas.openxmlformats.org/officeDocument/2006/relationships" id="271" r:id="R963551852a9d4d12"/>
   </p:sldIdLst>
   <p:sldSz cx="12192000" cy="6858000"/>
   <p:notesSz cx="6858000" cy="9144000"/>
@@ -456,7 +457,17 @@
           <a:lstStyle xmlns:a="http://schemas.openxmlformats.org/drawingml/2006/main"/>
           <a:p xmlns:a="http://schemas.openxmlformats.org/drawingml/2006/main">
             <a:r>
-              <a:t>Open with the core ask: reduce avoidable readmissions while protecting quality, capacity, and financial performance.</a:t>
+              <a:t>Open with the core ask: reduce avoidable readmissions while protecting quality, capacity, and financial performance. The opening metrics come from the integrated NHN analysis and ROI scenario table.</a:t>
+            </a:r>
+          </a:p>
+          <a:p xmlns:a="http://schemas.openxmlformats.org/drawingml/2006/main">
+            <a:r>
+              <a:t/>
+            </a:r>
+          </a:p>
+          <a:p xmlns:a="http://schemas.openxmlformats.org/drawingml/2006/main">
+            <a:r>
+              <a:t>References: INT-1, INT-2, INT-6, EXT-1. Full citations are maintained in REFERENCES.md.</a:t>
             </a:r>
           </a:p>
         </p:txBody>
@@ -526,7 +537,17 @@
           <a:lstStyle xmlns:a="http://schemas.openxmlformats.org/drawingml/2006/main"/>
           <a:p xmlns:a="http://schemas.openxmlformats.org/drawingml/2006/main">
             <a:r>
-              <a:t>This is the handoff from analytics to a native Tableau or Power BI dashboard build.</a:t>
+              <a:t>This is the handoff from analytics to a Tableau executive dashboard build for presentation and executive review.</a:t>
+            </a:r>
+          </a:p>
+          <a:p xmlns:a="http://schemas.openxmlformats.org/drawingml/2006/main">
+            <a:r>
+              <a:t/>
+            </a:r>
+          </a:p>
+          <a:p xmlns:a="http://schemas.openxmlformats.org/drawingml/2006/main">
+            <a:r>
+              <a:t>References: INT-2, INT-6, EXT-1. Full citations are maintained in REFERENCES.md.</a:t>
             </a:r>
           </a:p>
         </p:txBody>
@@ -596,7 +617,17 @@
           <a:lstStyle xmlns:a="http://schemas.openxmlformats.org/drawingml/2006/main"/>
           <a:p xmlns:a="http://schemas.openxmlformats.org/drawingml/2006/main">
             <a:r>
-              <a:t>The table is structured for Board discussion. It keeps recommendations traceable to evidence and timing.</a:t>
+              <a:t>The table is structured for Board discussion. It keeps recommendations traceable to evidence and timing, with no single recommendation treated as the only strategy.</a:t>
+            </a:r>
+          </a:p>
+          <a:p xmlns:a="http://schemas.openxmlformats.org/drawingml/2006/main">
+            <a:r>
+              <a:t/>
+            </a:r>
+          </a:p>
+          <a:p xmlns:a="http://schemas.openxmlformats.org/drawingml/2006/main">
+            <a:r>
+              <a:t>References: INT-6, EXT-5, EXT-6, EXT-7. Full citations are maintained in REFERENCES.md.</a:t>
             </a:r>
           </a:p>
         </p:txBody>
@@ -666,7 +697,17 @@
           <a:lstStyle xmlns:a="http://schemas.openxmlformats.org/drawingml/2006/main"/>
           <a:p xmlns:a="http://schemas.openxmlformats.org/drawingml/2006/main">
             <a:r>
-              <a:t>The ROI slide should be presented as a planning scenario, not a guaranteed budget result.</a:t>
+              <a:t>The ROI slide should be presented as a planning scenario, not a guaranteed budget result. Retain the current implementation cost assumptions and ask Finance to validate them before budget commitment.</a:t>
+            </a:r>
+          </a:p>
+          <a:p xmlns:a="http://schemas.openxmlformats.org/drawingml/2006/main">
+            <a:r>
+              <a:t/>
+            </a:r>
+          </a:p>
+          <a:p xmlns:a="http://schemas.openxmlformats.org/drawingml/2006/main">
+            <a:r>
+              <a:t>References: INT-4, INT-6, EXT-1, EXT-4. Full citations are maintained in REFERENCES.md.</a:t>
             </a:r>
           </a:p>
         </p:txBody>
@@ -736,7 +777,17 @@
           <a:lstStyle xmlns:a="http://schemas.openxmlformats.org/drawingml/2006/main"/>
           <a:p xmlns:a="http://schemas.openxmlformats.org/drawingml/2006/main">
             <a:r>
-              <a:t>Walk through the roadmap as a staged implementation, starting with governance, pilot design, and data quality.</a:t>
+              <a:t>Walk through the roadmap as a staged implementation, starting with governance, pilot design, and data quality. The first native dashboard build path is Tableau.</a:t>
+            </a:r>
+          </a:p>
+          <a:p xmlns:a="http://schemas.openxmlformats.org/drawingml/2006/main">
+            <a:r>
+              <a:t/>
+            </a:r>
+          </a:p>
+          <a:p xmlns:a="http://schemas.openxmlformats.org/drawingml/2006/main">
+            <a:r>
+              <a:t>References: INT-2, INT-6. Full citations are maintained in REFERENCES.md.</a:t>
             </a:r>
           </a:p>
         </p:txBody>
@@ -806,7 +857,17 @@
           <a:lstStyle xmlns:a="http://schemas.openxmlformats.org/drawingml/2006/main"/>
           <a:p xmlns:a="http://schemas.openxmlformats.org/drawingml/2006/main">
             <a:r>
-              <a:t>Define how the organization will know whether the program is working after launch.</a:t>
+              <a:t>Define how the organization will know whether the program is working after launch. Include model monitoring so clinical governance can track drift, recall, and precision over time.</a:t>
+            </a:r>
+          </a:p>
+          <a:p xmlns:a="http://schemas.openxmlformats.org/drawingml/2006/main">
+            <a:r>
+              <a:t/>
+            </a:r>
+          </a:p>
+          <a:p xmlns:a="http://schemas.openxmlformats.org/drawingml/2006/main">
+            <a:r>
+              <a:t>References: INT-6, EXT-7. Full citations are maintained in REFERENCES.md.</a:t>
             </a:r>
           </a:p>
         </p:txBody>
@@ -876,7 +937,97 @@
           <a:lstStyle xmlns:a="http://schemas.openxmlformats.org/drawingml/2006/main"/>
           <a:p xmlns:a="http://schemas.openxmlformats.org/drawingml/2006/main">
             <a:r>
-              <a:t>Close by asking for concrete approvals tied to a controlled pilot and transparent measurement cadence.</a:t>
+              <a:t>Close by asking for concrete approvals tied to a controlled pilot and transparent measurement cadence. Reinforce the data caveats before presenting the funding decision.</a:t>
+            </a:r>
+          </a:p>
+          <a:p xmlns:a="http://schemas.openxmlformats.org/drawingml/2006/main">
+            <a:r>
+              <a:t/>
+            </a:r>
+          </a:p>
+          <a:p xmlns:a="http://schemas.openxmlformats.org/drawingml/2006/main">
+            <a:r>
+              <a:t>References: INT-2, EXT-1, EXT-7. Full citations are maintained in REFERENCES.md.</a:t>
+            </a:r>
+          </a:p>
+        </p:txBody>
+      </p:sp>
+      <p:sp>
+        <p:nvSpPr>
+          <p:cNvPr id="4" name="Slide Number Placeholder 3"/>
+          <p:cNvSpPr>
+            <a:spLocks xmlns:a="http://schemas.openxmlformats.org/drawingml/2006/main" noGrp="1"/>
+          </p:cNvSpPr>
+          <p:nvPr>
+            <p:ph type="sldNum" idx="5"/>
+          </p:nvPr>
+        </p:nvSpPr>
+        <p:spPr/>
+        <p:txBody>
+          <a:bodyPr xmlns:a="http://schemas.openxmlformats.org/drawingml/2006/main"/>
+          <a:lstStyle xmlns:a="http://schemas.openxmlformats.org/drawingml/2006/main"/>
+          <a:p xmlns:a="http://schemas.openxmlformats.org/drawingml/2006/main"/>
+        </p:txBody>
+      </p:sp>
+    </p:spTree>
+  </p:cSld>
+  <p:clrMapOvr>
+    <a:masterClrMapping xmlns:a="http://schemas.openxmlformats.org/drawingml/2006/main"/>
+  </p:clrMapOvr>
+</p:notes>
+</file>
+
+<file path=ppt/notesSlides/notesSlide16.xml><?xml version="1.0" encoding="utf-8"?>
+<p:notes xmlns:p="http://schemas.openxmlformats.org/presentationml/2006/main">
+  <p:cSld>
+    <p:spTree>
+      <p:nvGrpSpPr>
+        <p:cNvPr id="1" name=""/>
+        <p:cNvGrpSpPr/>
+        <p:nvPr/>
+      </p:nvGrpSpPr>
+      <p:grpSpPr>
+        <a:xfrm xmlns:a="http://schemas.openxmlformats.org/drawingml/2006/main"/>
+      </p:grpSpPr>
+      <p:sp>
+        <p:nvSpPr>
+          <p:cNvPr id="2" name="Slide Image Placeholder 1"/>
+          <p:cNvSpPr>
+            <a:spLocks xmlns:a="http://schemas.openxmlformats.org/drawingml/2006/main" noGrp="1"/>
+          </p:cNvSpPr>
+          <p:nvPr>
+            <p:ph type="sldImg" idx="0"/>
+          </p:nvPr>
+        </p:nvSpPr>
+        <p:spPr/>
+      </p:sp>
+      <p:sp>
+        <p:nvSpPr>
+          <p:cNvPr id="3" name="Notes Placeholder 2"/>
+          <p:cNvSpPr>
+            <a:spLocks xmlns:a="http://schemas.openxmlformats.org/drawingml/2006/main" noGrp="1"/>
+          </p:cNvSpPr>
+          <p:nvPr>
+            <p:ph type="body" idx="1"/>
+          </p:nvPr>
+        </p:nvSpPr>
+        <p:spPr/>
+        <p:txBody>
+          <a:bodyPr xmlns:a="http://schemas.openxmlformats.org/drawingml/2006/main"/>
+          <a:lstStyle xmlns:a="http://schemas.openxmlformats.org/drawingml/2006/main"/>
+          <a:p xmlns:a="http://schemas.openxmlformats.org/drawingml/2006/main">
+            <a:r>
+              <a:t>Use this appendix slide when asked where the numbers and outside evidence came from. Full citations and internal source definitions are in REFERENCES.md.</a:t>
+            </a:r>
+          </a:p>
+          <a:p xmlns:a="http://schemas.openxmlformats.org/drawingml/2006/main">
+            <a:r>
+              <a:t/>
+            </a:r>
+          </a:p>
+          <a:p xmlns:a="http://schemas.openxmlformats.org/drawingml/2006/main">
+            <a:r>
+              <a:t>References: INT-1, INT-2, INT-3, INT-4, INT-5, INT-6, EXT-1, EXT-2, EXT-3, EXT-4, EXT-5, EXT-6, EXT-7, EXT-8. Full citations are maintained in REFERENCES.md.</a:t>
             </a:r>
           </a:p>
         </p:txBody>
@@ -946,7 +1097,17 @@
           <a:lstStyle xmlns:a="http://schemas.openxmlformats.org/drawingml/2006/main"/>
           <a:p xmlns:a="http://schemas.openxmlformats.org/drawingml/2006/main">
             <a:r>
-              <a:t>The summary combines clinical, financial, and operating findings into the Board-level decision path.</a:t>
+              <a:t>The summary combines clinical, financial, and operating findings into the Board-level decision path. Present the model as a staged risk input and keep the expected ROI as a planning scenario.</a:t>
+            </a:r>
+          </a:p>
+          <a:p xmlns:a="http://schemas.openxmlformats.org/drawingml/2006/main">
+            <a:r>
+              <a:t/>
+            </a:r>
+          </a:p>
+          <a:p xmlns:a="http://schemas.openxmlformats.org/drawingml/2006/main">
+            <a:r>
+              <a:t>References: INT-6, EXT-1, EXT-7. Full citations are maintained in REFERENCES.md.</a:t>
             </a:r>
           </a:p>
         </p:txBody>
@@ -1016,7 +1177,17 @@
           <a:lstStyle xmlns:a="http://schemas.openxmlformats.org/drawingml/2006/main"/>
           <a:p xmlns:a="http://schemas.openxmlformats.org/drawingml/2006/main">
             <a:r>
-              <a:t>Use this slide to frame why the work matters before moving into the integrated data and analysis.</a:t>
+              <a:t>Use this slide to frame why the work matters before moving into the integrated data and analysis. The business problem should cover clinical quality, capacity, care workload, and financial exposure.</a:t>
+            </a:r>
+          </a:p>
+          <a:p xmlns:a="http://schemas.openxmlformats.org/drawingml/2006/main">
+            <a:r>
+              <a:t/>
+            </a:r>
+          </a:p>
+          <a:p xmlns:a="http://schemas.openxmlformats.org/drawingml/2006/main">
+            <a:r>
+              <a:t>References: INT-1, EXT-1, EXT-3, EXT-4. Full citations are maintained in REFERENCES.md.</a:t>
             </a:r>
           </a:p>
         </p:txBody>
@@ -1086,7 +1257,17 @@
           <a:lstStyle xmlns:a="http://schemas.openxmlformats.org/drawingml/2006/main"/>
           <a:p xmlns:a="http://schemas.openxmlformats.org/drawingml/2006/main">
             <a:r>
-              <a:t>Call out that the data joins cleanly, while follow-up documentation and financial field quality remain limitations.</a:t>
+              <a:t>Call out that the data joins cleanly, while follow-up documentation and financial field quality remain limitations. These caveats should stay visible in the main deck.</a:t>
+            </a:r>
+          </a:p>
+          <a:p xmlns:a="http://schemas.openxmlformats.org/drawingml/2006/main">
+            <a:r>
+              <a:t/>
+            </a:r>
+          </a:p>
+          <a:p xmlns:a="http://schemas.openxmlformats.org/drawingml/2006/main">
+            <a:r>
+              <a:t>References: INT-3, INT-4, INT-5, INT-6. Full citations are maintained in REFERENCES.md.</a:t>
             </a:r>
           </a:p>
         </p:txBody>
@@ -1156,7 +1337,17 @@
           <a:lstStyle xmlns:a="http://schemas.openxmlformats.org/drawingml/2006/main"/>
           <a:p xmlns:a="http://schemas.openxmlformats.org/drawingml/2006/main">
             <a:r>
-              <a:t>Tie the high-risk segments back to operational decisions such as discharge review and care coordination assignment.</a:t>
+              <a:t>Tie the high-risk segments back to operational decisions such as discharge review and care coordination assignment. Treat segment findings as observed risk patterns from the analysis table.</a:t>
+            </a:r>
+          </a:p>
+          <a:p xmlns:a="http://schemas.openxmlformats.org/drawingml/2006/main">
+            <a:r>
+              <a:t/>
+            </a:r>
+          </a:p>
+          <a:p xmlns:a="http://schemas.openxmlformats.org/drawingml/2006/main">
+            <a:r>
+              <a:t>References: INT-3, INT-6, EXT-3. Full citations are maintained in REFERENCES.md.</a:t>
             </a:r>
           </a:p>
         </p:txBody>
@@ -1229,6 +1420,16 @@
               <a:t>The model is not positioned as a single decision engine. Use staged risk scoring, clinical rules, and operational review to balance recall and precision.</a:t>
             </a:r>
           </a:p>
+          <a:p xmlns:a="http://schemas.openxmlformats.org/drawingml/2006/main">
+            <a:r>
+              <a:t/>
+            </a:r>
+          </a:p>
+          <a:p xmlns:a="http://schemas.openxmlformats.org/drawingml/2006/main">
+            <a:r>
+              <a:t>References: INT-6, EXT-7, EXT-8. Full citations are maintained in REFERENCES.md.</a:t>
+            </a:r>
+          </a:p>
         </p:txBody>
       </p:sp>
       <p:sp>
@@ -1299,6 +1500,16 @@
               <a:t>Risk deciles turn the model into an operational queue, but coverage should be broad and supported by clinical rules rather than a narrow decile-10-only pilot.</a:t>
             </a:r>
           </a:p>
+          <a:p xmlns:a="http://schemas.openxmlformats.org/drawingml/2006/main">
+            <a:r>
+              <a:t/>
+            </a:r>
+          </a:p>
+          <a:p xmlns:a="http://schemas.openxmlformats.org/drawingml/2006/main">
+            <a:r>
+              <a:t>References: INT-6, EXT-7. Full citations are maintained in REFERENCES.md.</a:t>
+            </a:r>
+          </a:p>
         </p:txBody>
       </p:sp>
       <p:sp>
@@ -1369,6 +1580,16 @@
               <a:t>Keep the causal caveat visible, then make the stronger operational point: NHN should redesign targeting, timing, and intervention completion for high-risk patients.</a:t>
             </a:r>
           </a:p>
+          <a:p xmlns:a="http://schemas.openxmlformats.org/drawingml/2006/main">
+            <a:r>
+              <a:t/>
+            </a:r>
+          </a:p>
+          <a:p xmlns:a="http://schemas.openxmlformats.org/drawingml/2006/main">
+            <a:r>
+              <a:t>References: INT-5, INT-6, EXT-5, EXT-6. Full citations are maintained in REFERENCES.md.</a:t>
+            </a:r>
+          </a:p>
         </p:txBody>
       </p:sp>
       <p:sp>
@@ -1436,7 +1657,17 @@
           <a:lstStyle xmlns:a="http://schemas.openxmlformats.org/drawingml/2006/main"/>
           <a:p xmlns:a="http://schemas.openxmlformats.org/drawingml/2006/main">
             <a:r>
-              <a:t>The analysis gives a strong directional financial case while preserving data quality caveats.</a:t>
+              <a:t>The analysis gives a strong directional financial case while preserving data quality caveats. Use nonnegative financial fields and scenario sensitivity when presenting ROI.</a:t>
+            </a:r>
+          </a:p>
+          <a:p xmlns:a="http://schemas.openxmlformats.org/drawingml/2006/main">
+            <a:r>
+              <a:t/>
+            </a:r>
+          </a:p>
+          <a:p xmlns:a="http://schemas.openxmlformats.org/drawingml/2006/main">
+            <a:r>
+              <a:t>References: INT-4, INT-6, EXT-1, EXT-4. Full citations are maintained in REFERENCES.md.</a:t>
             </a:r>
           </a:p>
         </p:txBody>
@@ -1504,7 +1735,7 @@
   </p:cSld>
   <p:clrMap bg1="lt1" tx1="dk1" bg2="lt2" tx2="dk2" accent1="accent1" accent2="accent2" accent3="accent3" accent4="accent4" accent5="accent5" accent6="accent6" hlink="hlink" folHlink="folHlink"/>
   <p:sldLayoutIdLst>
-    <p:sldLayoutId xmlns:r="http://schemas.openxmlformats.org/officeDocument/2006/relationships" id="2147483649" r:id="R8bb6ccf7cdab4601"/>
+    <p:sldLayoutId xmlns:r="http://schemas.openxmlformats.org/officeDocument/2006/relationships" id="2147483649" r:id="Rcd62bc10a77549d6"/>
   </p:sldLayoutIdLst>
   <p:txStyles>
     <p:titleStyle>
@@ -3639,7 +3870,7 @@
                 <a:ea typeface="Helvetica Neue"/>
                 <a:cs typeface="Helvetica Neue"/>
               </a:rPr>
-              <a:t>Estimated net savings by scenario</a:t>
+              <a:t>Estimated net savings by scenario ($M)</a:t>
             </a:r>
           </a:p>
         </c:rich>
@@ -3699,7 +3930,7 @@
             <c:numRef>
               <c:f>'Chart Data'!$B$2:$B$4</c:f>
               <c:numCache>
-                <c:formatCode>$0.0M</c:formatCode>
+                <c:formatCode>$0.00M</c:formatCode>
                 <c:ptCount val="3"/>
                 <c:pt idx="0">
                   <c:v>4.2797</c:v>
@@ -3733,7 +3964,7 @@
           </c:txPr>
           <c:dLblPos val="outEnd"/>
           <c:showLegendKey val="0"/>
-          <c:showVal val="1"/>
+          <c:showVal val="0"/>
           <c:showCatName val="0"/>
           <c:showSerName val="0"/>
           <c:showPercent val="0"/>
@@ -3798,7 +4029,7 @@
             </a:ln>
           </c:spPr>
         </c:majorGridlines>
-        <c:numFmt formatCode="$0.0M"/>
+        <c:numFmt formatCode="$0.00M"/>
         <c:majorTickMark val="none"/>
         <c:minorTickMark val="none"/>
         <c:spPr>
@@ -3877,7 +4108,7 @@
           <p:cNvPr id="25" name="">
             <a:extLst xmlns:a="http://schemas.openxmlformats.org/drawingml/2006/main">
               <a:ext uri="{FF2B5EF4-FFF2-40B4-BE49-F238E27FC236}">
-                <a16:creationId xmlns:a16="http://schemas.microsoft.com/office/drawing/2014/main" id="{439E7B07-C4D5-4AB5-8F2B-591AEB1B0361}"/>
+                <a16:creationId xmlns:a16="http://schemas.microsoft.com/office/drawing/2014/main" id="{0E3F6426-4CDE-41ED-A209-D1AA6405DD22}"/>
               </a:ext>
             </a:extLst>
           </p:cNvPr>
@@ -3910,7 +4141,7 @@
           <p:cNvPr id="2" name="">
             <a:extLst xmlns:a="http://schemas.openxmlformats.org/drawingml/2006/main">
               <a:ext uri="{FF2B5EF4-FFF2-40B4-BE49-F238E27FC236}">
-                <a16:creationId xmlns:a16="http://schemas.microsoft.com/office/drawing/2014/main" id="{B372924F-A67F-4905-A8DE-5D0E5214557B}"/>
+                <a16:creationId xmlns:a16="http://schemas.microsoft.com/office/drawing/2014/main" id="{A193969D-D299-48C7-9A55-E1DCCFF5BD4F}"/>
               </a:ext>
             </a:extLst>
           </p:cNvPr>
@@ -3968,7 +4199,7 @@
           <p:cNvPr id="3" name="">
             <a:extLst xmlns:a="http://schemas.openxmlformats.org/drawingml/2006/main">
               <a:ext uri="{FF2B5EF4-FFF2-40B4-BE49-F238E27FC236}">
-                <a16:creationId xmlns:a16="http://schemas.microsoft.com/office/drawing/2014/main" id="{42088275-66DB-4F99-8FE6-556F85DA7A18}"/>
+                <a16:creationId xmlns:a16="http://schemas.microsoft.com/office/drawing/2014/main" id="{57C1415C-E6A8-44BD-9D01-E6CF71584D31}"/>
               </a:ext>
             </a:extLst>
           </p:cNvPr>
@@ -4026,7 +4257,7 @@
           <p:cNvPr id="4" name="">
             <a:extLst xmlns:a="http://schemas.openxmlformats.org/drawingml/2006/main">
               <a:ext uri="{FF2B5EF4-FFF2-40B4-BE49-F238E27FC236}">
-                <a16:creationId xmlns:a16="http://schemas.microsoft.com/office/drawing/2014/main" id="{79D8579A-5E49-4734-AC1A-5264FB2D9BA6}"/>
+                <a16:creationId xmlns:a16="http://schemas.microsoft.com/office/drawing/2014/main" id="{76BA78A8-B1A3-470E-9C90-35177565BB3D}"/>
               </a:ext>
             </a:extLst>
           </p:cNvPr>
@@ -4057,7 +4288,7 @@
           <p:cNvPr id="5" name="">
             <a:extLst xmlns:a="http://schemas.openxmlformats.org/drawingml/2006/main">
               <a:ext uri="{FF2B5EF4-FFF2-40B4-BE49-F238E27FC236}">
-                <a16:creationId xmlns:a16="http://schemas.microsoft.com/office/drawing/2014/main" id="{33D91A6B-C849-4CBB-A244-B76E3415D628}"/>
+                <a16:creationId xmlns:a16="http://schemas.microsoft.com/office/drawing/2014/main" id="{6A4182A9-F2BB-441B-AEB9-58D563BDA8A6}"/>
               </a:ext>
             </a:extLst>
           </p:cNvPr>
@@ -4115,7 +4346,7 @@
           <p:cNvPr id="6" name="">
             <a:extLst xmlns:a="http://schemas.openxmlformats.org/drawingml/2006/main">
               <a:ext uri="{FF2B5EF4-FFF2-40B4-BE49-F238E27FC236}">
-                <a16:creationId xmlns:a16="http://schemas.microsoft.com/office/drawing/2014/main" id="{A45B67B6-6D1D-4DAA-9A5B-4F2C74145DB6}"/>
+                <a16:creationId xmlns:a16="http://schemas.microsoft.com/office/drawing/2014/main" id="{B2663D8F-0DD8-45EB-BF27-5D4BA4AFC201}"/>
               </a:ext>
             </a:extLst>
           </p:cNvPr>
@@ -4173,7 +4404,7 @@
           <p:cNvPr id="7" name="">
             <a:extLst xmlns:a="http://schemas.openxmlformats.org/drawingml/2006/main">
               <a:ext uri="{FF2B5EF4-FFF2-40B4-BE49-F238E27FC236}">
-                <a16:creationId xmlns:a16="http://schemas.microsoft.com/office/drawing/2014/main" id="{9A5FB2EC-D7D7-422F-B109-DFE33A0DF2BA}"/>
+                <a16:creationId xmlns:a16="http://schemas.microsoft.com/office/drawing/2014/main" id="{90488D68-39B2-44DB-A70D-2BBA696E8371}"/>
               </a:ext>
             </a:extLst>
           </p:cNvPr>
@@ -4204,7 +4435,7 @@
           <p:cNvPr id="8" name="">
             <a:extLst xmlns:a="http://schemas.openxmlformats.org/drawingml/2006/main">
               <a:ext uri="{FF2B5EF4-FFF2-40B4-BE49-F238E27FC236}">
-                <a16:creationId xmlns:a16="http://schemas.microsoft.com/office/drawing/2014/main" id="{02348C08-87DF-4277-AF11-E0056336854A}"/>
+                <a16:creationId xmlns:a16="http://schemas.microsoft.com/office/drawing/2014/main" id="{2BD1569D-15C7-4E4B-B807-6BCEB246C21C}"/>
               </a:ext>
             </a:extLst>
           </p:cNvPr>
@@ -4262,7 +4493,7 @@
           <p:cNvPr id="9" name="">
             <a:extLst xmlns:a="http://schemas.openxmlformats.org/drawingml/2006/main">
               <a:ext uri="{FF2B5EF4-FFF2-40B4-BE49-F238E27FC236}">
-                <a16:creationId xmlns:a16="http://schemas.microsoft.com/office/drawing/2014/main" id="{32EB9014-3E35-476F-8E90-8E9CA5DFD28D}"/>
+                <a16:creationId xmlns:a16="http://schemas.microsoft.com/office/drawing/2014/main" id="{BFDF5187-63BE-4E5F-92EF-89CC855C4721}"/>
               </a:ext>
             </a:extLst>
           </p:cNvPr>
@@ -4320,7 +4551,7 @@
           <p:cNvPr id="10" name="">
             <a:extLst xmlns:a="http://schemas.openxmlformats.org/drawingml/2006/main">
               <a:ext uri="{FF2B5EF4-FFF2-40B4-BE49-F238E27FC236}">
-                <a16:creationId xmlns:a16="http://schemas.microsoft.com/office/drawing/2014/main" id="{7345E351-6491-4156-96E7-0592123BAA15}"/>
+                <a16:creationId xmlns:a16="http://schemas.microsoft.com/office/drawing/2014/main" id="{6EB496CE-9BF5-42C6-BE99-867C3085CB79}"/>
               </a:ext>
             </a:extLst>
           </p:cNvPr>
@@ -4351,7 +4582,7 @@
           <p:cNvPr id="11" name="">
             <a:extLst xmlns:a="http://schemas.openxmlformats.org/drawingml/2006/main">
               <a:ext uri="{FF2B5EF4-FFF2-40B4-BE49-F238E27FC236}">
-                <a16:creationId xmlns:a16="http://schemas.microsoft.com/office/drawing/2014/main" id="{57DEC62F-69B7-428C-B598-997E9F6DCD61}"/>
+                <a16:creationId xmlns:a16="http://schemas.microsoft.com/office/drawing/2014/main" id="{969E34D8-EEEC-4F3D-9256-6C68BFD5A62D}"/>
               </a:ext>
             </a:extLst>
           </p:cNvPr>
@@ -4409,7 +4640,7 @@
           <p:cNvPr id="12" name="">
             <a:extLst xmlns:a="http://schemas.openxmlformats.org/drawingml/2006/main">
               <a:ext uri="{FF2B5EF4-FFF2-40B4-BE49-F238E27FC236}">
-                <a16:creationId xmlns:a16="http://schemas.microsoft.com/office/drawing/2014/main" id="{AC62A115-8A80-437E-AD14-1C59237C829D}"/>
+                <a16:creationId xmlns:a16="http://schemas.microsoft.com/office/drawing/2014/main" id="{659AB179-82E8-48F8-B296-693CB3F6EFF3}"/>
               </a:ext>
             </a:extLst>
           </p:cNvPr>
@@ -4467,7 +4698,7 @@
           <p:cNvPr id="13" name="">
             <a:extLst xmlns:a="http://schemas.openxmlformats.org/drawingml/2006/main">
               <a:ext uri="{FF2B5EF4-FFF2-40B4-BE49-F238E27FC236}">
-                <a16:creationId xmlns:a16="http://schemas.microsoft.com/office/drawing/2014/main" id="{03AB14CB-461D-44D7-B997-80238A8228ED}"/>
+                <a16:creationId xmlns:a16="http://schemas.microsoft.com/office/drawing/2014/main" id="{4177BB77-48F0-4909-8FBB-19C92CB4DCB8}"/>
               </a:ext>
             </a:extLst>
           </p:cNvPr>
@@ -4525,7 +4756,7 @@
           <p:cNvPr id="14" name="">
             <a:extLst xmlns:a="http://schemas.openxmlformats.org/drawingml/2006/main">
               <a:ext uri="{FF2B5EF4-FFF2-40B4-BE49-F238E27FC236}">
-                <a16:creationId xmlns:a16="http://schemas.microsoft.com/office/drawing/2014/main" id="{C767AB11-C979-42A0-B23A-7F299905CEF3}"/>
+                <a16:creationId xmlns:a16="http://schemas.microsoft.com/office/drawing/2014/main" id="{BD2D60A7-8D3D-427B-9372-2D044F0AD69C}"/>
               </a:ext>
             </a:extLst>
           </p:cNvPr>
@@ -4583,7 +4814,7 @@
           <p:cNvPr id="15" name="">
             <a:extLst xmlns:a="http://schemas.openxmlformats.org/drawingml/2006/main">
               <a:ext uri="{FF2B5EF4-FFF2-40B4-BE49-F238E27FC236}">
-                <a16:creationId xmlns:a16="http://schemas.microsoft.com/office/drawing/2014/main" id="{16476F35-EA2F-4321-81DD-99F11ACA74F7}"/>
+                <a16:creationId xmlns:a16="http://schemas.microsoft.com/office/drawing/2014/main" id="{48FA6F78-4BEC-4FB3-A0F9-7D6EC727527F}"/>
               </a:ext>
             </a:extLst>
           </p:cNvPr>
@@ -4641,7 +4872,7 @@
           <p:cNvPr id="16" name="">
             <a:extLst xmlns:a="http://schemas.openxmlformats.org/drawingml/2006/main">
               <a:ext uri="{FF2B5EF4-FFF2-40B4-BE49-F238E27FC236}">
-                <a16:creationId xmlns:a16="http://schemas.microsoft.com/office/drawing/2014/main" id="{3E0713E7-EE73-40B2-89E1-6B465416A60F}"/>
+                <a16:creationId xmlns:a16="http://schemas.microsoft.com/office/drawing/2014/main" id="{7B0D5DDA-D791-488E-9B05-23E3A9F56EDB}"/>
               </a:ext>
             </a:extLst>
           </p:cNvPr>
@@ -4699,7 +4930,7 @@
           <p:cNvPr id="17" name="">
             <a:extLst xmlns:a="http://schemas.openxmlformats.org/drawingml/2006/main">
               <a:ext uri="{FF2B5EF4-FFF2-40B4-BE49-F238E27FC236}">
-                <a16:creationId xmlns:a16="http://schemas.microsoft.com/office/drawing/2014/main" id="{A4C528B4-008A-4B70-A1D4-4610B6CCC8D2}"/>
+                <a16:creationId xmlns:a16="http://schemas.microsoft.com/office/drawing/2014/main" id="{E32F3E2A-4560-4D8A-8B69-403F43F18EE8}"/>
               </a:ext>
             </a:extLst>
           </p:cNvPr>
@@ -4757,7 +4988,7 @@
           <p:cNvPr id="18" name="">
             <a:extLst xmlns:a="http://schemas.openxmlformats.org/drawingml/2006/main">
               <a:ext uri="{FF2B5EF4-FFF2-40B4-BE49-F238E27FC236}">
-                <a16:creationId xmlns:a16="http://schemas.microsoft.com/office/drawing/2014/main" id="{89C93DC2-709A-4428-B0C9-E789B5B1BE15}"/>
+                <a16:creationId xmlns:a16="http://schemas.microsoft.com/office/drawing/2014/main" id="{BE59D377-A965-47DC-A5DB-480E899D5062}"/>
               </a:ext>
             </a:extLst>
           </p:cNvPr>
@@ -4805,7 +5036,7 @@
                 <a:ea typeface="Helvetica Neue"/>
                 <a:cs typeface="Helvetica Neue"/>
               </a:rPr>
-              <a:t>$8.8M</a:t>
+              <a:t>$8.81M</a:t>
             </a:r>
           </a:p>
         </p:txBody>
@@ -4815,7 +5046,7 @@
           <p:cNvPr id="19" name="">
             <a:extLst xmlns:a="http://schemas.openxmlformats.org/drawingml/2006/main">
               <a:ext uri="{FF2B5EF4-FFF2-40B4-BE49-F238E27FC236}">
-                <a16:creationId xmlns:a16="http://schemas.microsoft.com/office/drawing/2014/main" id="{6DBF302E-FADB-4075-B45F-CC76358FF3BE}"/>
+                <a16:creationId xmlns:a16="http://schemas.microsoft.com/office/drawing/2014/main" id="{1A16AF4E-33F7-4036-B8E4-438923D82AD9}"/>
               </a:ext>
             </a:extLst>
           </p:cNvPr>
@@ -4873,7 +5104,7 @@
           <p:cNvPr id="20" name="">
             <a:extLst xmlns:a="http://schemas.openxmlformats.org/drawingml/2006/main">
               <a:ext uri="{FF2B5EF4-FFF2-40B4-BE49-F238E27FC236}">
-                <a16:creationId xmlns:a16="http://schemas.microsoft.com/office/drawing/2014/main" id="{88E95FC4-EAA4-4425-A2D2-D6DF735F533E}"/>
+                <a16:creationId xmlns:a16="http://schemas.microsoft.com/office/drawing/2014/main" id="{2EE5B9D7-09EA-47EB-BDFA-4A9B8BF8F9D3}"/>
               </a:ext>
             </a:extLst>
           </p:cNvPr>
@@ -4931,7 +5162,7 @@
           <p:cNvPr id="21" name="">
             <a:extLst xmlns:a="http://schemas.openxmlformats.org/drawingml/2006/main">
               <a:ext uri="{FF2B5EF4-FFF2-40B4-BE49-F238E27FC236}">
-                <a16:creationId xmlns:a16="http://schemas.microsoft.com/office/drawing/2014/main" id="{F0492752-B1C7-4D6D-A445-9A39F125A8CB}"/>
+                <a16:creationId xmlns:a16="http://schemas.microsoft.com/office/drawing/2014/main" id="{4A63723B-57C2-4A66-AB4B-22BD8F16B798}"/>
               </a:ext>
             </a:extLst>
           </p:cNvPr>
@@ -4989,7 +5220,7 @@
           <p:cNvPr id="22" name="">
             <a:extLst xmlns:a="http://schemas.openxmlformats.org/drawingml/2006/main">
               <a:ext uri="{FF2B5EF4-FFF2-40B4-BE49-F238E27FC236}">
-                <a16:creationId xmlns:a16="http://schemas.microsoft.com/office/drawing/2014/main" id="{A01FB986-8AED-4FDB-9620-64519E845F2A}"/>
+                <a16:creationId xmlns:a16="http://schemas.microsoft.com/office/drawing/2014/main" id="{61FB2F94-36E2-4570-8624-9510FABF2775}"/>
               </a:ext>
             </a:extLst>
           </p:cNvPr>
@@ -5047,7 +5278,7 @@
           <p:cNvPr id="23" name="">
             <a:extLst xmlns:a="http://schemas.openxmlformats.org/drawingml/2006/main">
               <a:ext uri="{FF2B5EF4-FFF2-40B4-BE49-F238E27FC236}">
-                <a16:creationId xmlns:a16="http://schemas.microsoft.com/office/drawing/2014/main" id="{F38407F9-FCE4-4C15-9FCE-96674E8DF912}"/>
+                <a16:creationId xmlns:a16="http://schemas.microsoft.com/office/drawing/2014/main" id="{76D7CA82-88A9-4B3C-B216-0C71DA9A8446}"/>
               </a:ext>
             </a:extLst>
           </p:cNvPr>
@@ -5078,7 +5309,7 @@
           <p:cNvPr id="24" name="">
             <a:extLst xmlns:a="http://schemas.openxmlformats.org/drawingml/2006/main">
               <a:ext uri="{FF2B5EF4-FFF2-40B4-BE49-F238E27FC236}">
-                <a16:creationId xmlns:a16="http://schemas.microsoft.com/office/drawing/2014/main" id="{5BAF69AE-5124-449A-98BB-C85118280E9A}"/>
+                <a16:creationId xmlns:a16="http://schemas.microsoft.com/office/drawing/2014/main" id="{AF882542-01DC-4610-82CC-7EFC9D9119B3}"/>
               </a:ext>
             </a:extLst>
           </p:cNvPr>
@@ -5134,7 +5365,7 @@
     </p:spTree>
     <p:extLst>
       <p:ext uri="{BB962C8B-B14F-4D97-AF65-F5344CB8AC3E}">
-        <p14:creationId xmlns:p14="http://schemas.microsoft.com/office/powerpoint/2010/main" val="1698933873"/>
+        <p14:creationId xmlns:p14="http://schemas.microsoft.com/office/powerpoint/2010/main" val="1189629964"/>
       </p:ext>
     </p:extLst>
   </p:cSld>
@@ -5165,7 +5396,7 @@
           <p:cNvPr id="16" name="">
             <a:extLst xmlns:a="http://schemas.openxmlformats.org/drawingml/2006/main">
               <a:ext uri="{FF2B5EF4-FFF2-40B4-BE49-F238E27FC236}">
-                <a16:creationId xmlns:a16="http://schemas.microsoft.com/office/drawing/2014/main" id="{83821B71-7827-4533-B0A5-847F58CA708E}"/>
+                <a16:creationId xmlns:a16="http://schemas.microsoft.com/office/drawing/2014/main" id="{BFF22199-8300-4353-9B8E-1321924EC24B}"/>
               </a:ext>
             </a:extLst>
           </p:cNvPr>
@@ -5198,7 +5429,7 @@
           <p:cNvPr id="2" name="">
             <a:extLst xmlns:a="http://schemas.openxmlformats.org/drawingml/2006/main">
               <a:ext uri="{FF2B5EF4-FFF2-40B4-BE49-F238E27FC236}">
-                <a16:creationId xmlns:a16="http://schemas.microsoft.com/office/drawing/2014/main" id="{C8DBA3E4-68A7-4F28-B7A0-1C30CC85C990}"/>
+                <a16:creationId xmlns:a16="http://schemas.microsoft.com/office/drawing/2014/main" id="{7CB2B3CB-7E73-4BF3-A30C-868303EBC35F}"/>
               </a:ext>
             </a:extLst>
           </p:cNvPr>
@@ -5256,7 +5487,7 @@
           <p:cNvPr id="3" name="">
             <a:extLst xmlns:a="http://schemas.openxmlformats.org/drawingml/2006/main">
               <a:ext uri="{FF2B5EF4-FFF2-40B4-BE49-F238E27FC236}">
-                <a16:creationId xmlns:a16="http://schemas.microsoft.com/office/drawing/2014/main" id="{1553B1E8-CFBA-4322-AFDA-CA3E42865B84}"/>
+                <a16:creationId xmlns:a16="http://schemas.microsoft.com/office/drawing/2014/main" id="{30CBC25A-C5B7-4FCD-8DDD-99A0B6B32FC6}"/>
               </a:ext>
             </a:extLst>
           </p:cNvPr>
@@ -5314,7 +5545,7 @@
           <p:cNvPr id="4" name="">
             <a:extLst xmlns:a="http://schemas.openxmlformats.org/drawingml/2006/main">
               <a:ext uri="{FF2B5EF4-FFF2-40B4-BE49-F238E27FC236}">
-                <a16:creationId xmlns:a16="http://schemas.microsoft.com/office/drawing/2014/main" id="{3C2D9A77-A298-43A7-94F6-FA7C56B0CCAE}"/>
+                <a16:creationId xmlns:a16="http://schemas.microsoft.com/office/drawing/2014/main" id="{3F28CED7-8F03-4C4F-8D5F-874DAA5EA7FE}"/>
               </a:ext>
             </a:extLst>
           </p:cNvPr>
@@ -5372,7 +5603,7 @@
           <p:cNvPr id="5" name="">
             <a:extLst xmlns:a="http://schemas.openxmlformats.org/drawingml/2006/main">
               <a:ext uri="{FF2B5EF4-FFF2-40B4-BE49-F238E27FC236}">
-                <a16:creationId xmlns:a16="http://schemas.microsoft.com/office/drawing/2014/main" id="{F98D3071-323C-48D3-A534-383A1E091726}"/>
+                <a16:creationId xmlns:a16="http://schemas.microsoft.com/office/drawing/2014/main" id="{A5490C71-ADBE-49E4-95A5-6C253B865FAA}"/>
               </a:ext>
             </a:extLst>
           </p:cNvPr>
@@ -5403,7 +5634,7 @@
           <p:cNvPr id="6" name="">
             <a:extLst xmlns:a="http://schemas.openxmlformats.org/drawingml/2006/main">
               <a:ext uri="{FF2B5EF4-FFF2-40B4-BE49-F238E27FC236}">
-                <a16:creationId xmlns:a16="http://schemas.microsoft.com/office/drawing/2014/main" id="{6A17F3C1-FC7C-40FC-A317-44EF2F0673D2}"/>
+                <a16:creationId xmlns:a16="http://schemas.microsoft.com/office/drawing/2014/main" id="{CA13ECD4-476F-487C-99A8-87CCB874FF68}"/>
               </a:ext>
             </a:extLst>
           </p:cNvPr>
@@ -5434,7 +5665,7 @@
           <p:cNvPr id="7" name="">
             <a:extLst xmlns:a="http://schemas.openxmlformats.org/drawingml/2006/main">
               <a:ext uri="{FF2B5EF4-FFF2-40B4-BE49-F238E27FC236}">
-                <a16:creationId xmlns:a16="http://schemas.microsoft.com/office/drawing/2014/main" id="{CBFB8834-28AC-49BF-B672-9F4DC4ADC3D3}"/>
+                <a16:creationId xmlns:a16="http://schemas.microsoft.com/office/drawing/2014/main" id="{F9C5A1F1-90AD-4850-BD85-D729C659E48C}"/>
               </a:ext>
             </a:extLst>
           </p:cNvPr>
@@ -5899,7 +6130,7 @@
           <p:cNvPr id="9" name="">
             <a:extLst xmlns:a="http://schemas.openxmlformats.org/drawingml/2006/main">
               <a:ext uri="{FF2B5EF4-FFF2-40B4-BE49-F238E27FC236}">
-                <a16:creationId xmlns:a16="http://schemas.microsoft.com/office/drawing/2014/main" id="{5A8AA28D-FB2C-428E-A732-31C72000A6AD}"/>
+                <a16:creationId xmlns:a16="http://schemas.microsoft.com/office/drawing/2014/main" id="{58FA3C3B-E003-4CB8-BEF0-2E407A141597}"/>
               </a:ext>
             </a:extLst>
           </p:cNvPr>
@@ -5957,7 +6188,7 @@
           <p:cNvPr id="10" name="">
             <a:extLst xmlns:a="http://schemas.openxmlformats.org/drawingml/2006/main">
               <a:ext uri="{FF2B5EF4-FFF2-40B4-BE49-F238E27FC236}">
-                <a16:creationId xmlns:a16="http://schemas.microsoft.com/office/drawing/2014/main" id="{0D9151E9-1D8C-4EDF-94A2-76D6A1859EF5}"/>
+                <a16:creationId xmlns:a16="http://schemas.microsoft.com/office/drawing/2014/main" id="{EC3395CF-3F8C-4C09-AF5C-5B4AFE38A14B}"/>
               </a:ext>
             </a:extLst>
           </p:cNvPr>
@@ -6005,7 +6236,7 @@
                 <a:ea typeface="Helvetica Neue"/>
                 <a:cs typeface="Helvetica Neue"/>
               </a:rPr>
-              <a:t>Tableau first</a:t>
+              <a:t>Tableau</a:t>
             </a:r>
           </a:p>
         </p:txBody>
@@ -6015,7 +6246,7 @@
           <p:cNvPr id="11" name="">
             <a:extLst xmlns:a="http://schemas.openxmlformats.org/drawingml/2006/main">
               <a:ext uri="{FF2B5EF4-FFF2-40B4-BE49-F238E27FC236}">
-                <a16:creationId xmlns:a16="http://schemas.microsoft.com/office/drawing/2014/main" id="{131D2F64-69D7-4836-9AF0-21A8AE343EEA}"/>
+                <a16:creationId xmlns:a16="http://schemas.microsoft.com/office/drawing/2014/main" id="{3008EE0E-6AC5-4CCF-A6E6-390E6C872FB6}"/>
               </a:ext>
             </a:extLst>
           </p:cNvPr>
@@ -6063,7 +6294,7 @@
                 <a:ea typeface="Helvetica Neue"/>
                 <a:cs typeface="Helvetica Neue"/>
               </a:rPr>
-              <a:t>Power BI backup path</a:t>
+              <a:t>Primary dashboard path</a:t>
             </a:r>
           </a:p>
         </p:txBody>
@@ -6073,7 +6304,7 @@
           <p:cNvPr id="12" name="">
             <a:extLst xmlns:a="http://schemas.openxmlformats.org/drawingml/2006/main">
               <a:ext uri="{FF2B5EF4-FFF2-40B4-BE49-F238E27FC236}">
-                <a16:creationId xmlns:a16="http://schemas.microsoft.com/office/drawing/2014/main" id="{6B1C6B73-EB66-4105-95D2-625C9984B2EE}"/>
+                <a16:creationId xmlns:a16="http://schemas.microsoft.com/office/drawing/2014/main" id="{C4A1AA90-69F9-487A-A86D-30F8199CA51D}"/>
               </a:ext>
             </a:extLst>
           </p:cNvPr>
@@ -6131,7 +6362,7 @@
           <p:cNvPr id="13" name="">
             <a:extLst xmlns:a="http://schemas.openxmlformats.org/drawingml/2006/main">
               <a:ext uri="{FF2B5EF4-FFF2-40B4-BE49-F238E27FC236}">
-                <a16:creationId xmlns:a16="http://schemas.microsoft.com/office/drawing/2014/main" id="{91542F8E-7AE9-4C16-9D5F-A4FCB8E71E47}"/>
+                <a16:creationId xmlns:a16="http://schemas.microsoft.com/office/drawing/2014/main" id="{5D9F7FCC-9D73-40CB-A059-94B989FDA8CA}"/>
               </a:ext>
             </a:extLst>
           </p:cNvPr>
@@ -6189,7 +6420,7 @@
           <p:cNvPr id="14" name="">
             <a:extLst xmlns:a="http://schemas.openxmlformats.org/drawingml/2006/main">
               <a:ext uri="{FF2B5EF4-FFF2-40B4-BE49-F238E27FC236}">
-                <a16:creationId xmlns:a16="http://schemas.microsoft.com/office/drawing/2014/main" id="{33F8F00A-E308-4B74-9256-837CD04D1A33}"/>
+                <a16:creationId xmlns:a16="http://schemas.microsoft.com/office/drawing/2014/main" id="{77551DFB-3732-49A6-A948-E450890EC830}"/>
               </a:ext>
             </a:extLst>
           </p:cNvPr>
@@ -6247,7 +6478,7 @@
           <p:cNvPr id="15" name="">
             <a:extLst xmlns:a="http://schemas.openxmlformats.org/drawingml/2006/main">
               <a:ext uri="{FF2B5EF4-FFF2-40B4-BE49-F238E27FC236}">
-                <a16:creationId xmlns:a16="http://schemas.microsoft.com/office/drawing/2014/main" id="{2E019303-775F-48E8-98AE-27018AADD0DE}"/>
+                <a16:creationId xmlns:a16="http://schemas.microsoft.com/office/drawing/2014/main" id="{EF03F3CB-7B35-489C-8668-8CCA1DE60797}"/>
               </a:ext>
             </a:extLst>
           </p:cNvPr>
@@ -6303,7 +6534,7 @@
     </p:spTree>
     <p:extLst>
       <p:ext uri="{BB962C8B-B14F-4D97-AF65-F5344CB8AC3E}">
-        <p14:creationId xmlns:p14="http://schemas.microsoft.com/office/powerpoint/2010/main" val="206534543"/>
+        <p14:creationId xmlns:p14="http://schemas.microsoft.com/office/powerpoint/2010/main" val="1302451168"/>
       </p:ext>
     </p:extLst>
   </p:cSld>
@@ -6334,7 +6565,7 @@
           <p:cNvPr id="10" name="">
             <a:extLst xmlns:a="http://schemas.openxmlformats.org/drawingml/2006/main">
               <a:ext uri="{FF2B5EF4-FFF2-40B4-BE49-F238E27FC236}">
-                <a16:creationId xmlns:a16="http://schemas.microsoft.com/office/drawing/2014/main" id="{B507F7CD-390D-4E52-BBED-4E569F0BBEDA}"/>
+                <a16:creationId xmlns:a16="http://schemas.microsoft.com/office/drawing/2014/main" id="{DEA938C9-8ECB-449C-A9FE-C467523E16C6}"/>
               </a:ext>
             </a:extLst>
           </p:cNvPr>
@@ -6367,7 +6598,7 @@
           <p:cNvPr id="2" name="">
             <a:extLst xmlns:a="http://schemas.openxmlformats.org/drawingml/2006/main">
               <a:ext uri="{FF2B5EF4-FFF2-40B4-BE49-F238E27FC236}">
-                <a16:creationId xmlns:a16="http://schemas.microsoft.com/office/drawing/2014/main" id="{1443E70E-C8E0-4FC1-A0EF-6B1C75B9A394}"/>
+                <a16:creationId xmlns:a16="http://schemas.microsoft.com/office/drawing/2014/main" id="{B21EC451-9291-4A42-984B-620D200D00F2}"/>
               </a:ext>
             </a:extLst>
           </p:cNvPr>
@@ -6425,7 +6656,7 @@
           <p:cNvPr id="3" name="">
             <a:extLst xmlns:a="http://schemas.openxmlformats.org/drawingml/2006/main">
               <a:ext uri="{FF2B5EF4-FFF2-40B4-BE49-F238E27FC236}">
-                <a16:creationId xmlns:a16="http://schemas.microsoft.com/office/drawing/2014/main" id="{9CE48A09-BEB3-4B49-8BF4-07FF52654F9E}"/>
+                <a16:creationId xmlns:a16="http://schemas.microsoft.com/office/drawing/2014/main" id="{1D0714FB-BDE9-468A-9072-FCD9DF0851B3}"/>
               </a:ext>
             </a:extLst>
           </p:cNvPr>
@@ -6483,7 +6714,7 @@
           <p:cNvPr id="4" name="">
             <a:extLst xmlns:a="http://schemas.openxmlformats.org/drawingml/2006/main">
               <a:ext uri="{FF2B5EF4-FFF2-40B4-BE49-F238E27FC236}">
-                <a16:creationId xmlns:a16="http://schemas.microsoft.com/office/drawing/2014/main" id="{630683AD-6892-4891-81AB-A87076D8BEED}"/>
+                <a16:creationId xmlns:a16="http://schemas.microsoft.com/office/drawing/2014/main" id="{830CBEF7-06B5-4E5A-BCAE-9DF42823480C}"/>
               </a:ext>
             </a:extLst>
           </p:cNvPr>
@@ -6541,7 +6772,7 @@
           <p:cNvPr id="5" name="">
             <a:extLst xmlns:a="http://schemas.openxmlformats.org/drawingml/2006/main">
               <a:ext uri="{FF2B5EF4-FFF2-40B4-BE49-F238E27FC236}">
-                <a16:creationId xmlns:a16="http://schemas.microsoft.com/office/drawing/2014/main" id="{FBCE7552-1375-4CCF-814B-3FA26E0D0862}"/>
+                <a16:creationId xmlns:a16="http://schemas.microsoft.com/office/drawing/2014/main" id="{2BBED889-8385-46AB-8FDE-74E3E7FD0812}"/>
               </a:ext>
             </a:extLst>
           </p:cNvPr>
@@ -6572,7 +6803,7 @@
           <p:cNvPr id="6" name="">
             <a:extLst xmlns:a="http://schemas.openxmlformats.org/drawingml/2006/main">
               <a:ext uri="{FF2B5EF4-FFF2-40B4-BE49-F238E27FC236}">
-                <a16:creationId xmlns:a16="http://schemas.microsoft.com/office/drawing/2014/main" id="{D4BE0B6F-8928-45B4-9312-529F9DA4756A}"/>
+                <a16:creationId xmlns:a16="http://schemas.microsoft.com/office/drawing/2014/main" id="{56EF6A2D-AB1F-4BBC-BB98-CA695234B87D}"/>
               </a:ext>
             </a:extLst>
           </p:cNvPr>
@@ -6603,7 +6834,7 @@
           <p:cNvPr id="7" name="">
             <a:extLst xmlns:a="http://schemas.openxmlformats.org/drawingml/2006/main">
               <a:ext uri="{FF2B5EF4-FFF2-40B4-BE49-F238E27FC236}">
-                <a16:creationId xmlns:a16="http://schemas.microsoft.com/office/drawing/2014/main" id="{520A9B4E-4DF9-455E-8901-4C343549B2EA}"/>
+                <a16:creationId xmlns:a16="http://schemas.microsoft.com/office/drawing/2014/main" id="{1E7E1496-1ADD-4BDD-83E6-72702EB27A75}"/>
               </a:ext>
             </a:extLst>
           </p:cNvPr>
@@ -7068,7 +7299,7 @@
           <p:cNvPr id="9" name="">
             <a:extLst xmlns:a="http://schemas.openxmlformats.org/drawingml/2006/main">
               <a:ext uri="{FF2B5EF4-FFF2-40B4-BE49-F238E27FC236}">
-                <a16:creationId xmlns:a16="http://schemas.microsoft.com/office/drawing/2014/main" id="{7FEF5E2C-A00B-4FF2-8F19-94BBF4628884}"/>
+                <a16:creationId xmlns:a16="http://schemas.microsoft.com/office/drawing/2014/main" id="{3208A363-BFEF-410C-AD61-9D236E555831}"/>
               </a:ext>
             </a:extLst>
           </p:cNvPr>
@@ -7124,7 +7355,7 @@
     </p:spTree>
     <p:extLst>
       <p:ext uri="{BB962C8B-B14F-4D97-AF65-F5344CB8AC3E}">
-        <p14:creationId xmlns:p14="http://schemas.microsoft.com/office/powerpoint/2010/main" val="1409476747"/>
+        <p14:creationId xmlns:p14="http://schemas.microsoft.com/office/powerpoint/2010/main" val="1792698719"/>
       </p:ext>
     </p:extLst>
   </p:cSld>
@@ -7155,7 +7386,7 @@
           <p:cNvPr id="11" name="">
             <a:extLst xmlns:a="http://schemas.openxmlformats.org/drawingml/2006/main">
               <a:ext uri="{FF2B5EF4-FFF2-40B4-BE49-F238E27FC236}">
-                <a16:creationId xmlns:a16="http://schemas.microsoft.com/office/drawing/2014/main" id="{A9BF50F2-61A7-4505-8F99-E3DEE011BE33}"/>
+                <a16:creationId xmlns:a16="http://schemas.microsoft.com/office/drawing/2014/main" id="{16629C5E-3365-4A57-B206-07131269A2F4}"/>
               </a:ext>
             </a:extLst>
           </p:cNvPr>
@@ -7188,7 +7419,7 @@
           <p:cNvPr id="2" name="">
             <a:extLst xmlns:a="http://schemas.openxmlformats.org/drawingml/2006/main">
               <a:ext uri="{FF2B5EF4-FFF2-40B4-BE49-F238E27FC236}">
-                <a16:creationId xmlns:a16="http://schemas.microsoft.com/office/drawing/2014/main" id="{A3688D4A-CA7D-4DCB-AE33-40447324F61A}"/>
+                <a16:creationId xmlns:a16="http://schemas.microsoft.com/office/drawing/2014/main" id="{337C59BE-AF39-445D-A134-2ECEAE26DBDD}"/>
               </a:ext>
             </a:extLst>
           </p:cNvPr>
@@ -7246,7 +7477,7 @@
           <p:cNvPr id="3" name="">
             <a:extLst xmlns:a="http://schemas.openxmlformats.org/drawingml/2006/main">
               <a:ext uri="{FF2B5EF4-FFF2-40B4-BE49-F238E27FC236}">
-                <a16:creationId xmlns:a16="http://schemas.microsoft.com/office/drawing/2014/main" id="{504A1BD0-712C-4F06-A513-263D4ACE9F27}"/>
+                <a16:creationId xmlns:a16="http://schemas.microsoft.com/office/drawing/2014/main" id="{98014D66-BAED-4ED0-B90F-BFBB38D5FB8B}"/>
               </a:ext>
             </a:extLst>
           </p:cNvPr>
@@ -7304,7 +7535,7 @@
           <p:cNvPr id="4" name="">
             <a:extLst xmlns:a="http://schemas.openxmlformats.org/drawingml/2006/main">
               <a:ext uri="{FF2B5EF4-FFF2-40B4-BE49-F238E27FC236}">
-                <a16:creationId xmlns:a16="http://schemas.microsoft.com/office/drawing/2014/main" id="{F82FCF62-6FF9-4C97-AEBD-38AAEC49155B}"/>
+                <a16:creationId xmlns:a16="http://schemas.microsoft.com/office/drawing/2014/main" id="{E5E9EBD6-65BE-434B-BD7A-E9232C9FE4AB}"/>
               </a:ext>
             </a:extLst>
           </p:cNvPr>
@@ -7352,7 +7583,7 @@
                 <a:ea typeface="Helvetica Neue"/>
                 <a:cs typeface="Helvetica Neue"/>
               </a:rPr>
-              <a:t>Expected Scenario Produces $8.8M Net Savings</a:t>
+              <a:t>Expected Scenario Produces $8.81M Net Savings</a:t>
             </a:r>
           </a:p>
         </p:txBody>
@@ -7362,7 +7593,7 @@
           <p:cNvPr id="5" name="">
             <a:extLst xmlns:a="http://schemas.openxmlformats.org/drawingml/2006/main">
               <a:ext uri="{FF2B5EF4-FFF2-40B4-BE49-F238E27FC236}">
-                <a16:creationId xmlns:a16="http://schemas.microsoft.com/office/drawing/2014/main" id="{8ECDC92D-D0B4-4C60-8CF2-2D363829EE24}"/>
+                <a16:creationId xmlns:a16="http://schemas.microsoft.com/office/drawing/2014/main" id="{E677A422-5294-4442-AC58-671660D1EE6D}"/>
               </a:ext>
             </a:extLst>
           </p:cNvPr>
@@ -7393,7 +7624,7 @@
           <p:cNvPr id="6" name="">
             <a:extLst xmlns:a="http://schemas.openxmlformats.org/drawingml/2006/main">
               <a:ext uri="{FF2B5EF4-FFF2-40B4-BE49-F238E27FC236}">
-                <a16:creationId xmlns:a16="http://schemas.microsoft.com/office/drawing/2014/main" id="{F99045E0-9DDD-49E1-BBB7-DA22F5EF0007}"/>
+                <a16:creationId xmlns:a16="http://schemas.microsoft.com/office/drawing/2014/main" id="{932002D4-1A4B-49A2-AAA9-9112B4AA9D87}"/>
               </a:ext>
             </a:extLst>
           </p:cNvPr>
@@ -7424,7 +7655,7 @@
           <p:cNvPr id="7" name="">
             <a:extLst xmlns:a="http://schemas.openxmlformats.org/drawingml/2006/main">
               <a:ext uri="{FF2B5EF4-FFF2-40B4-BE49-F238E27FC236}">
-                <a16:creationId xmlns:a16="http://schemas.microsoft.com/office/drawing/2014/main" id="{9206C92F-9EC0-4ADB-85F9-3B244BE5F771}"/>
+                <a16:creationId xmlns:a16="http://schemas.microsoft.com/office/drawing/2014/main" id="{8BD05FA5-99F4-4747-85CE-F37D2B0E1BDD}"/>
               </a:ext>
             </a:extLst>
           </p:cNvPr>
@@ -7489,7 +7720,7 @@
         </p:xfrm>
         <a:graphic xmlns:a="http://schemas.openxmlformats.org/drawingml/2006/main">
           <a:graphicData uri="http://schemas.openxmlformats.org/drawingml/2006/chart">
-            <c:chart xmlns:r="http://schemas.openxmlformats.org/officeDocument/2006/relationships" xmlns:c="http://schemas.openxmlformats.org/drawingml/2006/chart" r:id="Ra1ef5e475428458e"/>
+            <c:chart xmlns:r="http://schemas.openxmlformats.org/officeDocument/2006/relationships" xmlns:c="http://schemas.openxmlformats.org/drawingml/2006/chart" r:id="Ra59fd6fde9df49b5"/>
           </a:graphicData>
         </a:graphic>
       </p:graphicFrame>
@@ -7711,7 +7942,7 @@
                           <a:ea typeface="Helvetica Neue"/>
                           <a:cs typeface="Helvetica Neue"/>
                         </a:rPr>
-                        <a:t>$4.3M</a:t>
+                        <a:t>$4.28M</a:t>
                       </a:r>
                     </a:p>
                   </a:txBody>
@@ -7813,7 +8044,7 @@
                           <a:ea typeface="Helvetica Neue"/>
                           <a:cs typeface="Helvetica Neue"/>
                         </a:rPr>
-                        <a:t>$8.8M</a:t>
+                        <a:t>$8.81M</a:t>
                       </a:r>
                     </a:p>
                   </a:txBody>
@@ -7915,7 +8146,7 @@
                           <a:ea typeface="Helvetica Neue"/>
                           <a:cs typeface="Helvetica Neue"/>
                         </a:rPr>
-                        <a:t>$13.4M</a:t>
+                        <a:t>$13.36M</a:t>
                       </a:r>
                     </a:p>
                   </a:txBody>
@@ -7951,7 +8182,7 @@
           <p:cNvPr id="10" name="">
             <a:extLst xmlns:a="http://schemas.openxmlformats.org/drawingml/2006/main">
               <a:ext uri="{FF2B5EF4-FFF2-40B4-BE49-F238E27FC236}">
-                <a16:creationId xmlns:a16="http://schemas.microsoft.com/office/drawing/2014/main" id="{4BF3E0CE-E455-42C9-B382-D26A57B7B32E}"/>
+                <a16:creationId xmlns:a16="http://schemas.microsoft.com/office/drawing/2014/main" id="{9D56C27C-7357-4F00-81AC-057AAE1F2EBC}"/>
               </a:ext>
             </a:extLst>
           </p:cNvPr>
@@ -8007,7 +8238,7 @@
     </p:spTree>
     <p:extLst>
       <p:ext uri="{BB962C8B-B14F-4D97-AF65-F5344CB8AC3E}">
-        <p14:creationId xmlns:p14="http://schemas.microsoft.com/office/powerpoint/2010/main" val="703660515"/>
+        <p14:creationId xmlns:p14="http://schemas.microsoft.com/office/powerpoint/2010/main" val="1876704400"/>
       </p:ext>
     </p:extLst>
   </p:cSld>
@@ -8038,7 +8269,7 @@
           <p:cNvPr id="9" name="">
             <a:extLst xmlns:a="http://schemas.openxmlformats.org/drawingml/2006/main">
               <a:ext uri="{FF2B5EF4-FFF2-40B4-BE49-F238E27FC236}">
-                <a16:creationId xmlns:a16="http://schemas.microsoft.com/office/drawing/2014/main" id="{EF8C87C2-75E6-44E0-9B96-2206FC71979F}"/>
+                <a16:creationId xmlns:a16="http://schemas.microsoft.com/office/drawing/2014/main" id="{752B3AE4-F6A1-438A-8A4F-0CBCBC12A08B}"/>
               </a:ext>
             </a:extLst>
           </p:cNvPr>
@@ -8071,7 +8302,7 @@
           <p:cNvPr id="2" name="">
             <a:extLst xmlns:a="http://schemas.openxmlformats.org/drawingml/2006/main">
               <a:ext uri="{FF2B5EF4-FFF2-40B4-BE49-F238E27FC236}">
-                <a16:creationId xmlns:a16="http://schemas.microsoft.com/office/drawing/2014/main" id="{B5576396-AB08-4760-A704-4A645811D5E1}"/>
+                <a16:creationId xmlns:a16="http://schemas.microsoft.com/office/drawing/2014/main" id="{191A0E64-694C-4E45-BFE4-E3B90B59BACA}"/>
               </a:ext>
             </a:extLst>
           </p:cNvPr>
@@ -8129,7 +8360,7 @@
           <p:cNvPr id="3" name="">
             <a:extLst xmlns:a="http://schemas.openxmlformats.org/drawingml/2006/main">
               <a:ext uri="{FF2B5EF4-FFF2-40B4-BE49-F238E27FC236}">
-                <a16:creationId xmlns:a16="http://schemas.microsoft.com/office/drawing/2014/main" id="{193E03AD-8264-42B7-9598-E1194A894862}"/>
+                <a16:creationId xmlns:a16="http://schemas.microsoft.com/office/drawing/2014/main" id="{00BC45D7-7C82-491D-B4CD-69E30EA07106}"/>
               </a:ext>
             </a:extLst>
           </p:cNvPr>
@@ -8187,7 +8418,7 @@
           <p:cNvPr id="4" name="">
             <a:extLst xmlns:a="http://schemas.openxmlformats.org/drawingml/2006/main">
               <a:ext uri="{FF2B5EF4-FFF2-40B4-BE49-F238E27FC236}">
-                <a16:creationId xmlns:a16="http://schemas.microsoft.com/office/drawing/2014/main" id="{6B6DC849-3B89-43EB-9A90-513F1469C51A}"/>
+                <a16:creationId xmlns:a16="http://schemas.microsoft.com/office/drawing/2014/main" id="{0E90B695-4BFC-469B-BFD7-B6BC66557393}"/>
               </a:ext>
             </a:extLst>
           </p:cNvPr>
@@ -8245,7 +8476,7 @@
           <p:cNvPr id="5" name="">
             <a:extLst xmlns:a="http://schemas.openxmlformats.org/drawingml/2006/main">
               <a:ext uri="{FF2B5EF4-FFF2-40B4-BE49-F238E27FC236}">
-                <a16:creationId xmlns:a16="http://schemas.microsoft.com/office/drawing/2014/main" id="{21F5E8D5-8F62-4AAE-AFD2-849FA76A9322}"/>
+                <a16:creationId xmlns:a16="http://schemas.microsoft.com/office/drawing/2014/main" id="{1BADF9E5-019B-4F40-8620-1B41862CC95D}"/>
               </a:ext>
             </a:extLst>
           </p:cNvPr>
@@ -8276,7 +8507,7 @@
           <p:cNvPr id="6" name="">
             <a:extLst xmlns:a="http://schemas.openxmlformats.org/drawingml/2006/main">
               <a:ext uri="{FF2B5EF4-FFF2-40B4-BE49-F238E27FC236}">
-                <a16:creationId xmlns:a16="http://schemas.microsoft.com/office/drawing/2014/main" id="{F3BB6525-CFE6-44E8-A339-CFC9C2AF54D8}"/>
+                <a16:creationId xmlns:a16="http://schemas.microsoft.com/office/drawing/2014/main" id="{25C8FD7C-FD54-4598-A500-4B098618C787}"/>
               </a:ext>
             </a:extLst>
           </p:cNvPr>
@@ -8307,7 +8538,7 @@
           <p:cNvPr id="7" name="">
             <a:extLst xmlns:a="http://schemas.openxmlformats.org/drawingml/2006/main">
               <a:ext uri="{FF2B5EF4-FFF2-40B4-BE49-F238E27FC236}">
-                <a16:creationId xmlns:a16="http://schemas.microsoft.com/office/drawing/2014/main" id="{49A0D1F2-2D6B-455D-A6C9-35670CB73449}"/>
+                <a16:creationId xmlns:a16="http://schemas.microsoft.com/office/drawing/2014/main" id="{6540D6A3-16DB-4BD1-9DF8-394E1DC9EA80}"/>
               </a:ext>
             </a:extLst>
           </p:cNvPr>
@@ -8736,7 +8967,7 @@
                           <a:ea typeface="Helvetica Neue"/>
                           <a:cs typeface="Helvetica Neue"/>
                         </a:rPr>
-                        <a:t>Build Tableau or Power BI dashboard using the prepared dashboard extract.</a:t>
+                        <a:t>Build Tableau dashboard using the prepared dashboard extract.</a:t>
                       </a:r>
                     </a:p>
                   </a:txBody>
@@ -8894,7 +9125,7 @@
     </p:spTree>
     <p:extLst>
       <p:ext uri="{BB962C8B-B14F-4D97-AF65-F5344CB8AC3E}">
-        <p14:creationId xmlns:p14="http://schemas.microsoft.com/office/powerpoint/2010/main" val="1473638739"/>
+        <p14:creationId xmlns:p14="http://schemas.microsoft.com/office/powerpoint/2010/main" val="355520544"/>
       </p:ext>
     </p:extLst>
   </p:cSld>
@@ -8925,7 +9156,7 @@
           <p:cNvPr id="15" name="">
             <a:extLst xmlns:a="http://schemas.openxmlformats.org/drawingml/2006/main">
               <a:ext uri="{FF2B5EF4-FFF2-40B4-BE49-F238E27FC236}">
-                <a16:creationId xmlns:a16="http://schemas.microsoft.com/office/drawing/2014/main" id="{763EE97D-7ABA-4E5A-9FFD-D2E524AA09A9}"/>
+                <a16:creationId xmlns:a16="http://schemas.microsoft.com/office/drawing/2014/main" id="{09904F71-3191-4039-BFDB-3B420F8D0463}"/>
               </a:ext>
             </a:extLst>
           </p:cNvPr>
@@ -8958,7 +9189,7 @@
           <p:cNvPr id="2" name="">
             <a:extLst xmlns:a="http://schemas.openxmlformats.org/drawingml/2006/main">
               <a:ext uri="{FF2B5EF4-FFF2-40B4-BE49-F238E27FC236}">
-                <a16:creationId xmlns:a16="http://schemas.microsoft.com/office/drawing/2014/main" id="{4341200B-B214-4E53-9643-1658486BD38F}"/>
+                <a16:creationId xmlns:a16="http://schemas.microsoft.com/office/drawing/2014/main" id="{09B98AE4-EC27-4394-B969-6E9EEF5A7A50}"/>
               </a:ext>
             </a:extLst>
           </p:cNvPr>
@@ -9016,7 +9247,7 @@
           <p:cNvPr id="3" name="">
             <a:extLst xmlns:a="http://schemas.openxmlformats.org/drawingml/2006/main">
               <a:ext uri="{FF2B5EF4-FFF2-40B4-BE49-F238E27FC236}">
-                <a16:creationId xmlns:a16="http://schemas.microsoft.com/office/drawing/2014/main" id="{EF90C26A-A4C8-4A9F-9519-C28E1EAAE920}"/>
+                <a16:creationId xmlns:a16="http://schemas.microsoft.com/office/drawing/2014/main" id="{844E2ACC-9F07-486B-97AE-0F32991657A4}"/>
               </a:ext>
             </a:extLst>
           </p:cNvPr>
@@ -9074,7 +9305,7 @@
           <p:cNvPr id="4" name="">
             <a:extLst xmlns:a="http://schemas.openxmlformats.org/drawingml/2006/main">
               <a:ext uri="{FF2B5EF4-FFF2-40B4-BE49-F238E27FC236}">
-                <a16:creationId xmlns:a16="http://schemas.microsoft.com/office/drawing/2014/main" id="{545E2D77-B51A-4FDD-9FF6-9A4FBC38A12B}"/>
+                <a16:creationId xmlns:a16="http://schemas.microsoft.com/office/drawing/2014/main" id="{E3FF4B95-9C1A-4A1B-BB2F-6B91C78D6978}"/>
               </a:ext>
             </a:extLst>
           </p:cNvPr>
@@ -9132,7 +9363,7 @@
           <p:cNvPr id="5" name="">
             <a:extLst xmlns:a="http://schemas.openxmlformats.org/drawingml/2006/main">
               <a:ext uri="{FF2B5EF4-FFF2-40B4-BE49-F238E27FC236}">
-                <a16:creationId xmlns:a16="http://schemas.microsoft.com/office/drawing/2014/main" id="{2D7846AA-66E4-4E92-B378-C02A93870967}"/>
+                <a16:creationId xmlns:a16="http://schemas.microsoft.com/office/drawing/2014/main" id="{CEC64130-E647-4988-8B68-6D89B4013FF6}"/>
               </a:ext>
             </a:extLst>
           </p:cNvPr>
@@ -9163,7 +9394,7 @@
           <p:cNvPr id="6" name="">
             <a:extLst xmlns:a="http://schemas.openxmlformats.org/drawingml/2006/main">
               <a:ext uri="{FF2B5EF4-FFF2-40B4-BE49-F238E27FC236}">
-                <a16:creationId xmlns:a16="http://schemas.microsoft.com/office/drawing/2014/main" id="{D8FF1495-E2CF-479E-876C-C35FB4C06A1F}"/>
+                <a16:creationId xmlns:a16="http://schemas.microsoft.com/office/drawing/2014/main" id="{DC5555AC-8A25-4BD6-AA15-97C2FA2FD212}"/>
               </a:ext>
             </a:extLst>
           </p:cNvPr>
@@ -9194,7 +9425,7 @@
           <p:cNvPr id="7" name="">
             <a:extLst xmlns:a="http://schemas.openxmlformats.org/drawingml/2006/main">
               <a:ext uri="{FF2B5EF4-FFF2-40B4-BE49-F238E27FC236}">
-                <a16:creationId xmlns:a16="http://schemas.microsoft.com/office/drawing/2014/main" id="{96B53F55-4D6F-4F3D-8809-5002D783675B}"/>
+                <a16:creationId xmlns:a16="http://schemas.microsoft.com/office/drawing/2014/main" id="{EBB65FFB-FE94-408F-9C66-EF0ED80E4EFA}"/>
               </a:ext>
             </a:extLst>
           </p:cNvPr>
@@ -9866,7 +10097,7 @@
           <p:cNvPr id="9" name="">
             <a:extLst xmlns:a="http://schemas.openxmlformats.org/drawingml/2006/main">
               <a:ext uri="{FF2B5EF4-FFF2-40B4-BE49-F238E27FC236}">
-                <a16:creationId xmlns:a16="http://schemas.microsoft.com/office/drawing/2014/main" id="{25E0537E-5EFC-46C7-9013-B5877F298AFD}"/>
+                <a16:creationId xmlns:a16="http://schemas.microsoft.com/office/drawing/2014/main" id="{2778CB8F-7649-41FF-8DE2-81ED3F2BEC01}"/>
               </a:ext>
             </a:extLst>
           </p:cNvPr>
@@ -9924,7 +10155,7 @@
           <p:cNvPr id="10" name="">
             <a:extLst xmlns:a="http://schemas.openxmlformats.org/drawingml/2006/main">
               <a:ext uri="{FF2B5EF4-FFF2-40B4-BE49-F238E27FC236}">
-                <a16:creationId xmlns:a16="http://schemas.microsoft.com/office/drawing/2014/main" id="{ED0DDA90-A0A9-4572-A972-81F42BD07399}"/>
+                <a16:creationId xmlns:a16="http://schemas.microsoft.com/office/drawing/2014/main" id="{01F770E5-D141-49D7-AC23-055ABB019DCD}"/>
               </a:ext>
             </a:extLst>
           </p:cNvPr>
@@ -9982,7 +10213,7 @@
           <p:cNvPr id="11" name="">
             <a:extLst xmlns:a="http://schemas.openxmlformats.org/drawingml/2006/main">
               <a:ext uri="{FF2B5EF4-FFF2-40B4-BE49-F238E27FC236}">
-                <a16:creationId xmlns:a16="http://schemas.microsoft.com/office/drawing/2014/main" id="{628EEB44-E82B-4C6B-B1A7-42B50750DC81}"/>
+                <a16:creationId xmlns:a16="http://schemas.microsoft.com/office/drawing/2014/main" id="{A06F91EE-AD56-4037-ADDB-CB9F470ABFDF}"/>
               </a:ext>
             </a:extLst>
           </p:cNvPr>
@@ -10040,7 +10271,7 @@
           <p:cNvPr id="12" name="">
             <a:extLst xmlns:a="http://schemas.openxmlformats.org/drawingml/2006/main">
               <a:ext uri="{FF2B5EF4-FFF2-40B4-BE49-F238E27FC236}">
-                <a16:creationId xmlns:a16="http://schemas.microsoft.com/office/drawing/2014/main" id="{2DD0DB62-65A2-46C4-8B66-C1B21A219788}"/>
+                <a16:creationId xmlns:a16="http://schemas.microsoft.com/office/drawing/2014/main" id="{D950724A-FEE6-464C-B1E8-74FF21A44DEB}"/>
               </a:ext>
             </a:extLst>
           </p:cNvPr>
@@ -10098,7 +10329,7 @@
           <p:cNvPr id="13" name="">
             <a:extLst xmlns:a="http://schemas.openxmlformats.org/drawingml/2006/main">
               <a:ext uri="{FF2B5EF4-FFF2-40B4-BE49-F238E27FC236}">
-                <a16:creationId xmlns:a16="http://schemas.microsoft.com/office/drawing/2014/main" id="{120D5FAC-EE7C-41B1-8A79-01D921A05D24}"/>
+                <a16:creationId xmlns:a16="http://schemas.microsoft.com/office/drawing/2014/main" id="{C9C2D73B-B6F8-454C-BF7B-F60075C68D33}"/>
               </a:ext>
             </a:extLst>
           </p:cNvPr>
@@ -10156,7 +10387,7 @@
           <p:cNvPr id="14" name="">
             <a:extLst xmlns:a="http://schemas.openxmlformats.org/drawingml/2006/main">
               <a:ext uri="{FF2B5EF4-FFF2-40B4-BE49-F238E27FC236}">
-                <a16:creationId xmlns:a16="http://schemas.microsoft.com/office/drawing/2014/main" id="{2131ACC7-89F9-48AC-B3B2-AD86AB6B03CF}"/>
+                <a16:creationId xmlns:a16="http://schemas.microsoft.com/office/drawing/2014/main" id="{639C21FC-3C6D-439E-B797-4F61A6D2FFB5}"/>
               </a:ext>
             </a:extLst>
           </p:cNvPr>
@@ -10212,7 +10443,7 @@
     </p:spTree>
     <p:extLst>
       <p:ext uri="{BB962C8B-B14F-4D97-AF65-F5344CB8AC3E}">
-        <p14:creationId xmlns:p14="http://schemas.microsoft.com/office/powerpoint/2010/main" val="710527400"/>
+        <p14:creationId xmlns:p14="http://schemas.microsoft.com/office/powerpoint/2010/main" val="646916536"/>
       </p:ext>
     </p:extLst>
   </p:cSld>
@@ -10243,7 +10474,7 @@
           <p:cNvPr id="20" name="">
             <a:extLst xmlns:a="http://schemas.openxmlformats.org/drawingml/2006/main">
               <a:ext uri="{FF2B5EF4-FFF2-40B4-BE49-F238E27FC236}">
-                <a16:creationId xmlns:a16="http://schemas.microsoft.com/office/drawing/2014/main" id="{647010C8-495A-458C-8ED3-C9F7AC6B609D}"/>
+                <a16:creationId xmlns:a16="http://schemas.microsoft.com/office/drawing/2014/main" id="{1E257C25-928E-4516-99F2-2AF589D976ED}"/>
               </a:ext>
             </a:extLst>
           </p:cNvPr>
@@ -10276,7 +10507,7 @@
           <p:cNvPr id="2" name="">
             <a:extLst xmlns:a="http://schemas.openxmlformats.org/drawingml/2006/main">
               <a:ext uri="{FF2B5EF4-FFF2-40B4-BE49-F238E27FC236}">
-                <a16:creationId xmlns:a16="http://schemas.microsoft.com/office/drawing/2014/main" id="{488A34C1-DF2D-418B-8E19-FE24F515D4D7}"/>
+                <a16:creationId xmlns:a16="http://schemas.microsoft.com/office/drawing/2014/main" id="{290A9F91-7006-443A-B9CF-FCC9FEA4C41A}"/>
               </a:ext>
             </a:extLst>
           </p:cNvPr>
@@ -10334,7 +10565,7 @@
           <p:cNvPr id="3" name="">
             <a:extLst xmlns:a="http://schemas.openxmlformats.org/drawingml/2006/main">
               <a:ext uri="{FF2B5EF4-FFF2-40B4-BE49-F238E27FC236}">
-                <a16:creationId xmlns:a16="http://schemas.microsoft.com/office/drawing/2014/main" id="{9D233319-8CA4-43A2-8C06-C6B2E05EB8F5}"/>
+                <a16:creationId xmlns:a16="http://schemas.microsoft.com/office/drawing/2014/main" id="{9F3D5F91-1205-489E-A782-2DDC5403D2B4}"/>
               </a:ext>
             </a:extLst>
           </p:cNvPr>
@@ -10392,7 +10623,7 @@
           <p:cNvPr id="4" name="">
             <a:extLst xmlns:a="http://schemas.openxmlformats.org/drawingml/2006/main">
               <a:ext uri="{FF2B5EF4-FFF2-40B4-BE49-F238E27FC236}">
-                <a16:creationId xmlns:a16="http://schemas.microsoft.com/office/drawing/2014/main" id="{FDAE26A6-68C6-4D61-864F-9C756D37A5A1}"/>
+                <a16:creationId xmlns:a16="http://schemas.microsoft.com/office/drawing/2014/main" id="{18A1A501-AD96-4D0A-9253-FF4F616BC662}"/>
               </a:ext>
             </a:extLst>
           </p:cNvPr>
@@ -10450,7 +10681,7 @@
           <p:cNvPr id="5" name="">
             <a:extLst xmlns:a="http://schemas.openxmlformats.org/drawingml/2006/main">
               <a:ext uri="{FF2B5EF4-FFF2-40B4-BE49-F238E27FC236}">
-                <a16:creationId xmlns:a16="http://schemas.microsoft.com/office/drawing/2014/main" id="{D68E23C8-BCE4-4F82-9860-3BF2C195E4E6}"/>
+                <a16:creationId xmlns:a16="http://schemas.microsoft.com/office/drawing/2014/main" id="{09E28A62-3323-498E-9FF0-E6C0117EE3AB}"/>
               </a:ext>
             </a:extLst>
           </p:cNvPr>
@@ -10481,7 +10712,7 @@
           <p:cNvPr id="6" name="">
             <a:extLst xmlns:a="http://schemas.openxmlformats.org/drawingml/2006/main">
               <a:ext uri="{FF2B5EF4-FFF2-40B4-BE49-F238E27FC236}">
-                <a16:creationId xmlns:a16="http://schemas.microsoft.com/office/drawing/2014/main" id="{E8F9A4D5-16CC-4A36-AD6C-35D9CE72F731}"/>
+                <a16:creationId xmlns:a16="http://schemas.microsoft.com/office/drawing/2014/main" id="{2B6DFAB4-7087-4E95-B6B9-F0404A6B527F}"/>
               </a:ext>
             </a:extLst>
           </p:cNvPr>
@@ -10512,7 +10743,7 @@
           <p:cNvPr id="7" name="">
             <a:extLst xmlns:a="http://schemas.openxmlformats.org/drawingml/2006/main">
               <a:ext uri="{FF2B5EF4-FFF2-40B4-BE49-F238E27FC236}">
-                <a16:creationId xmlns:a16="http://schemas.microsoft.com/office/drawing/2014/main" id="{510A94D6-191D-4EB0-A647-13132F77FF76}"/>
+                <a16:creationId xmlns:a16="http://schemas.microsoft.com/office/drawing/2014/main" id="{23DE93A5-1B3C-4677-A889-5C78954FAA01}"/>
               </a:ext>
             </a:extLst>
           </p:cNvPr>
@@ -10570,7 +10801,7 @@
           <p:cNvPr id="8" name="">
             <a:extLst xmlns:a="http://schemas.openxmlformats.org/drawingml/2006/main">
               <a:ext uri="{FF2B5EF4-FFF2-40B4-BE49-F238E27FC236}">
-                <a16:creationId xmlns:a16="http://schemas.microsoft.com/office/drawing/2014/main" id="{AEE3BB0D-EA73-427C-A73F-1AC0EB7E180F}"/>
+                <a16:creationId xmlns:a16="http://schemas.microsoft.com/office/drawing/2014/main" id="{913295EB-668E-4B8C-8A01-A5D8E8F23EE9}"/>
               </a:ext>
             </a:extLst>
           </p:cNvPr>
@@ -10628,7 +10859,7 @@
           <p:cNvPr id="9" name="">
             <a:extLst xmlns:a="http://schemas.openxmlformats.org/drawingml/2006/main">
               <a:ext uri="{FF2B5EF4-FFF2-40B4-BE49-F238E27FC236}">
-                <a16:creationId xmlns:a16="http://schemas.microsoft.com/office/drawing/2014/main" id="{78042922-E4C4-4892-8E03-F8EB25D7658B}"/>
+                <a16:creationId xmlns:a16="http://schemas.microsoft.com/office/drawing/2014/main" id="{1A4E07D4-71BC-404A-AA5D-D12BD3056264}"/>
               </a:ext>
             </a:extLst>
           </p:cNvPr>
@@ -10686,7 +10917,7 @@
           <p:cNvPr id="10" name="">
             <a:extLst xmlns:a="http://schemas.openxmlformats.org/drawingml/2006/main">
               <a:ext uri="{FF2B5EF4-FFF2-40B4-BE49-F238E27FC236}">
-                <a16:creationId xmlns:a16="http://schemas.microsoft.com/office/drawing/2014/main" id="{8335782D-0C28-42BA-8110-1A07E23D324A}"/>
+                <a16:creationId xmlns:a16="http://schemas.microsoft.com/office/drawing/2014/main" id="{C8E699EC-B61E-4D7F-847F-0F32A5B87411}"/>
               </a:ext>
             </a:extLst>
           </p:cNvPr>
@@ -10744,7 +10975,7 @@
           <p:cNvPr id="11" name="">
             <a:extLst xmlns:a="http://schemas.openxmlformats.org/drawingml/2006/main">
               <a:ext uri="{FF2B5EF4-FFF2-40B4-BE49-F238E27FC236}">
-                <a16:creationId xmlns:a16="http://schemas.microsoft.com/office/drawing/2014/main" id="{1B67B7F7-912E-405A-9CD1-F3072206B040}"/>
+                <a16:creationId xmlns:a16="http://schemas.microsoft.com/office/drawing/2014/main" id="{B307BCC0-38A0-4A85-93CB-8375F352A306}"/>
               </a:ext>
             </a:extLst>
           </p:cNvPr>
@@ -10802,7 +11033,7 @@
           <p:cNvPr id="12" name="">
             <a:extLst xmlns:a="http://schemas.openxmlformats.org/drawingml/2006/main">
               <a:ext uri="{FF2B5EF4-FFF2-40B4-BE49-F238E27FC236}">
-                <a16:creationId xmlns:a16="http://schemas.microsoft.com/office/drawing/2014/main" id="{049EF215-DB35-4D03-A845-9AB5E6805C6F}"/>
+                <a16:creationId xmlns:a16="http://schemas.microsoft.com/office/drawing/2014/main" id="{3CA99134-97B1-430A-97CF-6C3CFC351250}"/>
               </a:ext>
             </a:extLst>
           </p:cNvPr>
@@ -10860,7 +11091,7 @@
           <p:cNvPr id="13" name="">
             <a:extLst xmlns:a="http://schemas.openxmlformats.org/drawingml/2006/main">
               <a:ext uri="{FF2B5EF4-FFF2-40B4-BE49-F238E27FC236}">
-                <a16:creationId xmlns:a16="http://schemas.microsoft.com/office/drawing/2014/main" id="{8CE2CAAB-9CE9-4A3A-B558-4C5DFB6E3C83}"/>
+                <a16:creationId xmlns:a16="http://schemas.microsoft.com/office/drawing/2014/main" id="{4D33CAAF-76F6-4CB7-B891-8C745A537966}"/>
               </a:ext>
             </a:extLst>
           </p:cNvPr>
@@ -10918,7 +11149,7 @@
           <p:cNvPr id="14" name="">
             <a:extLst xmlns:a="http://schemas.openxmlformats.org/drawingml/2006/main">
               <a:ext uri="{FF2B5EF4-FFF2-40B4-BE49-F238E27FC236}">
-                <a16:creationId xmlns:a16="http://schemas.microsoft.com/office/drawing/2014/main" id="{A9FF9E6E-3D49-4E0F-847D-F4DC6C58E140}"/>
+                <a16:creationId xmlns:a16="http://schemas.microsoft.com/office/drawing/2014/main" id="{FB0B98ED-19F2-4FD4-B40A-A70C07FDEB6A}"/>
               </a:ext>
             </a:extLst>
           </p:cNvPr>
@@ -10976,7 +11207,7 @@
           <p:cNvPr id="15" name="">
             <a:extLst xmlns:a="http://schemas.openxmlformats.org/drawingml/2006/main">
               <a:ext uri="{FF2B5EF4-FFF2-40B4-BE49-F238E27FC236}">
-                <a16:creationId xmlns:a16="http://schemas.microsoft.com/office/drawing/2014/main" id="{FB498C5F-E4F7-4EDC-AB7D-9EAB1D04C495}"/>
+                <a16:creationId xmlns:a16="http://schemas.microsoft.com/office/drawing/2014/main" id="{E23DECC9-C977-40F3-BFA7-D9DAC4EE5A36}"/>
               </a:ext>
             </a:extLst>
           </p:cNvPr>
@@ -11034,7 +11265,7 @@
           <p:cNvPr id="16" name="">
             <a:extLst xmlns:a="http://schemas.openxmlformats.org/drawingml/2006/main">
               <a:ext uri="{FF2B5EF4-FFF2-40B4-BE49-F238E27FC236}">
-                <a16:creationId xmlns:a16="http://schemas.microsoft.com/office/drawing/2014/main" id="{B8364671-68D7-473A-96FC-DCCE7CF6CB7E}"/>
+                <a16:creationId xmlns:a16="http://schemas.microsoft.com/office/drawing/2014/main" id="{7C5F4D6C-AB96-4364-B858-C03BC8A81113}"/>
               </a:ext>
             </a:extLst>
           </p:cNvPr>
@@ -11092,7 +11323,7 @@
           <p:cNvPr id="17" name="">
             <a:extLst xmlns:a="http://schemas.openxmlformats.org/drawingml/2006/main">
               <a:ext uri="{FF2B5EF4-FFF2-40B4-BE49-F238E27FC236}">
-                <a16:creationId xmlns:a16="http://schemas.microsoft.com/office/drawing/2014/main" id="{7021C20E-D189-47AE-B440-18FF41233689}"/>
+                <a16:creationId xmlns:a16="http://schemas.microsoft.com/office/drawing/2014/main" id="{55B78C60-762B-46C3-8499-F2EEB9C4A0EB}"/>
               </a:ext>
             </a:extLst>
           </p:cNvPr>
@@ -11150,7 +11381,7 @@
           <p:cNvPr id="18" name="">
             <a:extLst xmlns:a="http://schemas.openxmlformats.org/drawingml/2006/main">
               <a:ext uri="{FF2B5EF4-FFF2-40B4-BE49-F238E27FC236}">
-                <a16:creationId xmlns:a16="http://schemas.microsoft.com/office/drawing/2014/main" id="{F58230EA-439E-4314-98E3-7519A80F6257}"/>
+                <a16:creationId xmlns:a16="http://schemas.microsoft.com/office/drawing/2014/main" id="{914D1A81-A180-45D3-B1FC-256209F7F10C}"/>
               </a:ext>
             </a:extLst>
           </p:cNvPr>
@@ -11183,7 +11414,7 @@
           <p:cNvPr id="19" name="">
             <a:extLst xmlns:a="http://schemas.openxmlformats.org/drawingml/2006/main">
               <a:ext uri="{FF2B5EF4-FFF2-40B4-BE49-F238E27FC236}">
-                <a16:creationId xmlns:a16="http://schemas.microsoft.com/office/drawing/2014/main" id="{7AAE882B-FED5-4012-B263-91E5A4EE581E}"/>
+                <a16:creationId xmlns:a16="http://schemas.microsoft.com/office/drawing/2014/main" id="{A5D6D48E-FC2B-468A-8DE1-C9AD74832D1F}"/>
               </a:ext>
             </a:extLst>
           </p:cNvPr>
@@ -11239,7 +11470,778 @@
     </p:spTree>
     <p:extLst>
       <p:ext uri="{BB962C8B-B14F-4D97-AF65-F5344CB8AC3E}">
-        <p14:creationId xmlns:p14="http://schemas.microsoft.com/office/powerpoint/2010/main" val="284079066"/>
+        <p14:creationId xmlns:p14="http://schemas.microsoft.com/office/powerpoint/2010/main" val="1236330995"/>
+      </p:ext>
+    </p:extLst>
+  </p:cSld>
+</p:sld>
+</file>
+
+<file path=ppt/slides/slide16.xml><?xml version="1.0" encoding="utf-8"?>
+<p:sld xmlns:p="http://schemas.openxmlformats.org/presentationml/2006/main">
+  <p:cSld>
+    <p:bg>
+      <p:bgPr>
+        <a:solidFill xmlns:a="http://schemas.openxmlformats.org/drawingml/2006/main">
+          <a:srgbClr val="F5F8FA"/>
+        </a:solidFill>
+      </p:bgPr>
+    </p:bg>
+    <p:spTree>
+      <p:nvGrpSpPr>
+        <p:cNvPr id="1" name=""/>
+        <p:cNvGrpSpPr/>
+        <p:nvPr/>
+      </p:nvGrpSpPr>
+      <p:grpSpPr>
+        <a:xfrm xmlns:a="http://schemas.openxmlformats.org/drawingml/2006/main"/>
+      </p:grpSpPr>
+      <p:sp>
+        <p:nvSpPr>
+          <p:cNvPr id="11" name="">
+            <a:extLst xmlns:a="http://schemas.openxmlformats.org/drawingml/2006/main">
+              <a:ext uri="{FF2B5EF4-FFF2-40B4-BE49-F238E27FC236}">
+                <a16:creationId xmlns:a16="http://schemas.microsoft.com/office/drawing/2014/main" id="{59557B22-8305-410D-9E3C-056DC05422FF}"/>
+              </a:ext>
+            </a:extLst>
+          </p:cNvPr>
+          <p:cNvSpPr>
+            <a:spLocks xmlns:a="http://schemas.openxmlformats.org/drawingml/2006/main" noGrp="1"/>
+          </p:cNvSpPr>
+          <p:nvPr/>
+        </p:nvSpPr>
+        <p:spPr>
+          <a:xfrm xmlns:a="http://schemas.openxmlformats.org/drawingml/2006/main">
+            <a:off x="0" y="0"/>
+            <a:ext cx="12192000" cy="152400"/>
+          </a:xfrm>
+          <a:prstGeom xmlns:a="http://schemas.openxmlformats.org/drawingml/2006/main" prst="rect">
+            <a:avLst/>
+          </a:prstGeom>
+          <a:solidFill xmlns:a="http://schemas.openxmlformats.org/drawingml/2006/main">
+            <a:srgbClr val="0E5360"/>
+          </a:solidFill>
+          <a:ln xmlns:a="http://schemas.openxmlformats.org/drawingml/2006/main" w="0">
+            <a:solidFill>
+              <a:srgbClr val="0E5360"/>
+            </a:solidFill>
+            <a:prstDash val="solid"/>
+          </a:ln>
+        </p:spPr>
+      </p:sp>
+      <p:sp>
+        <p:nvSpPr>
+          <p:cNvPr id="2" name="">
+            <a:extLst xmlns:a="http://schemas.openxmlformats.org/drawingml/2006/main">
+              <a:ext uri="{FF2B5EF4-FFF2-40B4-BE49-F238E27FC236}">
+                <a16:creationId xmlns:a16="http://schemas.microsoft.com/office/drawing/2014/main" id="{E689CA61-4A80-4ACB-A30A-12BA69C2AC12}"/>
+              </a:ext>
+            </a:extLst>
+          </p:cNvPr>
+          <p:cNvSpPr>
+            <a:spLocks xmlns:a="http://schemas.openxmlformats.org/drawingml/2006/main" noGrp="1"/>
+          </p:cNvSpPr>
+          <p:nvPr/>
+        </p:nvSpPr>
+        <p:spPr>
+          <a:xfrm xmlns:a="http://schemas.openxmlformats.org/drawingml/2006/main">
+            <a:off x="609600" y="457200"/>
+            <a:ext cx="3429000" cy="247650"/>
+          </a:xfrm>
+          <a:prstGeom xmlns:a="http://schemas.openxmlformats.org/drawingml/2006/main" prst="rect">
+            <a:avLst/>
+          </a:prstGeom>
+          <a:noFill xmlns:a="http://schemas.openxmlformats.org/drawingml/2006/main"/>
+          <a:ln xmlns:a="http://schemas.openxmlformats.org/drawingml/2006/main" w="0">
+            <a:noFill/>
+            <a:prstDash val="solid"/>
+          </a:ln>
+        </p:spPr>
+        <p:txBody>
+          <a:bodyPr xmlns:a="http://schemas.openxmlformats.org/drawingml/2006/main">
+            <a:normAutofit fontScale="75926"/>
+          </a:bodyPr>
+          <a:lstStyle xmlns:a="http://schemas.openxmlformats.org/drawingml/2006/main"/>
+          <a:p xmlns:a="http://schemas.openxmlformats.org/drawingml/2006/main">
+            <a:pPr algn="l">
+              <a:defRPr sz="1350" b="1">
+                <a:solidFill>
+                  <a:srgbClr val="0B6F75"/>
+                </a:solidFill>
+                <a:latin typeface="Helvetica Neue"/>
+                <a:ea typeface="Helvetica Neue"/>
+                <a:cs typeface="Helvetica Neue"/>
+              </a:defRPr>
+            </a:pPr>
+            <a:r>
+              <a:rPr sz="1350" b="1">
+                <a:solidFill>
+                  <a:srgbClr val="0B6F75"/>
+                </a:solidFill>
+                <a:latin typeface="Helvetica Neue"/>
+                <a:ea typeface="Helvetica Neue"/>
+                <a:cs typeface="Helvetica Neue"/>
+              </a:rPr>
+              <a:t>Meds Consulting LLC</a:t>
+            </a:r>
+          </a:p>
+        </p:txBody>
+      </p:sp>
+      <p:sp>
+        <p:nvSpPr>
+          <p:cNvPr id="3" name="">
+            <a:extLst xmlns:a="http://schemas.openxmlformats.org/drawingml/2006/main">
+              <a:ext uri="{FF2B5EF4-FFF2-40B4-BE49-F238E27FC236}">
+                <a16:creationId xmlns:a16="http://schemas.microsoft.com/office/drawing/2014/main" id="{7302A09E-7085-4581-97B5-2E19AF74F95C}"/>
+              </a:ext>
+            </a:extLst>
+          </p:cNvPr>
+          <p:cNvSpPr>
+            <a:spLocks xmlns:a="http://schemas.openxmlformats.org/drawingml/2006/main" noGrp="1"/>
+          </p:cNvSpPr>
+          <p:nvPr/>
+        </p:nvSpPr>
+        <p:spPr>
+          <a:xfrm xmlns:a="http://schemas.openxmlformats.org/drawingml/2006/main">
+            <a:off x="8515350" y="476250"/>
+            <a:ext cx="2857500" cy="209550"/>
+          </a:xfrm>
+          <a:prstGeom xmlns:a="http://schemas.openxmlformats.org/drawingml/2006/main" prst="rect">
+            <a:avLst/>
+          </a:prstGeom>
+          <a:noFill xmlns:a="http://schemas.openxmlformats.org/drawingml/2006/main"/>
+          <a:ln xmlns:a="http://schemas.openxmlformats.org/drawingml/2006/main" w="0">
+            <a:noFill/>
+            <a:prstDash val="solid"/>
+          </a:ln>
+        </p:spPr>
+        <p:txBody>
+          <a:bodyPr xmlns:a="http://schemas.openxmlformats.org/drawingml/2006/main">
+            <a:normAutofit fontScale="93939"/>
+          </a:bodyPr>
+          <a:lstStyle xmlns:a="http://schemas.openxmlformats.org/drawingml/2006/main"/>
+          <a:p xmlns:a="http://schemas.openxmlformats.org/drawingml/2006/main">
+            <a:pPr algn="r">
+              <a:defRPr sz="825" b="1">
+                <a:solidFill>
+                  <a:srgbClr val="516773"/>
+                </a:solidFill>
+                <a:latin typeface="Helvetica Neue"/>
+                <a:ea typeface="Helvetica Neue"/>
+                <a:cs typeface="Helvetica Neue"/>
+              </a:defRPr>
+            </a:pPr>
+            <a:r>
+              <a:rPr sz="825" b="1">
+                <a:solidFill>
+                  <a:srgbClr val="516773"/>
+                </a:solidFill>
+                <a:latin typeface="Helvetica Neue"/>
+                <a:ea typeface="Helvetica Neue"/>
+                <a:cs typeface="Helvetica Neue"/>
+              </a:rPr>
+              <a:t>EVIDENCE</a:t>
+            </a:r>
+          </a:p>
+        </p:txBody>
+      </p:sp>
+      <p:sp>
+        <p:nvSpPr>
+          <p:cNvPr id="4" name="">
+            <a:extLst xmlns:a="http://schemas.openxmlformats.org/drawingml/2006/main">
+              <a:ext uri="{FF2B5EF4-FFF2-40B4-BE49-F238E27FC236}">
+                <a16:creationId xmlns:a16="http://schemas.microsoft.com/office/drawing/2014/main" id="{8BE5846E-8091-4C07-A81F-17442FCD666E}"/>
+              </a:ext>
+            </a:extLst>
+          </p:cNvPr>
+          <p:cNvSpPr>
+            <a:spLocks xmlns:a="http://schemas.openxmlformats.org/drawingml/2006/main" noGrp="1"/>
+          </p:cNvSpPr>
+          <p:nvPr/>
+        </p:nvSpPr>
+        <p:spPr>
+          <a:xfrm xmlns:a="http://schemas.openxmlformats.org/drawingml/2006/main">
+            <a:off x="609600" y="838200"/>
+            <a:ext cx="9334500" cy="666750"/>
+          </a:xfrm>
+          <a:prstGeom xmlns:a="http://schemas.openxmlformats.org/drawingml/2006/main" prst="rect">
+            <a:avLst/>
+          </a:prstGeom>
+          <a:noFill xmlns:a="http://schemas.openxmlformats.org/drawingml/2006/main"/>
+          <a:ln xmlns:a="http://schemas.openxmlformats.org/drawingml/2006/main" w="0">
+            <a:noFill/>
+            <a:prstDash val="solid"/>
+          </a:ln>
+        </p:spPr>
+        <p:txBody>
+          <a:bodyPr xmlns:a="http://schemas.openxmlformats.org/drawingml/2006/main">
+            <a:normAutofit fontScale="100000"/>
+          </a:bodyPr>
+          <a:lstStyle xmlns:a="http://schemas.openxmlformats.org/drawingml/2006/main"/>
+          <a:p xmlns:a="http://schemas.openxmlformats.org/drawingml/2006/main">
+            <a:pPr algn="l">
+              <a:defRPr sz="2550" b="1">
+                <a:solidFill>
+                  <a:srgbClr val="0B2A33"/>
+                </a:solidFill>
+                <a:latin typeface="Helvetica Neue"/>
+                <a:ea typeface="Helvetica Neue"/>
+                <a:cs typeface="Helvetica Neue"/>
+              </a:defRPr>
+            </a:pPr>
+            <a:r>
+              <a:rPr sz="2550" b="1">
+                <a:solidFill>
+                  <a:srgbClr val="0B2A33"/>
+                </a:solidFill>
+                <a:latin typeface="Helvetica Neue"/>
+                <a:ea typeface="Helvetica Neue"/>
+                <a:cs typeface="Helvetica Neue"/>
+              </a:rPr>
+              <a:t>References And Evidence Controls</a:t>
+            </a:r>
+          </a:p>
+        </p:txBody>
+      </p:sp>
+      <p:sp>
+        <p:nvSpPr>
+          <p:cNvPr id="5" name="">
+            <a:extLst xmlns:a="http://schemas.openxmlformats.org/drawingml/2006/main">
+              <a:ext uri="{FF2B5EF4-FFF2-40B4-BE49-F238E27FC236}">
+                <a16:creationId xmlns:a16="http://schemas.microsoft.com/office/drawing/2014/main" id="{54DBE2C1-1639-4D41-9938-9A1B03222A86}"/>
+              </a:ext>
+            </a:extLst>
+          </p:cNvPr>
+          <p:cNvSpPr>
+            <a:spLocks xmlns:a="http://schemas.openxmlformats.org/drawingml/2006/main" noGrp="1"/>
+          </p:cNvSpPr>
+          <p:nvPr/>
+        </p:nvSpPr>
+        <p:spPr>
+          <a:xfrm xmlns:a="http://schemas.openxmlformats.org/drawingml/2006/main">
+            <a:off x="609600" y="1543050"/>
+            <a:ext cx="9810750" cy="0"/>
+          </a:xfrm>
+          <a:prstGeom xmlns:a="http://schemas.openxmlformats.org/drawingml/2006/main" prst="line">
+            <a:avLst/>
+          </a:prstGeom>
+          <a:noFill xmlns:a="http://schemas.openxmlformats.org/drawingml/2006/main"/>
+          <a:ln xmlns:a="http://schemas.openxmlformats.org/drawingml/2006/main" w="19050">
+            <a:solidFill>
+              <a:srgbClr val="E4B73D"/>
+            </a:solidFill>
+            <a:prstDash val="solid"/>
+          </a:ln>
+        </p:spPr>
+      </p:sp>
+      <p:sp>
+        <p:nvSpPr>
+          <p:cNvPr id="6" name="">
+            <a:extLst xmlns:a="http://schemas.openxmlformats.org/drawingml/2006/main">
+              <a:ext uri="{FF2B5EF4-FFF2-40B4-BE49-F238E27FC236}">
+                <a16:creationId xmlns:a16="http://schemas.microsoft.com/office/drawing/2014/main" id="{9F3B343F-E750-4C44-8E6E-93924AA9692F}"/>
+              </a:ext>
+            </a:extLst>
+          </p:cNvPr>
+          <p:cNvSpPr>
+            <a:spLocks xmlns:a="http://schemas.openxmlformats.org/drawingml/2006/main" noGrp="1"/>
+          </p:cNvSpPr>
+          <p:nvPr/>
+        </p:nvSpPr>
+        <p:spPr>
+          <a:xfrm xmlns:a="http://schemas.openxmlformats.org/drawingml/2006/main">
+            <a:off x="609600" y="6286500"/>
+            <a:ext cx="10972800" cy="0"/>
+          </a:xfrm>
+          <a:prstGeom xmlns:a="http://schemas.openxmlformats.org/drawingml/2006/main" prst="line">
+            <a:avLst/>
+          </a:prstGeom>
+          <a:noFill xmlns:a="http://schemas.openxmlformats.org/drawingml/2006/main"/>
+          <a:ln xmlns:a="http://schemas.openxmlformats.org/drawingml/2006/main" w="9525">
+            <a:solidFill>
+              <a:srgbClr val="CFE0E6"/>
+            </a:solidFill>
+            <a:prstDash val="solid"/>
+          </a:ln>
+        </p:spPr>
+      </p:sp>
+      <p:sp>
+        <p:nvSpPr>
+          <p:cNvPr id="7" name="">
+            <a:extLst xmlns:a="http://schemas.openxmlformats.org/drawingml/2006/main">
+              <a:ext uri="{FF2B5EF4-FFF2-40B4-BE49-F238E27FC236}">
+                <a16:creationId xmlns:a16="http://schemas.microsoft.com/office/drawing/2014/main" id="{D3E508BD-06A2-44EF-9AE8-941F9A2328F2}"/>
+              </a:ext>
+            </a:extLst>
+          </p:cNvPr>
+          <p:cNvSpPr>
+            <a:spLocks xmlns:a="http://schemas.openxmlformats.org/drawingml/2006/main" noGrp="1"/>
+          </p:cNvSpPr>
+          <p:nvPr/>
+        </p:nvSpPr>
+        <p:spPr>
+          <a:xfrm xmlns:a="http://schemas.openxmlformats.org/drawingml/2006/main">
+            <a:off x="609600" y="6419850"/>
+            <a:ext cx="5334000" cy="190500"/>
+          </a:xfrm>
+          <a:prstGeom xmlns:a="http://schemas.openxmlformats.org/drawingml/2006/main" prst="rect">
+            <a:avLst/>
+          </a:prstGeom>
+          <a:noFill xmlns:a="http://schemas.openxmlformats.org/drawingml/2006/main"/>
+          <a:ln xmlns:a="http://schemas.openxmlformats.org/drawingml/2006/main" w="0">
+            <a:noFill/>
+            <a:prstDash val="solid"/>
+          </a:ln>
+        </p:spPr>
+        <p:txBody>
+          <a:bodyPr xmlns:a="http://schemas.openxmlformats.org/drawingml/2006/main">
+            <a:normAutofit fontScale="86667"/>
+          </a:bodyPr>
+          <a:lstStyle xmlns:a="http://schemas.openxmlformats.org/drawingml/2006/main"/>
+          <a:p xmlns:a="http://schemas.openxmlformats.org/drawingml/2006/main">
+            <a:pPr algn="l">
+              <a:defRPr sz="750" b="0">
+                <a:solidFill>
+                  <a:srgbClr val="66808A"/>
+                </a:solidFill>
+                <a:latin typeface="Helvetica Neue"/>
+                <a:ea typeface="Helvetica Neue"/>
+                <a:cs typeface="Helvetica Neue"/>
+              </a:defRPr>
+            </a:pPr>
+            <a:r>
+              <a:rPr sz="750" b="0">
+                <a:solidFill>
+                  <a:srgbClr val="66808A"/>
+                </a:solidFill>
+                <a:latin typeface="Helvetica Neue"/>
+                <a:ea typeface="Helvetica Neue"/>
+                <a:cs typeface="Helvetica Neue"/>
+              </a:rPr>
+              <a:t>Source: Option 1 Healthcare Consulting Packet and project analysis</a:t>
+            </a:r>
+          </a:p>
+        </p:txBody>
+      </p:sp>
+      <p:graphicFrame>
+        <p:nvGraphicFramePr>
+          <p:cNvPr id="18" name=""/>
+          <p:cNvGraphicFramePr/>
+          <p:nvPr/>
+        </p:nvGraphicFramePr>
+        <p:xfrm>
+          <a:off xmlns:a="http://schemas.openxmlformats.org/drawingml/2006/main" x="685800" y="1714500"/>
+          <a:ext xmlns:a="http://schemas.openxmlformats.org/drawingml/2006/main" cx="9906000" cy="3181350"/>
+        </p:xfrm>
+        <a:graphic xmlns:a="http://schemas.openxmlformats.org/drawingml/2006/main">
+          <a:graphicData uri="http://schemas.openxmlformats.org/drawingml/2006/table">
+            <a:tbl>
+              <a:tblPr firstRow="1" bandRow="1"/>
+              <a:tblGrid>
+                <a:gridCol w="3467100"/>
+                <a:gridCol w="6438900"/>
+              </a:tblGrid>
+              <a:tr h="454479">
+                <a:tc>
+                  <a:txBody>
+                    <a:bodyPr/>
+                    <a:lstStyle/>
+                    <a:p>
+                      <a:r>
+                        <a:rPr sz="825" b="1">
+                          <a:solidFill>
+                            <a:srgbClr val="FFFFFF"/>
+                          </a:solidFill>
+                          <a:latin typeface="Helvetica Neue"/>
+                          <a:ea typeface="Helvetica Neue"/>
+                          <a:cs typeface="Helvetica Neue"/>
+                        </a:rPr>
+                        <a:t>Evidence area</a:t>
+                      </a:r>
+                    </a:p>
+                  </a:txBody>
+                  <a:tcPr marL="91440" marR="91440" marT="45720" marB="45720">
+                    <a:solidFill>
+                      <a:srgbClr val="0E5360"/>
+                    </a:solidFill>
+                  </a:tcPr>
+                </a:tc>
+                <a:tc>
+                  <a:txBody>
+                    <a:bodyPr/>
+                    <a:lstStyle/>
+                    <a:p>
+                      <a:r>
+                        <a:rPr sz="825" b="1">
+                          <a:solidFill>
+                            <a:srgbClr val="FFFFFF"/>
+                          </a:solidFill>
+                          <a:latin typeface="Helvetica Neue"/>
+                          <a:ea typeface="Helvetica Neue"/>
+                          <a:cs typeface="Helvetica Neue"/>
+                        </a:rPr>
+                        <a:t>References used</a:t>
+                      </a:r>
+                    </a:p>
+                  </a:txBody>
+                  <a:tcPr marL="91440" marR="91440" marT="45720" marB="45720">
+                    <a:solidFill>
+                      <a:srgbClr val="0E5360"/>
+                    </a:solidFill>
+                  </a:tcPr>
+                </a:tc>
+              </a:tr>
+              <a:tr h="454479">
+                <a:tc>
+                  <a:txBody>
+                    <a:bodyPr/>
+                    <a:lstStyle/>
+                    <a:p>
+                      <a:r>
+                        <a:rPr sz="750">
+                          <a:solidFill>
+                            <a:srgbClr val="0B2A33"/>
+                          </a:solidFill>
+                          <a:latin typeface="Helvetica Neue"/>
+                          <a:ea typeface="Helvetica Neue"/>
+                          <a:cs typeface="Helvetica Neue"/>
+                        </a:rPr>
+                        <a:t>Project packet and NHN data</a:t>
+                      </a:r>
+                    </a:p>
+                  </a:txBody>
+                  <a:tcPr marL="91440" marR="91440" marT="45720" marB="45720"/>
+                </a:tc>
+                <a:tc>
+                  <a:txBody>
+                    <a:bodyPr/>
+                    <a:lstStyle/>
+                    <a:p>
+                      <a:r>
+                        <a:rPr sz="750">
+                          <a:solidFill>
+                            <a:srgbClr val="0B2A33"/>
+                          </a:solidFill>
+                          <a:latin typeface="Helvetica Neue"/>
+                          <a:ea typeface="Helvetica Neue"/>
+                          <a:cs typeface="Helvetica Neue"/>
+                        </a:rPr>
+                        <a:t>INT-1 through INT-6</a:t>
+                      </a:r>
+                    </a:p>
+                  </a:txBody>
+                  <a:tcPr marL="91440" marR="91440" marT="45720" marB="45720"/>
+                </a:tc>
+              </a:tr>
+              <a:tr h="454479">
+                <a:tc>
+                  <a:txBody>
+                    <a:bodyPr/>
+                    <a:lstStyle/>
+                    <a:p>
+                      <a:r>
+                        <a:rPr sz="750">
+                          <a:solidFill>
+                            <a:srgbClr val="0B2A33"/>
+                          </a:solidFill>
+                          <a:latin typeface="Helvetica Neue"/>
+                          <a:ea typeface="Helvetica Neue"/>
+                          <a:cs typeface="Helvetica Neue"/>
+                        </a:rPr>
+                        <a:t>CMS and payment context</a:t>
+                      </a:r>
+                    </a:p>
+                  </a:txBody>
+                  <a:tcPr marL="91440" marR="91440" marT="45720" marB="45720"/>
+                </a:tc>
+                <a:tc>
+                  <a:txBody>
+                    <a:bodyPr/>
+                    <a:lstStyle/>
+                    <a:p>
+                      <a:r>
+                        <a:rPr sz="750">
+                          <a:solidFill>
+                            <a:srgbClr val="0B2A33"/>
+                          </a:solidFill>
+                          <a:latin typeface="Helvetica Neue"/>
+                          <a:ea typeface="Helvetica Neue"/>
+                          <a:cs typeface="Helvetica Neue"/>
+                        </a:rPr>
+                        <a:t>EXT-1 and EXT-2</a:t>
+                      </a:r>
+                    </a:p>
+                  </a:txBody>
+                  <a:tcPr marL="91440" marR="91440" marT="45720" marB="45720"/>
+                </a:tc>
+              </a:tr>
+              <a:tr h="454479">
+                <a:tc>
+                  <a:txBody>
+                    <a:bodyPr/>
+                    <a:lstStyle/>
+                    <a:p>
+                      <a:r>
+                        <a:rPr sz="750">
+                          <a:solidFill>
+                            <a:srgbClr val="0B2A33"/>
+                          </a:solidFill>
+                          <a:latin typeface="Helvetica Neue"/>
+                          <a:ea typeface="Helvetica Neue"/>
+                          <a:cs typeface="Helvetica Neue"/>
+                        </a:rPr>
+                        <a:t>Readmission baseline context</a:t>
+                      </a:r>
+                    </a:p>
+                  </a:txBody>
+                  <a:tcPr marL="91440" marR="91440" marT="45720" marB="45720"/>
+                </a:tc>
+                <a:tc>
+                  <a:txBody>
+                    <a:bodyPr/>
+                    <a:lstStyle/>
+                    <a:p>
+                      <a:r>
+                        <a:rPr sz="750">
+                          <a:solidFill>
+                            <a:srgbClr val="0B2A33"/>
+                          </a:solidFill>
+                          <a:latin typeface="Helvetica Neue"/>
+                          <a:ea typeface="Helvetica Neue"/>
+                          <a:cs typeface="Helvetica Neue"/>
+                        </a:rPr>
+                        <a:t>EXT-3 and EXT-4</a:t>
+                      </a:r>
+                    </a:p>
+                  </a:txBody>
+                  <a:tcPr marL="91440" marR="91440" marT="45720" marB="45720"/>
+                </a:tc>
+              </a:tr>
+              <a:tr h="454479">
+                <a:tc>
+                  <a:txBody>
+                    <a:bodyPr/>
+                    <a:lstStyle/>
+                    <a:p>
+                      <a:r>
+                        <a:rPr sz="750">
+                          <a:solidFill>
+                            <a:srgbClr val="0B2A33"/>
+                          </a:solidFill>
+                          <a:latin typeface="Helvetica Neue"/>
+                          <a:ea typeface="Helvetica Neue"/>
+                          <a:cs typeface="Helvetica Neue"/>
+                        </a:rPr>
+                        <a:t>Care transition evidence</a:t>
+                      </a:r>
+                    </a:p>
+                  </a:txBody>
+                  <a:tcPr marL="91440" marR="91440" marT="45720" marB="45720"/>
+                </a:tc>
+                <a:tc>
+                  <a:txBody>
+                    <a:bodyPr/>
+                    <a:lstStyle/>
+                    <a:p>
+                      <a:r>
+                        <a:rPr sz="750">
+                          <a:solidFill>
+                            <a:srgbClr val="0B2A33"/>
+                          </a:solidFill>
+                          <a:latin typeface="Helvetica Neue"/>
+                          <a:ea typeface="Helvetica Neue"/>
+                          <a:cs typeface="Helvetica Neue"/>
+                        </a:rPr>
+                        <a:t>EXT-5 and EXT-6</a:t>
+                      </a:r>
+                    </a:p>
+                  </a:txBody>
+                  <a:tcPr marL="91440" marR="91440" marT="45720" marB="45720"/>
+                </a:tc>
+              </a:tr>
+              <a:tr h="454479">
+                <a:tc>
+                  <a:txBody>
+                    <a:bodyPr/>
+                    <a:lstStyle/>
+                    <a:p>
+                      <a:r>
+                        <a:rPr sz="750">
+                          <a:solidFill>
+                            <a:srgbClr val="0B2A33"/>
+                          </a:solidFill>
+                          <a:latin typeface="Helvetica Neue"/>
+                          <a:ea typeface="Helvetica Neue"/>
+                          <a:cs typeface="Helvetica Neue"/>
+                        </a:rPr>
+                        <a:t>Model reporting standards</a:t>
+                      </a:r>
+                    </a:p>
+                  </a:txBody>
+                  <a:tcPr marL="91440" marR="91440" marT="45720" marB="45720"/>
+                </a:tc>
+                <a:tc>
+                  <a:txBody>
+                    <a:bodyPr/>
+                    <a:lstStyle/>
+                    <a:p>
+                      <a:r>
+                        <a:rPr sz="750">
+                          <a:solidFill>
+                            <a:srgbClr val="0B2A33"/>
+                          </a:solidFill>
+                          <a:latin typeface="Helvetica Neue"/>
+                          <a:ea typeface="Helvetica Neue"/>
+                          <a:cs typeface="Helvetica Neue"/>
+                        </a:rPr>
+                        <a:t>EXT-7 and EXT-8</a:t>
+                      </a:r>
+                    </a:p>
+                  </a:txBody>
+                  <a:tcPr marL="91440" marR="91440" marT="45720" marB="45720"/>
+                </a:tc>
+              </a:tr>
+              <a:tr h="454479">
+                <a:tc>
+                  <a:txBody>
+                    <a:bodyPr/>
+                    <a:lstStyle/>
+                    <a:p>
+                      <a:r>
+                        <a:rPr sz="750">
+                          <a:solidFill>
+                            <a:srgbClr val="0B2A33"/>
+                          </a:solidFill>
+                          <a:latin typeface="Helvetica Neue"/>
+                          <a:ea typeface="Helvetica Neue"/>
+                          <a:cs typeface="Helvetica Neue"/>
+                        </a:rPr>
+                        <a:t>Repository controls</a:t>
+                      </a:r>
+                    </a:p>
+                  </a:txBody>
+                  <a:tcPr marL="91440" marR="91440" marT="45720" marB="45720"/>
+                </a:tc>
+                <a:tc>
+                  <a:txBody>
+                    <a:bodyPr/>
+                    <a:lstStyle/>
+                    <a:p>
+                      <a:r>
+                        <a:rPr sz="750">
+                          <a:solidFill>
+                            <a:srgbClr val="0B2A33"/>
+                          </a:solidFill>
+                          <a:latin typeface="Helvetica Neue"/>
+                          <a:ea typeface="Helvetica Neue"/>
+                          <a:cs typeface="Helvetica Neue"/>
+                        </a:rPr>
+                        <a:t>REFERENCES.md, EVIDENCE_STANDARDS.md, REPORT_EVIDENCE_AUDIT.md</a:t>
+                      </a:r>
+                    </a:p>
+                  </a:txBody>
+                  <a:tcPr marL="91440" marR="91440" marT="45720" marB="45720"/>
+                </a:tc>
+              </a:tr>
+            </a:tbl>
+          </a:graphicData>
+        </a:graphic>
+      </p:graphicFrame>
+      <p:sp>
+        <p:nvSpPr>
+          <p:cNvPr id="9" name="">
+            <a:extLst xmlns:a="http://schemas.openxmlformats.org/drawingml/2006/main">
+              <a:ext uri="{FF2B5EF4-FFF2-40B4-BE49-F238E27FC236}">
+                <a16:creationId xmlns:a16="http://schemas.microsoft.com/office/drawing/2014/main" id="{A16E7B38-609F-4433-AFBD-D1A104295366}"/>
+              </a:ext>
+            </a:extLst>
+          </p:cNvPr>
+          <p:cNvSpPr>
+            <a:spLocks xmlns:a="http://schemas.openxmlformats.org/drawingml/2006/main" noGrp="1"/>
+          </p:cNvSpPr>
+          <p:nvPr/>
+        </p:nvSpPr>
+        <p:spPr>
+          <a:xfrm xmlns:a="http://schemas.openxmlformats.org/drawingml/2006/main">
+            <a:off x="1200150" y="5257800"/>
+            <a:ext cx="8839200" cy="533400"/>
+          </a:xfrm>
+          <a:prstGeom xmlns:a="http://schemas.openxmlformats.org/drawingml/2006/main" prst="rect">
+            <a:avLst/>
+          </a:prstGeom>
+          <a:solidFill xmlns:a="http://schemas.openxmlformats.org/drawingml/2006/main">
+            <a:srgbClr val="EFF6FF"/>
+          </a:solidFill>
+          <a:ln xmlns:a="http://schemas.openxmlformats.org/drawingml/2006/main" w="9525">
+            <a:solidFill>
+              <a:srgbClr val="BFDBFE"/>
+            </a:solidFill>
+            <a:prstDash val="solid"/>
+          </a:ln>
+        </p:spPr>
+      </p:sp>
+      <p:sp>
+        <p:nvSpPr>
+          <p:cNvPr id="10" name="">
+            <a:extLst xmlns:a="http://schemas.openxmlformats.org/drawingml/2006/main">
+              <a:ext uri="{FF2B5EF4-FFF2-40B4-BE49-F238E27FC236}">
+                <a16:creationId xmlns:a16="http://schemas.microsoft.com/office/drawing/2014/main" id="{20A2E37D-0E1B-46C6-8A63-46EDF907879C}"/>
+              </a:ext>
+            </a:extLst>
+          </p:cNvPr>
+          <p:cNvSpPr>
+            <a:spLocks xmlns:a="http://schemas.openxmlformats.org/drawingml/2006/main" noGrp="1"/>
+          </p:cNvSpPr>
+          <p:nvPr/>
+        </p:nvSpPr>
+        <p:spPr>
+          <a:xfrm xmlns:a="http://schemas.openxmlformats.org/drawingml/2006/main">
+            <a:off x="1504950" y="5410200"/>
+            <a:ext cx="8229600" cy="285750"/>
+          </a:xfrm>
+          <a:prstGeom xmlns:a="http://schemas.openxmlformats.org/drawingml/2006/main" prst="rect">
+            <a:avLst/>
+          </a:prstGeom>
+          <a:noFill xmlns:a="http://schemas.openxmlformats.org/drawingml/2006/main"/>
+          <a:ln xmlns:a="http://schemas.openxmlformats.org/drawingml/2006/main" w="0">
+            <a:noFill/>
+            <a:prstDash val="solid"/>
+          </a:ln>
+        </p:spPr>
+        <p:txBody>
+          <a:bodyPr xmlns:a="http://schemas.openxmlformats.org/drawingml/2006/main">
+            <a:normAutofit fontScale="85000"/>
+          </a:bodyPr>
+          <a:lstStyle xmlns:a="http://schemas.openxmlformats.org/drawingml/2006/main"/>
+          <a:p xmlns:a="http://schemas.openxmlformats.org/drawingml/2006/main">
+            <a:pPr algn="ctr">
+              <a:defRPr sz="1500" b="1">
+                <a:solidFill>
+                  <a:srgbClr val="0E5360"/>
+                </a:solidFill>
+                <a:latin typeface="Helvetica Neue"/>
+                <a:ea typeface="Helvetica Neue"/>
+                <a:cs typeface="Helvetica Neue"/>
+              </a:defRPr>
+            </a:pPr>
+            <a:r>
+              <a:rPr sz="1500" b="1">
+                <a:solidFill>
+                  <a:srgbClr val="0E5360"/>
+                </a:solidFill>
+                <a:latin typeface="Helvetica Neue"/>
+                <a:ea typeface="Helvetica Neue"/>
+                <a:cs typeface="Helvetica Neue"/>
+              </a:rPr>
+              <a:t>Evidence audit passed: 8 external references used and core metrics reconciled to source files.</a:t>
+            </a:r>
+          </a:p>
+        </p:txBody>
+      </p:sp>
+    </p:spTree>
+    <p:extLst>
+      <p:ext uri="{BB962C8B-B14F-4D97-AF65-F5344CB8AC3E}">
+        <p14:creationId xmlns:p14="http://schemas.microsoft.com/office/powerpoint/2010/main" val="1695097297"/>
       </p:ext>
     </p:extLst>
   </p:cSld>
@@ -11270,7 +12272,7 @@
           <p:cNvPr id="26" name="">
             <a:extLst xmlns:a="http://schemas.openxmlformats.org/drawingml/2006/main">
               <a:ext uri="{FF2B5EF4-FFF2-40B4-BE49-F238E27FC236}">
-                <a16:creationId xmlns:a16="http://schemas.microsoft.com/office/drawing/2014/main" id="{D243622B-F5AE-48E7-86BB-F961BE055CB7}"/>
+                <a16:creationId xmlns:a16="http://schemas.microsoft.com/office/drawing/2014/main" id="{6632477C-5FB7-418E-9F8D-F7601C63F014}"/>
               </a:ext>
             </a:extLst>
           </p:cNvPr>
@@ -11303,7 +12305,7 @@
           <p:cNvPr id="2" name="">
             <a:extLst xmlns:a="http://schemas.openxmlformats.org/drawingml/2006/main">
               <a:ext uri="{FF2B5EF4-FFF2-40B4-BE49-F238E27FC236}">
-                <a16:creationId xmlns:a16="http://schemas.microsoft.com/office/drawing/2014/main" id="{52511823-63C8-4D41-87F4-7C063CF45BAE}"/>
+                <a16:creationId xmlns:a16="http://schemas.microsoft.com/office/drawing/2014/main" id="{4FBFE1D4-06F1-406B-91B8-3A00CC8D6B7D}"/>
               </a:ext>
             </a:extLst>
           </p:cNvPr>
@@ -11361,7 +12363,7 @@
           <p:cNvPr id="3" name="">
             <a:extLst xmlns:a="http://schemas.openxmlformats.org/drawingml/2006/main">
               <a:ext uri="{FF2B5EF4-FFF2-40B4-BE49-F238E27FC236}">
-                <a16:creationId xmlns:a16="http://schemas.microsoft.com/office/drawing/2014/main" id="{28A26CCF-F5A3-4A80-AD38-11C7392775E3}"/>
+                <a16:creationId xmlns:a16="http://schemas.microsoft.com/office/drawing/2014/main" id="{39D528B5-D0F1-4271-BFA6-CCF50919C273}"/>
               </a:ext>
             </a:extLst>
           </p:cNvPr>
@@ -11419,7 +12421,7 @@
           <p:cNvPr id="4" name="">
             <a:extLst xmlns:a="http://schemas.openxmlformats.org/drawingml/2006/main">
               <a:ext uri="{FF2B5EF4-FFF2-40B4-BE49-F238E27FC236}">
-                <a16:creationId xmlns:a16="http://schemas.microsoft.com/office/drawing/2014/main" id="{F8BDAB80-26A9-47CD-9117-7E4F49443AC0}"/>
+                <a16:creationId xmlns:a16="http://schemas.microsoft.com/office/drawing/2014/main" id="{9821D84C-96BC-402F-B065-F6DAEF00A7A6}"/>
               </a:ext>
             </a:extLst>
           </p:cNvPr>
@@ -11477,7 +12479,7 @@
           <p:cNvPr id="5" name="">
             <a:extLst xmlns:a="http://schemas.openxmlformats.org/drawingml/2006/main">
               <a:ext uri="{FF2B5EF4-FFF2-40B4-BE49-F238E27FC236}">
-                <a16:creationId xmlns:a16="http://schemas.microsoft.com/office/drawing/2014/main" id="{6D59480E-8F60-4484-8BA7-199CDD55C9F9}"/>
+                <a16:creationId xmlns:a16="http://schemas.microsoft.com/office/drawing/2014/main" id="{85D618A2-8431-4BDA-8B1E-61C7045B7FE6}"/>
               </a:ext>
             </a:extLst>
           </p:cNvPr>
@@ -11508,7 +12510,7 @@
           <p:cNvPr id="6" name="">
             <a:extLst xmlns:a="http://schemas.openxmlformats.org/drawingml/2006/main">
               <a:ext uri="{FF2B5EF4-FFF2-40B4-BE49-F238E27FC236}">
-                <a16:creationId xmlns:a16="http://schemas.microsoft.com/office/drawing/2014/main" id="{23AB3C9C-404E-4D5B-BEEA-BD664B374A74}"/>
+                <a16:creationId xmlns:a16="http://schemas.microsoft.com/office/drawing/2014/main" id="{9FBB4768-D411-4E85-A726-94643D9C96B3}"/>
               </a:ext>
             </a:extLst>
           </p:cNvPr>
@@ -11539,7 +12541,7 @@
           <p:cNvPr id="7" name="">
             <a:extLst xmlns:a="http://schemas.openxmlformats.org/drawingml/2006/main">
               <a:ext uri="{FF2B5EF4-FFF2-40B4-BE49-F238E27FC236}">
-                <a16:creationId xmlns:a16="http://schemas.microsoft.com/office/drawing/2014/main" id="{C92C5EB1-BD86-4EEB-AEFF-0AF0DA0D95AC}"/>
+                <a16:creationId xmlns:a16="http://schemas.microsoft.com/office/drawing/2014/main" id="{8006C2D3-3A41-481A-B9A0-49DA8DADC4C0}"/>
               </a:ext>
             </a:extLst>
           </p:cNvPr>
@@ -11597,7 +12599,7 @@
           <p:cNvPr id="8" name="">
             <a:extLst xmlns:a="http://schemas.openxmlformats.org/drawingml/2006/main">
               <a:ext uri="{FF2B5EF4-FFF2-40B4-BE49-F238E27FC236}">
-                <a16:creationId xmlns:a16="http://schemas.microsoft.com/office/drawing/2014/main" id="{4CFA757C-B466-4D66-AF6B-AA48D4BCC46F}"/>
+                <a16:creationId xmlns:a16="http://schemas.microsoft.com/office/drawing/2014/main" id="{ECA4135B-84FE-493D-95B6-9AFC395170C7}"/>
               </a:ext>
             </a:extLst>
           </p:cNvPr>
@@ -11655,7 +12657,7 @@
           <p:cNvPr id="9" name="">
             <a:extLst xmlns:a="http://schemas.openxmlformats.org/drawingml/2006/main">
               <a:ext uri="{FF2B5EF4-FFF2-40B4-BE49-F238E27FC236}">
-                <a16:creationId xmlns:a16="http://schemas.microsoft.com/office/drawing/2014/main" id="{00B59234-37AF-4824-B882-82B5BD1FBE68}"/>
+                <a16:creationId xmlns:a16="http://schemas.microsoft.com/office/drawing/2014/main" id="{1386DAE1-2352-4DDD-8654-F8C774EB57F1}"/>
               </a:ext>
             </a:extLst>
           </p:cNvPr>
@@ -11713,7 +12715,7 @@
           <p:cNvPr id="10" name="">
             <a:extLst xmlns:a="http://schemas.openxmlformats.org/drawingml/2006/main">
               <a:ext uri="{FF2B5EF4-FFF2-40B4-BE49-F238E27FC236}">
-                <a16:creationId xmlns:a16="http://schemas.microsoft.com/office/drawing/2014/main" id="{7519065D-2098-471F-B80F-6A6994B09335}"/>
+                <a16:creationId xmlns:a16="http://schemas.microsoft.com/office/drawing/2014/main" id="{213C27C0-6C42-4BDC-8DA3-3202190572FE}"/>
               </a:ext>
             </a:extLst>
           </p:cNvPr>
@@ -11771,7 +12773,7 @@
           <p:cNvPr id="11" name="">
             <a:extLst xmlns:a="http://schemas.openxmlformats.org/drawingml/2006/main">
               <a:ext uri="{FF2B5EF4-FFF2-40B4-BE49-F238E27FC236}">
-                <a16:creationId xmlns:a16="http://schemas.microsoft.com/office/drawing/2014/main" id="{C85EBBB6-BF01-4AA3-ACB4-50F859230A28}"/>
+                <a16:creationId xmlns:a16="http://schemas.microsoft.com/office/drawing/2014/main" id="{D2BAF84A-F1C7-4CF0-96D0-5640FE0B6CFF}"/>
               </a:ext>
             </a:extLst>
           </p:cNvPr>
@@ -11829,7 +12831,7 @@
           <p:cNvPr id="12" name="">
             <a:extLst xmlns:a="http://schemas.openxmlformats.org/drawingml/2006/main">
               <a:ext uri="{FF2B5EF4-FFF2-40B4-BE49-F238E27FC236}">
-                <a16:creationId xmlns:a16="http://schemas.microsoft.com/office/drawing/2014/main" id="{8640ABAD-186D-4A35-AA96-1612ADC9815B}"/>
+                <a16:creationId xmlns:a16="http://schemas.microsoft.com/office/drawing/2014/main" id="{4D789C3C-8BFD-4D93-BEC0-3FB533B71F65}"/>
               </a:ext>
             </a:extLst>
           </p:cNvPr>
@@ -11877,7 +12879,7 @@
                 <a:ea typeface="Helvetica Neue"/>
                 <a:cs typeface="Helvetica Neue"/>
               </a:rPr>
-              <a:t>74.0%</a:t>
+              <a:t>0.74</a:t>
             </a:r>
           </a:p>
         </p:txBody>
@@ -11887,7 +12889,7 @@
           <p:cNvPr id="13" name="">
             <a:extLst xmlns:a="http://schemas.openxmlformats.org/drawingml/2006/main">
               <a:ext uri="{FF2B5EF4-FFF2-40B4-BE49-F238E27FC236}">
-                <a16:creationId xmlns:a16="http://schemas.microsoft.com/office/drawing/2014/main" id="{34971C6D-CAF5-40A3-8B5D-173A7C303B7D}"/>
+                <a16:creationId xmlns:a16="http://schemas.microsoft.com/office/drawing/2014/main" id="{3EFF62CE-5021-4244-856F-81709D9F6394}"/>
               </a:ext>
             </a:extLst>
           </p:cNvPr>
@@ -11945,7 +12947,7 @@
           <p:cNvPr id="14" name="">
             <a:extLst xmlns:a="http://schemas.openxmlformats.org/drawingml/2006/main">
               <a:ext uri="{FF2B5EF4-FFF2-40B4-BE49-F238E27FC236}">
-                <a16:creationId xmlns:a16="http://schemas.microsoft.com/office/drawing/2014/main" id="{B4B290D1-B025-4EA1-9B14-8FFB8FA46DE3}"/>
+                <a16:creationId xmlns:a16="http://schemas.microsoft.com/office/drawing/2014/main" id="{A87AB30A-6C06-469E-A4D6-C41C5C34FC21}"/>
               </a:ext>
             </a:extLst>
           </p:cNvPr>
@@ -12003,7 +13005,7 @@
           <p:cNvPr id="15" name="">
             <a:extLst xmlns:a="http://schemas.openxmlformats.org/drawingml/2006/main">
               <a:ext uri="{FF2B5EF4-FFF2-40B4-BE49-F238E27FC236}">
-                <a16:creationId xmlns:a16="http://schemas.microsoft.com/office/drawing/2014/main" id="{DEE79C02-BA9B-42E3-A108-86517E8CBED6}"/>
+                <a16:creationId xmlns:a16="http://schemas.microsoft.com/office/drawing/2014/main" id="{685206DB-D8E3-478A-991D-92BD6C9F7F6A}"/>
               </a:ext>
             </a:extLst>
           </p:cNvPr>
@@ -12061,7 +13063,7 @@
           <p:cNvPr id="16" name="">
             <a:extLst xmlns:a="http://schemas.openxmlformats.org/drawingml/2006/main">
               <a:ext uri="{FF2B5EF4-FFF2-40B4-BE49-F238E27FC236}">
-                <a16:creationId xmlns:a16="http://schemas.microsoft.com/office/drawing/2014/main" id="{3F2CBAAD-C2FF-4952-821A-8510A82D14B9}"/>
+                <a16:creationId xmlns:a16="http://schemas.microsoft.com/office/drawing/2014/main" id="{63DC23CC-34E8-441C-B68D-DE1F50C13DE9}"/>
               </a:ext>
             </a:extLst>
           </p:cNvPr>
@@ -12119,7 +13121,7 @@
           <p:cNvPr id="17" name="">
             <a:extLst xmlns:a="http://schemas.openxmlformats.org/drawingml/2006/main">
               <a:ext uri="{FF2B5EF4-FFF2-40B4-BE49-F238E27FC236}">
-                <a16:creationId xmlns:a16="http://schemas.microsoft.com/office/drawing/2014/main" id="{B8FB98EA-7D7A-46FA-89EE-E02DF08E3EEB}"/>
+                <a16:creationId xmlns:a16="http://schemas.microsoft.com/office/drawing/2014/main" id="{198228B1-4A1D-463E-BABC-17D344A25E35}"/>
               </a:ext>
             </a:extLst>
           </p:cNvPr>
@@ -12177,7 +13179,7 @@
           <p:cNvPr id="18" name="">
             <a:extLst xmlns:a="http://schemas.openxmlformats.org/drawingml/2006/main">
               <a:ext uri="{FF2B5EF4-FFF2-40B4-BE49-F238E27FC236}">
-                <a16:creationId xmlns:a16="http://schemas.microsoft.com/office/drawing/2014/main" id="{BDAC89C9-3D9D-41D0-970A-E145ACC7CB65}"/>
+                <a16:creationId xmlns:a16="http://schemas.microsoft.com/office/drawing/2014/main" id="{5F215902-EEF7-4427-8FCE-F4F8709AA9CC}"/>
               </a:ext>
             </a:extLst>
           </p:cNvPr>
@@ -12235,7 +13237,7 @@
           <p:cNvPr id="19" name="">
             <a:extLst xmlns:a="http://schemas.openxmlformats.org/drawingml/2006/main">
               <a:ext uri="{FF2B5EF4-FFF2-40B4-BE49-F238E27FC236}">
-                <a16:creationId xmlns:a16="http://schemas.microsoft.com/office/drawing/2014/main" id="{FF4D12C6-B7E5-49E9-A593-3934A95F4039}"/>
+                <a16:creationId xmlns:a16="http://schemas.microsoft.com/office/drawing/2014/main" id="{169B6D39-E9BC-4996-9A8B-9B71C97D2BDC}"/>
               </a:ext>
             </a:extLst>
           </p:cNvPr>
@@ -12283,7 +13285,7 @@
                 <a:ea typeface="Helvetica Neue"/>
                 <a:cs typeface="Helvetica Neue"/>
               </a:rPr>
-              <a:t>$8.8M net savings</a:t>
+              <a:t>$8.81M net savings</a:t>
             </a:r>
           </a:p>
         </p:txBody>
@@ -12293,7 +13295,7 @@
           <p:cNvPr id="20" name="">
             <a:extLst xmlns:a="http://schemas.openxmlformats.org/drawingml/2006/main">
               <a:ext uri="{FF2B5EF4-FFF2-40B4-BE49-F238E27FC236}">
-                <a16:creationId xmlns:a16="http://schemas.microsoft.com/office/drawing/2014/main" id="{1FE5351B-E9E7-4278-8ACA-E6A7C0E96A8B}"/>
+                <a16:creationId xmlns:a16="http://schemas.microsoft.com/office/drawing/2014/main" id="{008C911C-65F2-4ADD-9346-AB1B81C9977B}"/>
               </a:ext>
             </a:extLst>
           </p:cNvPr>
@@ -12351,7 +13353,7 @@
           <p:cNvPr id="21" name="">
             <a:extLst xmlns:a="http://schemas.openxmlformats.org/drawingml/2006/main">
               <a:ext uri="{FF2B5EF4-FFF2-40B4-BE49-F238E27FC236}">
-                <a16:creationId xmlns:a16="http://schemas.microsoft.com/office/drawing/2014/main" id="{A0DD7038-9E73-4C3F-B06F-1E8B43C3C8B8}"/>
+                <a16:creationId xmlns:a16="http://schemas.microsoft.com/office/drawing/2014/main" id="{268F26B7-2594-45A5-B6B3-155E72392D84}"/>
               </a:ext>
             </a:extLst>
           </p:cNvPr>
@@ -12409,7 +13411,7 @@
           <p:cNvPr id="22" name="">
             <a:extLst xmlns:a="http://schemas.openxmlformats.org/drawingml/2006/main">
               <a:ext uri="{FF2B5EF4-FFF2-40B4-BE49-F238E27FC236}">
-                <a16:creationId xmlns:a16="http://schemas.microsoft.com/office/drawing/2014/main" id="{1A3A5F48-FEE0-4BCB-B20B-D94294475F66}"/>
+                <a16:creationId xmlns:a16="http://schemas.microsoft.com/office/drawing/2014/main" id="{8B0D8547-7CE9-43C9-BCD9-821A1805F622}"/>
               </a:ext>
             </a:extLst>
           </p:cNvPr>
@@ -12467,7 +13469,7 @@
           <p:cNvPr id="23" name="">
             <a:extLst xmlns:a="http://schemas.openxmlformats.org/drawingml/2006/main">
               <a:ext uri="{FF2B5EF4-FFF2-40B4-BE49-F238E27FC236}">
-                <a16:creationId xmlns:a16="http://schemas.microsoft.com/office/drawing/2014/main" id="{033E8FD0-17DD-4D46-9A2D-E1ECC56DDE74}"/>
+                <a16:creationId xmlns:a16="http://schemas.microsoft.com/office/drawing/2014/main" id="{17F89496-AB3E-47DE-B3E8-61272FD24638}"/>
               </a:ext>
             </a:extLst>
           </p:cNvPr>
@@ -12525,7 +13527,7 @@
           <p:cNvPr id="24" name="">
             <a:extLst xmlns:a="http://schemas.openxmlformats.org/drawingml/2006/main">
               <a:ext uri="{FF2B5EF4-FFF2-40B4-BE49-F238E27FC236}">
-                <a16:creationId xmlns:a16="http://schemas.microsoft.com/office/drawing/2014/main" id="{F7CDC9FE-BEF5-4890-811C-EAE28D58C9D1}"/>
+                <a16:creationId xmlns:a16="http://schemas.microsoft.com/office/drawing/2014/main" id="{C132B6D0-3DF6-4E4D-A0FA-DBB67676835D}"/>
               </a:ext>
             </a:extLst>
           </p:cNvPr>
@@ -12583,7 +13585,7 @@
           <p:cNvPr id="25" name="">
             <a:extLst xmlns:a="http://schemas.openxmlformats.org/drawingml/2006/main">
               <a:ext uri="{FF2B5EF4-FFF2-40B4-BE49-F238E27FC236}">
-                <a16:creationId xmlns:a16="http://schemas.microsoft.com/office/drawing/2014/main" id="{F75C446A-5B57-4A93-8749-ECE28B6F25B4}"/>
+                <a16:creationId xmlns:a16="http://schemas.microsoft.com/office/drawing/2014/main" id="{2AB77778-868B-4950-A821-C6563D6163E4}"/>
               </a:ext>
             </a:extLst>
           </p:cNvPr>
@@ -12639,7 +13641,7 @@
     </p:spTree>
     <p:extLst>
       <p:ext uri="{BB962C8B-B14F-4D97-AF65-F5344CB8AC3E}">
-        <p14:creationId xmlns:p14="http://schemas.microsoft.com/office/powerpoint/2010/main" val="419728171"/>
+        <p14:creationId xmlns:p14="http://schemas.microsoft.com/office/powerpoint/2010/main" val="1197699656"/>
       </p:ext>
     </p:extLst>
   </p:cSld>
@@ -12670,7 +13672,7 @@
           <p:cNvPr id="15" name="">
             <a:extLst xmlns:a="http://schemas.openxmlformats.org/drawingml/2006/main">
               <a:ext uri="{FF2B5EF4-FFF2-40B4-BE49-F238E27FC236}">
-                <a16:creationId xmlns:a16="http://schemas.microsoft.com/office/drawing/2014/main" id="{6829FEA4-DCC0-4766-A00F-99101135CB54}"/>
+                <a16:creationId xmlns:a16="http://schemas.microsoft.com/office/drawing/2014/main" id="{54BD1461-9006-4FF7-88F8-D91C946639A2}"/>
               </a:ext>
             </a:extLst>
           </p:cNvPr>
@@ -12703,7 +13705,7 @@
           <p:cNvPr id="2" name="">
             <a:extLst xmlns:a="http://schemas.openxmlformats.org/drawingml/2006/main">
               <a:ext uri="{FF2B5EF4-FFF2-40B4-BE49-F238E27FC236}">
-                <a16:creationId xmlns:a16="http://schemas.microsoft.com/office/drawing/2014/main" id="{0D57F728-F5FA-4A24-B814-F262D6D0B5DD}"/>
+                <a16:creationId xmlns:a16="http://schemas.microsoft.com/office/drawing/2014/main" id="{85E71EF6-E127-414D-9211-375B7C5DE600}"/>
               </a:ext>
             </a:extLst>
           </p:cNvPr>
@@ -12761,7 +13763,7 @@
           <p:cNvPr id="3" name="">
             <a:extLst xmlns:a="http://schemas.openxmlformats.org/drawingml/2006/main">
               <a:ext uri="{FF2B5EF4-FFF2-40B4-BE49-F238E27FC236}">
-                <a16:creationId xmlns:a16="http://schemas.microsoft.com/office/drawing/2014/main" id="{BAE4EEFE-E8A6-4F6E-9CF5-A5F6EE5C6F58}"/>
+                <a16:creationId xmlns:a16="http://schemas.microsoft.com/office/drawing/2014/main" id="{008E3378-DDFD-4EE8-BDE1-367638B86363}"/>
               </a:ext>
             </a:extLst>
           </p:cNvPr>
@@ -12819,7 +13821,7 @@
           <p:cNvPr id="4" name="">
             <a:extLst xmlns:a="http://schemas.openxmlformats.org/drawingml/2006/main">
               <a:ext uri="{FF2B5EF4-FFF2-40B4-BE49-F238E27FC236}">
-                <a16:creationId xmlns:a16="http://schemas.microsoft.com/office/drawing/2014/main" id="{F3D28402-CE9F-4C50-BA1D-38A3B92DB35E}"/>
+                <a16:creationId xmlns:a16="http://schemas.microsoft.com/office/drawing/2014/main" id="{6A80A08D-6F44-43B0-8A95-A2AD0F1D0CE3}"/>
               </a:ext>
             </a:extLst>
           </p:cNvPr>
@@ -12877,7 +13879,7 @@
           <p:cNvPr id="5" name="">
             <a:extLst xmlns:a="http://schemas.openxmlformats.org/drawingml/2006/main">
               <a:ext uri="{FF2B5EF4-FFF2-40B4-BE49-F238E27FC236}">
-                <a16:creationId xmlns:a16="http://schemas.microsoft.com/office/drawing/2014/main" id="{05F91669-52A2-4B3C-A3F7-274147DE45EF}"/>
+                <a16:creationId xmlns:a16="http://schemas.microsoft.com/office/drawing/2014/main" id="{A8DE506C-FE63-4EE4-96CC-16D1CD5FF3E3}"/>
               </a:ext>
             </a:extLst>
           </p:cNvPr>
@@ -12908,7 +13910,7 @@
           <p:cNvPr id="6" name="">
             <a:extLst xmlns:a="http://schemas.openxmlformats.org/drawingml/2006/main">
               <a:ext uri="{FF2B5EF4-FFF2-40B4-BE49-F238E27FC236}">
-                <a16:creationId xmlns:a16="http://schemas.microsoft.com/office/drawing/2014/main" id="{6E8D77C3-D502-4D7B-BDF3-1689C91A9CFD}"/>
+                <a16:creationId xmlns:a16="http://schemas.microsoft.com/office/drawing/2014/main" id="{96265940-D258-4EEB-9F43-608D0BDD4AE1}"/>
               </a:ext>
             </a:extLst>
           </p:cNvPr>
@@ -12939,7 +13941,7 @@
           <p:cNvPr id="7" name="">
             <a:extLst xmlns:a="http://schemas.openxmlformats.org/drawingml/2006/main">
               <a:ext uri="{FF2B5EF4-FFF2-40B4-BE49-F238E27FC236}">
-                <a16:creationId xmlns:a16="http://schemas.microsoft.com/office/drawing/2014/main" id="{46A72346-3E81-4928-825E-633843B799A1}"/>
+                <a16:creationId xmlns:a16="http://schemas.microsoft.com/office/drawing/2014/main" id="{DA3E0CB6-CEF0-4375-9BE8-E518623B20E6}"/>
               </a:ext>
             </a:extLst>
           </p:cNvPr>
@@ -13004,7 +14006,7 @@
         </p:xfrm>
         <a:graphic xmlns:a="http://schemas.openxmlformats.org/drawingml/2006/main">
           <a:graphicData uri="http://schemas.openxmlformats.org/drawingml/2006/chart">
-            <c:chart xmlns:r="http://schemas.openxmlformats.org/officeDocument/2006/relationships" xmlns:c="http://schemas.openxmlformats.org/drawingml/2006/chart" r:id="Rc6f35de54efd4421"/>
+            <c:chart xmlns:r="http://schemas.openxmlformats.org/officeDocument/2006/relationships" xmlns:c="http://schemas.openxmlformats.org/drawingml/2006/chart" r:id="R945e4001f8e14085"/>
           </a:graphicData>
         </a:graphic>
       </p:graphicFrame>
@@ -13013,7 +14015,7 @@
           <p:cNvPr id="9" name="">
             <a:extLst xmlns:a="http://schemas.openxmlformats.org/drawingml/2006/main">
               <a:ext uri="{FF2B5EF4-FFF2-40B4-BE49-F238E27FC236}">
-                <a16:creationId xmlns:a16="http://schemas.microsoft.com/office/drawing/2014/main" id="{D00F6F06-4CD4-48E4-A1BD-6D1113930C0B}"/>
+                <a16:creationId xmlns:a16="http://schemas.microsoft.com/office/drawing/2014/main" id="{7B7CE20F-8FCD-441E-9108-9DEE482E6566}"/>
               </a:ext>
             </a:extLst>
           </p:cNvPr>
@@ -13071,7 +14073,7 @@
           <p:cNvPr id="10" name="">
             <a:extLst xmlns:a="http://schemas.openxmlformats.org/drawingml/2006/main">
               <a:ext uri="{FF2B5EF4-FFF2-40B4-BE49-F238E27FC236}">
-                <a16:creationId xmlns:a16="http://schemas.microsoft.com/office/drawing/2014/main" id="{6F45632A-F3C1-44A3-9EA1-2647FC67C065}"/>
+                <a16:creationId xmlns:a16="http://schemas.microsoft.com/office/drawing/2014/main" id="{888EF4B7-044D-4FE0-A8D0-B619F0CE0199}"/>
               </a:ext>
             </a:extLst>
           </p:cNvPr>
@@ -13129,7 +14131,7 @@
           <p:cNvPr id="11" name="">
             <a:extLst xmlns:a="http://schemas.openxmlformats.org/drawingml/2006/main">
               <a:ext uri="{FF2B5EF4-FFF2-40B4-BE49-F238E27FC236}">
-                <a16:creationId xmlns:a16="http://schemas.microsoft.com/office/drawing/2014/main" id="{73882036-A3F3-4D69-BED9-F1C396AC64BF}"/>
+                <a16:creationId xmlns:a16="http://schemas.microsoft.com/office/drawing/2014/main" id="{4826A4FD-4C3A-4B6C-8F7D-71B1AB6EA719}"/>
               </a:ext>
             </a:extLst>
           </p:cNvPr>
@@ -13187,7 +14189,7 @@
           <p:cNvPr id="12" name="">
             <a:extLst xmlns:a="http://schemas.openxmlformats.org/drawingml/2006/main">
               <a:ext uri="{FF2B5EF4-FFF2-40B4-BE49-F238E27FC236}">
-                <a16:creationId xmlns:a16="http://schemas.microsoft.com/office/drawing/2014/main" id="{5BC821AA-FBA3-4C16-BE2B-EEBF83B89545}"/>
+                <a16:creationId xmlns:a16="http://schemas.microsoft.com/office/drawing/2014/main" id="{E008F651-D91F-41A8-B40E-D6A7C80BA662}"/>
               </a:ext>
             </a:extLst>
           </p:cNvPr>
@@ -13245,7 +14247,7 @@
           <p:cNvPr id="13" name="">
             <a:extLst xmlns:a="http://schemas.openxmlformats.org/drawingml/2006/main">
               <a:ext uri="{FF2B5EF4-FFF2-40B4-BE49-F238E27FC236}">
-                <a16:creationId xmlns:a16="http://schemas.microsoft.com/office/drawing/2014/main" id="{A627DCF5-AE62-4E9D-B735-ED65638AEDE0}"/>
+                <a16:creationId xmlns:a16="http://schemas.microsoft.com/office/drawing/2014/main" id="{B0195288-99B9-4BD6-934C-06A397172B53}"/>
               </a:ext>
             </a:extLst>
           </p:cNvPr>
@@ -13303,7 +14305,7 @@
           <p:cNvPr id="14" name="">
             <a:extLst xmlns:a="http://schemas.openxmlformats.org/drawingml/2006/main">
               <a:ext uri="{FF2B5EF4-FFF2-40B4-BE49-F238E27FC236}">
-                <a16:creationId xmlns:a16="http://schemas.microsoft.com/office/drawing/2014/main" id="{87D3B4EF-A7E7-41B8-940C-B734A95E3233}"/>
+                <a16:creationId xmlns:a16="http://schemas.microsoft.com/office/drawing/2014/main" id="{DCC69412-F2FC-4726-8FC8-C7808F2CF65C}"/>
               </a:ext>
             </a:extLst>
           </p:cNvPr>
@@ -13359,7 +14361,7 @@
     </p:spTree>
     <p:extLst>
       <p:ext uri="{BB962C8B-B14F-4D97-AF65-F5344CB8AC3E}">
-        <p14:creationId xmlns:p14="http://schemas.microsoft.com/office/powerpoint/2010/main" val="887650448"/>
+        <p14:creationId xmlns:p14="http://schemas.microsoft.com/office/powerpoint/2010/main" val="82086666"/>
       </p:ext>
     </p:extLst>
   </p:cSld>
@@ -13390,7 +14392,7 @@
           <p:cNvPr id="11" name="">
             <a:extLst xmlns:a="http://schemas.openxmlformats.org/drawingml/2006/main">
               <a:ext uri="{FF2B5EF4-FFF2-40B4-BE49-F238E27FC236}">
-                <a16:creationId xmlns:a16="http://schemas.microsoft.com/office/drawing/2014/main" id="{50EED113-4676-4724-8709-58172C9B1013}"/>
+                <a16:creationId xmlns:a16="http://schemas.microsoft.com/office/drawing/2014/main" id="{C1157C25-3F20-4F94-A7CD-EEDB09045178}"/>
               </a:ext>
             </a:extLst>
           </p:cNvPr>
@@ -13423,7 +14425,7 @@
           <p:cNvPr id="2" name="">
             <a:extLst xmlns:a="http://schemas.openxmlformats.org/drawingml/2006/main">
               <a:ext uri="{FF2B5EF4-FFF2-40B4-BE49-F238E27FC236}">
-                <a16:creationId xmlns:a16="http://schemas.microsoft.com/office/drawing/2014/main" id="{269CDF15-795E-4DBF-95F2-0A6DA7AE5643}"/>
+                <a16:creationId xmlns:a16="http://schemas.microsoft.com/office/drawing/2014/main" id="{3076A669-5DF7-40D6-90DC-648B1DBA1C17}"/>
               </a:ext>
             </a:extLst>
           </p:cNvPr>
@@ -13481,7 +14483,7 @@
           <p:cNvPr id="3" name="">
             <a:extLst xmlns:a="http://schemas.openxmlformats.org/drawingml/2006/main">
               <a:ext uri="{FF2B5EF4-FFF2-40B4-BE49-F238E27FC236}">
-                <a16:creationId xmlns:a16="http://schemas.microsoft.com/office/drawing/2014/main" id="{5B048A33-EAFC-4A7D-97CD-E512892EF667}"/>
+                <a16:creationId xmlns:a16="http://schemas.microsoft.com/office/drawing/2014/main" id="{FAE77168-7B7E-40E1-8440-5B09D17BE0D9}"/>
               </a:ext>
             </a:extLst>
           </p:cNvPr>
@@ -13539,7 +14541,7 @@
           <p:cNvPr id="4" name="">
             <a:extLst xmlns:a="http://schemas.openxmlformats.org/drawingml/2006/main">
               <a:ext uri="{FF2B5EF4-FFF2-40B4-BE49-F238E27FC236}">
-                <a16:creationId xmlns:a16="http://schemas.microsoft.com/office/drawing/2014/main" id="{6F55E3DE-B6BF-4C4D-AB8E-2D52F87C7A37}"/>
+                <a16:creationId xmlns:a16="http://schemas.microsoft.com/office/drawing/2014/main" id="{B1A44AE4-9804-4F8D-AADD-7451A4FD45DB}"/>
               </a:ext>
             </a:extLst>
           </p:cNvPr>
@@ -13597,7 +14599,7 @@
           <p:cNvPr id="5" name="">
             <a:extLst xmlns:a="http://schemas.openxmlformats.org/drawingml/2006/main">
               <a:ext uri="{FF2B5EF4-FFF2-40B4-BE49-F238E27FC236}">
-                <a16:creationId xmlns:a16="http://schemas.microsoft.com/office/drawing/2014/main" id="{2C1A4318-A2EE-47FA-9A05-D3CDB1727F41}"/>
+                <a16:creationId xmlns:a16="http://schemas.microsoft.com/office/drawing/2014/main" id="{94BFBB99-8612-4FD7-877F-6017A6C9AC98}"/>
               </a:ext>
             </a:extLst>
           </p:cNvPr>
@@ -13628,7 +14630,7 @@
           <p:cNvPr id="6" name="">
             <a:extLst xmlns:a="http://schemas.openxmlformats.org/drawingml/2006/main">
               <a:ext uri="{FF2B5EF4-FFF2-40B4-BE49-F238E27FC236}">
-                <a16:creationId xmlns:a16="http://schemas.microsoft.com/office/drawing/2014/main" id="{1FEDE7E7-6FB9-46B7-9300-8AF1485482F2}"/>
+                <a16:creationId xmlns:a16="http://schemas.microsoft.com/office/drawing/2014/main" id="{4158FA26-30A0-4BDA-A2E2-9E92641B15FB}"/>
               </a:ext>
             </a:extLst>
           </p:cNvPr>
@@ -13659,7 +14661,7 @@
           <p:cNvPr id="7" name="">
             <a:extLst xmlns:a="http://schemas.openxmlformats.org/drawingml/2006/main">
               <a:ext uri="{FF2B5EF4-FFF2-40B4-BE49-F238E27FC236}">
-                <a16:creationId xmlns:a16="http://schemas.microsoft.com/office/drawing/2014/main" id="{6B4D5A27-F8C7-40AF-AC2B-789801FE3756}"/>
+                <a16:creationId xmlns:a16="http://schemas.microsoft.com/office/drawing/2014/main" id="{69FE98A7-2444-4C51-B427-FBAAA05F6538}"/>
               </a:ext>
             </a:extLst>
           </p:cNvPr>
@@ -14407,7 +15409,7 @@
           <p:cNvPr id="10" name="">
             <a:extLst xmlns:a="http://schemas.openxmlformats.org/drawingml/2006/main">
               <a:ext uri="{FF2B5EF4-FFF2-40B4-BE49-F238E27FC236}">
-                <a16:creationId xmlns:a16="http://schemas.microsoft.com/office/drawing/2014/main" id="{7C573BB0-4A33-4788-AC87-9DE1B0D34D02}"/>
+                <a16:creationId xmlns:a16="http://schemas.microsoft.com/office/drawing/2014/main" id="{1B25271A-7132-4469-8F36-DBCE5037C390}"/>
               </a:ext>
             </a:extLst>
           </p:cNvPr>
@@ -14463,7 +15465,7 @@
     </p:spTree>
     <p:extLst>
       <p:ext uri="{BB962C8B-B14F-4D97-AF65-F5344CB8AC3E}">
-        <p14:creationId xmlns:p14="http://schemas.microsoft.com/office/powerpoint/2010/main" val="979313966"/>
+        <p14:creationId xmlns:p14="http://schemas.microsoft.com/office/powerpoint/2010/main" val="1528845104"/>
       </p:ext>
     </p:extLst>
   </p:cSld>
@@ -14494,7 +15496,7 @@
           <p:cNvPr id="15" name="">
             <a:extLst xmlns:a="http://schemas.openxmlformats.org/drawingml/2006/main">
               <a:ext uri="{FF2B5EF4-FFF2-40B4-BE49-F238E27FC236}">
-                <a16:creationId xmlns:a16="http://schemas.microsoft.com/office/drawing/2014/main" id="{8207F2B7-491B-4B48-9152-A1C26F1339CC}"/>
+                <a16:creationId xmlns:a16="http://schemas.microsoft.com/office/drawing/2014/main" id="{BEA54DD1-6BBE-4BD5-ACA2-E439875B91E0}"/>
               </a:ext>
             </a:extLst>
           </p:cNvPr>
@@ -14527,7 +15529,7 @@
           <p:cNvPr id="2" name="">
             <a:extLst xmlns:a="http://schemas.openxmlformats.org/drawingml/2006/main">
               <a:ext uri="{FF2B5EF4-FFF2-40B4-BE49-F238E27FC236}">
-                <a16:creationId xmlns:a16="http://schemas.microsoft.com/office/drawing/2014/main" id="{9F8ED8BB-B718-4D08-B4D2-981BB449527E}"/>
+                <a16:creationId xmlns:a16="http://schemas.microsoft.com/office/drawing/2014/main" id="{66E6B475-9103-4708-B711-C75925D717B7}"/>
               </a:ext>
             </a:extLst>
           </p:cNvPr>
@@ -14585,7 +15587,7 @@
           <p:cNvPr id="3" name="">
             <a:extLst xmlns:a="http://schemas.openxmlformats.org/drawingml/2006/main">
               <a:ext uri="{FF2B5EF4-FFF2-40B4-BE49-F238E27FC236}">
-                <a16:creationId xmlns:a16="http://schemas.microsoft.com/office/drawing/2014/main" id="{3E7204FF-4569-443B-9909-1261E6102809}"/>
+                <a16:creationId xmlns:a16="http://schemas.microsoft.com/office/drawing/2014/main" id="{15D2F288-5BD1-48AE-AAA9-B13FAAD44890}"/>
               </a:ext>
             </a:extLst>
           </p:cNvPr>
@@ -14643,7 +15645,7 @@
           <p:cNvPr id="4" name="">
             <a:extLst xmlns:a="http://schemas.openxmlformats.org/drawingml/2006/main">
               <a:ext uri="{FF2B5EF4-FFF2-40B4-BE49-F238E27FC236}">
-                <a16:creationId xmlns:a16="http://schemas.microsoft.com/office/drawing/2014/main" id="{92489F4C-FEE4-4F94-8D00-83EC2E575298}"/>
+                <a16:creationId xmlns:a16="http://schemas.microsoft.com/office/drawing/2014/main" id="{836E6F63-E2B2-4DD8-8135-B15E8F4C4E0B}"/>
               </a:ext>
             </a:extLst>
           </p:cNvPr>
@@ -14701,7 +15703,7 @@
           <p:cNvPr id="5" name="">
             <a:extLst xmlns:a="http://schemas.openxmlformats.org/drawingml/2006/main">
               <a:ext uri="{FF2B5EF4-FFF2-40B4-BE49-F238E27FC236}">
-                <a16:creationId xmlns:a16="http://schemas.microsoft.com/office/drawing/2014/main" id="{DA9ACB0B-BFDA-4878-B8A3-4AD439B49455}"/>
+                <a16:creationId xmlns:a16="http://schemas.microsoft.com/office/drawing/2014/main" id="{B35DD356-A533-46CE-B685-33FE0AC49A66}"/>
               </a:ext>
             </a:extLst>
           </p:cNvPr>
@@ -14732,7 +15734,7 @@
           <p:cNvPr id="6" name="">
             <a:extLst xmlns:a="http://schemas.openxmlformats.org/drawingml/2006/main">
               <a:ext uri="{FF2B5EF4-FFF2-40B4-BE49-F238E27FC236}">
-                <a16:creationId xmlns:a16="http://schemas.microsoft.com/office/drawing/2014/main" id="{32FD8BCB-A4D5-42D5-AE0B-34EA786DF8CF}"/>
+                <a16:creationId xmlns:a16="http://schemas.microsoft.com/office/drawing/2014/main" id="{BF00193A-4981-40FA-AE84-3D29D337BA35}"/>
               </a:ext>
             </a:extLst>
           </p:cNvPr>
@@ -14763,7 +15765,7 @@
           <p:cNvPr id="7" name="">
             <a:extLst xmlns:a="http://schemas.openxmlformats.org/drawingml/2006/main">
               <a:ext uri="{FF2B5EF4-FFF2-40B4-BE49-F238E27FC236}">
-                <a16:creationId xmlns:a16="http://schemas.microsoft.com/office/drawing/2014/main" id="{D4DD4190-7B2E-4FE6-ABFA-94CC1C5B7425}"/>
+                <a16:creationId xmlns:a16="http://schemas.microsoft.com/office/drawing/2014/main" id="{2112945E-E665-4B1C-AF1F-626085A1B9B3}"/>
               </a:ext>
             </a:extLst>
           </p:cNvPr>
@@ -14828,7 +15830,7 @@
         </p:xfrm>
         <a:graphic xmlns:a="http://schemas.openxmlformats.org/drawingml/2006/main">
           <a:graphicData uri="http://schemas.openxmlformats.org/drawingml/2006/chart">
-            <c:chart xmlns:r="http://schemas.openxmlformats.org/officeDocument/2006/relationships" xmlns:c="http://schemas.openxmlformats.org/drawingml/2006/chart" r:id="R9721f9cf7a4c466b"/>
+            <c:chart xmlns:r="http://schemas.openxmlformats.org/officeDocument/2006/relationships" xmlns:c="http://schemas.openxmlformats.org/drawingml/2006/chart" r:id="R197e08bf427942c9"/>
           </a:graphicData>
         </a:graphic>
       </p:graphicFrame>
@@ -14837,7 +15839,7 @@
           <p:cNvPr id="9" name="">
             <a:extLst xmlns:a="http://schemas.openxmlformats.org/drawingml/2006/main">
               <a:ext uri="{FF2B5EF4-FFF2-40B4-BE49-F238E27FC236}">
-                <a16:creationId xmlns:a16="http://schemas.microsoft.com/office/drawing/2014/main" id="{2EBADE8D-BF55-485D-9A92-5601B8919308}"/>
+                <a16:creationId xmlns:a16="http://schemas.microsoft.com/office/drawing/2014/main" id="{809F3DAC-406B-437F-BB00-B5BB19573F4E}"/>
               </a:ext>
             </a:extLst>
           </p:cNvPr>
@@ -14895,7 +15897,7 @@
           <p:cNvPr id="10" name="">
             <a:extLst xmlns:a="http://schemas.openxmlformats.org/drawingml/2006/main">
               <a:ext uri="{FF2B5EF4-FFF2-40B4-BE49-F238E27FC236}">
-                <a16:creationId xmlns:a16="http://schemas.microsoft.com/office/drawing/2014/main" id="{33210240-4665-4A48-A6C1-8D6409AAF33E}"/>
+                <a16:creationId xmlns:a16="http://schemas.microsoft.com/office/drawing/2014/main" id="{152240EC-C059-415E-99E8-793B90A29869}"/>
               </a:ext>
             </a:extLst>
           </p:cNvPr>
@@ -14953,7 +15955,7 @@
           <p:cNvPr id="11" name="">
             <a:extLst xmlns:a="http://schemas.openxmlformats.org/drawingml/2006/main">
               <a:ext uri="{FF2B5EF4-FFF2-40B4-BE49-F238E27FC236}">
-                <a16:creationId xmlns:a16="http://schemas.microsoft.com/office/drawing/2014/main" id="{2E9A378F-FA15-4F7B-A27E-4F67C58E75F4}"/>
+                <a16:creationId xmlns:a16="http://schemas.microsoft.com/office/drawing/2014/main" id="{DBEBE5F6-A025-471D-B554-BE379657B6DD}"/>
               </a:ext>
             </a:extLst>
           </p:cNvPr>
@@ -15011,7 +16013,7 @@
           <p:cNvPr id="12" name="">
             <a:extLst xmlns:a="http://schemas.openxmlformats.org/drawingml/2006/main">
               <a:ext uri="{FF2B5EF4-FFF2-40B4-BE49-F238E27FC236}">
-                <a16:creationId xmlns:a16="http://schemas.microsoft.com/office/drawing/2014/main" id="{F9664400-5CC0-4B15-B775-3370D4C7E93B}"/>
+                <a16:creationId xmlns:a16="http://schemas.microsoft.com/office/drawing/2014/main" id="{E5DC5AF0-5E1A-4F4E-854D-43AF811F7213}"/>
               </a:ext>
             </a:extLst>
           </p:cNvPr>
@@ -15069,7 +16071,7 @@
           <p:cNvPr id="13" name="">
             <a:extLst xmlns:a="http://schemas.openxmlformats.org/drawingml/2006/main">
               <a:ext uri="{FF2B5EF4-FFF2-40B4-BE49-F238E27FC236}">
-                <a16:creationId xmlns:a16="http://schemas.microsoft.com/office/drawing/2014/main" id="{3F3984C5-B76D-4231-AA07-0BD1C3FD3C10}"/>
+                <a16:creationId xmlns:a16="http://schemas.microsoft.com/office/drawing/2014/main" id="{0D6D94EB-FF9F-450A-9761-FE76D4411911}"/>
               </a:ext>
             </a:extLst>
           </p:cNvPr>
@@ -15127,7 +16129,7 @@
           <p:cNvPr id="14" name="">
             <a:extLst xmlns:a="http://schemas.openxmlformats.org/drawingml/2006/main">
               <a:ext uri="{FF2B5EF4-FFF2-40B4-BE49-F238E27FC236}">
-                <a16:creationId xmlns:a16="http://schemas.microsoft.com/office/drawing/2014/main" id="{D3DD2B1A-F2FB-4A46-9B5C-7B3B3257BA0F}"/>
+                <a16:creationId xmlns:a16="http://schemas.microsoft.com/office/drawing/2014/main" id="{14A13B91-49DB-4DBD-8F4D-F3E5E9467258}"/>
               </a:ext>
             </a:extLst>
           </p:cNvPr>
@@ -15183,7 +16185,7 @@
     </p:spTree>
     <p:extLst>
       <p:ext uri="{BB962C8B-B14F-4D97-AF65-F5344CB8AC3E}">
-        <p14:creationId xmlns:p14="http://schemas.microsoft.com/office/powerpoint/2010/main" val="141616397"/>
+        <p14:creationId xmlns:p14="http://schemas.microsoft.com/office/powerpoint/2010/main" val="2059029578"/>
       </p:ext>
     </p:extLst>
   </p:cSld>
@@ -15214,7 +16216,7 @@
           <p:cNvPr id="11" name="">
             <a:extLst xmlns:a="http://schemas.openxmlformats.org/drawingml/2006/main">
               <a:ext uri="{FF2B5EF4-FFF2-40B4-BE49-F238E27FC236}">
-                <a16:creationId xmlns:a16="http://schemas.microsoft.com/office/drawing/2014/main" id="{8E16DAF1-8B8D-4DDC-8695-F91B56F89807}"/>
+                <a16:creationId xmlns:a16="http://schemas.microsoft.com/office/drawing/2014/main" id="{D8D2575F-F388-4EAE-9E9E-1CD1402EAAD5}"/>
               </a:ext>
             </a:extLst>
           </p:cNvPr>
@@ -15247,7 +16249,7 @@
           <p:cNvPr id="2" name="">
             <a:extLst xmlns:a="http://schemas.openxmlformats.org/drawingml/2006/main">
               <a:ext uri="{FF2B5EF4-FFF2-40B4-BE49-F238E27FC236}">
-                <a16:creationId xmlns:a16="http://schemas.microsoft.com/office/drawing/2014/main" id="{396E090D-59AE-47CE-8D33-AF71D0F672A3}"/>
+                <a16:creationId xmlns:a16="http://schemas.microsoft.com/office/drawing/2014/main" id="{DB66DFCB-8E80-4FE5-BBDE-EEF25D3E6166}"/>
               </a:ext>
             </a:extLst>
           </p:cNvPr>
@@ -15305,7 +16307,7 @@
           <p:cNvPr id="3" name="">
             <a:extLst xmlns:a="http://schemas.openxmlformats.org/drawingml/2006/main">
               <a:ext uri="{FF2B5EF4-FFF2-40B4-BE49-F238E27FC236}">
-                <a16:creationId xmlns:a16="http://schemas.microsoft.com/office/drawing/2014/main" id="{7465F6E0-C69A-4929-A339-CE0DEEEBD402}"/>
+                <a16:creationId xmlns:a16="http://schemas.microsoft.com/office/drawing/2014/main" id="{D270504D-90F9-46F5-A1B8-24ED801C18AF}"/>
               </a:ext>
             </a:extLst>
           </p:cNvPr>
@@ -15363,7 +16365,7 @@
           <p:cNvPr id="4" name="">
             <a:extLst xmlns:a="http://schemas.openxmlformats.org/drawingml/2006/main">
               <a:ext uri="{FF2B5EF4-FFF2-40B4-BE49-F238E27FC236}">
-                <a16:creationId xmlns:a16="http://schemas.microsoft.com/office/drawing/2014/main" id="{CD630FD0-4C44-4C19-AEB3-9FECD2967C20}"/>
+                <a16:creationId xmlns:a16="http://schemas.microsoft.com/office/drawing/2014/main" id="{16BCA50A-5BF0-4CDA-899D-D78AB1133FCC}"/>
               </a:ext>
             </a:extLst>
           </p:cNvPr>
@@ -15421,7 +16423,7 @@
           <p:cNvPr id="5" name="">
             <a:extLst xmlns:a="http://schemas.openxmlformats.org/drawingml/2006/main">
               <a:ext uri="{FF2B5EF4-FFF2-40B4-BE49-F238E27FC236}">
-                <a16:creationId xmlns:a16="http://schemas.microsoft.com/office/drawing/2014/main" id="{81891705-8B35-4603-A19E-3A61EA805B30}"/>
+                <a16:creationId xmlns:a16="http://schemas.microsoft.com/office/drawing/2014/main" id="{8D4579BD-CE4D-4373-9851-555FB6979417}"/>
               </a:ext>
             </a:extLst>
           </p:cNvPr>
@@ -15452,7 +16454,7 @@
           <p:cNvPr id="6" name="">
             <a:extLst xmlns:a="http://schemas.openxmlformats.org/drawingml/2006/main">
               <a:ext uri="{FF2B5EF4-FFF2-40B4-BE49-F238E27FC236}">
-                <a16:creationId xmlns:a16="http://schemas.microsoft.com/office/drawing/2014/main" id="{A5293AB6-7744-4359-AE2E-EEC31D76A7E0}"/>
+                <a16:creationId xmlns:a16="http://schemas.microsoft.com/office/drawing/2014/main" id="{40B91B3F-75E9-47EE-8D7E-86DF39C8235E}"/>
               </a:ext>
             </a:extLst>
           </p:cNvPr>
@@ -15483,7 +16485,7 @@
           <p:cNvPr id="7" name="">
             <a:extLst xmlns:a="http://schemas.openxmlformats.org/drawingml/2006/main">
               <a:ext uri="{FF2B5EF4-FFF2-40B4-BE49-F238E27FC236}">
-                <a16:creationId xmlns:a16="http://schemas.microsoft.com/office/drawing/2014/main" id="{6CA5B1EB-56BD-4B9E-AB84-AC9344388800}"/>
+                <a16:creationId xmlns:a16="http://schemas.microsoft.com/office/drawing/2014/main" id="{8D03BFA5-D6DD-464C-9365-113260DE4EB1}"/>
               </a:ext>
             </a:extLst>
           </p:cNvPr>
@@ -15548,7 +16550,7 @@
         </p:xfrm>
         <a:graphic xmlns:a="http://schemas.openxmlformats.org/drawingml/2006/main">
           <a:graphicData uri="http://schemas.openxmlformats.org/drawingml/2006/chart">
-            <c:chart xmlns:r="http://schemas.openxmlformats.org/officeDocument/2006/relationships" xmlns:c="http://schemas.openxmlformats.org/drawingml/2006/chart" r:id="Rb8315d8531af466d"/>
+            <c:chart xmlns:r="http://schemas.openxmlformats.org/officeDocument/2006/relationships" xmlns:c="http://schemas.openxmlformats.org/drawingml/2006/chart" r:id="R1e1ae4342807431e"/>
           </a:graphicData>
         </a:graphic>
       </p:graphicFrame>
@@ -15881,7 +16883,7 @@
           <p:cNvPr id="10" name="">
             <a:extLst xmlns:a="http://schemas.openxmlformats.org/drawingml/2006/main">
               <a:ext uri="{FF2B5EF4-FFF2-40B4-BE49-F238E27FC236}">
-                <a16:creationId xmlns:a16="http://schemas.microsoft.com/office/drawing/2014/main" id="{2822DFFE-D974-490F-AC86-E9C2CDE3CCB3}"/>
+                <a16:creationId xmlns:a16="http://schemas.microsoft.com/office/drawing/2014/main" id="{03FC167F-D52E-48EF-9099-A7C9AA11F1C2}"/>
               </a:ext>
             </a:extLst>
           </p:cNvPr>
@@ -15937,7 +16939,7 @@
     </p:spTree>
     <p:extLst>
       <p:ext uri="{BB962C8B-B14F-4D97-AF65-F5344CB8AC3E}">
-        <p14:creationId xmlns:p14="http://schemas.microsoft.com/office/powerpoint/2010/main" val="1570559966"/>
+        <p14:creationId xmlns:p14="http://schemas.microsoft.com/office/powerpoint/2010/main" val="677977107"/>
       </p:ext>
     </p:extLst>
   </p:cSld>
@@ -15968,7 +16970,7 @@
           <p:cNvPr id="13" name="">
             <a:extLst xmlns:a="http://schemas.openxmlformats.org/drawingml/2006/main">
               <a:ext uri="{FF2B5EF4-FFF2-40B4-BE49-F238E27FC236}">
-                <a16:creationId xmlns:a16="http://schemas.microsoft.com/office/drawing/2014/main" id="{1935A2AD-E8B9-49C6-B3C5-7C8BDFB4B64A}"/>
+                <a16:creationId xmlns:a16="http://schemas.microsoft.com/office/drawing/2014/main" id="{113BE426-BADE-4B3B-B1B3-C59F0AA5A229}"/>
               </a:ext>
             </a:extLst>
           </p:cNvPr>
@@ -16001,7 +17003,7 @@
           <p:cNvPr id="2" name="">
             <a:extLst xmlns:a="http://schemas.openxmlformats.org/drawingml/2006/main">
               <a:ext uri="{FF2B5EF4-FFF2-40B4-BE49-F238E27FC236}">
-                <a16:creationId xmlns:a16="http://schemas.microsoft.com/office/drawing/2014/main" id="{5690E54C-EE41-41FD-B834-776B67B67635}"/>
+                <a16:creationId xmlns:a16="http://schemas.microsoft.com/office/drawing/2014/main" id="{B3C88470-9AC5-4EA0-8365-C6DDA3271BBD}"/>
               </a:ext>
             </a:extLst>
           </p:cNvPr>
@@ -16059,7 +17061,7 @@
           <p:cNvPr id="3" name="">
             <a:extLst xmlns:a="http://schemas.openxmlformats.org/drawingml/2006/main">
               <a:ext uri="{FF2B5EF4-FFF2-40B4-BE49-F238E27FC236}">
-                <a16:creationId xmlns:a16="http://schemas.microsoft.com/office/drawing/2014/main" id="{DECBFD0E-D23E-4DA3-8644-FD9F0D6D517E}"/>
+                <a16:creationId xmlns:a16="http://schemas.microsoft.com/office/drawing/2014/main" id="{0E04BB34-D3CF-464C-B212-46B62B6949E9}"/>
               </a:ext>
             </a:extLst>
           </p:cNvPr>
@@ -16117,7 +17119,7 @@
           <p:cNvPr id="4" name="">
             <a:extLst xmlns:a="http://schemas.openxmlformats.org/drawingml/2006/main">
               <a:ext uri="{FF2B5EF4-FFF2-40B4-BE49-F238E27FC236}">
-                <a16:creationId xmlns:a16="http://schemas.microsoft.com/office/drawing/2014/main" id="{E115C2FC-DEC4-4982-AD2F-199E1582AEF7}"/>
+                <a16:creationId xmlns:a16="http://schemas.microsoft.com/office/drawing/2014/main" id="{A62C39B7-31B6-4C28-A018-DDD7E3BA6560}"/>
               </a:ext>
             </a:extLst>
           </p:cNvPr>
@@ -16175,7 +17177,7 @@
           <p:cNvPr id="5" name="">
             <a:extLst xmlns:a="http://schemas.openxmlformats.org/drawingml/2006/main">
               <a:ext uri="{FF2B5EF4-FFF2-40B4-BE49-F238E27FC236}">
-                <a16:creationId xmlns:a16="http://schemas.microsoft.com/office/drawing/2014/main" id="{6D90D2AD-CAA7-426C-ADBA-D0A47ECF33DB}"/>
+                <a16:creationId xmlns:a16="http://schemas.microsoft.com/office/drawing/2014/main" id="{8A22963F-ED0E-457E-B7C1-EA1D21619111}"/>
               </a:ext>
             </a:extLst>
           </p:cNvPr>
@@ -16206,7 +17208,7 @@
           <p:cNvPr id="6" name="">
             <a:extLst xmlns:a="http://schemas.openxmlformats.org/drawingml/2006/main">
               <a:ext uri="{FF2B5EF4-FFF2-40B4-BE49-F238E27FC236}">
-                <a16:creationId xmlns:a16="http://schemas.microsoft.com/office/drawing/2014/main" id="{627E2D98-622C-45D7-9D1A-8B60B759F99F}"/>
+                <a16:creationId xmlns:a16="http://schemas.microsoft.com/office/drawing/2014/main" id="{434959EA-2F12-4EBD-AE53-52DF332F0A6A}"/>
               </a:ext>
             </a:extLst>
           </p:cNvPr>
@@ -16237,7 +17239,7 @@
           <p:cNvPr id="7" name="">
             <a:extLst xmlns:a="http://schemas.openxmlformats.org/drawingml/2006/main">
               <a:ext uri="{FF2B5EF4-FFF2-40B4-BE49-F238E27FC236}">
-                <a16:creationId xmlns:a16="http://schemas.microsoft.com/office/drawing/2014/main" id="{FDC10387-D5EE-4F48-8231-407ABA44F2C8}"/>
+                <a16:creationId xmlns:a16="http://schemas.microsoft.com/office/drawing/2014/main" id="{CDCA2CEC-95FE-46AD-A0F5-20F13873BFBD}"/>
               </a:ext>
             </a:extLst>
           </p:cNvPr>
@@ -16302,7 +17304,7 @@
         </p:xfrm>
         <a:graphic xmlns:a="http://schemas.openxmlformats.org/drawingml/2006/main">
           <a:graphicData uri="http://schemas.openxmlformats.org/drawingml/2006/chart">
-            <c:chart xmlns:r="http://schemas.openxmlformats.org/officeDocument/2006/relationships" xmlns:c="http://schemas.openxmlformats.org/drawingml/2006/chart" r:id="Rb587a4e4d1664521"/>
+            <c:chart xmlns:r="http://schemas.openxmlformats.org/officeDocument/2006/relationships" xmlns:c="http://schemas.openxmlformats.org/drawingml/2006/chart" r:id="R427db85df41f4245"/>
           </a:graphicData>
         </a:graphic>
       </p:graphicFrame>
@@ -16311,7 +17313,7 @@
           <p:cNvPr id="9" name="">
             <a:extLst xmlns:a="http://schemas.openxmlformats.org/drawingml/2006/main">
               <a:ext uri="{FF2B5EF4-FFF2-40B4-BE49-F238E27FC236}">
-                <a16:creationId xmlns:a16="http://schemas.microsoft.com/office/drawing/2014/main" id="{9DD422AD-2352-4EC6-A825-0BABCFA6AD2C}"/>
+                <a16:creationId xmlns:a16="http://schemas.microsoft.com/office/drawing/2014/main" id="{A84BF552-5991-4F85-98A9-938FBA349BCA}"/>
               </a:ext>
             </a:extLst>
           </p:cNvPr>
@@ -16344,7 +17346,7 @@
           <p:cNvPr id="10" name="">
             <a:extLst xmlns:a="http://schemas.openxmlformats.org/drawingml/2006/main">
               <a:ext uri="{FF2B5EF4-FFF2-40B4-BE49-F238E27FC236}">
-                <a16:creationId xmlns:a16="http://schemas.microsoft.com/office/drawing/2014/main" id="{87E7E831-3E28-4AB9-B3E2-B69135B5012A}"/>
+                <a16:creationId xmlns:a16="http://schemas.microsoft.com/office/drawing/2014/main" id="{036F6F12-A485-4A91-9762-E43C89B7B76C}"/>
               </a:ext>
             </a:extLst>
           </p:cNvPr>
@@ -16402,7 +17404,7 @@
           <p:cNvPr id="11" name="">
             <a:extLst xmlns:a="http://schemas.openxmlformats.org/drawingml/2006/main">
               <a:ext uri="{FF2B5EF4-FFF2-40B4-BE49-F238E27FC236}">
-                <a16:creationId xmlns:a16="http://schemas.microsoft.com/office/drawing/2014/main" id="{8224014D-3D33-4530-850B-11FF00A98155}"/>
+                <a16:creationId xmlns:a16="http://schemas.microsoft.com/office/drawing/2014/main" id="{644C757D-502D-40E2-80FA-13720D0A0067}"/>
               </a:ext>
             </a:extLst>
           </p:cNvPr>
@@ -16460,7 +17462,7 @@
           <p:cNvPr id="12" name="">
             <a:extLst xmlns:a="http://schemas.openxmlformats.org/drawingml/2006/main">
               <a:ext uri="{FF2B5EF4-FFF2-40B4-BE49-F238E27FC236}">
-                <a16:creationId xmlns:a16="http://schemas.microsoft.com/office/drawing/2014/main" id="{37A12535-9153-4DF5-B687-31013935C795}"/>
+                <a16:creationId xmlns:a16="http://schemas.microsoft.com/office/drawing/2014/main" id="{3614D308-8BAB-470C-B01A-0377A3C7D74A}"/>
               </a:ext>
             </a:extLst>
           </p:cNvPr>
@@ -16516,7 +17518,7 @@
     </p:spTree>
     <p:extLst>
       <p:ext uri="{BB962C8B-B14F-4D97-AF65-F5344CB8AC3E}">
-        <p14:creationId xmlns:p14="http://schemas.microsoft.com/office/powerpoint/2010/main" val="1189871397"/>
+        <p14:creationId xmlns:p14="http://schemas.microsoft.com/office/powerpoint/2010/main" val="1175682088"/>
       </p:ext>
     </p:extLst>
   </p:cSld>
@@ -16547,7 +17549,7 @@
           <p:cNvPr id="15" name="">
             <a:extLst xmlns:a="http://schemas.openxmlformats.org/drawingml/2006/main">
               <a:ext uri="{FF2B5EF4-FFF2-40B4-BE49-F238E27FC236}">
-                <a16:creationId xmlns:a16="http://schemas.microsoft.com/office/drawing/2014/main" id="{1CB6E78B-4A7C-422D-9F61-143308BB5A75}"/>
+                <a16:creationId xmlns:a16="http://schemas.microsoft.com/office/drawing/2014/main" id="{BD91240C-2833-452F-A9E0-F2ACD383ED53}"/>
               </a:ext>
             </a:extLst>
           </p:cNvPr>
@@ -16580,7 +17582,7 @@
           <p:cNvPr id="2" name="">
             <a:extLst xmlns:a="http://schemas.openxmlformats.org/drawingml/2006/main">
               <a:ext uri="{FF2B5EF4-FFF2-40B4-BE49-F238E27FC236}">
-                <a16:creationId xmlns:a16="http://schemas.microsoft.com/office/drawing/2014/main" id="{5D64EA10-E126-4DEC-8A95-0C089803DA42}"/>
+                <a16:creationId xmlns:a16="http://schemas.microsoft.com/office/drawing/2014/main" id="{E74C7C1A-FE2B-4DAF-8B11-CE05014FBC47}"/>
               </a:ext>
             </a:extLst>
           </p:cNvPr>
@@ -16638,7 +17640,7 @@
           <p:cNvPr id="3" name="">
             <a:extLst xmlns:a="http://schemas.openxmlformats.org/drawingml/2006/main">
               <a:ext uri="{FF2B5EF4-FFF2-40B4-BE49-F238E27FC236}">
-                <a16:creationId xmlns:a16="http://schemas.microsoft.com/office/drawing/2014/main" id="{FCE77B2A-B9FA-4DFD-BA6C-2FFE7AF71400}"/>
+                <a16:creationId xmlns:a16="http://schemas.microsoft.com/office/drawing/2014/main" id="{6C05DE4F-FA41-420B-9408-B5B3BFA0C694}"/>
               </a:ext>
             </a:extLst>
           </p:cNvPr>
@@ -16696,7 +17698,7 @@
           <p:cNvPr id="4" name="">
             <a:extLst xmlns:a="http://schemas.openxmlformats.org/drawingml/2006/main">
               <a:ext uri="{FF2B5EF4-FFF2-40B4-BE49-F238E27FC236}">
-                <a16:creationId xmlns:a16="http://schemas.microsoft.com/office/drawing/2014/main" id="{26CBED8C-0689-4004-A084-5850EA24C509}"/>
+                <a16:creationId xmlns:a16="http://schemas.microsoft.com/office/drawing/2014/main" id="{6C3214CA-6A6E-4AAC-8D8D-69B9B255D6FF}"/>
               </a:ext>
             </a:extLst>
           </p:cNvPr>
@@ -16754,7 +17756,7 @@
           <p:cNvPr id="5" name="">
             <a:extLst xmlns:a="http://schemas.openxmlformats.org/drawingml/2006/main">
               <a:ext uri="{FF2B5EF4-FFF2-40B4-BE49-F238E27FC236}">
-                <a16:creationId xmlns:a16="http://schemas.microsoft.com/office/drawing/2014/main" id="{A41B576F-4D16-403C-AABB-4CC5C8C682AE}"/>
+                <a16:creationId xmlns:a16="http://schemas.microsoft.com/office/drawing/2014/main" id="{4E582EED-EEB9-43E2-9EF2-512805E0DCD7}"/>
               </a:ext>
             </a:extLst>
           </p:cNvPr>
@@ -16785,7 +17787,7 @@
           <p:cNvPr id="6" name="">
             <a:extLst xmlns:a="http://schemas.openxmlformats.org/drawingml/2006/main">
               <a:ext uri="{FF2B5EF4-FFF2-40B4-BE49-F238E27FC236}">
-                <a16:creationId xmlns:a16="http://schemas.microsoft.com/office/drawing/2014/main" id="{2A039B33-72D9-4FBE-A94D-07020B1BC1F6}"/>
+                <a16:creationId xmlns:a16="http://schemas.microsoft.com/office/drawing/2014/main" id="{7DEA5FBA-779B-4057-86AA-81D9E251F981}"/>
               </a:ext>
             </a:extLst>
           </p:cNvPr>
@@ -16816,7 +17818,7 @@
           <p:cNvPr id="7" name="">
             <a:extLst xmlns:a="http://schemas.openxmlformats.org/drawingml/2006/main">
               <a:ext uri="{FF2B5EF4-FFF2-40B4-BE49-F238E27FC236}">
-                <a16:creationId xmlns:a16="http://schemas.microsoft.com/office/drawing/2014/main" id="{BA5B6B7D-F5EE-41E1-A6D5-65D7ECA49BC3}"/>
+                <a16:creationId xmlns:a16="http://schemas.microsoft.com/office/drawing/2014/main" id="{797AEA5F-97AA-47DB-B601-B625F63196F9}"/>
               </a:ext>
             </a:extLst>
           </p:cNvPr>
@@ -16881,7 +17883,7 @@
         </p:xfrm>
         <a:graphic xmlns:a="http://schemas.openxmlformats.org/drawingml/2006/main">
           <a:graphicData uri="http://schemas.openxmlformats.org/drawingml/2006/chart">
-            <c:chart xmlns:r="http://schemas.openxmlformats.org/officeDocument/2006/relationships" xmlns:c="http://schemas.openxmlformats.org/drawingml/2006/chart" r:id="R9e8de37064ee42e4"/>
+            <c:chart xmlns:r="http://schemas.openxmlformats.org/officeDocument/2006/relationships" xmlns:c="http://schemas.openxmlformats.org/drawingml/2006/chart" r:id="R2a3f965b2d1c4fb1"/>
           </a:graphicData>
         </a:graphic>
       </p:graphicFrame>
@@ -16890,7 +17892,7 @@
           <p:cNvPr id="9" name="">
             <a:extLst xmlns:a="http://schemas.openxmlformats.org/drawingml/2006/main">
               <a:ext uri="{FF2B5EF4-FFF2-40B4-BE49-F238E27FC236}">
-                <a16:creationId xmlns:a16="http://schemas.microsoft.com/office/drawing/2014/main" id="{9681EA5F-4829-45F1-8206-D17127E7C722}"/>
+                <a16:creationId xmlns:a16="http://schemas.microsoft.com/office/drawing/2014/main" id="{E6BAD7C0-E163-4209-9CBD-6F0EF7F7A3BA}"/>
               </a:ext>
             </a:extLst>
           </p:cNvPr>
@@ -16948,7 +17950,7 @@
           <p:cNvPr id="10" name="">
             <a:extLst xmlns:a="http://schemas.openxmlformats.org/drawingml/2006/main">
               <a:ext uri="{FF2B5EF4-FFF2-40B4-BE49-F238E27FC236}">
-                <a16:creationId xmlns:a16="http://schemas.microsoft.com/office/drawing/2014/main" id="{80095EFC-5566-4DE2-B08E-B739882845DB}"/>
+                <a16:creationId xmlns:a16="http://schemas.microsoft.com/office/drawing/2014/main" id="{F5FC5BA0-EDF6-469C-BB9B-B4FF611AEB1C}"/>
               </a:ext>
             </a:extLst>
           </p:cNvPr>
@@ -17006,7 +18008,7 @@
           <p:cNvPr id="11" name="">
             <a:extLst xmlns:a="http://schemas.openxmlformats.org/drawingml/2006/main">
               <a:ext uri="{FF2B5EF4-FFF2-40B4-BE49-F238E27FC236}">
-                <a16:creationId xmlns:a16="http://schemas.microsoft.com/office/drawing/2014/main" id="{E34F8325-2951-4854-8CCD-6CA143C5A8EA}"/>
+                <a16:creationId xmlns:a16="http://schemas.microsoft.com/office/drawing/2014/main" id="{78B21FBA-7E01-48A4-A6C7-DAE5FC3E6F93}"/>
               </a:ext>
             </a:extLst>
           </p:cNvPr>
@@ -17064,7 +18066,7 @@
           <p:cNvPr id="12" name="">
             <a:extLst xmlns:a="http://schemas.openxmlformats.org/drawingml/2006/main">
               <a:ext uri="{FF2B5EF4-FFF2-40B4-BE49-F238E27FC236}">
-                <a16:creationId xmlns:a16="http://schemas.microsoft.com/office/drawing/2014/main" id="{85E5AEC0-404C-4895-8F1C-586F93AE3561}"/>
+                <a16:creationId xmlns:a16="http://schemas.microsoft.com/office/drawing/2014/main" id="{AFCB023C-3D85-41B7-9F30-07C36E13B181}"/>
               </a:ext>
             </a:extLst>
           </p:cNvPr>
@@ -17122,7 +18124,7 @@
           <p:cNvPr id="13" name="">
             <a:extLst xmlns:a="http://schemas.openxmlformats.org/drawingml/2006/main">
               <a:ext uri="{FF2B5EF4-FFF2-40B4-BE49-F238E27FC236}">
-                <a16:creationId xmlns:a16="http://schemas.microsoft.com/office/drawing/2014/main" id="{C9D467AD-E45E-41C8-B22E-70DF7018BE17}"/>
+                <a16:creationId xmlns:a16="http://schemas.microsoft.com/office/drawing/2014/main" id="{78ECE31F-82B7-4D7D-BB09-2C33CBAA5CA8}"/>
               </a:ext>
             </a:extLst>
           </p:cNvPr>
@@ -17180,7 +18182,7 @@
           <p:cNvPr id="14" name="">
             <a:extLst xmlns:a="http://schemas.openxmlformats.org/drawingml/2006/main">
               <a:ext uri="{FF2B5EF4-FFF2-40B4-BE49-F238E27FC236}">
-                <a16:creationId xmlns:a16="http://schemas.microsoft.com/office/drawing/2014/main" id="{6F4C45E9-665B-43EC-8E2A-FF2525E21B57}"/>
+                <a16:creationId xmlns:a16="http://schemas.microsoft.com/office/drawing/2014/main" id="{C45BAD29-B436-4230-8D39-61C99BCE5FFE}"/>
               </a:ext>
             </a:extLst>
           </p:cNvPr>
@@ -17236,7 +18238,7 @@
     </p:spTree>
     <p:extLst>
       <p:ext uri="{BB962C8B-B14F-4D97-AF65-F5344CB8AC3E}">
-        <p14:creationId xmlns:p14="http://schemas.microsoft.com/office/powerpoint/2010/main" val="1451116441"/>
+        <p14:creationId xmlns:p14="http://schemas.microsoft.com/office/powerpoint/2010/main" val="717851529"/>
       </p:ext>
     </p:extLst>
   </p:cSld>
@@ -17267,7 +18269,7 @@
           <p:cNvPr id="11" name="">
             <a:extLst xmlns:a="http://schemas.openxmlformats.org/drawingml/2006/main">
               <a:ext uri="{FF2B5EF4-FFF2-40B4-BE49-F238E27FC236}">
-                <a16:creationId xmlns:a16="http://schemas.microsoft.com/office/drawing/2014/main" id="{87F314C6-2469-448A-9F3D-04BBB4CE6EE7}"/>
+                <a16:creationId xmlns:a16="http://schemas.microsoft.com/office/drawing/2014/main" id="{CCA834A5-0660-44EC-8EAD-65669525486F}"/>
               </a:ext>
             </a:extLst>
           </p:cNvPr>
@@ -17300,7 +18302,7 @@
           <p:cNvPr id="2" name="">
             <a:extLst xmlns:a="http://schemas.openxmlformats.org/drawingml/2006/main">
               <a:ext uri="{FF2B5EF4-FFF2-40B4-BE49-F238E27FC236}">
-                <a16:creationId xmlns:a16="http://schemas.microsoft.com/office/drawing/2014/main" id="{A9EF3B88-C182-4F3D-A5A2-E374FD0BEADA}"/>
+                <a16:creationId xmlns:a16="http://schemas.microsoft.com/office/drawing/2014/main" id="{E51E9FDA-12AB-413E-91B8-F81E5F607C2D}"/>
               </a:ext>
             </a:extLst>
           </p:cNvPr>
@@ -17358,7 +18360,7 @@
           <p:cNvPr id="3" name="">
             <a:extLst xmlns:a="http://schemas.openxmlformats.org/drawingml/2006/main">
               <a:ext uri="{FF2B5EF4-FFF2-40B4-BE49-F238E27FC236}">
-                <a16:creationId xmlns:a16="http://schemas.microsoft.com/office/drawing/2014/main" id="{8C6A9FE8-184C-43D8-9CD1-789FE22A44AF}"/>
+                <a16:creationId xmlns:a16="http://schemas.microsoft.com/office/drawing/2014/main" id="{701E9665-9182-4888-B466-238C1C946A89}"/>
               </a:ext>
             </a:extLst>
           </p:cNvPr>
@@ -17416,7 +18418,7 @@
           <p:cNvPr id="4" name="">
             <a:extLst xmlns:a="http://schemas.openxmlformats.org/drawingml/2006/main">
               <a:ext uri="{FF2B5EF4-FFF2-40B4-BE49-F238E27FC236}">
-                <a16:creationId xmlns:a16="http://schemas.microsoft.com/office/drawing/2014/main" id="{6478654B-9E78-4263-8E63-A5D2F239ADB7}"/>
+                <a16:creationId xmlns:a16="http://schemas.microsoft.com/office/drawing/2014/main" id="{96F02E54-270E-4E4A-9F30-EE2BA196CBEA}"/>
               </a:ext>
             </a:extLst>
           </p:cNvPr>
@@ -17474,7 +18476,7 @@
           <p:cNvPr id="5" name="">
             <a:extLst xmlns:a="http://schemas.openxmlformats.org/drawingml/2006/main">
               <a:ext uri="{FF2B5EF4-FFF2-40B4-BE49-F238E27FC236}">
-                <a16:creationId xmlns:a16="http://schemas.microsoft.com/office/drawing/2014/main" id="{F5D58281-A65B-4619-A8B9-455E6E0BFA95}"/>
+                <a16:creationId xmlns:a16="http://schemas.microsoft.com/office/drawing/2014/main" id="{F2799408-DB62-4B09-A533-1BFCF4C8502A}"/>
               </a:ext>
             </a:extLst>
           </p:cNvPr>
@@ -17505,7 +18507,7 @@
           <p:cNvPr id="6" name="">
             <a:extLst xmlns:a="http://schemas.openxmlformats.org/drawingml/2006/main">
               <a:ext uri="{FF2B5EF4-FFF2-40B4-BE49-F238E27FC236}">
-                <a16:creationId xmlns:a16="http://schemas.microsoft.com/office/drawing/2014/main" id="{3DB16A33-3C87-4DF5-81C7-203D460DDFBC}"/>
+                <a16:creationId xmlns:a16="http://schemas.microsoft.com/office/drawing/2014/main" id="{08363115-1E69-4900-BEE4-25C43B3E69C2}"/>
               </a:ext>
             </a:extLst>
           </p:cNvPr>
@@ -17536,7 +18538,7 @@
           <p:cNvPr id="7" name="">
             <a:extLst xmlns:a="http://schemas.openxmlformats.org/drawingml/2006/main">
               <a:ext uri="{FF2B5EF4-FFF2-40B4-BE49-F238E27FC236}">
-                <a16:creationId xmlns:a16="http://schemas.microsoft.com/office/drawing/2014/main" id="{D6834F27-DD74-4A03-BF9F-823FD1137D21}"/>
+                <a16:creationId xmlns:a16="http://schemas.microsoft.com/office/drawing/2014/main" id="{7EBED3B3-060F-4410-B59F-57CA1F2A0CD4}"/>
               </a:ext>
             </a:extLst>
           </p:cNvPr>
@@ -17601,7 +18603,7 @@
         </p:xfrm>
         <a:graphic xmlns:a="http://schemas.openxmlformats.org/drawingml/2006/main">
           <a:graphicData uri="http://schemas.openxmlformats.org/drawingml/2006/chart">
-            <c:chart xmlns:r="http://schemas.openxmlformats.org/officeDocument/2006/relationships" xmlns:c="http://schemas.openxmlformats.org/drawingml/2006/chart" r:id="R89c126d5e70e412f"/>
+            <c:chart xmlns:r="http://schemas.openxmlformats.org/officeDocument/2006/relationships" xmlns:c="http://schemas.openxmlformats.org/drawingml/2006/chart" r:id="R5b1221c945c3489f"/>
           </a:graphicData>
         </a:graphic>
       </p:graphicFrame>
@@ -17778,7 +18780,7 @@
                           <a:ea typeface="Helvetica Neue"/>
                           <a:cs typeface="Helvetica Neue"/>
                         </a:rPr>
-                        <a:t>$172.1M</a:t>
+                        <a:t>$172.11M</a:t>
                       </a:r>
                     </a:p>
                   </a:txBody>
@@ -17798,7 +18800,7 @@
                           <a:ea typeface="Helvetica Neue"/>
                           <a:cs typeface="Helvetica Neue"/>
                         </a:rPr>
-                        <a:t>$12.1M</a:t>
+                        <a:t>$12.11M</a:t>
                       </a:r>
                     </a:p>
                   </a:txBody>
@@ -17860,7 +18862,7 @@
                           <a:ea typeface="Helvetica Neue"/>
                           <a:cs typeface="Helvetica Neue"/>
                         </a:rPr>
-                        <a:t>$131.0M</a:t>
+                        <a:t>$131.01M</a:t>
                       </a:r>
                     </a:p>
                   </a:txBody>
@@ -17880,7 +18882,7 @@
                           <a:ea typeface="Helvetica Neue"/>
                           <a:cs typeface="Helvetica Neue"/>
                         </a:rPr>
-                        <a:t>$9.1M</a:t>
+                        <a:t>$9.14M</a:t>
                       </a:r>
                     </a:p>
                   </a:txBody>
@@ -17896,7 +18898,7 @@
           <p:cNvPr id="10" name="">
             <a:extLst xmlns:a="http://schemas.openxmlformats.org/drawingml/2006/main">
               <a:ext uri="{FF2B5EF4-FFF2-40B4-BE49-F238E27FC236}">
-                <a16:creationId xmlns:a16="http://schemas.microsoft.com/office/drawing/2014/main" id="{FA70C294-BC8A-438C-B86A-183B2FC556AC}"/>
+                <a16:creationId xmlns:a16="http://schemas.microsoft.com/office/drawing/2014/main" id="{1BFD301F-6FC7-4E9E-AB53-93194BE5D397}"/>
               </a:ext>
             </a:extLst>
           </p:cNvPr>
@@ -17952,7 +18954,7 @@
     </p:spTree>
     <p:extLst>
       <p:ext uri="{BB962C8B-B14F-4D97-AF65-F5344CB8AC3E}">
-        <p14:creationId xmlns:p14="http://schemas.microsoft.com/office/powerpoint/2010/main" val="497804570"/>
+        <p14:creationId xmlns:p14="http://schemas.microsoft.com/office/powerpoint/2010/main" val="389667063"/>
       </p:ext>
     </p:extLst>
   </p:cSld>

</xml_diff>